<commit_message>
Document neutral split visual verification
</commit_message>
<xml_diff>
--- a/artifacts/mdpr-vs-skill/mdpr-baseline-result.pptx
+++ b/artifacts/mdpr-vs-skill/mdpr-baseline-result.pptx
@@ -6802,7 +6802,7 @@
                 <a:ea typeface="Pretendard" pitchFamily="34" charset="-122"/>
                 <a:cs typeface="Pretendard" pitchFamily="34" charset="-120"/>
               </a:rPr>
-              <a:t>SlideIntentScoreProfile + itemCount + blockType + density =&gt; candidate LayoutPresets =&gt; deterministic score =&gt; selected LayoutPreset</a:t>
+              <a:t>SlideIntentScoreProfile + itemCount + blockType + density =&gt; candidate LayoutPresets =&gt; deterministic score + bounded recent-geometry reuse penalty =&gt; selected LayoutPreset</a:t>
             </a:r>
             <a:endParaRPr lang="en-US" sz="1800" dirty="0"/>
           </a:p>
@@ -10749,61 +10749,7 @@
       </p:grpSpPr>
       <p:sp>
         <p:nvSpPr>
-          <p:cNvPr id="2" name="Shape 0"/>
-          <p:cNvSpPr/>
-          <p:nvPr/>
-        </p:nvSpPr>
-        <p:spPr>
-          <a:xfrm>
-            <a:off x="822960" y="1554480"/>
-            <a:ext cx="4937760" cy="73152"/>
-          </a:xfrm>
-          <a:prstGeom prst="rect">
-            <a:avLst/>
-          </a:prstGeom>
-          <a:solidFill>
-            <a:srgbClr val="2563EB"/>
-          </a:solidFill>
-          <a:ln w="12700">
-            <a:solidFill>
-              <a:srgbClr val="2563EB">
-                <a:alpha val="0"/>
-              </a:srgbClr>
-            </a:solidFill>
-            <a:prstDash val="solid"/>
-          </a:ln>
-        </p:spPr>
-      </p:sp>
-      <p:sp>
-        <p:nvSpPr>
-          <p:cNvPr id="3" name="Shape 1"/>
-          <p:cNvSpPr/>
-          <p:nvPr/>
-        </p:nvSpPr>
-        <p:spPr>
-          <a:xfrm>
-            <a:off x="6400800" y="1554480"/>
-            <a:ext cx="4937760" cy="73152"/>
-          </a:xfrm>
-          <a:prstGeom prst="rect">
-            <a:avLst/>
-          </a:prstGeom>
-          <a:solidFill>
-            <a:srgbClr val="2563EB"/>
-          </a:solidFill>
-          <a:ln w="12700">
-            <a:solidFill>
-              <a:srgbClr val="2563EB">
-                <a:alpha val="0"/>
-              </a:srgbClr>
-            </a:solidFill>
-            <a:prstDash val="solid"/>
-          </a:ln>
-        </p:spPr>
-      </p:sp>
-      <p:sp>
-        <p:nvSpPr>
-          <p:cNvPr id="4" name="mdpr:example-decks-from-mdpr-1f8782:title:__title:example-decks-from-mdpr-1f8782"/>
+          <p:cNvPr id="2" name="mdpr:example-decks-from-mdpr-1f8782:title:__title:example-decks-from-mdpr-1f8782"/>
           <p:cNvSpPr txBox="1"/>
           <p:nvPr/>
         </p:nvSpPr>
@@ -10845,13 +10791,13 @@
       </p:sp>
       <p:sp>
         <p:nvSpPr>
-          <p:cNvPr id="5" name="mdpr:example-decks-from-mdpr-1f8782:left:block-26-block-26-block-26"/>
+          <p:cNvPr id="3" name="mdpr:example-decks-from-mdpr-1f8782:left:block-26-block-26-block-26"/>
           <p:cNvSpPr txBox="1"/>
           <p:nvPr/>
         </p:nvSpPr>
         <p:spPr>
           <a:xfrm>
-            <a:off x="896112" y="2606040"/>
+            <a:off x="896112" y="1463040"/>
             <a:ext cx="4791456" cy="762000"/>
           </a:xfrm>
           <a:prstGeom prst="rect">
@@ -10861,7 +10807,7 @@
           <a:ln/>
         </p:spPr>
         <p:txBody>
-          <a:bodyPr wrap="square" lIns="0" tIns="25400" rIns="25400" bIns="0" rtlCol="0" anchor="ctr"/>
+          <a:bodyPr wrap="square" lIns="0" tIns="25400" rIns="25400" bIns="0" rtlCol="0" anchor="t"/>
           <a:lstStyle/>
           <a:p>
             <a:pPr algn="l" indent="0" marL="0">
@@ -10887,13 +10833,13 @@
       </p:sp>
       <p:sp>
         <p:nvSpPr>
-          <p:cNvPr id="6" name="mdpr:example-decks-from-mdpr-1f8782:left:block-26-block-26-block-26"/>
+          <p:cNvPr id="4" name="mdpr:example-decks-from-mdpr-1f8782:left:block-26-block-26-block-26"/>
           <p:cNvSpPr txBox="1"/>
           <p:nvPr/>
         </p:nvSpPr>
         <p:spPr>
           <a:xfrm>
-            <a:off x="896112" y="3368040"/>
+            <a:off x="896112" y="2225040"/>
             <a:ext cx="4791456" cy="762000"/>
           </a:xfrm>
           <a:prstGeom prst="rect">
@@ -10903,7 +10849,7 @@
           <a:ln/>
         </p:spPr>
         <p:txBody>
-          <a:bodyPr wrap="square" lIns="0" tIns="25400" rIns="25400" bIns="0" rtlCol="0" anchor="ctr"/>
+          <a:bodyPr wrap="square" lIns="0" tIns="25400" rIns="25400" bIns="0" rtlCol="0" anchor="t"/>
           <a:lstStyle/>
           <a:p>
             <a:pPr algn="l" indent="0" marL="0">
@@ -10929,13 +10875,13 @@
       </p:sp>
       <p:sp>
         <p:nvSpPr>
-          <p:cNvPr id="7" name="mdpr:example-decks-from-mdpr-1f8782:left:block-26-block-26-block-26"/>
+          <p:cNvPr id="5" name="mdpr:example-decks-from-mdpr-1f8782:left:block-26-block-26-block-26"/>
           <p:cNvSpPr txBox="1"/>
           <p:nvPr/>
         </p:nvSpPr>
         <p:spPr>
           <a:xfrm>
-            <a:off x="896112" y="4130040"/>
+            <a:off x="896112" y="2987040"/>
             <a:ext cx="4791456" cy="762000"/>
           </a:xfrm>
           <a:prstGeom prst="rect">
@@ -10945,7 +10891,7 @@
           <a:ln/>
         </p:spPr>
         <p:txBody>
-          <a:bodyPr wrap="square" lIns="0" tIns="25400" rIns="25400" bIns="0" rtlCol="0" anchor="ctr"/>
+          <a:bodyPr wrap="square" lIns="0" tIns="25400" rIns="25400" bIns="0" rtlCol="0" anchor="t"/>
           <a:lstStyle/>
           <a:p>
             <a:pPr algn="l" indent="0" marL="0">
@@ -10971,13 +10917,13 @@
       </p:sp>
       <p:sp>
         <p:nvSpPr>
-          <p:cNvPr id="8" name="mdpr:example-decks-from-mdpr-1f8782:right:block-26-block-26"/>
+          <p:cNvPr id="6" name="mdpr:example-decks-from-mdpr-1f8782:right:block-26-block-26"/>
           <p:cNvSpPr txBox="1"/>
           <p:nvPr/>
         </p:nvSpPr>
         <p:spPr>
           <a:xfrm>
-            <a:off x="6473952" y="2819400"/>
+            <a:off x="6473952" y="1463040"/>
             <a:ext cx="4791456" cy="1097280"/>
           </a:xfrm>
           <a:prstGeom prst="rect">
@@ -10987,7 +10933,7 @@
           <a:ln/>
         </p:spPr>
         <p:txBody>
-          <a:bodyPr wrap="square" lIns="0" tIns="25400" rIns="25400" bIns="0" rtlCol="0" anchor="ctr"/>
+          <a:bodyPr wrap="square" lIns="0" tIns="25400" rIns="25400" bIns="0" rtlCol="0" anchor="t"/>
           <a:lstStyle/>
           <a:p>
             <a:pPr algn="l" indent="0" marL="0">
@@ -11013,13 +10959,13 @@
       </p:sp>
       <p:sp>
         <p:nvSpPr>
-          <p:cNvPr id="9" name="mdpr:example-decks-from-mdpr-1f8782:right:block-26-block-26"/>
+          <p:cNvPr id="7" name="mdpr:example-decks-from-mdpr-1f8782:right:block-26-block-26"/>
           <p:cNvSpPr txBox="1"/>
           <p:nvPr/>
         </p:nvSpPr>
         <p:spPr>
           <a:xfrm>
-            <a:off x="6473952" y="3916680"/>
+            <a:off x="6473952" y="2560320"/>
             <a:ext cx="4791456" cy="762000"/>
           </a:xfrm>
           <a:prstGeom prst="rect">
@@ -11029,7 +10975,7 @@
           <a:ln/>
         </p:spPr>
         <p:txBody>
-          <a:bodyPr wrap="square" lIns="0" tIns="25400" rIns="25400" bIns="0" rtlCol="0" anchor="ctr"/>
+          <a:bodyPr wrap="square" lIns="0" tIns="25400" rIns="25400" bIns="0" rtlCol="0" anchor="t"/>
           <a:lstStyle/>
           <a:p>
             <a:pPr algn="l" indent="0" marL="0">

</xml_diff>

<commit_message>
Remove section title echoes from comparison corpus
</commit_message>
<xml_diff>
--- a/artifacts/mdpr-vs-skill/mdpr-baseline-result.pptx
+++ b/artifacts/mdpr-vs-skill/mdpr-baseline-result.pptx
@@ -4388,7 +4388,7 @@
                 <a:ea typeface="Pretendard" pitchFamily="34" charset="-122"/>
                 <a:cs typeface="Pretendard" pitchFamily="34" charset="-120"/>
               </a:rPr>
-              <a:t>slide candidate</a:t>
+              <a:t>subsection or autosplit boundary</a:t>
             </a:r>
             <a:endParaRPr lang="en-US" sz="2200" dirty="0"/>
           </a:p>
@@ -4430,7 +4430,7 @@
                 <a:ea typeface="Pretendard" pitchFamily="34" charset="-122"/>
                 <a:cs typeface="Pretendard" pitchFamily="34" charset="-120"/>
               </a:rPr>
-              <a:t>subsection or autosplit boundary</a:t>
+              <a:t>Procedure</a:t>
             </a:r>
             <a:endParaRPr lang="en-US" sz="2200" dirty="0"/>
           </a:p>
@@ -5941,48 +5941,6 @@
                 <a:ea typeface="Pretendard" pitchFamily="34" charset="-122"/>
                 <a:cs typeface="Pretendard" pitchFamily="34" charset="-120"/>
               </a:rPr>
-              <a:t>Layout Selection Rules</a:t>
-            </a:r>
-            <a:endParaRPr lang="en-US" sz="2200" dirty="0"/>
-          </a:p>
-        </p:txBody>
-      </p:sp>
-      <p:sp>
-        <p:nvSpPr>
-          <p:cNvPr id="14" name="mdpr:1-3-c0cf7e:item-2:block-16-chunk-1"/>
-          <p:cNvSpPr txBox="1"/>
-          <p:nvPr/>
-        </p:nvSpPr>
-        <p:spPr>
-          <a:xfrm>
-            <a:off x="1133856" y="3489960"/>
-            <a:ext cx="9820656" cy="426720"/>
-          </a:xfrm>
-          <a:prstGeom prst="rect">
-            <a:avLst/>
-          </a:prstGeom>
-          <a:noFill/>
-          <a:ln/>
-        </p:spPr>
-        <p:txBody>
-          <a:bodyPr wrap="square" lIns="0" tIns="25400" rIns="25400" bIns="0" rtlCol="0" anchor="ctr"/>
-          <a:lstStyle/>
-          <a:p>
-            <a:pPr algn="ctr" indent="0" marL="0">
-              <a:lnSpc>
-                <a:spcPct val="120000"/>
-              </a:lnSpc>
-              <a:buNone/>
-            </a:pPr>
-            <a:r>
-              <a:rPr lang="en-US" sz="2200" dirty="0">
-                <a:solidFill>
-                  <a:srgbClr val="111111"/>
-                </a:solidFill>
-                <a:latin typeface="Pretendard" pitchFamily="34" charset="0"/>
-                <a:ea typeface="Pretendard" pitchFamily="34" charset="-122"/>
-                <a:cs typeface="Pretendard" pitchFamily="34" charset="-120"/>
-              </a:rPr>
               <a:t>Selection Formula</a:t>
             </a:r>
             <a:endParaRPr lang="en-US" sz="2200" dirty="0"/>
@@ -5991,13 +5949,13 @@
       </p:sp>
       <p:sp>
         <p:nvSpPr>
-          <p:cNvPr id="15" name="mdpr:1-3-c0cf7e:item-3:block-16-chunk-1"/>
+          <p:cNvPr id="14" name="mdpr:1-3-c0cf7e:item-2:block-16-chunk-1"/>
           <p:cNvSpPr txBox="1"/>
           <p:nvPr/>
         </p:nvSpPr>
         <p:spPr>
           <a:xfrm>
-            <a:off x="1133856" y="4806696"/>
+            <a:off x="1133856" y="3489960"/>
             <a:ext cx="9820656" cy="426720"/>
           </a:xfrm>
           <a:prstGeom prst="rect">
@@ -6026,6 +5984,48 @@
                 <a:cs typeface="Pretendard" pitchFamily="34" charset="-120"/>
               </a:rPr>
               <a:t>Intent Detection</a:t>
+            </a:r>
+            <a:endParaRPr lang="en-US" sz="2200" dirty="0"/>
+          </a:p>
+        </p:txBody>
+      </p:sp>
+      <p:sp>
+        <p:nvSpPr>
+          <p:cNvPr id="15" name="mdpr:1-3-c0cf7e:item-3:block-16-chunk-1"/>
+          <p:cNvSpPr txBox="1"/>
+          <p:nvPr/>
+        </p:nvSpPr>
+        <p:spPr>
+          <a:xfrm>
+            <a:off x="1133856" y="4806696"/>
+            <a:ext cx="9820656" cy="426720"/>
+          </a:xfrm>
+          <a:prstGeom prst="rect">
+            <a:avLst/>
+          </a:prstGeom>
+          <a:noFill/>
+          <a:ln/>
+        </p:spPr>
+        <p:txBody>
+          <a:bodyPr wrap="square" lIns="0" tIns="25400" rIns="25400" bIns="0" rtlCol="0" anchor="ctr"/>
+          <a:lstStyle/>
+          <a:p>
+            <a:pPr algn="ctr" indent="0" marL="0">
+              <a:lnSpc>
+                <a:spcPct val="120000"/>
+              </a:lnSpc>
+              <a:buNone/>
+            </a:pPr>
+            <a:r>
+              <a:rPr lang="en-US" sz="2200" dirty="0">
+                <a:solidFill>
+                  <a:srgbClr val="111111"/>
+                </a:solidFill>
+                <a:latin typeface="Pretendard" pitchFamily="34" charset="0"/>
+                <a:ea typeface="Pretendard" pitchFamily="34" charset="-122"/>
+                <a:cs typeface="Pretendard" pitchFamily="34" charset="-120"/>
+              </a:rPr>
+              <a:t>Count-Based Layouts</a:t>
             </a:r>
             <a:endParaRPr lang="en-US" sz="2200" dirty="0"/>
           </a:p>
@@ -6449,7 +6449,7 @@
                 <a:ea typeface="Pretendard" pitchFamily="34" charset="-122"/>
                 <a:cs typeface="Pretendard" pitchFamily="34" charset="-120"/>
               </a:rPr>
-              <a:t>Count-Based Layouts</a:t>
+              <a:t>Presets</a:t>
             </a:r>
             <a:endParaRPr lang="en-US" sz="2200" dirty="0"/>
           </a:p>
@@ -6491,7 +6491,7 @@
                 <a:ea typeface="Pretendard" pitchFamily="34" charset="-122"/>
                 <a:cs typeface="Pretendard" pitchFamily="34" charset="-120"/>
               </a:rPr>
-              <a:t>Presets</a:t>
+              <a:t>Pipeline Diagram Routing</a:t>
             </a:r>
             <a:endParaRPr lang="en-US" sz="2200" dirty="0"/>
           </a:p>
@@ -7942,48 +7942,6 @@
                 <a:ea typeface="Pretendard" pitchFamily="34" charset="-122"/>
                 <a:cs typeface="Pretendard" pitchFamily="34" charset="-120"/>
               </a:rPr>
-              <a:t>Rendering Rules</a:t>
-            </a:r>
-            <a:endParaRPr lang="en-US" sz="2200" dirty="0"/>
-          </a:p>
-        </p:txBody>
-      </p:sp>
-      <p:sp>
-        <p:nvSpPr>
-          <p:cNvPr id="14" name="mdpr:1-3-0466ef:item-2:block-20-chunk-1"/>
-          <p:cNvSpPr txBox="1"/>
-          <p:nvPr/>
-        </p:nvSpPr>
-        <p:spPr>
-          <a:xfrm>
-            <a:off x="1133856" y="3489960"/>
-            <a:ext cx="9820656" cy="426720"/>
-          </a:xfrm>
-          <a:prstGeom prst="rect">
-            <a:avLst/>
-          </a:prstGeom>
-          <a:noFill/>
-          <a:ln/>
-        </p:spPr>
-        <p:txBody>
-          <a:bodyPr wrap="square" lIns="0" tIns="25400" rIns="25400" bIns="0" rtlCol="0" anchor="ctr"/>
-          <a:lstStyle/>
-          <a:p>
-            <a:pPr algn="ctr" indent="0" marL="0">
-              <a:lnSpc>
-                <a:spcPct val="120000"/>
-              </a:lnSpc>
-              <a:buNone/>
-            </a:pPr>
-            <a:r>
-              <a:rPr lang="en-US" sz="2200" dirty="0">
-                <a:solidFill>
-                  <a:srgbClr val="111111"/>
-                </a:solidFill>
-                <a:latin typeface="Pretendard" pitchFamily="34" charset="0"/>
-                <a:ea typeface="Pretendard" pitchFamily="34" charset="-122"/>
-                <a:cs typeface="Pretendard" pitchFamily="34" charset="-120"/>
-              </a:rPr>
               <a:t>Shared Renderer Contract</a:t>
             </a:r>
             <a:endParaRPr lang="en-US" sz="2200" dirty="0"/>
@@ -7992,13 +7950,13 @@
       </p:sp>
       <p:sp>
         <p:nvSpPr>
-          <p:cNvPr id="15" name="mdpr:1-3-0466ef:item-3:block-20-chunk-1"/>
+          <p:cNvPr id="14" name="mdpr:1-3-0466ef:item-2:block-20-chunk-1"/>
           <p:cNvSpPr txBox="1"/>
           <p:nvPr/>
         </p:nvSpPr>
         <p:spPr>
           <a:xfrm>
-            <a:off x="1133856" y="4806696"/>
+            <a:off x="1133856" y="3489960"/>
             <a:ext cx="9820656" cy="426720"/>
           </a:xfrm>
           <a:prstGeom prst="rect">
@@ -8027,6 +7985,48 @@
                 <a:cs typeface="Pretendard" pitchFamily="34" charset="-120"/>
               </a:rPr>
               <a:t>PPTX Renderer</a:t>
+            </a:r>
+            <a:endParaRPr lang="en-US" sz="2200" dirty="0"/>
+          </a:p>
+        </p:txBody>
+      </p:sp>
+      <p:sp>
+        <p:nvSpPr>
+          <p:cNvPr id="15" name="mdpr:1-3-0466ef:item-3:block-20-chunk-1"/>
+          <p:cNvSpPr txBox="1"/>
+          <p:nvPr/>
+        </p:nvSpPr>
+        <p:spPr>
+          <a:xfrm>
+            <a:off x="1133856" y="4806696"/>
+            <a:ext cx="9820656" cy="426720"/>
+          </a:xfrm>
+          <a:prstGeom prst="rect">
+            <a:avLst/>
+          </a:prstGeom>
+          <a:noFill/>
+          <a:ln/>
+        </p:spPr>
+        <p:txBody>
+          <a:bodyPr wrap="square" lIns="0" tIns="25400" rIns="25400" bIns="0" rtlCol="0" anchor="ctr"/>
+          <a:lstStyle/>
+          <a:p>
+            <a:pPr algn="ctr" indent="0" marL="0">
+              <a:lnSpc>
+                <a:spcPct val="120000"/>
+              </a:lnSpc>
+              <a:buNone/>
+            </a:pPr>
+            <a:r>
+              <a:rPr lang="en-US" sz="2200" dirty="0">
+                <a:solidFill>
+                  <a:srgbClr val="111111"/>
+                </a:solidFill>
+                <a:latin typeface="Pretendard" pitchFamily="34" charset="0"/>
+                <a:ea typeface="Pretendard" pitchFamily="34" charset="-122"/>
+                <a:cs typeface="Pretendard" pitchFamily="34" charset="-120"/>
+              </a:rPr>
+              <a:t>Decoration Styles</a:t>
             </a:r>
             <a:endParaRPr lang="en-US" sz="2200" dirty="0"/>
           </a:p>
@@ -8450,7 +8450,7 @@
                 <a:ea typeface="Pretendard" pitchFamily="34" charset="-122"/>
                 <a:cs typeface="Pretendard" pitchFamily="34" charset="-120"/>
               </a:rPr>
-              <a:t>Decoration Styles</a:t>
+              <a:t>Color and Theme Policy</a:t>
             </a:r>
             <a:endParaRPr lang="en-US" sz="2200" dirty="0"/>
           </a:p>
@@ -8492,7 +8492,7 @@
                 <a:ea typeface="Pretendard" pitchFamily="34" charset="-122"/>
                 <a:cs typeface="Pretendard" pitchFamily="34" charset="-120"/>
               </a:rPr>
-              <a:t>Color and Theme Policy</a:t>
+              <a:t>Surface Policy</a:t>
             </a:r>
             <a:endParaRPr lang="en-US" sz="2200" dirty="0"/>
           </a:p>
@@ -9180,48 +9180,6 @@
                 <a:ea typeface="Pretendard" pitchFamily="34" charset="-122"/>
                 <a:cs typeface="Pretendard" pitchFamily="34" charset="-120"/>
               </a:rPr>
-              <a:t>Validation and Overflow Policy</a:t>
-            </a:r>
-            <a:endParaRPr lang="en-US" sz="2200" dirty="0"/>
-          </a:p>
-        </p:txBody>
-      </p:sp>
-      <p:sp>
-        <p:nvSpPr>
-          <p:cNvPr id="14" name="mdpr:1-3-4b2f30:item-2:block-23-chunk-1"/>
-          <p:cNvSpPr txBox="1"/>
-          <p:nvPr/>
-        </p:nvSpPr>
-        <p:spPr>
-          <a:xfrm>
-            <a:off x="1133856" y="3489960"/>
-            <a:ext cx="9820656" cy="426720"/>
-          </a:xfrm>
-          <a:prstGeom prst="rect">
-            <a:avLst/>
-          </a:prstGeom>
-          <a:noFill/>
-          <a:ln/>
-        </p:spPr>
-        <p:txBody>
-          <a:bodyPr wrap="square" lIns="0" tIns="25400" rIns="25400" bIns="0" rtlCol="0" anchor="ctr"/>
-          <a:lstStyle/>
-          <a:p>
-            <a:pPr algn="ctr" indent="0" marL="0">
-              <a:lnSpc>
-                <a:spcPct val="120000"/>
-              </a:lnSpc>
-              <a:buNone/>
-            </a:pPr>
-            <a:r>
-              <a:rPr lang="en-US" sz="2200" dirty="0">
-                <a:solidFill>
-                  <a:srgbClr val="111111"/>
-                </a:solidFill>
-                <a:latin typeface="Pretendard" pitchFamily="34" charset="0"/>
-                <a:ea typeface="Pretendard" pitchFamily="34" charset="-122"/>
-                <a:cs typeface="Pretendard" pitchFamily="34" charset="-120"/>
-              </a:rPr>
               <a:t>Validation Checks</a:t>
             </a:r>
             <a:endParaRPr lang="en-US" sz="2200" dirty="0"/>
@@ -9230,13 +9188,13 @@
       </p:sp>
       <p:sp>
         <p:nvSpPr>
-          <p:cNvPr id="15" name="mdpr:1-3-4b2f30:item-3:block-23-chunk-1"/>
+          <p:cNvPr id="14" name="mdpr:1-3-4b2f30:item-2:block-23-chunk-1"/>
           <p:cNvSpPr txBox="1"/>
           <p:nvPr/>
         </p:nvSpPr>
         <p:spPr>
           <a:xfrm>
-            <a:off x="1133856" y="4806696"/>
+            <a:off x="1133856" y="3489960"/>
             <a:ext cx="9820656" cy="426720"/>
           </a:xfrm>
           <a:prstGeom prst="rect">
@@ -9265,6 +9223,48 @@
                 <a:cs typeface="Pretendard" pitchFamily="34" charset="-120"/>
               </a:rPr>
               <a:t>Overflow Resolution Order</a:t>
+            </a:r>
+            <a:endParaRPr lang="en-US" sz="2200" dirty="0"/>
+          </a:p>
+        </p:txBody>
+      </p:sp>
+      <p:sp>
+        <p:nvSpPr>
+          <p:cNvPr id="15" name="mdpr:1-3-4b2f30:item-3:block-23-chunk-1"/>
+          <p:cNvSpPr txBox="1"/>
+          <p:nvPr/>
+        </p:nvSpPr>
+        <p:spPr>
+          <a:xfrm>
+            <a:off x="1133856" y="4806696"/>
+            <a:ext cx="9820656" cy="426720"/>
+          </a:xfrm>
+          <a:prstGeom prst="rect">
+            <a:avLst/>
+          </a:prstGeom>
+          <a:noFill/>
+          <a:ln/>
+        </p:spPr>
+        <p:txBody>
+          <a:bodyPr wrap="square" lIns="0" tIns="25400" rIns="25400" bIns="0" rtlCol="0" anchor="ctr"/>
+          <a:lstStyle/>
+          <a:p>
+            <a:pPr algn="ctr" indent="0" marL="0">
+              <a:lnSpc>
+                <a:spcPct val="120000"/>
+              </a:lnSpc>
+              <a:buNone/>
+            </a:pPr>
+            <a:r>
+              <a:rPr lang="en-US" sz="2200" dirty="0">
+                <a:solidFill>
+                  <a:srgbClr val="111111"/>
+                </a:solidFill>
+                <a:latin typeface="Pretendard" pitchFamily="34" charset="0"/>
+                <a:ea typeface="Pretendard" pitchFamily="34" charset="-122"/>
+                <a:cs typeface="Pretendard" pitchFamily="34" charset="-120"/>
+              </a:rPr>
+              <a:t>Diagnostics</a:t>
             </a:r>
             <a:endParaRPr lang="en-US" sz="2200" dirty="0"/>
           </a:p>
@@ -9688,7 +9688,7 @@
                 <a:ea typeface="Pretendard" pitchFamily="34" charset="-122"/>
                 <a:cs typeface="Pretendard" pitchFamily="34" charset="-120"/>
               </a:rPr>
-              <a:t>Diagnostics</a:t>
+              <a:t>Text Normalization</a:t>
             </a:r>
             <a:endParaRPr lang="en-US" sz="2200" dirty="0"/>
           </a:p>
@@ -9730,7 +9730,7 @@
                 <a:ea typeface="Pretendard" pitchFamily="34" charset="-122"/>
                 <a:cs typeface="Pretendard" pitchFamily="34" charset="-120"/>
               </a:rPr>
-              <a:t>Text Normalization</a:t>
+              <a:t>Title Regions</a:t>
             </a:r>
             <a:endParaRPr lang="en-US" sz="2200" dirty="0"/>
           </a:p>
@@ -23948,48 +23948,6 @@
                 <a:ea typeface="Pretendard" pitchFamily="34" charset="-122"/>
                 <a:cs typeface="Pretendard" pitchFamily="34" charset="-120"/>
               </a:rPr>
-              <a:t>Architecture</a:t>
-            </a:r>
-            <a:endParaRPr lang="en-US" sz="2200" dirty="0"/>
-          </a:p>
-        </p:txBody>
-      </p:sp>
-      <p:sp>
-        <p:nvSpPr>
-          <p:cNvPr id="16" name="mdpr:1-2-c51ee9:item-2:block-9-chunk-1"/>
-          <p:cNvSpPr txBox="1"/>
-          <p:nvPr/>
-        </p:nvSpPr>
-        <p:spPr>
-          <a:xfrm>
-            <a:off x="6528816" y="2209800"/>
-            <a:ext cx="4608576" cy="426720"/>
-          </a:xfrm>
-          <a:prstGeom prst="rect">
-            <a:avLst/>
-          </a:prstGeom>
-          <a:noFill/>
-          <a:ln/>
-        </p:spPr>
-        <p:txBody>
-          <a:bodyPr wrap="square" lIns="0" tIns="25400" rIns="25400" bIns="0" rtlCol="0" anchor="ctr"/>
-          <a:lstStyle/>
-          <a:p>
-            <a:pPr algn="ctr" indent="0" marL="0">
-              <a:lnSpc>
-                <a:spcPct val="120000"/>
-              </a:lnSpc>
-              <a:buNone/>
-            </a:pPr>
-            <a:r>
-              <a:rPr lang="en-US" sz="2200" dirty="0">
-                <a:solidFill>
-                  <a:srgbClr val="111111"/>
-                </a:solidFill>
-                <a:latin typeface="Pretendard" pitchFamily="34" charset="0"/>
-                <a:ea typeface="Pretendard" pitchFamily="34" charset="-122"/>
-                <a:cs typeface="Pretendard" pitchFamily="34" charset="-120"/>
-              </a:rPr>
               <a:t>Flow</a:t>
             </a:r>
             <a:endParaRPr lang="en-US" sz="2200" dirty="0"/>
@@ -23998,13 +23956,13 @@
       </p:sp>
       <p:sp>
         <p:nvSpPr>
-          <p:cNvPr id="17" name="mdpr:1-2-c51ee9:item-3:block-9-chunk-1"/>
+          <p:cNvPr id="16" name="mdpr:1-2-c51ee9:item-2:block-9-chunk-1"/>
           <p:cNvSpPr txBox="1"/>
           <p:nvPr/>
         </p:nvSpPr>
         <p:spPr>
           <a:xfrm>
-            <a:off x="1042416" y="4495800"/>
+            <a:off x="6528816" y="2209800"/>
             <a:ext cx="4608576" cy="426720"/>
           </a:xfrm>
           <a:prstGeom prst="rect">
@@ -24040,13 +23998,13 @@
       </p:sp>
       <p:sp>
         <p:nvSpPr>
-          <p:cNvPr id="18" name="mdpr:1-2-c51ee9:item-4:block-9-chunk-1"/>
+          <p:cNvPr id="17" name="mdpr:1-2-c51ee9:item-3:block-9-chunk-1"/>
           <p:cNvSpPr txBox="1"/>
           <p:nvPr/>
         </p:nvSpPr>
         <p:spPr>
           <a:xfrm>
-            <a:off x="6528816" y="4495800"/>
+            <a:off x="1042416" y="4495800"/>
             <a:ext cx="4608576" cy="426720"/>
           </a:xfrm>
           <a:prstGeom prst="rect">
@@ -24075,6 +24033,48 @@
                 <a:cs typeface="Pretendard" pitchFamily="34" charset="-120"/>
               </a:rPr>
               <a:t>Design Principles</a:t>
+            </a:r>
+            <a:endParaRPr lang="en-US" sz="2200" dirty="0"/>
+          </a:p>
+        </p:txBody>
+      </p:sp>
+      <p:sp>
+        <p:nvSpPr>
+          <p:cNvPr id="18" name="mdpr:1-2-c51ee9:item-4:block-9-chunk-1"/>
+          <p:cNvSpPr txBox="1"/>
+          <p:nvPr/>
+        </p:nvSpPr>
+        <p:spPr>
+          <a:xfrm>
+            <a:off x="6528816" y="4328160"/>
+            <a:ext cx="4608576" cy="762000"/>
+          </a:xfrm>
+          <a:prstGeom prst="rect">
+            <a:avLst/>
+          </a:prstGeom>
+          <a:noFill/>
+          <a:ln/>
+        </p:spPr>
+        <p:txBody>
+          <a:bodyPr wrap="square" lIns="0" tIns="25400" rIns="25400" bIns="0" rtlCol="0" anchor="ctr"/>
+          <a:lstStyle/>
+          <a:p>
+            <a:pPr algn="ctr" indent="0" marL="0">
+              <a:lnSpc>
+                <a:spcPct val="120000"/>
+              </a:lnSpc>
+              <a:buNone/>
+            </a:pPr>
+            <a:r>
+              <a:rPr lang="en-US" sz="2200" dirty="0">
+                <a:solidFill>
+                  <a:srgbClr val="111111"/>
+                </a:solidFill>
+                <a:latin typeface="Pretendard" pitchFamily="34" charset="0"/>
+                <a:ea typeface="Pretendard" pitchFamily="34" charset="-122"/>
+                <a:cs typeface="Pretendard" pitchFamily="34" charset="-120"/>
+              </a:rPr>
+              <a:t>core does not know renderers. It emits Presentation IR only.</a:t>
             </a:r>
             <a:endParaRPr lang="en-US" sz="2200" dirty="0"/>
           </a:p>
@@ -25748,48 +25748,6 @@
                 <a:ea typeface="Pretendard" pitchFamily="34" charset="-122"/>
                 <a:cs typeface="Pretendard" pitchFamily="34" charset="-120"/>
               </a:rPr>
-              <a:t>Page Splitting Rules</a:t>
-            </a:r>
-            <a:endParaRPr lang="en-US" sz="2200" dirty="0"/>
-          </a:p>
-        </p:txBody>
-      </p:sp>
-      <p:sp>
-        <p:nvSpPr>
-          <p:cNvPr id="14" name="mdpr:1-3-c49d80:item-2:block-12-chunk-1"/>
-          <p:cNvSpPr txBox="1"/>
-          <p:nvPr/>
-        </p:nvSpPr>
-        <p:spPr>
-          <a:xfrm>
-            <a:off x="1133856" y="3489960"/>
-            <a:ext cx="9820656" cy="426720"/>
-          </a:xfrm>
-          <a:prstGeom prst="rect">
-            <a:avLst/>
-          </a:prstGeom>
-          <a:noFill/>
-          <a:ln/>
-        </p:spPr>
-        <p:txBody>
-          <a:bodyPr wrap="square" lIns="0" tIns="25400" rIns="25400" bIns="0" rtlCol="0" anchor="ctr"/>
-          <a:lstStyle/>
-          <a:p>
-            <a:pPr algn="ctr" indent="0" marL="0">
-              <a:lnSpc>
-                <a:spcPct val="120000"/>
-              </a:lnSpc>
-              <a:buNone/>
-            </a:pPr>
-            <a:r>
-              <a:rPr lang="en-US" sz="2200" dirty="0">
-                <a:solidFill>
-                  <a:srgbClr val="111111"/>
-                </a:solidFill>
-                <a:latin typeface="Pretendard" pitchFamily="34" charset="0"/>
-                <a:ea typeface="Pretendard" pitchFamily="34" charset="-122"/>
-                <a:cs typeface="Pretendard" pitchFamily="34" charset="-120"/>
-              </a:rPr>
               <a:t>Heading Rules</a:t>
             </a:r>
             <a:endParaRPr lang="en-US" sz="2200" dirty="0"/>
@@ -25798,13 +25756,13 @@
       </p:sp>
       <p:sp>
         <p:nvSpPr>
-          <p:cNvPr id="15" name="mdpr:1-3-c49d80:item-3:block-12-chunk-1"/>
+          <p:cNvPr id="14" name="mdpr:1-3-c49d80:item-2:block-12-chunk-1"/>
           <p:cNvSpPr txBox="1"/>
           <p:nvPr/>
         </p:nvSpPr>
         <p:spPr>
           <a:xfrm>
-            <a:off x="1133856" y="4806696"/>
+            <a:off x="1133856" y="3489960"/>
             <a:ext cx="9820656" cy="426720"/>
           </a:xfrm>
           <a:prstGeom prst="rect">
@@ -25833,6 +25791,48 @@
                 <a:cs typeface="Pretendard" pitchFamily="34" charset="-120"/>
               </a:rPr>
               <a:t>cover or section</a:t>
+            </a:r>
+            <a:endParaRPr lang="en-US" sz="2200" dirty="0"/>
+          </a:p>
+        </p:txBody>
+      </p:sp>
+      <p:sp>
+        <p:nvSpPr>
+          <p:cNvPr id="15" name="mdpr:1-3-c49d80:item-3:block-12-chunk-1"/>
+          <p:cNvSpPr txBox="1"/>
+          <p:nvPr/>
+        </p:nvSpPr>
+        <p:spPr>
+          <a:xfrm>
+            <a:off x="1133856" y="4806696"/>
+            <a:ext cx="9820656" cy="426720"/>
+          </a:xfrm>
+          <a:prstGeom prst="rect">
+            <a:avLst/>
+          </a:prstGeom>
+          <a:noFill/>
+          <a:ln/>
+        </p:spPr>
+        <p:txBody>
+          <a:bodyPr wrap="square" lIns="0" tIns="25400" rIns="25400" bIns="0" rtlCol="0" anchor="ctr"/>
+          <a:lstStyle/>
+          <a:p>
+            <a:pPr algn="ctr" indent="0" marL="0">
+              <a:lnSpc>
+                <a:spcPct val="120000"/>
+              </a:lnSpc>
+              <a:buNone/>
+            </a:pPr>
+            <a:r>
+              <a:rPr lang="en-US" sz="2200" dirty="0">
+                <a:solidFill>
+                  <a:srgbClr val="111111"/>
+                </a:solidFill>
+                <a:latin typeface="Pretendard" pitchFamily="34" charset="0"/>
+                <a:ea typeface="Pretendard" pitchFamily="34" charset="-122"/>
+                <a:cs typeface="Pretendard" pitchFamily="34" charset="-120"/>
+              </a:rPr>
+              <a:t>slide candidate</a:t>
             </a:r>
             <a:endParaRPr lang="en-US" sz="2200" dirty="0"/>
           </a:p>

</xml_diff>

<commit_message>
Verify continuous Agenda numbering
</commit_message>
<xml_diff>
--- a/artifacts/mdpr-vs-skill/mdpr-baseline-result.pptx
+++ b/artifacts/mdpr-vs-skill/mdpr-baseline-result.pptx
@@ -16218,7 +16218,7 @@
                 <a:ea typeface="Pretendard" pitchFamily="34" charset="-122"/>
                 <a:cs typeface="Pretendard" pitchFamily="34" charset="-120"/>
               </a:rPr>
-              <a:t>01  Example: examples/basic/deck.md</a:t>
+              <a:t>09  Example: examples/basic/deck.md</a:t>
             </a:r>
             <a:endParaRPr lang="en-US" sz="1800" dirty="0"/>
           </a:p>
@@ -16260,7 +16260,7 @@
                 <a:ea typeface="Pretendard" pitchFamily="34" charset="-122"/>
                 <a:cs typeface="Pretendard" pitchFamily="34" charset="-120"/>
               </a:rPr>
-              <a:t>02  Example: examples/comparison/deck.md</a:t>
+              <a:t>10  Example: examples/comparison/deck.md</a:t>
             </a:r>
             <a:endParaRPr lang="en-US" sz="1800" dirty="0"/>
           </a:p>
@@ -16302,7 +16302,7 @@
                 <a:ea typeface="Pretendard" pitchFamily="34" charset="-122"/>
                 <a:cs typeface="Pretendard" pitchFamily="34" charset="-120"/>
               </a:rPr>
-              <a:t>03  Example: examples/pipeline/deck.md</a:t>
+              <a:t>11  Example: examples/pipeline/deck.md</a:t>
             </a:r>
             <a:endParaRPr lang="en-US" sz="1800" dirty="0"/>
           </a:p>
@@ -16344,7 +16344,7 @@
                 <a:ea typeface="Pretendard" pitchFamily="34" charset="-122"/>
                 <a:cs typeface="Pretendard" pitchFamily="34" charset="-120"/>
               </a:rPr>
-              <a:t>04  Example: examples/diagram-arrangements/deck.md</a:t>
+              <a:t>12  Example: examples/diagram-arrangements/deck.md</a:t>
             </a:r>
             <a:endParaRPr lang="en-US" sz="1800" dirty="0"/>
           </a:p>
@@ -16386,7 +16386,7 @@
                 <a:ea typeface="Pretendard" pitchFamily="34" charset="-122"/>
                 <a:cs typeface="Pretendard" pitchFamily="34" charset="-120"/>
               </a:rPr>
-              <a:t>05  Example: examples/five-methods/deck.md</a:t>
+              <a:t>13  Example: examples/five-methods/deck.md</a:t>
             </a:r>
             <a:endParaRPr lang="en-US" sz="1800" dirty="0"/>
           </a:p>
@@ -16428,7 +16428,7 @@
                 <a:ea typeface="Pretendard" pitchFamily="34" charset="-122"/>
                 <a:cs typeface="Pretendard" pitchFamily="34" charset="-120"/>
               </a:rPr>
-              <a:t>06  Example: examples/theme-preview-en/deck.md</a:t>
+              <a:t>14  Example: examples/theme-preview-en/deck.md</a:t>
             </a:r>
             <a:endParaRPr lang="en-US" sz="1800" dirty="0"/>
           </a:p>
@@ -16470,7 +16470,7 @@
                 <a:ea typeface="Pretendard" pitchFamily="34" charset="-122"/>
                 <a:cs typeface="Pretendard" pitchFamily="34" charset="-120"/>
               </a:rPr>
-              <a:t>07  Current skill output expectations</a:t>
+              <a:t>15  Current skill output expectations</a:t>
             </a:r>
             <a:endParaRPr lang="en-US" sz="1800" dirty="0"/>
           </a:p>
@@ -16512,7 +16512,7 @@
                 <a:ea typeface="Pretendard" pitchFamily="34" charset="-122"/>
                 <a:cs typeface="Pretendard" pitchFamily="34" charset="-120"/>
               </a:rPr>
-              <a:t>08  End state</a:t>
+              <a:t>16  End state</a:t>
             </a:r>
             <a:endParaRPr lang="en-US" sz="1800" dirty="0"/>
           </a:p>

</xml_diff>

<commit_message>
Refresh MDPR comparison evidence
</commit_message>
<xml_diff>
--- a/artifacts/mdpr-vs-skill/mdpr-baseline-result.pptx
+++ b/artifacts/mdpr-vs-skill/mdpr-baseline-result.pptx
@@ -8594,8 +8594,8 @@
         </p:blipFill>
         <p:spPr>
           <a:xfrm>
-            <a:off x="777240" y="1417320"/>
-            <a:ext cx="10652760" cy="4800600"/>
+            <a:off x="777240" y="3035808"/>
+            <a:ext cx="10652760" cy="1572768"/>
           </a:xfrm>
           <a:prstGeom prst="rect">
             <a:avLst/>
@@ -8610,8 +8610,8 @@
         </p:nvSpPr>
         <p:spPr>
           <a:xfrm>
-            <a:off x="777240" y="1417320"/>
-            <a:ext cx="10652760" cy="4800600"/>
+            <a:off x="777240" y="3035808"/>
+            <a:ext cx="10652760" cy="1572768"/>
           </a:xfrm>
           <a:prstGeom prst="rect">
             <a:avLst/>
@@ -8688,8 +8688,8 @@
         </p:nvSpPr>
         <p:spPr>
           <a:xfrm>
-            <a:off x="941832" y="1563624"/>
-            <a:ext cx="10323576" cy="4507992"/>
+            <a:off x="941832" y="3182112"/>
+            <a:ext cx="10323576" cy="1280160"/>
           </a:xfrm>
           <a:prstGeom prst="rect">
             <a:avLst/>
@@ -10487,8 +10487,8 @@
         </p:blipFill>
         <p:spPr>
           <a:xfrm>
-            <a:off x="777240" y="1417320"/>
-            <a:ext cx="10652760" cy="4800600"/>
+            <a:off x="777240" y="2560320"/>
+            <a:ext cx="10652760" cy="2505456"/>
           </a:xfrm>
           <a:prstGeom prst="rect">
             <a:avLst/>
@@ -10503,8 +10503,8 @@
         </p:nvSpPr>
         <p:spPr>
           <a:xfrm>
-            <a:off x="777240" y="1417320"/>
-            <a:ext cx="10652760" cy="4800600"/>
+            <a:off x="777240" y="2560320"/>
+            <a:ext cx="10652760" cy="2505456"/>
           </a:xfrm>
           <a:prstGeom prst="rect">
             <a:avLst/>
@@ -10581,8 +10581,8 @@
         </p:nvSpPr>
         <p:spPr>
           <a:xfrm>
-            <a:off x="941832" y="1563624"/>
-            <a:ext cx="10323576" cy="4507992"/>
+            <a:off x="941832" y="2706624"/>
+            <a:ext cx="10323576" cy="2212848"/>
           </a:xfrm>
           <a:prstGeom prst="rect">
             <a:avLst/>

</xml_diff>

<commit_message>
Refresh twenty-loop visual comparison
</commit_message>
<xml_diff>
--- a/artifacts/mdpr-vs-skill/mdpr-baseline-result.pptx
+++ b/artifacts/mdpr-vs-skill/mdpr-baseline-result.pptx
@@ -4002,243 +4002,16 @@
           <a:chExt cx="0" cy="0"/>
         </a:xfrm>
       </p:grpSpPr>
-      <p:pic>
-        <p:nvPicPr>
-          <p:cNvPr id="2" name="Image 0" descr="preencoded.png">    </p:cNvPr>
-          <p:cNvPicPr>
-            <a:picLocks noChangeAspect="1"/>
-          </p:cNvPicPr>
-          <p:nvPr/>
-        </p:nvPicPr>
-        <p:blipFill>
-          <a:blip r:embed="rId1">
-            <a:extLst>
-              <a:ext uri="{96DAC541-7B7A-43D3-8B79-37D633B846F1}">
-                <asvg:svgBlip xmlns:asvg="http://schemas.microsoft.com/office/drawing/2016/SVG/main" r:embed="rId2"/>
-              </a:ext>
-            </a:extLst>
-          </a:blip>
-          <a:stretch>
-            <a:fillRect/>
-          </a:stretch>
-        </p:blipFill>
-        <p:spPr>
-          <a:xfrm>
-            <a:off x="914400" y="1865376"/>
-            <a:ext cx="10241280" cy="1024128"/>
-          </a:xfrm>
-          <a:prstGeom prst="rect">
-            <a:avLst/>
-          </a:prstGeom>
-        </p:spPr>
-      </p:pic>
-      <p:sp>
-        <p:nvSpPr>
-          <p:cNvPr id="3" name="Shape 0"/>
+      <p:sp>
+        <p:nvSpPr>
+          <p:cNvPr id="2" name="Shape 0"/>
           <p:cNvSpPr/>
           <p:nvPr/>
         </p:nvSpPr>
         <p:spPr>
           <a:xfrm>
-            <a:off x="914400" y="1865376"/>
-            <a:ext cx="10241280" cy="1024128"/>
-          </a:xfrm>
-          <a:prstGeom prst="rect">
-            <a:avLst/>
-          </a:prstGeom>
-          <a:solidFill>
-            <a:srgbClr val="FFFFFF">
-              <a:alpha val="0"/>
-            </a:srgbClr>
-          </a:solidFill>
-          <a:ln w="12700">
-            <a:solidFill>
-              <a:srgbClr val="E2E8F0">
-                <a:alpha val="0"/>
-              </a:srgbClr>
-            </a:solidFill>
-            <a:prstDash val="solid"/>
-          </a:ln>
-          <a:effectLst>
-            <a:outerShdw sx="100000" sy="100000" kx="0" ky="0" algn="bl" rotWithShape="0" blurRad="12700" dist="50800" dir="2700000">
-              <a:srgbClr val="000000">
-                <a:alpha val="8000"/>
-              </a:srgbClr>
-            </a:outerShdw>
-          </a:effectLst>
-        </p:spPr>
-      </p:sp>
-      <p:pic>
-        <p:nvPicPr>
-          <p:cNvPr id="4" name="Image 1" descr="preencoded.png">    </p:cNvPr>
-          <p:cNvPicPr>
-            <a:picLocks noChangeAspect="1"/>
-          </p:cNvPicPr>
-          <p:nvPr/>
-        </p:nvPicPr>
-        <p:blipFill>
-          <a:blip r:embed="rId3">
-            <a:extLst>
-              <a:ext uri="{96DAC541-7B7A-43D3-8B79-37D633B846F1}">
-                <asvg:svgBlip xmlns:asvg="http://schemas.microsoft.com/office/drawing/2016/SVG/main" r:embed="rId4"/>
-              </a:ext>
-            </a:extLst>
-          </a:blip>
-          <a:stretch>
-            <a:fillRect/>
-          </a:stretch>
-        </p:blipFill>
-        <p:spPr>
-          <a:xfrm>
-            <a:off x="914400" y="3191256"/>
-            <a:ext cx="10241280" cy="1024128"/>
-          </a:xfrm>
-          <a:prstGeom prst="rect">
-            <a:avLst/>
-          </a:prstGeom>
-        </p:spPr>
-      </p:pic>
-      <p:sp>
-        <p:nvSpPr>
-          <p:cNvPr id="5" name="Shape 1"/>
-          <p:cNvSpPr/>
-          <p:nvPr/>
-        </p:nvSpPr>
-        <p:spPr>
-          <a:xfrm>
-            <a:off x="914400" y="3191256"/>
-            <a:ext cx="10241280" cy="1024128"/>
-          </a:xfrm>
-          <a:prstGeom prst="rect">
-            <a:avLst/>
-          </a:prstGeom>
-          <a:solidFill>
-            <a:srgbClr val="FFFFFF">
-              <a:alpha val="0"/>
-            </a:srgbClr>
-          </a:solidFill>
-          <a:ln w="12700">
-            <a:solidFill>
-              <a:srgbClr val="E2E8F0">
-                <a:alpha val="0"/>
-              </a:srgbClr>
-            </a:solidFill>
-            <a:prstDash val="solid"/>
-          </a:ln>
-          <a:effectLst>
-            <a:outerShdw sx="100000" sy="100000" kx="0" ky="0" algn="bl" rotWithShape="0" blurRad="12700" dist="50800" dir="2700000">
-              <a:srgbClr val="000000">
-                <a:alpha val="8000"/>
-              </a:srgbClr>
-            </a:outerShdw>
-          </a:effectLst>
-        </p:spPr>
-      </p:sp>
-      <p:pic>
-        <p:nvPicPr>
-          <p:cNvPr id="6" name="Image 2" descr="preencoded.png">    </p:cNvPr>
-          <p:cNvPicPr>
-            <a:picLocks noChangeAspect="1"/>
-          </p:cNvPicPr>
-          <p:nvPr/>
-        </p:nvPicPr>
-        <p:blipFill>
-          <a:blip r:embed="rId5">
-            <a:extLst>
-              <a:ext uri="{96DAC541-7B7A-43D3-8B79-37D633B846F1}">
-                <asvg:svgBlip xmlns:asvg="http://schemas.microsoft.com/office/drawing/2016/SVG/main" r:embed="rId6"/>
-              </a:ext>
-            </a:extLst>
-          </a:blip>
-          <a:stretch>
-            <a:fillRect/>
-          </a:stretch>
-        </p:blipFill>
-        <p:spPr>
-          <a:xfrm>
-            <a:off x="914400" y="4507992"/>
-            <a:ext cx="10241280" cy="1024128"/>
-          </a:xfrm>
-          <a:prstGeom prst="rect">
-            <a:avLst/>
-          </a:prstGeom>
-        </p:spPr>
-      </p:pic>
-      <p:sp>
-        <p:nvSpPr>
-          <p:cNvPr id="7" name="Shape 2"/>
-          <p:cNvSpPr/>
-          <p:nvPr/>
-        </p:nvSpPr>
-        <p:spPr>
-          <a:xfrm>
-            <a:off x="914400" y="4507992"/>
-            <a:ext cx="10241280" cy="1024128"/>
-          </a:xfrm>
-          <a:prstGeom prst="rect">
-            <a:avLst/>
-          </a:prstGeom>
-          <a:solidFill>
-            <a:srgbClr val="FFFFFF">
-              <a:alpha val="0"/>
-            </a:srgbClr>
-          </a:solidFill>
-          <a:ln w="12700">
-            <a:solidFill>
-              <a:srgbClr val="E2E8F0">
-                <a:alpha val="0"/>
-              </a:srgbClr>
-            </a:solidFill>
-            <a:prstDash val="solid"/>
-          </a:ln>
-          <a:effectLst>
-            <a:outerShdw sx="100000" sy="100000" kx="0" ky="0" algn="bl" rotWithShape="0" blurRad="12700" dist="50800" dir="2700000">
-              <a:srgbClr val="000000">
-                <a:alpha val="8000"/>
-              </a:srgbClr>
-            </a:outerShdw>
-          </a:effectLst>
-        </p:spPr>
-      </p:sp>
-      <p:sp>
-        <p:nvSpPr>
-          <p:cNvPr id="8" name="Shape 3"/>
-          <p:cNvSpPr/>
-          <p:nvPr/>
-        </p:nvSpPr>
-        <p:spPr>
-          <a:xfrm>
-            <a:off x="786384" y="1956816"/>
-            <a:ext cx="32004" cy="3483864"/>
-          </a:xfrm>
-          <a:prstGeom prst="rect">
-            <a:avLst/>
-          </a:prstGeom>
-          <a:solidFill>
-            <a:srgbClr val="DBEAFE">
-              <a:alpha val="80000"/>
-            </a:srgbClr>
-          </a:solidFill>
-          <a:ln w="12700">
-            <a:solidFill>
-              <a:srgbClr val="DBEAFE">
-                <a:alpha val="0"/>
-              </a:srgbClr>
-            </a:solidFill>
-            <a:prstDash val="solid"/>
-          </a:ln>
-        </p:spPr>
-      </p:sp>
-      <p:sp>
-        <p:nvSpPr>
-          <p:cNvPr id="9" name="Shape 4"/>
-          <p:cNvSpPr/>
-          <p:nvPr/>
-        </p:nvSpPr>
-        <p:spPr>
-          <a:xfrm>
-            <a:off x="914400" y="1865376"/>
-            <a:ext cx="73152" cy="1024128"/>
+            <a:off x="822960" y="1938528"/>
+            <a:ext cx="73152" cy="2514600"/>
           </a:xfrm>
           <a:prstGeom prst="rect">
             <a:avLst/>
@@ -4258,14 +4031,14 @@
       </p:sp>
       <p:sp>
         <p:nvSpPr>
-          <p:cNvPr id="10" name="Shape 5"/>
+          <p:cNvPr id="3" name="Shape 1"/>
           <p:cNvSpPr/>
           <p:nvPr/>
         </p:nvSpPr>
         <p:spPr>
           <a:xfrm>
-            <a:off x="914400" y="3191256"/>
-            <a:ext cx="73152" cy="1024128"/>
+            <a:off x="4343400" y="1938528"/>
+            <a:ext cx="73152" cy="2514600"/>
           </a:xfrm>
           <a:prstGeom prst="rect">
             <a:avLst/>
@@ -4285,14 +4058,14 @@
       </p:sp>
       <p:sp>
         <p:nvSpPr>
-          <p:cNvPr id="11" name="Shape 6"/>
+          <p:cNvPr id="4" name="Shape 2"/>
           <p:cNvSpPr/>
           <p:nvPr/>
         </p:nvSpPr>
         <p:spPr>
           <a:xfrm>
-            <a:off x="914400" y="4507992"/>
-            <a:ext cx="73152" cy="1024128"/>
+            <a:off x="7863840" y="1938528"/>
+            <a:ext cx="73152" cy="2514600"/>
           </a:xfrm>
           <a:prstGeom prst="rect">
             <a:avLst/>
@@ -4312,7 +4085,7 @@
       </p:sp>
       <p:sp>
         <p:nvSpPr>
-          <p:cNvPr id="12" name="mdpr:2-3-2107ad:title:__title:2-3-2107ad"/>
+          <p:cNvPr id="5" name="mdpr:2-3-2107ad:title:__title:2-3-2107ad"/>
           <p:cNvSpPr txBox="1"/>
           <p:nvPr/>
         </p:nvSpPr>
@@ -4346,7 +4119,24 @@
                 <a:ea typeface="Pretendard" pitchFamily="34" charset="-122"/>
                 <a:cs typeface="Pretendard" pitchFamily="34" charset="-120"/>
               </a:rPr>
-              <a:t>Page Splitting Rules (Cont. 2/3)</a:t>
+              <a:t>Page Splitting Rules</a:t>
+            </a:r>
+            <a:pPr algn="ctr" indent="0" marL="0">
+              <a:lnSpc>
+                <a:spcPct val="120000"/>
+              </a:lnSpc>
+              <a:buNone/>
+            </a:pPr>
+            <a:r>
+              <a:rPr lang="en-US" sz="2000" dirty="0">
+                <a:solidFill>
+                  <a:srgbClr val="919191"/>
+                </a:solidFill>
+                <a:latin typeface="Pretendard" pitchFamily="34" charset="0"/>
+                <a:ea typeface="Pretendard" pitchFamily="34" charset="-122"/>
+                <a:cs typeface="Pretendard" pitchFamily="34" charset="-120"/>
+              </a:rPr>
+              <a:t> (Cont. 2/3)</a:t>
             </a:r>
             <a:endParaRPr lang="en-US" sz="3400" dirty="0"/>
           </a:p>
@@ -4354,14 +4144,14 @@
       </p:sp>
       <p:sp>
         <p:nvSpPr>
-          <p:cNvPr id="13" name="mdpr:2-3-2107ad:item-1:block-12-chunk-2"/>
+          <p:cNvPr id="6" name="mdpr:2-3-2107ad:item-1:block-12-chunk-2"/>
           <p:cNvSpPr txBox="1"/>
           <p:nvPr/>
         </p:nvSpPr>
         <p:spPr>
           <a:xfrm>
-            <a:off x="1133856" y="2164080"/>
-            <a:ext cx="9820656" cy="426720"/>
+            <a:off x="1042416" y="2814828"/>
+            <a:ext cx="2825496" cy="762000"/>
           </a:xfrm>
           <a:prstGeom prst="rect">
             <a:avLst/>
@@ -4396,14 +4186,14 @@
       </p:sp>
       <p:sp>
         <p:nvSpPr>
-          <p:cNvPr id="14" name="mdpr:2-3-2107ad:item-2:block-12-chunk-2"/>
+          <p:cNvPr id="7" name="mdpr:2-3-2107ad:item-2:block-12-chunk-2"/>
           <p:cNvSpPr txBox="1"/>
           <p:nvPr/>
         </p:nvSpPr>
         <p:spPr>
           <a:xfrm>
-            <a:off x="1133856" y="3489960"/>
-            <a:ext cx="9820656" cy="426720"/>
+            <a:off x="4562856" y="2982468"/>
+            <a:ext cx="2825496" cy="426720"/>
           </a:xfrm>
           <a:prstGeom prst="rect">
             <a:avLst/>
@@ -4438,14 +4228,14 @@
       </p:sp>
       <p:sp>
         <p:nvSpPr>
-          <p:cNvPr id="15" name="mdpr:2-3-2107ad:item-3:block-12-chunk-2"/>
+          <p:cNvPr id="8" name="mdpr:2-3-2107ad:item-3:block-12-chunk-2"/>
           <p:cNvSpPr txBox="1"/>
           <p:nvPr/>
         </p:nvSpPr>
         <p:spPr>
           <a:xfrm>
-            <a:off x="1133856" y="4806696"/>
-            <a:ext cx="9820656" cy="426720"/>
+            <a:off x="8083296" y="2647188"/>
+            <a:ext cx="2825496" cy="1097280"/>
           </a:xfrm>
           <a:prstGeom prst="rect">
             <a:avLst/>
@@ -4639,7 +4429,24 @@
                 <a:ea typeface="Pretendard" pitchFamily="34" charset="-122"/>
                 <a:cs typeface="Pretendard" pitchFamily="34" charset="-120"/>
               </a:rPr>
-              <a:t>Page Splitting Rules (Cont. 3/3)</a:t>
+              <a:t>Page Splitting Rules</a:t>
+            </a:r>
+            <a:pPr algn="ctr" indent="0" marL="0">
+              <a:lnSpc>
+                <a:spcPct val="120000"/>
+              </a:lnSpc>
+              <a:buNone/>
+            </a:pPr>
+            <a:r>
+              <a:rPr lang="en-US" sz="2000" dirty="0">
+                <a:solidFill>
+                  <a:srgbClr val="919191"/>
+                </a:solidFill>
+                <a:latin typeface="Pretendard" pitchFamily="34" charset="0"/>
+                <a:ea typeface="Pretendard" pitchFamily="34" charset="-122"/>
+                <a:cs typeface="Pretendard" pitchFamily="34" charset="-120"/>
+              </a:rPr>
+              <a:t> (Cont. 3/3)</a:t>
             </a:r>
             <a:endParaRPr lang="en-US" sz="3400" dirty="0"/>
           </a:p>
@@ -5761,35 +5568,6 @@
         </p:nvSpPr>
         <p:spPr>
           <a:xfrm>
-            <a:off x="786384" y="1956816"/>
-            <a:ext cx="32004" cy="3483864"/>
-          </a:xfrm>
-          <a:prstGeom prst="rect">
-            <a:avLst/>
-          </a:prstGeom>
-          <a:solidFill>
-            <a:srgbClr val="DBEAFE">
-              <a:alpha val="80000"/>
-            </a:srgbClr>
-          </a:solidFill>
-          <a:ln w="12700">
-            <a:solidFill>
-              <a:srgbClr val="DBEAFE">
-                <a:alpha val="0"/>
-              </a:srgbClr>
-            </a:solidFill>
-            <a:prstDash val="solid"/>
-          </a:ln>
-        </p:spPr>
-      </p:sp>
-      <p:sp>
-        <p:nvSpPr>
-          <p:cNvPr id="9" name="Shape 4"/>
-          <p:cNvSpPr/>
-          <p:nvPr/>
-        </p:nvSpPr>
-        <p:spPr>
-          <a:xfrm>
             <a:off x="914400" y="1865376"/>
             <a:ext cx="73152" cy="1024128"/>
           </a:xfrm>
@@ -5811,7 +5589,7 @@
       </p:sp>
       <p:sp>
         <p:nvSpPr>
-          <p:cNvPr id="10" name="Shape 5"/>
+          <p:cNvPr id="9" name="Shape 4"/>
           <p:cNvSpPr/>
           <p:nvPr/>
         </p:nvSpPr>
@@ -5838,7 +5616,7 @@
       </p:sp>
       <p:sp>
         <p:nvSpPr>
-          <p:cNvPr id="11" name="Shape 6"/>
+          <p:cNvPr id="10" name="Shape 5"/>
           <p:cNvSpPr/>
           <p:nvPr/>
         </p:nvSpPr>
@@ -5865,7 +5643,7 @@
       </p:sp>
       <p:sp>
         <p:nvSpPr>
-          <p:cNvPr id="12" name="mdpr:1-3-c0cf7e:title:__title:1-3-c0cf7e"/>
+          <p:cNvPr id="11" name="mdpr:1-3-c0cf7e:title:__title:1-3-c0cf7e"/>
           <p:cNvSpPr txBox="1"/>
           <p:nvPr/>
         </p:nvSpPr>
@@ -5907,7 +5685,7 @@
       </p:sp>
       <p:sp>
         <p:nvSpPr>
-          <p:cNvPr id="13" name="mdpr:1-3-c0cf7e:item-1:block-16-chunk-1"/>
+          <p:cNvPr id="12" name="mdpr:1-3-c0cf7e:item-1:block-16-chunk-1"/>
           <p:cNvSpPr txBox="1"/>
           <p:nvPr/>
         </p:nvSpPr>
@@ -5949,7 +5727,7 @@
       </p:sp>
       <p:sp>
         <p:nvSpPr>
-          <p:cNvPr id="14" name="mdpr:1-3-c0cf7e:item-2:block-16-chunk-1"/>
+          <p:cNvPr id="13" name="mdpr:1-3-c0cf7e:item-2:block-16-chunk-1"/>
           <p:cNvSpPr txBox="1"/>
           <p:nvPr/>
         </p:nvSpPr>
@@ -5991,7 +5769,7 @@
       </p:sp>
       <p:sp>
         <p:nvSpPr>
-          <p:cNvPr id="15" name="mdpr:1-3-c0cf7e:item-3:block-16-chunk-1"/>
+          <p:cNvPr id="14" name="mdpr:1-3-c0cf7e:item-3:block-16-chunk-1"/>
           <p:cNvSpPr txBox="1"/>
           <p:nvPr/>
         </p:nvSpPr>
@@ -6269,35 +6047,6 @@
         </p:nvSpPr>
         <p:spPr>
           <a:xfrm>
-            <a:off x="786384" y="1956816"/>
-            <a:ext cx="32004" cy="3483864"/>
-          </a:xfrm>
-          <a:prstGeom prst="rect">
-            <a:avLst/>
-          </a:prstGeom>
-          <a:solidFill>
-            <a:srgbClr val="DBEAFE">
-              <a:alpha val="80000"/>
-            </a:srgbClr>
-          </a:solidFill>
-          <a:ln w="12700">
-            <a:solidFill>
-              <a:srgbClr val="DBEAFE">
-                <a:alpha val="0"/>
-              </a:srgbClr>
-            </a:solidFill>
-            <a:prstDash val="solid"/>
-          </a:ln>
-        </p:spPr>
-      </p:sp>
-      <p:sp>
-        <p:nvSpPr>
-          <p:cNvPr id="9" name="Shape 4"/>
-          <p:cNvSpPr/>
-          <p:nvPr/>
-        </p:nvSpPr>
-        <p:spPr>
-          <a:xfrm>
             <a:off x="914400" y="1865376"/>
             <a:ext cx="73152" cy="1024128"/>
           </a:xfrm>
@@ -6319,7 +6068,7 @@
       </p:sp>
       <p:sp>
         <p:nvSpPr>
-          <p:cNvPr id="10" name="Shape 5"/>
+          <p:cNvPr id="9" name="Shape 4"/>
           <p:cNvSpPr/>
           <p:nvPr/>
         </p:nvSpPr>
@@ -6346,7 +6095,7 @@
       </p:sp>
       <p:sp>
         <p:nvSpPr>
-          <p:cNvPr id="11" name="Shape 6"/>
+          <p:cNvPr id="10" name="Shape 5"/>
           <p:cNvSpPr/>
           <p:nvPr/>
         </p:nvSpPr>
@@ -6373,7 +6122,7 @@
       </p:sp>
       <p:sp>
         <p:nvSpPr>
-          <p:cNvPr id="12" name="mdpr:2-3-500204:title:__title:2-3-500204"/>
+          <p:cNvPr id="11" name="mdpr:2-3-500204:title:__title:2-3-500204"/>
           <p:cNvSpPr txBox="1"/>
           <p:nvPr/>
         </p:nvSpPr>
@@ -6407,7 +6156,24 @@
                 <a:ea typeface="Pretendard" pitchFamily="34" charset="-122"/>
                 <a:cs typeface="Pretendard" pitchFamily="34" charset="-120"/>
               </a:rPr>
-              <a:t>Layout Selection Rules (Cont. 2/3)</a:t>
+              <a:t>Layout Selection Rules</a:t>
+            </a:r>
+            <a:pPr algn="ctr" indent="0" marL="0">
+              <a:lnSpc>
+                <a:spcPct val="120000"/>
+              </a:lnSpc>
+              <a:buNone/>
+            </a:pPr>
+            <a:r>
+              <a:rPr lang="en-US" sz="2000" dirty="0">
+                <a:solidFill>
+                  <a:srgbClr val="919191"/>
+                </a:solidFill>
+                <a:latin typeface="Pretendard" pitchFamily="34" charset="0"/>
+                <a:ea typeface="Pretendard" pitchFamily="34" charset="-122"/>
+                <a:cs typeface="Pretendard" pitchFamily="34" charset="-120"/>
+              </a:rPr>
+              <a:t> (Cont. 2/3)</a:t>
             </a:r>
             <a:endParaRPr lang="en-US" sz="3400" dirty="0"/>
           </a:p>
@@ -6415,7 +6181,7 @@
       </p:sp>
       <p:sp>
         <p:nvSpPr>
-          <p:cNvPr id="13" name="mdpr:2-3-500204:item-1:block-16-chunk-2"/>
+          <p:cNvPr id="12" name="mdpr:2-3-500204:item-1:block-16-chunk-2"/>
           <p:cNvSpPr txBox="1"/>
           <p:nvPr/>
         </p:nvSpPr>
@@ -6457,7 +6223,7 @@
       </p:sp>
       <p:sp>
         <p:nvSpPr>
-          <p:cNvPr id="14" name="mdpr:2-3-500204:item-2:block-16-chunk-2"/>
+          <p:cNvPr id="13" name="mdpr:2-3-500204:item-2:block-16-chunk-2"/>
           <p:cNvSpPr txBox="1"/>
           <p:nvPr/>
         </p:nvSpPr>
@@ -6499,7 +6265,7 @@
       </p:sp>
       <p:sp>
         <p:nvSpPr>
-          <p:cNvPr id="15" name="mdpr:2-3-500204:item-3:block-16-chunk-2"/>
+          <p:cNvPr id="14" name="mdpr:2-3-500204:item-3:block-16-chunk-2"/>
           <p:cNvSpPr txBox="1"/>
           <p:nvPr/>
         </p:nvSpPr>
@@ -6700,7 +6466,24 @@
                 <a:ea typeface="Pretendard" pitchFamily="34" charset="-122"/>
                 <a:cs typeface="Pretendard" pitchFamily="34" charset="-120"/>
               </a:rPr>
-              <a:t>Layout Selection Rules (Cont. 3/3)</a:t>
+              <a:t>Layout Selection Rules</a:t>
+            </a:r>
+            <a:pPr algn="ctr" indent="0" marL="0">
+              <a:lnSpc>
+                <a:spcPct val="120000"/>
+              </a:lnSpc>
+              <a:buNone/>
+            </a:pPr>
+            <a:r>
+              <a:rPr lang="en-US" sz="2000" dirty="0">
+                <a:solidFill>
+                  <a:srgbClr val="919191"/>
+                </a:solidFill>
+                <a:latin typeface="Pretendard" pitchFamily="34" charset="0"/>
+                <a:ea typeface="Pretendard" pitchFamily="34" charset="-122"/>
+                <a:cs typeface="Pretendard" pitchFamily="34" charset="-120"/>
+              </a:rPr>
+              <a:t> (Cont. 3/3)</a:t>
             </a:r>
             <a:endParaRPr lang="en-US" sz="3400" dirty="0"/>
           </a:p>
@@ -7556,243 +7339,16 @@
           <a:chExt cx="0" cy="0"/>
         </a:xfrm>
       </p:grpSpPr>
-      <p:pic>
-        <p:nvPicPr>
-          <p:cNvPr id="2" name="Image 0" descr="preencoded.png">    </p:cNvPr>
-          <p:cNvPicPr>
-            <a:picLocks noChangeAspect="1"/>
-          </p:cNvPicPr>
-          <p:nvPr/>
-        </p:nvPicPr>
-        <p:blipFill>
-          <a:blip r:embed="rId1">
-            <a:extLst>
-              <a:ext uri="{96DAC541-7B7A-43D3-8B79-37D633B846F1}">
-                <asvg:svgBlip xmlns:asvg="http://schemas.microsoft.com/office/drawing/2016/SVG/main" r:embed="rId2"/>
-              </a:ext>
-            </a:extLst>
-          </a:blip>
-          <a:stretch>
-            <a:fillRect/>
-          </a:stretch>
-        </p:blipFill>
-        <p:spPr>
-          <a:xfrm>
-            <a:off x="914400" y="1865376"/>
-            <a:ext cx="10241280" cy="1024128"/>
-          </a:xfrm>
-          <a:prstGeom prst="rect">
-            <a:avLst/>
-          </a:prstGeom>
-        </p:spPr>
-      </p:pic>
-      <p:sp>
-        <p:nvSpPr>
-          <p:cNvPr id="3" name="Shape 0"/>
+      <p:sp>
+        <p:nvSpPr>
+          <p:cNvPr id="2" name="Shape 0"/>
           <p:cNvSpPr/>
           <p:nvPr/>
         </p:nvSpPr>
         <p:spPr>
           <a:xfrm>
-            <a:off x="914400" y="1865376"/>
-            <a:ext cx="10241280" cy="1024128"/>
-          </a:xfrm>
-          <a:prstGeom prst="rect">
-            <a:avLst/>
-          </a:prstGeom>
-          <a:solidFill>
-            <a:srgbClr val="FFFFFF">
-              <a:alpha val="0"/>
-            </a:srgbClr>
-          </a:solidFill>
-          <a:ln w="12700">
-            <a:solidFill>
-              <a:srgbClr val="E2E8F0">
-                <a:alpha val="0"/>
-              </a:srgbClr>
-            </a:solidFill>
-            <a:prstDash val="solid"/>
-          </a:ln>
-          <a:effectLst>
-            <a:outerShdw sx="100000" sy="100000" kx="0" ky="0" algn="bl" rotWithShape="0" blurRad="12700" dist="50800" dir="2700000">
-              <a:srgbClr val="000000">
-                <a:alpha val="8000"/>
-              </a:srgbClr>
-            </a:outerShdw>
-          </a:effectLst>
-        </p:spPr>
-      </p:sp>
-      <p:pic>
-        <p:nvPicPr>
-          <p:cNvPr id="4" name="Image 1" descr="preencoded.png">    </p:cNvPr>
-          <p:cNvPicPr>
-            <a:picLocks noChangeAspect="1"/>
-          </p:cNvPicPr>
-          <p:nvPr/>
-        </p:nvPicPr>
-        <p:blipFill>
-          <a:blip r:embed="rId3">
-            <a:extLst>
-              <a:ext uri="{96DAC541-7B7A-43D3-8B79-37D633B846F1}">
-                <asvg:svgBlip xmlns:asvg="http://schemas.microsoft.com/office/drawing/2016/SVG/main" r:embed="rId4"/>
-              </a:ext>
-            </a:extLst>
-          </a:blip>
-          <a:stretch>
-            <a:fillRect/>
-          </a:stretch>
-        </p:blipFill>
-        <p:spPr>
-          <a:xfrm>
-            <a:off x="914400" y="3191256"/>
-            <a:ext cx="10241280" cy="1024128"/>
-          </a:xfrm>
-          <a:prstGeom prst="rect">
-            <a:avLst/>
-          </a:prstGeom>
-        </p:spPr>
-      </p:pic>
-      <p:sp>
-        <p:nvSpPr>
-          <p:cNvPr id="5" name="Shape 1"/>
-          <p:cNvSpPr/>
-          <p:nvPr/>
-        </p:nvSpPr>
-        <p:spPr>
-          <a:xfrm>
-            <a:off x="914400" y="3191256"/>
-            <a:ext cx="10241280" cy="1024128"/>
-          </a:xfrm>
-          <a:prstGeom prst="rect">
-            <a:avLst/>
-          </a:prstGeom>
-          <a:solidFill>
-            <a:srgbClr val="FFFFFF">
-              <a:alpha val="0"/>
-            </a:srgbClr>
-          </a:solidFill>
-          <a:ln w="12700">
-            <a:solidFill>
-              <a:srgbClr val="E2E8F0">
-                <a:alpha val="0"/>
-              </a:srgbClr>
-            </a:solidFill>
-            <a:prstDash val="solid"/>
-          </a:ln>
-          <a:effectLst>
-            <a:outerShdw sx="100000" sy="100000" kx="0" ky="0" algn="bl" rotWithShape="0" blurRad="12700" dist="50800" dir="2700000">
-              <a:srgbClr val="000000">
-                <a:alpha val="8000"/>
-              </a:srgbClr>
-            </a:outerShdw>
-          </a:effectLst>
-        </p:spPr>
-      </p:sp>
-      <p:pic>
-        <p:nvPicPr>
-          <p:cNvPr id="6" name="Image 2" descr="preencoded.png">    </p:cNvPr>
-          <p:cNvPicPr>
-            <a:picLocks noChangeAspect="1"/>
-          </p:cNvPicPr>
-          <p:nvPr/>
-        </p:nvPicPr>
-        <p:blipFill>
-          <a:blip r:embed="rId5">
-            <a:extLst>
-              <a:ext uri="{96DAC541-7B7A-43D3-8B79-37D633B846F1}">
-                <asvg:svgBlip xmlns:asvg="http://schemas.microsoft.com/office/drawing/2016/SVG/main" r:embed="rId6"/>
-              </a:ext>
-            </a:extLst>
-          </a:blip>
-          <a:stretch>
-            <a:fillRect/>
-          </a:stretch>
-        </p:blipFill>
-        <p:spPr>
-          <a:xfrm>
-            <a:off x="914400" y="4507992"/>
-            <a:ext cx="10241280" cy="1024128"/>
-          </a:xfrm>
-          <a:prstGeom prst="rect">
-            <a:avLst/>
-          </a:prstGeom>
-        </p:spPr>
-      </p:pic>
-      <p:sp>
-        <p:nvSpPr>
-          <p:cNvPr id="7" name="Shape 2"/>
-          <p:cNvSpPr/>
-          <p:nvPr/>
-        </p:nvSpPr>
-        <p:spPr>
-          <a:xfrm>
-            <a:off x="914400" y="4507992"/>
-            <a:ext cx="10241280" cy="1024128"/>
-          </a:xfrm>
-          <a:prstGeom prst="rect">
-            <a:avLst/>
-          </a:prstGeom>
-          <a:solidFill>
-            <a:srgbClr val="FFFFFF">
-              <a:alpha val="0"/>
-            </a:srgbClr>
-          </a:solidFill>
-          <a:ln w="12700">
-            <a:solidFill>
-              <a:srgbClr val="E2E8F0">
-                <a:alpha val="0"/>
-              </a:srgbClr>
-            </a:solidFill>
-            <a:prstDash val="solid"/>
-          </a:ln>
-          <a:effectLst>
-            <a:outerShdw sx="100000" sy="100000" kx="0" ky="0" algn="bl" rotWithShape="0" blurRad="12700" dist="50800" dir="2700000">
-              <a:srgbClr val="000000">
-                <a:alpha val="8000"/>
-              </a:srgbClr>
-            </a:outerShdw>
-          </a:effectLst>
-        </p:spPr>
-      </p:sp>
-      <p:sp>
-        <p:nvSpPr>
-          <p:cNvPr id="8" name="Shape 3"/>
-          <p:cNvSpPr/>
-          <p:nvPr/>
-        </p:nvSpPr>
-        <p:spPr>
-          <a:xfrm>
-            <a:off x="786384" y="1956816"/>
-            <a:ext cx="32004" cy="3483864"/>
-          </a:xfrm>
-          <a:prstGeom prst="rect">
-            <a:avLst/>
-          </a:prstGeom>
-          <a:solidFill>
-            <a:srgbClr val="DBEAFE">
-              <a:alpha val="80000"/>
-            </a:srgbClr>
-          </a:solidFill>
-          <a:ln w="12700">
-            <a:solidFill>
-              <a:srgbClr val="DBEAFE">
-                <a:alpha val="0"/>
-              </a:srgbClr>
-            </a:solidFill>
-            <a:prstDash val="solid"/>
-          </a:ln>
-        </p:spPr>
-      </p:sp>
-      <p:sp>
-        <p:nvSpPr>
-          <p:cNvPr id="9" name="Shape 4"/>
-          <p:cNvSpPr/>
-          <p:nvPr/>
-        </p:nvSpPr>
-        <p:spPr>
-          <a:xfrm>
-            <a:off x="914400" y="1865376"/>
-            <a:ext cx="73152" cy="1024128"/>
+            <a:off x="914400" y="1463040"/>
+            <a:ext cx="10241280" cy="73152"/>
           </a:xfrm>
           <a:prstGeom prst="rect">
             <a:avLst/>
@@ -7812,61 +7368,7 @@
       </p:sp>
       <p:sp>
         <p:nvSpPr>
-          <p:cNvPr id="10" name="Shape 5"/>
-          <p:cNvSpPr/>
-          <p:nvPr/>
-        </p:nvSpPr>
-        <p:spPr>
-          <a:xfrm>
-            <a:off x="914400" y="3191256"/>
-            <a:ext cx="73152" cy="1024128"/>
-          </a:xfrm>
-          <a:prstGeom prst="rect">
-            <a:avLst/>
-          </a:prstGeom>
-          <a:solidFill>
-            <a:srgbClr val="DBEAFE"/>
-          </a:solidFill>
-          <a:ln w="12700">
-            <a:solidFill>
-              <a:srgbClr val="DBEAFE">
-                <a:alpha val="0"/>
-              </a:srgbClr>
-            </a:solidFill>
-            <a:prstDash val="solid"/>
-          </a:ln>
-        </p:spPr>
-      </p:sp>
-      <p:sp>
-        <p:nvSpPr>
-          <p:cNvPr id="11" name="Shape 6"/>
-          <p:cNvSpPr/>
-          <p:nvPr/>
-        </p:nvSpPr>
-        <p:spPr>
-          <a:xfrm>
-            <a:off x="914400" y="4507992"/>
-            <a:ext cx="73152" cy="1024128"/>
-          </a:xfrm>
-          <a:prstGeom prst="rect">
-            <a:avLst/>
-          </a:prstGeom>
-          <a:solidFill>
-            <a:srgbClr val="2563EB"/>
-          </a:solidFill>
-          <a:ln w="12700">
-            <a:solidFill>
-              <a:srgbClr val="2563EB">
-                <a:alpha val="0"/>
-              </a:srgbClr>
-            </a:solidFill>
-            <a:prstDash val="solid"/>
-          </a:ln>
-        </p:spPr>
-      </p:sp>
-      <p:sp>
-        <p:nvSpPr>
-          <p:cNvPr id="12" name="mdpr:1-3-0466ef:title:__title:1-3-0466ef"/>
+          <p:cNvPr id="3" name="mdpr:1-3-0466ef:title:__title:1-3-0466ef"/>
           <p:cNvSpPr txBox="1"/>
           <p:nvPr/>
         </p:nvSpPr>
@@ -7908,14 +7410,14 @@
       </p:sp>
       <p:sp>
         <p:nvSpPr>
-          <p:cNvPr id="13" name="mdpr:1-3-0466ef:item-1:block-20-chunk-1"/>
+          <p:cNvPr id="4" name="mdpr:1-3-0466ef:body:block-20-chunk-1"/>
           <p:cNvSpPr txBox="1"/>
           <p:nvPr/>
         </p:nvSpPr>
         <p:spPr>
           <a:xfrm>
-            <a:off x="1133856" y="2164080"/>
-            <a:ext cx="9820656" cy="426720"/>
+            <a:off x="987552" y="3063240"/>
+            <a:ext cx="10094976" cy="426720"/>
           </a:xfrm>
           <a:prstGeom prst="rect">
             <a:avLst/>
@@ -7927,7 +7429,7 @@
           <a:bodyPr wrap="square" lIns="0" tIns="25400" rIns="25400" bIns="0" rtlCol="0" anchor="ctr"/>
           <a:lstStyle/>
           <a:p>
-            <a:pPr algn="ctr" indent="0" marL="0">
+            <a:pPr algn="l" indent="0" marL="0">
               <a:lnSpc>
                 <a:spcPct val="120000"/>
               </a:lnSpc>
@@ -7942,7 +7444,7 @@
                 <a:ea typeface="Pretendard" pitchFamily="34" charset="-122"/>
                 <a:cs typeface="Pretendard" pitchFamily="34" charset="-120"/>
               </a:rPr>
-              <a:t>Shared Renderer Contract</a:t>
+              <a:t>- Shared Renderer Contract</a:t>
             </a:r>
             <a:endParaRPr lang="en-US" sz="2200" dirty="0"/>
           </a:p>
@@ -7950,14 +7452,14 @@
       </p:sp>
       <p:sp>
         <p:nvSpPr>
-          <p:cNvPr id="14" name="mdpr:1-3-0466ef:item-2:block-20-chunk-1"/>
+          <p:cNvPr id="5" name="mdpr:1-3-0466ef:body:block-20-chunk-1"/>
           <p:cNvSpPr txBox="1"/>
           <p:nvPr/>
         </p:nvSpPr>
         <p:spPr>
           <a:xfrm>
-            <a:off x="1133856" y="3489960"/>
-            <a:ext cx="9820656" cy="426720"/>
+            <a:off x="987552" y="3489960"/>
+            <a:ext cx="10094976" cy="426720"/>
           </a:xfrm>
           <a:prstGeom prst="rect">
             <a:avLst/>
@@ -7969,7 +7471,7 @@
           <a:bodyPr wrap="square" lIns="0" tIns="25400" rIns="25400" bIns="0" rtlCol="0" anchor="ctr"/>
           <a:lstStyle/>
           <a:p>
-            <a:pPr algn="ctr" indent="0" marL="0">
+            <a:pPr algn="l" indent="0" marL="0">
               <a:lnSpc>
                 <a:spcPct val="120000"/>
               </a:lnSpc>
@@ -7984,7 +7486,7 @@
                 <a:ea typeface="Pretendard" pitchFamily="34" charset="-122"/>
                 <a:cs typeface="Pretendard" pitchFamily="34" charset="-120"/>
               </a:rPr>
-              <a:t>PPTX Renderer</a:t>
+              <a:t>- PPTX Renderer</a:t>
             </a:r>
             <a:endParaRPr lang="en-US" sz="2200" dirty="0"/>
           </a:p>
@@ -7992,14 +7494,14 @@
       </p:sp>
       <p:sp>
         <p:nvSpPr>
-          <p:cNvPr id="15" name="mdpr:1-3-0466ef:item-3:block-20-chunk-1"/>
+          <p:cNvPr id="6" name="mdpr:1-3-0466ef:body:block-20-chunk-1"/>
           <p:cNvSpPr txBox="1"/>
           <p:nvPr/>
         </p:nvSpPr>
         <p:spPr>
           <a:xfrm>
-            <a:off x="1133856" y="4806696"/>
-            <a:ext cx="9820656" cy="426720"/>
+            <a:off x="987552" y="3916680"/>
+            <a:ext cx="10094976" cy="426720"/>
           </a:xfrm>
           <a:prstGeom prst="rect">
             <a:avLst/>
@@ -8011,7 +7513,7 @@
           <a:bodyPr wrap="square" lIns="0" tIns="25400" rIns="25400" bIns="0" rtlCol="0" anchor="ctr"/>
           <a:lstStyle/>
           <a:p>
-            <a:pPr algn="ctr" indent="0" marL="0">
+            <a:pPr algn="l" indent="0" marL="0">
               <a:lnSpc>
                 <a:spcPct val="120000"/>
               </a:lnSpc>
@@ -8026,7 +7528,7 @@
                 <a:ea typeface="Pretendard" pitchFamily="34" charset="-122"/>
                 <a:cs typeface="Pretendard" pitchFamily="34" charset="-120"/>
               </a:rPr>
-              <a:t>Decoration Styles</a:t>
+              <a:t>- Decoration Styles</a:t>
             </a:r>
             <a:endParaRPr lang="en-US" sz="2200" dirty="0"/>
           </a:p>
@@ -8064,243 +7566,16 @@
           <a:chExt cx="0" cy="0"/>
         </a:xfrm>
       </p:grpSpPr>
-      <p:pic>
-        <p:nvPicPr>
-          <p:cNvPr id="2" name="Image 0" descr="preencoded.png">    </p:cNvPr>
-          <p:cNvPicPr>
-            <a:picLocks noChangeAspect="1"/>
-          </p:cNvPicPr>
-          <p:nvPr/>
-        </p:nvPicPr>
-        <p:blipFill>
-          <a:blip r:embed="rId1">
-            <a:extLst>
-              <a:ext uri="{96DAC541-7B7A-43D3-8B79-37D633B846F1}">
-                <asvg:svgBlip xmlns:asvg="http://schemas.microsoft.com/office/drawing/2016/SVG/main" r:embed="rId2"/>
-              </a:ext>
-            </a:extLst>
-          </a:blip>
-          <a:stretch>
-            <a:fillRect/>
-          </a:stretch>
-        </p:blipFill>
-        <p:spPr>
-          <a:xfrm>
-            <a:off x="914400" y="1865376"/>
-            <a:ext cx="10241280" cy="1024128"/>
-          </a:xfrm>
-          <a:prstGeom prst="rect">
-            <a:avLst/>
-          </a:prstGeom>
-        </p:spPr>
-      </p:pic>
-      <p:sp>
-        <p:nvSpPr>
-          <p:cNvPr id="3" name="Shape 0"/>
+      <p:sp>
+        <p:nvSpPr>
+          <p:cNvPr id="2" name="Shape 0"/>
           <p:cNvSpPr/>
           <p:nvPr/>
         </p:nvSpPr>
         <p:spPr>
           <a:xfrm>
-            <a:off x="914400" y="1865376"/>
-            <a:ext cx="10241280" cy="1024128"/>
-          </a:xfrm>
-          <a:prstGeom prst="rect">
-            <a:avLst/>
-          </a:prstGeom>
-          <a:solidFill>
-            <a:srgbClr val="FFFFFF">
-              <a:alpha val="0"/>
-            </a:srgbClr>
-          </a:solidFill>
-          <a:ln w="12700">
-            <a:solidFill>
-              <a:srgbClr val="E2E8F0">
-                <a:alpha val="0"/>
-              </a:srgbClr>
-            </a:solidFill>
-            <a:prstDash val="solid"/>
-          </a:ln>
-          <a:effectLst>
-            <a:outerShdw sx="100000" sy="100000" kx="0" ky="0" algn="bl" rotWithShape="0" blurRad="12700" dist="50800" dir="2700000">
-              <a:srgbClr val="000000">
-                <a:alpha val="8000"/>
-              </a:srgbClr>
-            </a:outerShdw>
-          </a:effectLst>
-        </p:spPr>
-      </p:sp>
-      <p:pic>
-        <p:nvPicPr>
-          <p:cNvPr id="4" name="Image 1" descr="preencoded.png">    </p:cNvPr>
-          <p:cNvPicPr>
-            <a:picLocks noChangeAspect="1"/>
-          </p:cNvPicPr>
-          <p:nvPr/>
-        </p:nvPicPr>
-        <p:blipFill>
-          <a:blip r:embed="rId3">
-            <a:extLst>
-              <a:ext uri="{96DAC541-7B7A-43D3-8B79-37D633B846F1}">
-                <asvg:svgBlip xmlns:asvg="http://schemas.microsoft.com/office/drawing/2016/SVG/main" r:embed="rId4"/>
-              </a:ext>
-            </a:extLst>
-          </a:blip>
-          <a:stretch>
-            <a:fillRect/>
-          </a:stretch>
-        </p:blipFill>
-        <p:spPr>
-          <a:xfrm>
-            <a:off x="914400" y="3191256"/>
-            <a:ext cx="10241280" cy="1024128"/>
-          </a:xfrm>
-          <a:prstGeom prst="rect">
-            <a:avLst/>
-          </a:prstGeom>
-        </p:spPr>
-      </p:pic>
-      <p:sp>
-        <p:nvSpPr>
-          <p:cNvPr id="5" name="Shape 1"/>
-          <p:cNvSpPr/>
-          <p:nvPr/>
-        </p:nvSpPr>
-        <p:spPr>
-          <a:xfrm>
-            <a:off x="914400" y="3191256"/>
-            <a:ext cx="10241280" cy="1024128"/>
-          </a:xfrm>
-          <a:prstGeom prst="rect">
-            <a:avLst/>
-          </a:prstGeom>
-          <a:solidFill>
-            <a:srgbClr val="FFFFFF">
-              <a:alpha val="0"/>
-            </a:srgbClr>
-          </a:solidFill>
-          <a:ln w="12700">
-            <a:solidFill>
-              <a:srgbClr val="E2E8F0">
-                <a:alpha val="0"/>
-              </a:srgbClr>
-            </a:solidFill>
-            <a:prstDash val="solid"/>
-          </a:ln>
-          <a:effectLst>
-            <a:outerShdw sx="100000" sy="100000" kx="0" ky="0" algn="bl" rotWithShape="0" blurRad="12700" dist="50800" dir="2700000">
-              <a:srgbClr val="000000">
-                <a:alpha val="8000"/>
-              </a:srgbClr>
-            </a:outerShdw>
-          </a:effectLst>
-        </p:spPr>
-      </p:sp>
-      <p:pic>
-        <p:nvPicPr>
-          <p:cNvPr id="6" name="Image 2" descr="preencoded.png">    </p:cNvPr>
-          <p:cNvPicPr>
-            <a:picLocks noChangeAspect="1"/>
-          </p:cNvPicPr>
-          <p:nvPr/>
-        </p:nvPicPr>
-        <p:blipFill>
-          <a:blip r:embed="rId5">
-            <a:extLst>
-              <a:ext uri="{96DAC541-7B7A-43D3-8B79-37D633B846F1}">
-                <asvg:svgBlip xmlns:asvg="http://schemas.microsoft.com/office/drawing/2016/SVG/main" r:embed="rId6"/>
-              </a:ext>
-            </a:extLst>
-          </a:blip>
-          <a:stretch>
-            <a:fillRect/>
-          </a:stretch>
-        </p:blipFill>
-        <p:spPr>
-          <a:xfrm>
-            <a:off x="914400" y="4507992"/>
-            <a:ext cx="10241280" cy="1024128"/>
-          </a:xfrm>
-          <a:prstGeom prst="rect">
-            <a:avLst/>
-          </a:prstGeom>
-        </p:spPr>
-      </p:pic>
-      <p:sp>
-        <p:nvSpPr>
-          <p:cNvPr id="7" name="Shape 2"/>
-          <p:cNvSpPr/>
-          <p:nvPr/>
-        </p:nvSpPr>
-        <p:spPr>
-          <a:xfrm>
-            <a:off x="914400" y="4507992"/>
-            <a:ext cx="10241280" cy="1024128"/>
-          </a:xfrm>
-          <a:prstGeom prst="rect">
-            <a:avLst/>
-          </a:prstGeom>
-          <a:solidFill>
-            <a:srgbClr val="FFFFFF">
-              <a:alpha val="0"/>
-            </a:srgbClr>
-          </a:solidFill>
-          <a:ln w="12700">
-            <a:solidFill>
-              <a:srgbClr val="E2E8F0">
-                <a:alpha val="0"/>
-              </a:srgbClr>
-            </a:solidFill>
-            <a:prstDash val="solid"/>
-          </a:ln>
-          <a:effectLst>
-            <a:outerShdw sx="100000" sy="100000" kx="0" ky="0" algn="bl" rotWithShape="0" blurRad="12700" dist="50800" dir="2700000">
-              <a:srgbClr val="000000">
-                <a:alpha val="8000"/>
-              </a:srgbClr>
-            </a:outerShdw>
-          </a:effectLst>
-        </p:spPr>
-      </p:sp>
-      <p:sp>
-        <p:nvSpPr>
-          <p:cNvPr id="8" name="Shape 3"/>
-          <p:cNvSpPr/>
-          <p:nvPr/>
-        </p:nvSpPr>
-        <p:spPr>
-          <a:xfrm>
-            <a:off x="786384" y="1956816"/>
-            <a:ext cx="32004" cy="3483864"/>
-          </a:xfrm>
-          <a:prstGeom prst="rect">
-            <a:avLst/>
-          </a:prstGeom>
-          <a:solidFill>
-            <a:srgbClr val="DBEAFE">
-              <a:alpha val="80000"/>
-            </a:srgbClr>
-          </a:solidFill>
-          <a:ln w="12700">
-            <a:solidFill>
-              <a:srgbClr val="DBEAFE">
-                <a:alpha val="0"/>
-              </a:srgbClr>
-            </a:solidFill>
-            <a:prstDash val="solid"/>
-          </a:ln>
-        </p:spPr>
-      </p:sp>
-      <p:sp>
-        <p:nvSpPr>
-          <p:cNvPr id="9" name="Shape 4"/>
-          <p:cNvSpPr/>
-          <p:nvPr/>
-        </p:nvSpPr>
-        <p:spPr>
-          <a:xfrm>
-            <a:off x="914400" y="1865376"/>
-            <a:ext cx="73152" cy="1024128"/>
+            <a:off x="822960" y="1938528"/>
+            <a:ext cx="73152" cy="2514600"/>
           </a:xfrm>
           <a:prstGeom prst="rect">
             <a:avLst/>
@@ -8320,14 +7595,14 @@
       </p:sp>
       <p:sp>
         <p:nvSpPr>
-          <p:cNvPr id="10" name="Shape 5"/>
+          <p:cNvPr id="3" name="Shape 1"/>
           <p:cNvSpPr/>
           <p:nvPr/>
         </p:nvSpPr>
         <p:spPr>
           <a:xfrm>
-            <a:off x="914400" y="3191256"/>
-            <a:ext cx="73152" cy="1024128"/>
+            <a:off x="4343400" y="1938528"/>
+            <a:ext cx="73152" cy="2514600"/>
           </a:xfrm>
           <a:prstGeom prst="rect">
             <a:avLst/>
@@ -8347,14 +7622,14 @@
       </p:sp>
       <p:sp>
         <p:nvSpPr>
-          <p:cNvPr id="11" name="Shape 6"/>
+          <p:cNvPr id="4" name="Shape 2"/>
           <p:cNvSpPr/>
           <p:nvPr/>
         </p:nvSpPr>
         <p:spPr>
           <a:xfrm>
-            <a:off x="914400" y="4507992"/>
-            <a:ext cx="73152" cy="1024128"/>
+            <a:off x="7863840" y="1938528"/>
+            <a:ext cx="73152" cy="2514600"/>
           </a:xfrm>
           <a:prstGeom prst="rect">
             <a:avLst/>
@@ -8374,7 +7649,7 @@
       </p:sp>
       <p:sp>
         <p:nvSpPr>
-          <p:cNvPr id="12" name="mdpr:2-3-068207:title:__title:2-3-068207"/>
+          <p:cNvPr id="5" name="mdpr:2-3-068207:title:__title:2-3-068207"/>
           <p:cNvSpPr txBox="1"/>
           <p:nvPr/>
         </p:nvSpPr>
@@ -8408,7 +7683,24 @@
                 <a:ea typeface="Pretendard" pitchFamily="34" charset="-122"/>
                 <a:cs typeface="Pretendard" pitchFamily="34" charset="-120"/>
               </a:rPr>
-              <a:t>Rendering Rules (Cont. 2/3)</a:t>
+              <a:t>Rendering Rules</a:t>
+            </a:r>
+            <a:pPr algn="ctr" indent="0" marL="0">
+              <a:lnSpc>
+                <a:spcPct val="120000"/>
+              </a:lnSpc>
+              <a:buNone/>
+            </a:pPr>
+            <a:r>
+              <a:rPr lang="en-US" sz="2000" dirty="0">
+                <a:solidFill>
+                  <a:srgbClr val="919191"/>
+                </a:solidFill>
+                <a:latin typeface="Pretendard" pitchFamily="34" charset="0"/>
+                <a:ea typeface="Pretendard" pitchFamily="34" charset="-122"/>
+                <a:cs typeface="Pretendard" pitchFamily="34" charset="-120"/>
+              </a:rPr>
+              <a:t> (Cont. 2/3)</a:t>
             </a:r>
             <a:endParaRPr lang="en-US" sz="3400" dirty="0"/>
           </a:p>
@@ -8416,14 +7708,14 @@
       </p:sp>
       <p:sp>
         <p:nvSpPr>
-          <p:cNvPr id="13" name="mdpr:2-3-068207:item-1:block-20-chunk-2"/>
+          <p:cNvPr id="6" name="mdpr:2-3-068207:item-1:block-20-chunk-2"/>
           <p:cNvSpPr txBox="1"/>
           <p:nvPr/>
         </p:nvSpPr>
         <p:spPr>
           <a:xfrm>
-            <a:off x="1133856" y="2164080"/>
-            <a:ext cx="9820656" cy="426720"/>
+            <a:off x="1042416" y="2814828"/>
+            <a:ext cx="2825496" cy="762000"/>
           </a:xfrm>
           <a:prstGeom prst="rect">
             <a:avLst/>
@@ -8458,14 +7750,14 @@
       </p:sp>
       <p:sp>
         <p:nvSpPr>
-          <p:cNvPr id="14" name="mdpr:2-3-068207:item-2:block-20-chunk-2"/>
+          <p:cNvPr id="7" name="mdpr:2-3-068207:item-2:block-20-chunk-2"/>
           <p:cNvSpPr txBox="1"/>
           <p:nvPr/>
         </p:nvSpPr>
         <p:spPr>
           <a:xfrm>
-            <a:off x="1133856" y="3489960"/>
-            <a:ext cx="9820656" cy="426720"/>
+            <a:off x="4562856" y="2982468"/>
+            <a:ext cx="2825496" cy="426720"/>
           </a:xfrm>
           <a:prstGeom prst="rect">
             <a:avLst/>
@@ -8500,14 +7792,14 @@
       </p:sp>
       <p:sp>
         <p:nvSpPr>
-          <p:cNvPr id="15" name="mdpr:2-3-068207:item-3:block-20-chunk-2"/>
+          <p:cNvPr id="8" name="mdpr:2-3-068207:item-3:block-20-chunk-2"/>
           <p:cNvSpPr txBox="1"/>
           <p:nvPr/>
         </p:nvSpPr>
         <p:spPr>
           <a:xfrm>
-            <a:off x="1133856" y="4806696"/>
-            <a:ext cx="9820656" cy="426720"/>
+            <a:off x="8083296" y="2647188"/>
+            <a:ext cx="2825496" cy="1097280"/>
           </a:xfrm>
           <a:prstGeom prst="rect">
             <a:avLst/>
@@ -8674,7 +7966,24 @@
                 <a:ea typeface="Pretendard" pitchFamily="34" charset="-122"/>
                 <a:cs typeface="Pretendard" pitchFamily="34" charset="-120"/>
               </a:rPr>
-              <a:t>Rendering Rules (Cont. 3/3)</a:t>
+              <a:t>Rendering Rules</a:t>
+            </a:r>
+            <a:pPr algn="ctr" indent="0" marL="0">
+              <a:lnSpc>
+                <a:spcPct val="120000"/>
+              </a:lnSpc>
+              <a:buNone/>
+            </a:pPr>
+            <a:r>
+              <a:rPr lang="en-US" sz="2000" dirty="0">
+                <a:solidFill>
+                  <a:srgbClr val="919191"/>
+                </a:solidFill>
+                <a:latin typeface="Pretendard" pitchFamily="34" charset="0"/>
+                <a:ea typeface="Pretendard" pitchFamily="34" charset="-122"/>
+                <a:cs typeface="Pretendard" pitchFamily="34" charset="-120"/>
+              </a:rPr>
+              <a:t> (Cont. 3/3)</a:t>
             </a:r>
             <a:endParaRPr lang="en-US" sz="3400" dirty="0"/>
           </a:p>
@@ -8794,243 +8103,16 @@
           <a:chExt cx="0" cy="0"/>
         </a:xfrm>
       </p:grpSpPr>
-      <p:pic>
-        <p:nvPicPr>
-          <p:cNvPr id="2" name="Image 0" descr="preencoded.png">    </p:cNvPr>
-          <p:cNvPicPr>
-            <a:picLocks noChangeAspect="1"/>
-          </p:cNvPicPr>
-          <p:nvPr/>
-        </p:nvPicPr>
-        <p:blipFill>
-          <a:blip r:embed="rId1">
-            <a:extLst>
-              <a:ext uri="{96DAC541-7B7A-43D3-8B79-37D633B846F1}">
-                <asvg:svgBlip xmlns:asvg="http://schemas.microsoft.com/office/drawing/2016/SVG/main" r:embed="rId2"/>
-              </a:ext>
-            </a:extLst>
-          </a:blip>
-          <a:stretch>
-            <a:fillRect/>
-          </a:stretch>
-        </p:blipFill>
-        <p:spPr>
-          <a:xfrm>
-            <a:off x="914400" y="1865376"/>
-            <a:ext cx="10241280" cy="1024128"/>
-          </a:xfrm>
-          <a:prstGeom prst="rect">
-            <a:avLst/>
-          </a:prstGeom>
-        </p:spPr>
-      </p:pic>
-      <p:sp>
-        <p:nvSpPr>
-          <p:cNvPr id="3" name="Shape 0"/>
+      <p:sp>
+        <p:nvSpPr>
+          <p:cNvPr id="2" name="Shape 0"/>
           <p:cNvSpPr/>
           <p:nvPr/>
         </p:nvSpPr>
         <p:spPr>
           <a:xfrm>
-            <a:off x="914400" y="1865376"/>
-            <a:ext cx="10241280" cy="1024128"/>
-          </a:xfrm>
-          <a:prstGeom prst="rect">
-            <a:avLst/>
-          </a:prstGeom>
-          <a:solidFill>
-            <a:srgbClr val="FFFFFF">
-              <a:alpha val="0"/>
-            </a:srgbClr>
-          </a:solidFill>
-          <a:ln w="12700">
-            <a:solidFill>
-              <a:srgbClr val="E2E8F0">
-                <a:alpha val="0"/>
-              </a:srgbClr>
-            </a:solidFill>
-            <a:prstDash val="solid"/>
-          </a:ln>
-          <a:effectLst>
-            <a:outerShdw sx="100000" sy="100000" kx="0" ky="0" algn="bl" rotWithShape="0" blurRad="12700" dist="50800" dir="2700000">
-              <a:srgbClr val="000000">
-                <a:alpha val="8000"/>
-              </a:srgbClr>
-            </a:outerShdw>
-          </a:effectLst>
-        </p:spPr>
-      </p:sp>
-      <p:pic>
-        <p:nvPicPr>
-          <p:cNvPr id="4" name="Image 1" descr="preencoded.png">    </p:cNvPr>
-          <p:cNvPicPr>
-            <a:picLocks noChangeAspect="1"/>
-          </p:cNvPicPr>
-          <p:nvPr/>
-        </p:nvPicPr>
-        <p:blipFill>
-          <a:blip r:embed="rId3">
-            <a:extLst>
-              <a:ext uri="{96DAC541-7B7A-43D3-8B79-37D633B846F1}">
-                <asvg:svgBlip xmlns:asvg="http://schemas.microsoft.com/office/drawing/2016/SVG/main" r:embed="rId4"/>
-              </a:ext>
-            </a:extLst>
-          </a:blip>
-          <a:stretch>
-            <a:fillRect/>
-          </a:stretch>
-        </p:blipFill>
-        <p:spPr>
-          <a:xfrm>
-            <a:off x="914400" y="3191256"/>
-            <a:ext cx="10241280" cy="1024128"/>
-          </a:xfrm>
-          <a:prstGeom prst="rect">
-            <a:avLst/>
-          </a:prstGeom>
-        </p:spPr>
-      </p:pic>
-      <p:sp>
-        <p:nvSpPr>
-          <p:cNvPr id="5" name="Shape 1"/>
-          <p:cNvSpPr/>
-          <p:nvPr/>
-        </p:nvSpPr>
-        <p:spPr>
-          <a:xfrm>
-            <a:off x="914400" y="3191256"/>
-            <a:ext cx="10241280" cy="1024128"/>
-          </a:xfrm>
-          <a:prstGeom prst="rect">
-            <a:avLst/>
-          </a:prstGeom>
-          <a:solidFill>
-            <a:srgbClr val="FFFFFF">
-              <a:alpha val="0"/>
-            </a:srgbClr>
-          </a:solidFill>
-          <a:ln w="12700">
-            <a:solidFill>
-              <a:srgbClr val="E2E8F0">
-                <a:alpha val="0"/>
-              </a:srgbClr>
-            </a:solidFill>
-            <a:prstDash val="solid"/>
-          </a:ln>
-          <a:effectLst>
-            <a:outerShdw sx="100000" sy="100000" kx="0" ky="0" algn="bl" rotWithShape="0" blurRad="12700" dist="50800" dir="2700000">
-              <a:srgbClr val="000000">
-                <a:alpha val="8000"/>
-              </a:srgbClr>
-            </a:outerShdw>
-          </a:effectLst>
-        </p:spPr>
-      </p:sp>
-      <p:pic>
-        <p:nvPicPr>
-          <p:cNvPr id="6" name="Image 2" descr="preencoded.png">    </p:cNvPr>
-          <p:cNvPicPr>
-            <a:picLocks noChangeAspect="1"/>
-          </p:cNvPicPr>
-          <p:nvPr/>
-        </p:nvPicPr>
-        <p:blipFill>
-          <a:blip r:embed="rId5">
-            <a:extLst>
-              <a:ext uri="{96DAC541-7B7A-43D3-8B79-37D633B846F1}">
-                <asvg:svgBlip xmlns:asvg="http://schemas.microsoft.com/office/drawing/2016/SVG/main" r:embed="rId6"/>
-              </a:ext>
-            </a:extLst>
-          </a:blip>
-          <a:stretch>
-            <a:fillRect/>
-          </a:stretch>
-        </p:blipFill>
-        <p:spPr>
-          <a:xfrm>
-            <a:off x="914400" y="4507992"/>
-            <a:ext cx="10241280" cy="1024128"/>
-          </a:xfrm>
-          <a:prstGeom prst="rect">
-            <a:avLst/>
-          </a:prstGeom>
-        </p:spPr>
-      </p:pic>
-      <p:sp>
-        <p:nvSpPr>
-          <p:cNvPr id="7" name="Shape 2"/>
-          <p:cNvSpPr/>
-          <p:nvPr/>
-        </p:nvSpPr>
-        <p:spPr>
-          <a:xfrm>
-            <a:off x="914400" y="4507992"/>
-            <a:ext cx="10241280" cy="1024128"/>
-          </a:xfrm>
-          <a:prstGeom prst="rect">
-            <a:avLst/>
-          </a:prstGeom>
-          <a:solidFill>
-            <a:srgbClr val="FFFFFF">
-              <a:alpha val="0"/>
-            </a:srgbClr>
-          </a:solidFill>
-          <a:ln w="12700">
-            <a:solidFill>
-              <a:srgbClr val="E2E8F0">
-                <a:alpha val="0"/>
-              </a:srgbClr>
-            </a:solidFill>
-            <a:prstDash val="solid"/>
-          </a:ln>
-          <a:effectLst>
-            <a:outerShdw sx="100000" sy="100000" kx="0" ky="0" algn="bl" rotWithShape="0" blurRad="12700" dist="50800" dir="2700000">
-              <a:srgbClr val="000000">
-                <a:alpha val="8000"/>
-              </a:srgbClr>
-            </a:outerShdw>
-          </a:effectLst>
-        </p:spPr>
-      </p:sp>
-      <p:sp>
-        <p:nvSpPr>
-          <p:cNvPr id="8" name="Shape 3"/>
-          <p:cNvSpPr/>
-          <p:nvPr/>
-        </p:nvSpPr>
-        <p:spPr>
-          <a:xfrm>
-            <a:off x="786384" y="1956816"/>
-            <a:ext cx="32004" cy="3483864"/>
-          </a:xfrm>
-          <a:prstGeom prst="rect">
-            <a:avLst/>
-          </a:prstGeom>
-          <a:solidFill>
-            <a:srgbClr val="DBEAFE">
-              <a:alpha val="80000"/>
-            </a:srgbClr>
-          </a:solidFill>
-          <a:ln w="12700">
-            <a:solidFill>
-              <a:srgbClr val="DBEAFE">
-                <a:alpha val="0"/>
-              </a:srgbClr>
-            </a:solidFill>
-            <a:prstDash val="solid"/>
-          </a:ln>
-        </p:spPr>
-      </p:sp>
-      <p:sp>
-        <p:nvSpPr>
-          <p:cNvPr id="9" name="Shape 4"/>
-          <p:cNvSpPr/>
-          <p:nvPr/>
-        </p:nvSpPr>
-        <p:spPr>
-          <a:xfrm>
-            <a:off x="914400" y="1865376"/>
-            <a:ext cx="73152" cy="1024128"/>
+            <a:off x="822960" y="1938528"/>
+            <a:ext cx="73152" cy="2514600"/>
           </a:xfrm>
           <a:prstGeom prst="rect">
             <a:avLst/>
@@ -9050,14 +8132,14 @@
       </p:sp>
       <p:sp>
         <p:nvSpPr>
-          <p:cNvPr id="10" name="Shape 5"/>
+          <p:cNvPr id="3" name="Shape 1"/>
           <p:cNvSpPr/>
           <p:nvPr/>
         </p:nvSpPr>
         <p:spPr>
           <a:xfrm>
-            <a:off x="914400" y="3191256"/>
-            <a:ext cx="73152" cy="1024128"/>
+            <a:off x="4343400" y="1938528"/>
+            <a:ext cx="73152" cy="2514600"/>
           </a:xfrm>
           <a:prstGeom prst="rect">
             <a:avLst/>
@@ -9077,14 +8159,14 @@
       </p:sp>
       <p:sp>
         <p:nvSpPr>
-          <p:cNvPr id="11" name="Shape 6"/>
+          <p:cNvPr id="4" name="Shape 2"/>
           <p:cNvSpPr/>
           <p:nvPr/>
         </p:nvSpPr>
         <p:spPr>
           <a:xfrm>
-            <a:off x="914400" y="4507992"/>
-            <a:ext cx="73152" cy="1024128"/>
+            <a:off x="7863840" y="1938528"/>
+            <a:ext cx="73152" cy="2514600"/>
           </a:xfrm>
           <a:prstGeom prst="rect">
             <a:avLst/>
@@ -9104,7 +8186,7 @@
       </p:sp>
       <p:sp>
         <p:nvSpPr>
-          <p:cNvPr id="12" name="mdpr:1-3-4b2f30:title:__title:1-3-4b2f30"/>
+          <p:cNvPr id="5" name="mdpr:1-3-4b2f30:title:__title:1-3-4b2f30"/>
           <p:cNvSpPr txBox="1"/>
           <p:nvPr/>
         </p:nvSpPr>
@@ -9146,14 +8228,14 @@
       </p:sp>
       <p:sp>
         <p:nvSpPr>
-          <p:cNvPr id="13" name="mdpr:1-3-4b2f30:item-1:block-23-chunk-1"/>
+          <p:cNvPr id="6" name="mdpr:1-3-4b2f30:item-1:block-23-chunk-1"/>
           <p:cNvSpPr txBox="1"/>
           <p:nvPr/>
         </p:nvSpPr>
         <p:spPr>
           <a:xfrm>
-            <a:off x="1133856" y="2164080"/>
-            <a:ext cx="9820656" cy="426720"/>
+            <a:off x="1042416" y="2982468"/>
+            <a:ext cx="2825496" cy="426720"/>
           </a:xfrm>
           <a:prstGeom prst="rect">
             <a:avLst/>
@@ -9188,14 +8270,14 @@
       </p:sp>
       <p:sp>
         <p:nvSpPr>
-          <p:cNvPr id="14" name="mdpr:1-3-4b2f30:item-2:block-23-chunk-1"/>
+          <p:cNvPr id="7" name="mdpr:1-3-4b2f30:item-2:block-23-chunk-1"/>
           <p:cNvSpPr txBox="1"/>
           <p:nvPr/>
         </p:nvSpPr>
         <p:spPr>
           <a:xfrm>
-            <a:off x="1133856" y="3489960"/>
-            <a:ext cx="9820656" cy="426720"/>
+            <a:off x="4562856" y="2814828"/>
+            <a:ext cx="2825496" cy="762000"/>
           </a:xfrm>
           <a:prstGeom prst="rect">
             <a:avLst/>
@@ -9230,14 +8312,14 @@
       </p:sp>
       <p:sp>
         <p:nvSpPr>
-          <p:cNvPr id="15" name="mdpr:1-3-4b2f30:item-3:block-23-chunk-1"/>
+          <p:cNvPr id="8" name="mdpr:1-3-4b2f30:item-3:block-23-chunk-1"/>
           <p:cNvSpPr txBox="1"/>
           <p:nvPr/>
         </p:nvSpPr>
         <p:spPr>
           <a:xfrm>
-            <a:off x="1133856" y="4806696"/>
-            <a:ext cx="9820656" cy="426720"/>
+            <a:off x="8083296" y="2982468"/>
+            <a:ext cx="2825496" cy="426720"/>
           </a:xfrm>
           <a:prstGeom prst="rect">
             <a:avLst/>
@@ -9508,35 +8590,6 @@
         </p:nvSpPr>
         <p:spPr>
           <a:xfrm>
-            <a:off x="786384" y="1956816"/>
-            <a:ext cx="32004" cy="3483864"/>
-          </a:xfrm>
-          <a:prstGeom prst="rect">
-            <a:avLst/>
-          </a:prstGeom>
-          <a:solidFill>
-            <a:srgbClr val="DBEAFE">
-              <a:alpha val="80000"/>
-            </a:srgbClr>
-          </a:solidFill>
-          <a:ln w="12700">
-            <a:solidFill>
-              <a:srgbClr val="DBEAFE">
-                <a:alpha val="0"/>
-              </a:srgbClr>
-            </a:solidFill>
-            <a:prstDash val="solid"/>
-          </a:ln>
-        </p:spPr>
-      </p:sp>
-      <p:sp>
-        <p:nvSpPr>
-          <p:cNvPr id="9" name="Shape 4"/>
-          <p:cNvSpPr/>
-          <p:nvPr/>
-        </p:nvSpPr>
-        <p:spPr>
-          <a:xfrm>
             <a:off x="914400" y="1865376"/>
             <a:ext cx="73152" cy="1024128"/>
           </a:xfrm>
@@ -9558,7 +8611,7 @@
       </p:sp>
       <p:sp>
         <p:nvSpPr>
-          <p:cNvPr id="10" name="Shape 5"/>
+          <p:cNvPr id="9" name="Shape 4"/>
           <p:cNvSpPr/>
           <p:nvPr/>
         </p:nvSpPr>
@@ -9585,7 +8638,7 @@
       </p:sp>
       <p:sp>
         <p:nvSpPr>
-          <p:cNvPr id="11" name="Shape 6"/>
+          <p:cNvPr id="10" name="Shape 5"/>
           <p:cNvSpPr/>
           <p:nvPr/>
         </p:nvSpPr>
@@ -9612,7 +8665,7 @@
       </p:sp>
       <p:sp>
         <p:nvSpPr>
-          <p:cNvPr id="12" name="mdpr:2-3-fe6c97:title:__title:2-3-fe6c97"/>
+          <p:cNvPr id="11" name="mdpr:2-3-fe6c97:title:__title:2-3-fe6c97"/>
           <p:cNvSpPr txBox="1"/>
           <p:nvPr/>
         </p:nvSpPr>
@@ -9646,7 +8699,24 @@
                 <a:ea typeface="Pretendard" pitchFamily="34" charset="-122"/>
                 <a:cs typeface="Pretendard" pitchFamily="34" charset="-120"/>
               </a:rPr>
-              <a:t>Validation and Overflow Policy (Cont. 2/3)</a:t>
+              <a:t>Validation and Overflow Policy</a:t>
+            </a:r>
+            <a:pPr algn="ctr" indent="0" marL="0">
+              <a:lnSpc>
+                <a:spcPct val="120000"/>
+              </a:lnSpc>
+              <a:buNone/>
+            </a:pPr>
+            <a:r>
+              <a:rPr lang="en-US" sz="2000" dirty="0">
+                <a:solidFill>
+                  <a:srgbClr val="919191"/>
+                </a:solidFill>
+                <a:latin typeface="Pretendard" pitchFamily="34" charset="0"/>
+                <a:ea typeface="Pretendard" pitchFamily="34" charset="-122"/>
+                <a:cs typeface="Pretendard" pitchFamily="34" charset="-120"/>
+              </a:rPr>
+              <a:t> (Cont. 2/3)</a:t>
             </a:r>
             <a:endParaRPr lang="en-US" sz="3400" dirty="0"/>
           </a:p>
@@ -9654,7 +8724,7 @@
       </p:sp>
       <p:sp>
         <p:nvSpPr>
-          <p:cNvPr id="13" name="mdpr:2-3-fe6c97:item-1:block-23-chunk-2"/>
+          <p:cNvPr id="12" name="mdpr:2-3-fe6c97:item-1:block-23-chunk-2"/>
           <p:cNvSpPr txBox="1"/>
           <p:nvPr/>
         </p:nvSpPr>
@@ -9696,7 +8766,7 @@
       </p:sp>
       <p:sp>
         <p:nvSpPr>
-          <p:cNvPr id="14" name="mdpr:2-3-fe6c97:item-2:block-23-chunk-2"/>
+          <p:cNvPr id="13" name="mdpr:2-3-fe6c97:item-2:block-23-chunk-2"/>
           <p:cNvSpPr txBox="1"/>
           <p:nvPr/>
         </p:nvSpPr>
@@ -9738,7 +8808,7 @@
       </p:sp>
       <p:sp>
         <p:nvSpPr>
-          <p:cNvPr id="15" name="mdpr:2-3-fe6c97:item-3:block-23-chunk-2"/>
+          <p:cNvPr id="14" name="mdpr:2-3-fe6c97:item-3:block-23-chunk-2"/>
           <p:cNvSpPr txBox="1"/>
           <p:nvPr/>
         </p:nvSpPr>
@@ -9818,35 +8888,6 @@
         </p:nvSpPr>
         <p:spPr>
           <a:xfrm>
-            <a:off x="6080760" y="1737360"/>
-            <a:ext cx="22860" cy="3968496"/>
-          </a:xfrm>
-          <a:prstGeom prst="rect">
-            <a:avLst/>
-          </a:prstGeom>
-          <a:solidFill>
-            <a:srgbClr val="E2E8F0">
-              <a:alpha val="90000"/>
-            </a:srgbClr>
-          </a:solidFill>
-          <a:ln w="12700">
-            <a:solidFill>
-              <a:srgbClr val="E2E8F0">
-                <a:alpha val="0"/>
-              </a:srgbClr>
-            </a:solidFill>
-            <a:prstDash val="solid"/>
-          </a:ln>
-        </p:spPr>
-      </p:sp>
-      <p:sp>
-        <p:nvSpPr>
-          <p:cNvPr id="3" name="Shape 1"/>
-          <p:cNvSpPr/>
-          <p:nvPr/>
-        </p:nvSpPr>
-        <p:spPr>
-          <a:xfrm>
             <a:off x="822960" y="1737360"/>
             <a:ext cx="73152" cy="841248"/>
           </a:xfrm>
@@ -9868,7 +8909,7 @@
       </p:sp>
       <p:sp>
         <p:nvSpPr>
-          <p:cNvPr id="4" name="Shape 2"/>
+          <p:cNvPr id="3" name="Shape 1"/>
           <p:cNvSpPr/>
           <p:nvPr/>
         </p:nvSpPr>
@@ -9895,7 +8936,7 @@
       </p:sp>
       <p:sp>
         <p:nvSpPr>
-          <p:cNvPr id="5" name="Shape 3"/>
+          <p:cNvPr id="4" name="Shape 2"/>
           <p:cNvSpPr/>
           <p:nvPr/>
         </p:nvSpPr>
@@ -9922,7 +8963,7 @@
       </p:sp>
       <p:sp>
         <p:nvSpPr>
-          <p:cNvPr id="6" name="Shape 4"/>
+          <p:cNvPr id="5" name="Shape 3"/>
           <p:cNvSpPr/>
           <p:nvPr/>
         </p:nvSpPr>
@@ -9949,7 +8990,7 @@
       </p:sp>
       <p:sp>
         <p:nvSpPr>
-          <p:cNvPr id="7" name="Shape 5"/>
+          <p:cNvPr id="6" name="Shape 4"/>
           <p:cNvSpPr/>
           <p:nvPr/>
         </p:nvSpPr>
@@ -9976,7 +9017,7 @@
       </p:sp>
       <p:sp>
         <p:nvSpPr>
-          <p:cNvPr id="8" name="Shape 6"/>
+          <p:cNvPr id="7" name="Shape 5"/>
           <p:cNvSpPr/>
           <p:nvPr/>
         </p:nvSpPr>
@@ -10003,7 +9044,7 @@
       </p:sp>
       <p:sp>
         <p:nvSpPr>
-          <p:cNvPr id="9" name="Shape 7"/>
+          <p:cNvPr id="8" name="Shape 6"/>
           <p:cNvSpPr/>
           <p:nvPr/>
         </p:nvSpPr>
@@ -10030,7 +9071,7 @@
       </p:sp>
       <p:sp>
         <p:nvSpPr>
-          <p:cNvPr id="10" name="Shape 8"/>
+          <p:cNvPr id="9" name="Shape 7"/>
           <p:cNvSpPr/>
           <p:nvPr/>
         </p:nvSpPr>
@@ -10057,7 +9098,7 @@
       </p:sp>
       <p:sp>
         <p:nvSpPr>
-          <p:cNvPr id="11" name="mdpr:1-2-0772f8:title:__title:1-2-0772f8"/>
+          <p:cNvPr id="10" name="mdpr:1-2-0772f8:title:__title:1-2-0772f8"/>
           <p:cNvSpPr txBox="1"/>
           <p:nvPr/>
         </p:nvSpPr>
@@ -10099,7 +9140,7 @@
       </p:sp>
       <p:sp>
         <p:nvSpPr>
-          <p:cNvPr id="12" name="mdpr:1-2-0772f8:toc-item-1:toc-item-1"/>
+          <p:cNvPr id="11" name="mdpr:1-2-0772f8:toc-item-1:toc-item-1"/>
           <p:cNvSpPr txBox="1"/>
           <p:nvPr/>
         </p:nvSpPr>
@@ -10141,7 +9182,7 @@
       </p:sp>
       <p:sp>
         <p:nvSpPr>
-          <p:cNvPr id="13" name="mdpr:1-2-0772f8:toc-item-2:toc-item-2"/>
+          <p:cNvPr id="12" name="mdpr:1-2-0772f8:toc-item-2:toc-item-2"/>
           <p:cNvSpPr txBox="1"/>
           <p:nvPr/>
         </p:nvSpPr>
@@ -10183,7 +9224,7 @@
       </p:sp>
       <p:sp>
         <p:nvSpPr>
-          <p:cNvPr id="14" name="mdpr:1-2-0772f8:toc-item-3:toc-item-3"/>
+          <p:cNvPr id="13" name="mdpr:1-2-0772f8:toc-item-3:toc-item-3"/>
           <p:cNvSpPr txBox="1"/>
           <p:nvPr/>
         </p:nvSpPr>
@@ -10225,7 +9266,7 @@
       </p:sp>
       <p:sp>
         <p:nvSpPr>
-          <p:cNvPr id="15" name="mdpr:1-2-0772f8:toc-item-4:toc-item-4"/>
+          <p:cNvPr id="14" name="mdpr:1-2-0772f8:toc-item-4:toc-item-4"/>
           <p:cNvSpPr txBox="1"/>
           <p:nvPr/>
         </p:nvSpPr>
@@ -10267,7 +9308,7 @@
       </p:sp>
       <p:sp>
         <p:nvSpPr>
-          <p:cNvPr id="16" name="mdpr:1-2-0772f8:toc-item-5:toc-item-5"/>
+          <p:cNvPr id="15" name="mdpr:1-2-0772f8:toc-item-5:toc-item-5"/>
           <p:cNvSpPr txBox="1"/>
           <p:nvPr/>
         </p:nvSpPr>
@@ -10309,7 +9350,7 @@
       </p:sp>
       <p:sp>
         <p:nvSpPr>
-          <p:cNvPr id="17" name="mdpr:1-2-0772f8:toc-item-6:toc-item-6"/>
+          <p:cNvPr id="16" name="mdpr:1-2-0772f8:toc-item-6:toc-item-6"/>
           <p:cNvSpPr txBox="1"/>
           <p:nvPr/>
         </p:nvSpPr>
@@ -10351,7 +9392,7 @@
       </p:sp>
       <p:sp>
         <p:nvSpPr>
-          <p:cNvPr id="18" name="mdpr:1-2-0772f8:toc-item-7:toc-item-7"/>
+          <p:cNvPr id="17" name="mdpr:1-2-0772f8:toc-item-7:toc-item-7"/>
           <p:cNvSpPr txBox="1"/>
           <p:nvPr/>
         </p:nvSpPr>
@@ -10393,7 +9434,7 @@
       </p:sp>
       <p:sp>
         <p:nvSpPr>
-          <p:cNvPr id="19" name="mdpr:1-2-0772f8:toc-item-8:toc-item-8"/>
+          <p:cNvPr id="18" name="mdpr:1-2-0772f8:toc-item-8:toc-item-8"/>
           <p:cNvSpPr txBox="1"/>
           <p:nvPr/>
         </p:nvSpPr>
@@ -10567,7 +9608,24 @@
                 <a:ea typeface="Pretendard" pitchFamily="34" charset="-122"/>
                 <a:cs typeface="Pretendard" pitchFamily="34" charset="-120"/>
               </a:rPr>
-              <a:t>Validation and Overflow Policy (Cont. 3/3)</a:t>
+              <a:t>Validation and Overflow Policy</a:t>
+            </a:r>
+            <a:pPr algn="ctr" indent="0" marL="0">
+              <a:lnSpc>
+                <a:spcPct val="120000"/>
+              </a:lnSpc>
+              <a:buNone/>
+            </a:pPr>
+            <a:r>
+              <a:rPr lang="en-US" sz="2000" dirty="0">
+                <a:solidFill>
+                  <a:srgbClr val="919191"/>
+                </a:solidFill>
+                <a:latin typeface="Pretendard" pitchFamily="34" charset="0"/>
+                <a:ea typeface="Pretendard" pitchFamily="34" charset="-122"/>
+                <a:cs typeface="Pretendard" pitchFamily="34" charset="-120"/>
+              </a:rPr>
+              <a:t> (Cont. 3/3)</a:t>
             </a:r>
             <a:endParaRPr lang="en-US" sz="3400" dirty="0"/>
           </a:p>
@@ -11851,35 +10909,6 @@
         </p:nvSpPr>
         <p:spPr>
           <a:xfrm>
-            <a:off x="786384" y="1956816"/>
-            <a:ext cx="32004" cy="3483864"/>
-          </a:xfrm>
-          <a:prstGeom prst="rect">
-            <a:avLst/>
-          </a:prstGeom>
-          <a:solidFill>
-            <a:srgbClr val="DBEAFE">
-              <a:alpha val="80000"/>
-            </a:srgbClr>
-          </a:solidFill>
-          <a:ln w="12700">
-            <a:solidFill>
-              <a:srgbClr val="DBEAFE">
-                <a:alpha val="0"/>
-              </a:srgbClr>
-            </a:solidFill>
-            <a:prstDash val="solid"/>
-          </a:ln>
-        </p:spPr>
-      </p:sp>
-      <p:sp>
-        <p:nvSpPr>
-          <p:cNvPr id="9" name="Shape 4"/>
-          <p:cNvSpPr/>
-          <p:nvPr/>
-        </p:nvSpPr>
-        <p:spPr>
-          <a:xfrm>
             <a:off x="914400" y="1865376"/>
             <a:ext cx="73152" cy="1024128"/>
           </a:xfrm>
@@ -11901,7 +10930,7 @@
       </p:sp>
       <p:sp>
         <p:nvSpPr>
-          <p:cNvPr id="10" name="Shape 5"/>
+          <p:cNvPr id="9" name="Shape 4"/>
           <p:cNvSpPr/>
           <p:nvPr/>
         </p:nvSpPr>
@@ -11928,7 +10957,7 @@
       </p:sp>
       <p:sp>
         <p:nvSpPr>
-          <p:cNvPr id="11" name="Shape 6"/>
+          <p:cNvPr id="10" name="Shape 5"/>
           <p:cNvSpPr/>
           <p:nvPr/>
         </p:nvSpPr>
@@ -11955,7 +10984,7 @@
       </p:sp>
       <p:sp>
         <p:nvSpPr>
-          <p:cNvPr id="12" name="mdpr:2-3-4f52c2:title:__title:2-3-4f52c2"/>
+          <p:cNvPr id="11" name="mdpr:2-3-4f52c2:title:__title:2-3-4f52c2"/>
           <p:cNvSpPr txBox="1"/>
           <p:nvPr/>
         </p:nvSpPr>
@@ -11989,7 +11018,24 @@
                 <a:ea typeface="Pretendard" pitchFamily="34" charset="-122"/>
                 <a:cs typeface="Pretendard" pitchFamily="34" charset="-120"/>
               </a:rPr>
-              <a:t>Example: examples/basic/deck.md (Cont. 2/3)</a:t>
+              <a:t>Example: examples/basic/deck.md</a:t>
+            </a:r>
+            <a:pPr algn="ctr" indent="0" marL="0">
+              <a:lnSpc>
+                <a:spcPct val="120000"/>
+              </a:lnSpc>
+              <a:buNone/>
+            </a:pPr>
+            <a:r>
+              <a:rPr lang="en-US" sz="2000" dirty="0">
+                <a:solidFill>
+                  <a:srgbClr val="919191"/>
+                </a:solidFill>
+                <a:latin typeface="Pretendard" pitchFamily="34" charset="0"/>
+                <a:ea typeface="Pretendard" pitchFamily="34" charset="-122"/>
+                <a:cs typeface="Pretendard" pitchFamily="34" charset="-120"/>
+              </a:rPr>
+              <a:t> (Cont. 2/3)</a:t>
             </a:r>
             <a:endParaRPr lang="en-US" sz="3400" dirty="0"/>
           </a:p>
@@ -11997,7 +11043,7 @@
       </p:sp>
       <p:sp>
         <p:nvSpPr>
-          <p:cNvPr id="13" name="mdpr:2-3-4f52c2:item-1:block-28-chunk-2"/>
+          <p:cNvPr id="12" name="mdpr:2-3-4f52c2:item-1:block-28-chunk-2"/>
           <p:cNvSpPr txBox="1"/>
           <p:nvPr/>
         </p:nvSpPr>
@@ -12039,7 +11085,7 @@
       </p:sp>
       <p:sp>
         <p:nvSpPr>
-          <p:cNvPr id="14" name="mdpr:2-3-4f52c2:item-2:block-28-chunk-2"/>
+          <p:cNvPr id="13" name="mdpr:2-3-4f52c2:item-2:block-28-chunk-2"/>
           <p:cNvSpPr txBox="1"/>
           <p:nvPr/>
         </p:nvSpPr>
@@ -12081,7 +11127,7 @@
       </p:sp>
       <p:sp>
         <p:nvSpPr>
-          <p:cNvPr id="15" name="mdpr:2-3-4f52c2:item-3:block-28-chunk-2"/>
+          <p:cNvPr id="14" name="mdpr:2-3-4f52c2:item-3:block-28-chunk-2"/>
           <p:cNvSpPr txBox="1"/>
           <p:nvPr/>
         </p:nvSpPr>
@@ -12153,243 +11199,16 @@
           <a:chExt cx="0" cy="0"/>
         </a:xfrm>
       </p:grpSpPr>
-      <p:pic>
-        <p:nvPicPr>
-          <p:cNvPr id="2" name="Image 0" descr="preencoded.png">    </p:cNvPr>
-          <p:cNvPicPr>
-            <a:picLocks noChangeAspect="1"/>
-          </p:cNvPicPr>
-          <p:nvPr/>
-        </p:nvPicPr>
-        <p:blipFill>
-          <a:blip r:embed="rId1">
-            <a:extLst>
-              <a:ext uri="{96DAC541-7B7A-43D3-8B79-37D633B846F1}">
-                <asvg:svgBlip xmlns:asvg="http://schemas.microsoft.com/office/drawing/2016/SVG/main" r:embed="rId2"/>
-              </a:ext>
-            </a:extLst>
-          </a:blip>
-          <a:stretch>
-            <a:fillRect/>
-          </a:stretch>
-        </p:blipFill>
-        <p:spPr>
-          <a:xfrm>
-            <a:off x="914400" y="1865376"/>
-            <a:ext cx="10241280" cy="1024128"/>
-          </a:xfrm>
-          <a:prstGeom prst="rect">
-            <a:avLst/>
-          </a:prstGeom>
-        </p:spPr>
-      </p:pic>
-      <p:sp>
-        <p:nvSpPr>
-          <p:cNvPr id="3" name="Shape 0"/>
+      <p:sp>
+        <p:nvSpPr>
+          <p:cNvPr id="2" name="Shape 0"/>
           <p:cNvSpPr/>
           <p:nvPr/>
         </p:nvSpPr>
         <p:spPr>
           <a:xfrm>
-            <a:off x="914400" y="1865376"/>
-            <a:ext cx="10241280" cy="1024128"/>
-          </a:xfrm>
-          <a:prstGeom prst="rect">
-            <a:avLst/>
-          </a:prstGeom>
-          <a:solidFill>
-            <a:srgbClr val="FFFFFF">
-              <a:alpha val="0"/>
-            </a:srgbClr>
-          </a:solidFill>
-          <a:ln w="12700">
-            <a:solidFill>
-              <a:srgbClr val="E2E8F0">
-                <a:alpha val="0"/>
-              </a:srgbClr>
-            </a:solidFill>
-            <a:prstDash val="solid"/>
-          </a:ln>
-          <a:effectLst>
-            <a:outerShdw sx="100000" sy="100000" kx="0" ky="0" algn="bl" rotWithShape="0" blurRad="12700" dist="50800" dir="2700000">
-              <a:srgbClr val="000000">
-                <a:alpha val="8000"/>
-              </a:srgbClr>
-            </a:outerShdw>
-          </a:effectLst>
-        </p:spPr>
-      </p:sp>
-      <p:pic>
-        <p:nvPicPr>
-          <p:cNvPr id="4" name="Image 1" descr="preencoded.png">    </p:cNvPr>
-          <p:cNvPicPr>
-            <a:picLocks noChangeAspect="1"/>
-          </p:cNvPicPr>
-          <p:nvPr/>
-        </p:nvPicPr>
-        <p:blipFill>
-          <a:blip r:embed="rId3">
-            <a:extLst>
-              <a:ext uri="{96DAC541-7B7A-43D3-8B79-37D633B846F1}">
-                <asvg:svgBlip xmlns:asvg="http://schemas.microsoft.com/office/drawing/2016/SVG/main" r:embed="rId4"/>
-              </a:ext>
-            </a:extLst>
-          </a:blip>
-          <a:stretch>
-            <a:fillRect/>
-          </a:stretch>
-        </p:blipFill>
-        <p:spPr>
-          <a:xfrm>
-            <a:off x="914400" y="3191256"/>
-            <a:ext cx="10241280" cy="1024128"/>
-          </a:xfrm>
-          <a:prstGeom prst="rect">
-            <a:avLst/>
-          </a:prstGeom>
-        </p:spPr>
-      </p:pic>
-      <p:sp>
-        <p:nvSpPr>
-          <p:cNvPr id="5" name="Shape 1"/>
-          <p:cNvSpPr/>
-          <p:nvPr/>
-        </p:nvSpPr>
-        <p:spPr>
-          <a:xfrm>
-            <a:off x="914400" y="3191256"/>
-            <a:ext cx="10241280" cy="1024128"/>
-          </a:xfrm>
-          <a:prstGeom prst="rect">
-            <a:avLst/>
-          </a:prstGeom>
-          <a:solidFill>
-            <a:srgbClr val="FFFFFF">
-              <a:alpha val="0"/>
-            </a:srgbClr>
-          </a:solidFill>
-          <a:ln w="12700">
-            <a:solidFill>
-              <a:srgbClr val="E2E8F0">
-                <a:alpha val="0"/>
-              </a:srgbClr>
-            </a:solidFill>
-            <a:prstDash val="solid"/>
-          </a:ln>
-          <a:effectLst>
-            <a:outerShdw sx="100000" sy="100000" kx="0" ky="0" algn="bl" rotWithShape="0" blurRad="12700" dist="50800" dir="2700000">
-              <a:srgbClr val="000000">
-                <a:alpha val="8000"/>
-              </a:srgbClr>
-            </a:outerShdw>
-          </a:effectLst>
-        </p:spPr>
-      </p:sp>
-      <p:pic>
-        <p:nvPicPr>
-          <p:cNvPr id="6" name="Image 2" descr="preencoded.png">    </p:cNvPr>
-          <p:cNvPicPr>
-            <a:picLocks noChangeAspect="1"/>
-          </p:cNvPicPr>
-          <p:nvPr/>
-        </p:nvPicPr>
-        <p:blipFill>
-          <a:blip r:embed="rId5">
-            <a:extLst>
-              <a:ext uri="{96DAC541-7B7A-43D3-8B79-37D633B846F1}">
-                <asvg:svgBlip xmlns:asvg="http://schemas.microsoft.com/office/drawing/2016/SVG/main" r:embed="rId6"/>
-              </a:ext>
-            </a:extLst>
-          </a:blip>
-          <a:stretch>
-            <a:fillRect/>
-          </a:stretch>
-        </p:blipFill>
-        <p:spPr>
-          <a:xfrm>
-            <a:off x="914400" y="4507992"/>
-            <a:ext cx="10241280" cy="1024128"/>
-          </a:xfrm>
-          <a:prstGeom prst="rect">
-            <a:avLst/>
-          </a:prstGeom>
-        </p:spPr>
-      </p:pic>
-      <p:sp>
-        <p:nvSpPr>
-          <p:cNvPr id="7" name="Shape 2"/>
-          <p:cNvSpPr/>
-          <p:nvPr/>
-        </p:nvSpPr>
-        <p:spPr>
-          <a:xfrm>
-            <a:off x="914400" y="4507992"/>
-            <a:ext cx="10241280" cy="1024128"/>
-          </a:xfrm>
-          <a:prstGeom prst="rect">
-            <a:avLst/>
-          </a:prstGeom>
-          <a:solidFill>
-            <a:srgbClr val="FFFFFF">
-              <a:alpha val="0"/>
-            </a:srgbClr>
-          </a:solidFill>
-          <a:ln w="12700">
-            <a:solidFill>
-              <a:srgbClr val="E2E8F0">
-                <a:alpha val="0"/>
-              </a:srgbClr>
-            </a:solidFill>
-            <a:prstDash val="solid"/>
-          </a:ln>
-          <a:effectLst>
-            <a:outerShdw sx="100000" sy="100000" kx="0" ky="0" algn="bl" rotWithShape="0" blurRad="12700" dist="50800" dir="2700000">
-              <a:srgbClr val="000000">
-                <a:alpha val="8000"/>
-              </a:srgbClr>
-            </a:outerShdw>
-          </a:effectLst>
-        </p:spPr>
-      </p:sp>
-      <p:sp>
-        <p:nvSpPr>
-          <p:cNvPr id="8" name="Shape 3"/>
-          <p:cNvSpPr/>
-          <p:nvPr/>
-        </p:nvSpPr>
-        <p:spPr>
-          <a:xfrm>
-            <a:off x="786384" y="1956816"/>
-            <a:ext cx="32004" cy="3483864"/>
-          </a:xfrm>
-          <a:prstGeom prst="rect">
-            <a:avLst/>
-          </a:prstGeom>
-          <a:solidFill>
-            <a:srgbClr val="DBEAFE">
-              <a:alpha val="80000"/>
-            </a:srgbClr>
-          </a:solidFill>
-          <a:ln w="12700">
-            <a:solidFill>
-              <a:srgbClr val="DBEAFE">
-                <a:alpha val="0"/>
-              </a:srgbClr>
-            </a:solidFill>
-            <a:prstDash val="solid"/>
-          </a:ln>
-        </p:spPr>
-      </p:sp>
-      <p:sp>
-        <p:nvSpPr>
-          <p:cNvPr id="9" name="Shape 4"/>
-          <p:cNvSpPr/>
-          <p:nvPr/>
-        </p:nvSpPr>
-        <p:spPr>
-          <a:xfrm>
-            <a:off x="914400" y="1865376"/>
-            <a:ext cx="73152" cy="1024128"/>
+            <a:off x="822960" y="1938528"/>
+            <a:ext cx="73152" cy="2514600"/>
           </a:xfrm>
           <a:prstGeom prst="rect">
             <a:avLst/>
@@ -12409,14 +11228,14 @@
       </p:sp>
       <p:sp>
         <p:nvSpPr>
-          <p:cNvPr id="10" name="Shape 5"/>
+          <p:cNvPr id="3" name="Shape 1"/>
           <p:cNvSpPr/>
           <p:nvPr/>
         </p:nvSpPr>
         <p:spPr>
           <a:xfrm>
-            <a:off x="914400" y="3191256"/>
-            <a:ext cx="73152" cy="1024128"/>
+            <a:off x="4343400" y="1938528"/>
+            <a:ext cx="73152" cy="2514600"/>
           </a:xfrm>
           <a:prstGeom prst="rect">
             <a:avLst/>
@@ -12436,14 +11255,14 @@
       </p:sp>
       <p:sp>
         <p:nvSpPr>
-          <p:cNvPr id="11" name="Shape 6"/>
+          <p:cNvPr id="4" name="Shape 2"/>
           <p:cNvSpPr/>
           <p:nvPr/>
         </p:nvSpPr>
         <p:spPr>
           <a:xfrm>
-            <a:off x="914400" y="4507992"/>
-            <a:ext cx="73152" cy="1024128"/>
+            <a:off x="7863840" y="1938528"/>
+            <a:ext cx="73152" cy="2514600"/>
           </a:xfrm>
           <a:prstGeom prst="rect">
             <a:avLst/>
@@ -12463,7 +11282,7 @@
       </p:sp>
       <p:sp>
         <p:nvSpPr>
-          <p:cNvPr id="12" name="mdpr:3-3-9304f5:title:__title:3-3-9304f5"/>
+          <p:cNvPr id="5" name="mdpr:3-3-9304f5:title:__title:3-3-9304f5"/>
           <p:cNvSpPr txBox="1"/>
           <p:nvPr/>
         </p:nvSpPr>
@@ -12497,7 +11316,24 @@
                 <a:ea typeface="Pretendard" pitchFamily="34" charset="-122"/>
                 <a:cs typeface="Pretendard" pitchFamily="34" charset="-120"/>
               </a:rPr>
-              <a:t>Example: examples/basic/deck.md (Cont. 3/3)</a:t>
+              <a:t>Example: examples/basic/deck.md</a:t>
+            </a:r>
+            <a:pPr algn="ctr" indent="0" marL="0">
+              <a:lnSpc>
+                <a:spcPct val="120000"/>
+              </a:lnSpc>
+              <a:buNone/>
+            </a:pPr>
+            <a:r>
+              <a:rPr lang="en-US" sz="2000" dirty="0">
+                <a:solidFill>
+                  <a:srgbClr val="919191"/>
+                </a:solidFill>
+                <a:latin typeface="Pretendard" pitchFamily="34" charset="0"/>
+                <a:ea typeface="Pretendard" pitchFamily="34" charset="-122"/>
+                <a:cs typeface="Pretendard" pitchFamily="34" charset="-120"/>
+              </a:rPr>
+              <a:t> (Cont. 3/3)</a:t>
             </a:r>
             <a:endParaRPr lang="en-US" sz="3400" dirty="0"/>
           </a:p>
@@ -12505,14 +11341,14 @@
       </p:sp>
       <p:sp>
         <p:nvSpPr>
-          <p:cNvPr id="13" name="mdpr:3-3-9304f5:item-1:block-28-chunk-3"/>
+          <p:cNvPr id="6" name="mdpr:3-3-9304f5:item-1:block-28-chunk-3"/>
           <p:cNvSpPr txBox="1"/>
           <p:nvPr/>
         </p:nvSpPr>
         <p:spPr>
           <a:xfrm>
-            <a:off x="1133856" y="2164080"/>
-            <a:ext cx="9820656" cy="426720"/>
+            <a:off x="1042416" y="2982468"/>
+            <a:ext cx="2825496" cy="426720"/>
           </a:xfrm>
           <a:prstGeom prst="rect">
             <a:avLst/>
@@ -12547,14 +11383,14 @@
       </p:sp>
       <p:sp>
         <p:nvSpPr>
-          <p:cNvPr id="14" name="mdpr:3-3-9304f5:item-2:block-28-chunk-3"/>
+          <p:cNvPr id="7" name="mdpr:3-3-9304f5:item-2:block-28-chunk-3"/>
           <p:cNvSpPr txBox="1"/>
           <p:nvPr/>
         </p:nvSpPr>
         <p:spPr>
           <a:xfrm>
-            <a:off x="1133856" y="3489960"/>
-            <a:ext cx="9820656" cy="426720"/>
+            <a:off x="4562856" y="2982468"/>
+            <a:ext cx="2825496" cy="426720"/>
           </a:xfrm>
           <a:prstGeom prst="rect">
             <a:avLst/>
@@ -12589,14 +11425,14 @@
       </p:sp>
       <p:sp>
         <p:nvSpPr>
-          <p:cNvPr id="15" name="mdpr:3-3-9304f5:item-3:block-28-chunk-3"/>
+          <p:cNvPr id="8" name="mdpr:3-3-9304f5:item-3:block-28-chunk-3"/>
           <p:cNvSpPr txBox="1"/>
           <p:nvPr/>
         </p:nvSpPr>
         <p:spPr>
           <a:xfrm>
-            <a:off x="1133856" y="4806696"/>
-            <a:ext cx="9820656" cy="426720"/>
+            <a:off x="8083296" y="2814828"/>
+            <a:ext cx="2825496" cy="762000"/>
           </a:xfrm>
           <a:prstGeom prst="rect">
             <a:avLst/>
@@ -13275,280 +12111,16 @@
           <a:chExt cx="0" cy="0"/>
         </a:xfrm>
       </p:grpSpPr>
-      <p:pic>
-        <p:nvPicPr>
-          <p:cNvPr id="2" name="Image 0" descr="preencoded.png">    </p:cNvPr>
-          <p:cNvPicPr>
-            <a:picLocks noChangeAspect="1"/>
-          </p:cNvPicPr>
-          <p:nvPr/>
-        </p:nvPicPr>
-        <p:blipFill>
-          <a:blip r:embed="rId1">
-            <a:extLst>
-              <a:ext uri="{96DAC541-7B7A-43D3-8B79-37D633B846F1}">
-                <asvg:svgBlip xmlns:asvg="http://schemas.microsoft.com/office/drawing/2016/SVG/main" r:embed="rId2"/>
-              </a:ext>
-            </a:extLst>
-          </a:blip>
-          <a:stretch>
-            <a:fillRect/>
-          </a:stretch>
-        </p:blipFill>
-        <p:spPr>
-          <a:xfrm>
-            <a:off x="822960" y="1463040"/>
-            <a:ext cx="5029200" cy="1920240"/>
-          </a:xfrm>
-          <a:prstGeom prst="rect">
-            <a:avLst/>
-          </a:prstGeom>
-        </p:spPr>
-      </p:pic>
-      <p:sp>
-        <p:nvSpPr>
-          <p:cNvPr id="3" name="Shape 0"/>
+      <p:sp>
+        <p:nvSpPr>
+          <p:cNvPr id="2" name="Shape 0"/>
           <p:cNvSpPr/>
           <p:nvPr/>
         </p:nvSpPr>
         <p:spPr>
           <a:xfrm>
-            <a:off x="822960" y="1463040"/>
-            <a:ext cx="5029200" cy="1920240"/>
-          </a:xfrm>
-          <a:prstGeom prst="rect">
-            <a:avLst/>
-          </a:prstGeom>
-          <a:solidFill>
-            <a:srgbClr val="FFFFFF">
-              <a:alpha val="0"/>
-            </a:srgbClr>
-          </a:solidFill>
-          <a:ln w="12700">
-            <a:solidFill>
-              <a:srgbClr val="E2E8F0">
-                <a:alpha val="0"/>
-              </a:srgbClr>
-            </a:solidFill>
-            <a:prstDash val="solid"/>
-          </a:ln>
-          <a:effectLst>
-            <a:outerShdw sx="100000" sy="100000" kx="0" ky="0" algn="bl" rotWithShape="0" blurRad="12700" dist="50800" dir="2700000">
-              <a:srgbClr val="000000">
-                <a:alpha val="8000"/>
-              </a:srgbClr>
-            </a:outerShdw>
-          </a:effectLst>
-        </p:spPr>
-      </p:sp>
-      <p:pic>
-        <p:nvPicPr>
-          <p:cNvPr id="4" name="Image 1" descr="preencoded.png">    </p:cNvPr>
-          <p:cNvPicPr>
-            <a:picLocks noChangeAspect="1"/>
-          </p:cNvPicPr>
-          <p:nvPr/>
-        </p:nvPicPr>
-        <p:blipFill>
-          <a:blip r:embed="rId3">
-            <a:extLst>
-              <a:ext uri="{96DAC541-7B7A-43D3-8B79-37D633B846F1}">
-                <asvg:svgBlip xmlns:asvg="http://schemas.microsoft.com/office/drawing/2016/SVG/main" r:embed="rId4"/>
-              </a:ext>
-            </a:extLst>
-          </a:blip>
-          <a:stretch>
-            <a:fillRect/>
-          </a:stretch>
-        </p:blipFill>
-        <p:spPr>
-          <a:xfrm>
-            <a:off x="6309360" y="1463040"/>
-            <a:ext cx="5029200" cy="1920240"/>
-          </a:xfrm>
-          <a:prstGeom prst="rect">
-            <a:avLst/>
-          </a:prstGeom>
-        </p:spPr>
-      </p:pic>
-      <p:sp>
-        <p:nvSpPr>
-          <p:cNvPr id="5" name="Shape 1"/>
-          <p:cNvSpPr/>
-          <p:nvPr/>
-        </p:nvSpPr>
-        <p:spPr>
-          <a:xfrm>
-            <a:off x="6309360" y="1463040"/>
-            <a:ext cx="5029200" cy="1920240"/>
-          </a:xfrm>
-          <a:prstGeom prst="rect">
-            <a:avLst/>
-          </a:prstGeom>
-          <a:solidFill>
-            <a:srgbClr val="FFFFFF">
-              <a:alpha val="0"/>
-            </a:srgbClr>
-          </a:solidFill>
-          <a:ln w="12700">
-            <a:solidFill>
-              <a:srgbClr val="E2E8F0">
-                <a:alpha val="0"/>
-              </a:srgbClr>
-            </a:solidFill>
-            <a:prstDash val="solid"/>
-          </a:ln>
-          <a:effectLst>
-            <a:outerShdw sx="100000" sy="100000" kx="0" ky="0" algn="bl" rotWithShape="0" blurRad="12700" dist="50800" dir="2700000">
-              <a:srgbClr val="000000">
-                <a:alpha val="8000"/>
-              </a:srgbClr>
-            </a:outerShdw>
-          </a:effectLst>
-        </p:spPr>
-      </p:sp>
-      <p:pic>
-        <p:nvPicPr>
-          <p:cNvPr id="6" name="Image 2" descr="preencoded.png">    </p:cNvPr>
-          <p:cNvPicPr>
-            <a:picLocks noChangeAspect="1"/>
-          </p:cNvPicPr>
-          <p:nvPr/>
-        </p:nvPicPr>
-        <p:blipFill>
-          <a:blip r:embed="rId5">
-            <a:extLst>
-              <a:ext uri="{96DAC541-7B7A-43D3-8B79-37D633B846F1}">
-                <asvg:svgBlip xmlns:asvg="http://schemas.microsoft.com/office/drawing/2016/SVG/main" r:embed="rId6"/>
-              </a:ext>
-            </a:extLst>
-          </a:blip>
-          <a:stretch>
-            <a:fillRect/>
-          </a:stretch>
-        </p:blipFill>
-        <p:spPr>
-          <a:xfrm>
-            <a:off x="822960" y="3749040"/>
-            <a:ext cx="5029200" cy="1920240"/>
-          </a:xfrm>
-          <a:prstGeom prst="rect">
-            <a:avLst/>
-          </a:prstGeom>
-        </p:spPr>
-      </p:pic>
-      <p:sp>
-        <p:nvSpPr>
-          <p:cNvPr id="7" name="Shape 2"/>
-          <p:cNvSpPr/>
-          <p:nvPr/>
-        </p:nvSpPr>
-        <p:spPr>
-          <a:xfrm>
-            <a:off x="822960" y="3749040"/>
-            <a:ext cx="5029200" cy="1920240"/>
-          </a:xfrm>
-          <a:prstGeom prst="rect">
-            <a:avLst/>
-          </a:prstGeom>
-          <a:solidFill>
-            <a:srgbClr val="FFFFFF">
-              <a:alpha val="0"/>
-            </a:srgbClr>
-          </a:solidFill>
-          <a:ln w="12700">
-            <a:solidFill>
-              <a:srgbClr val="E2E8F0">
-                <a:alpha val="0"/>
-              </a:srgbClr>
-            </a:solidFill>
-            <a:prstDash val="solid"/>
-          </a:ln>
-          <a:effectLst>
-            <a:outerShdw sx="100000" sy="100000" kx="0" ky="0" algn="bl" rotWithShape="0" blurRad="12700" dist="50800" dir="2700000">
-              <a:srgbClr val="000000">
-                <a:alpha val="8000"/>
-              </a:srgbClr>
-            </a:outerShdw>
-          </a:effectLst>
-        </p:spPr>
-      </p:sp>
-      <p:pic>
-        <p:nvPicPr>
-          <p:cNvPr id="8" name="Image 3" descr="preencoded.png">    </p:cNvPr>
-          <p:cNvPicPr>
-            <a:picLocks noChangeAspect="1"/>
-          </p:cNvPicPr>
-          <p:nvPr/>
-        </p:nvPicPr>
-        <p:blipFill>
-          <a:blip r:embed="rId7">
-            <a:extLst>
-              <a:ext uri="{96DAC541-7B7A-43D3-8B79-37D633B846F1}">
-                <asvg:svgBlip xmlns:asvg="http://schemas.microsoft.com/office/drawing/2016/SVG/main" r:embed="rId8"/>
-              </a:ext>
-            </a:extLst>
-          </a:blip>
-          <a:stretch>
-            <a:fillRect/>
-          </a:stretch>
-        </p:blipFill>
-        <p:spPr>
-          <a:xfrm>
-            <a:off x="6309360" y="3749040"/>
-            <a:ext cx="5029200" cy="1920240"/>
-          </a:xfrm>
-          <a:prstGeom prst="rect">
-            <a:avLst/>
-          </a:prstGeom>
-        </p:spPr>
-      </p:pic>
-      <p:sp>
-        <p:nvSpPr>
-          <p:cNvPr id="9" name="Shape 3"/>
-          <p:cNvSpPr/>
-          <p:nvPr/>
-        </p:nvSpPr>
-        <p:spPr>
-          <a:xfrm>
-            <a:off x="6309360" y="3749040"/>
-            <a:ext cx="5029200" cy="1920240"/>
-          </a:xfrm>
-          <a:prstGeom prst="rect">
-            <a:avLst/>
-          </a:prstGeom>
-          <a:solidFill>
-            <a:srgbClr val="FFFFFF">
-              <a:alpha val="0"/>
-            </a:srgbClr>
-          </a:solidFill>
-          <a:ln w="12700">
-            <a:solidFill>
-              <a:srgbClr val="E2E8F0">
-                <a:alpha val="0"/>
-              </a:srgbClr>
-            </a:solidFill>
-            <a:prstDash val="solid"/>
-          </a:ln>
-          <a:effectLst>
-            <a:outerShdw sx="100000" sy="100000" kx="0" ky="0" algn="bl" rotWithShape="0" blurRad="12700" dist="50800" dir="2700000">
-              <a:srgbClr val="000000">
-                <a:alpha val="8000"/>
-              </a:srgbClr>
-            </a:outerShdw>
-          </a:effectLst>
-        </p:spPr>
-      </p:sp>
-      <p:sp>
-        <p:nvSpPr>
-          <p:cNvPr id="10" name="Shape 4"/>
-          <p:cNvSpPr/>
-          <p:nvPr/>
-        </p:nvSpPr>
-        <p:spPr>
-          <a:xfrm>
-            <a:off x="822960" y="1463040"/>
-            <a:ext cx="73152" cy="1920240"/>
+            <a:off x="685800" y="2103120"/>
+            <a:ext cx="73152" cy="2240280"/>
           </a:xfrm>
           <a:prstGeom prst="rect">
             <a:avLst/>
@@ -13568,14 +12140,14 @@
       </p:sp>
       <p:sp>
         <p:nvSpPr>
-          <p:cNvPr id="11" name="Shape 5"/>
+          <p:cNvPr id="3" name="Shape 1"/>
           <p:cNvSpPr/>
           <p:nvPr/>
         </p:nvSpPr>
         <p:spPr>
           <a:xfrm>
-            <a:off x="6309360" y="1463040"/>
-            <a:ext cx="73152" cy="1920240"/>
+            <a:off x="3520440" y="2103120"/>
+            <a:ext cx="73152" cy="2240280"/>
           </a:xfrm>
           <a:prstGeom prst="rect">
             <a:avLst/>
@@ -13595,14 +12167,14 @@
       </p:sp>
       <p:sp>
         <p:nvSpPr>
-          <p:cNvPr id="12" name="Shape 6"/>
+          <p:cNvPr id="4" name="Shape 2"/>
           <p:cNvSpPr/>
           <p:nvPr/>
         </p:nvSpPr>
         <p:spPr>
           <a:xfrm>
-            <a:off x="822960" y="3749040"/>
-            <a:ext cx="73152" cy="1920240"/>
+            <a:off x="6355080" y="2103120"/>
+            <a:ext cx="73152" cy="2240280"/>
           </a:xfrm>
           <a:prstGeom prst="rect">
             <a:avLst/>
@@ -13622,14 +12194,14 @@
       </p:sp>
       <p:sp>
         <p:nvSpPr>
-          <p:cNvPr id="13" name="Shape 7"/>
+          <p:cNvPr id="5" name="Shape 3"/>
           <p:cNvSpPr/>
           <p:nvPr/>
         </p:nvSpPr>
         <p:spPr>
           <a:xfrm>
-            <a:off x="6309360" y="3749040"/>
-            <a:ext cx="73152" cy="1920240"/>
+            <a:off x="9189720" y="2103120"/>
+            <a:ext cx="73152" cy="2240280"/>
           </a:xfrm>
           <a:prstGeom prst="rect">
             <a:avLst/>
@@ -13649,7 +12221,7 @@
       </p:sp>
       <p:sp>
         <p:nvSpPr>
-          <p:cNvPr id="14" name="mdpr:2-2-447582:title:__title:2-2-447582"/>
+          <p:cNvPr id="6" name="mdpr:2-2-447582:title:__title:2-2-447582"/>
           <p:cNvSpPr txBox="1"/>
           <p:nvPr/>
         </p:nvSpPr>
@@ -13683,7 +12255,24 @@
                 <a:ea typeface="Pretendard" pitchFamily="34" charset="-122"/>
                 <a:cs typeface="Pretendard" pitchFamily="34" charset="-120"/>
               </a:rPr>
-              <a:t>Example: examples/comparison/deck.md (Cont. 2/2)</a:t>
+              <a:t>Example: examples/comparison/deck.md</a:t>
+            </a:r>
+            <a:pPr algn="ctr" indent="0" marL="0">
+              <a:lnSpc>
+                <a:spcPct val="120000"/>
+              </a:lnSpc>
+              <a:buNone/>
+            </a:pPr>
+            <a:r>
+              <a:rPr lang="en-US" sz="2000" dirty="0">
+                <a:solidFill>
+                  <a:srgbClr val="919191"/>
+                </a:solidFill>
+                <a:latin typeface="Pretendard" pitchFamily="34" charset="0"/>
+                <a:ea typeface="Pretendard" pitchFamily="34" charset="-122"/>
+                <a:cs typeface="Pretendard" pitchFamily="34" charset="-120"/>
+              </a:rPr>
+              <a:t> (Cont. 2/2)</a:t>
             </a:r>
             <a:endParaRPr lang="en-US" sz="3400" dirty="0"/>
           </a:p>
@@ -13691,14 +12280,14 @@
       </p:sp>
       <p:sp>
         <p:nvSpPr>
-          <p:cNvPr id="15" name="mdpr:2-2-447582:item-1:block-30-chunk-2"/>
+          <p:cNvPr id="7" name="mdpr:2-2-447582:item-1:block-30-chunk-2"/>
           <p:cNvSpPr txBox="1"/>
           <p:nvPr/>
         </p:nvSpPr>
         <p:spPr>
           <a:xfrm>
-            <a:off x="1042416" y="2209800"/>
-            <a:ext cx="4608576" cy="426720"/>
+            <a:off x="905256" y="2674620"/>
+            <a:ext cx="1911096" cy="1097280"/>
           </a:xfrm>
           <a:prstGeom prst="rect">
             <a:avLst/>
@@ -13733,14 +12322,14 @@
       </p:sp>
       <p:sp>
         <p:nvSpPr>
-          <p:cNvPr id="16" name="mdpr:2-2-447582:item-2:block-30-chunk-2"/>
+          <p:cNvPr id="8" name="mdpr:2-2-447582:item-2:block-30-chunk-2"/>
           <p:cNvSpPr txBox="1"/>
           <p:nvPr/>
         </p:nvSpPr>
         <p:spPr>
           <a:xfrm>
-            <a:off x="6528816" y="2209800"/>
-            <a:ext cx="4608576" cy="426720"/>
+            <a:off x="3739896" y="2842260"/>
+            <a:ext cx="1911096" cy="762000"/>
           </a:xfrm>
           <a:prstGeom prst="rect">
             <a:avLst/>
@@ -13775,14 +12364,14 @@
       </p:sp>
       <p:sp>
         <p:nvSpPr>
-          <p:cNvPr id="17" name="mdpr:2-2-447582:item-3:block-30-chunk-2"/>
+          <p:cNvPr id="9" name="mdpr:2-2-447582:item-3:block-30-chunk-2"/>
           <p:cNvSpPr txBox="1"/>
           <p:nvPr/>
         </p:nvSpPr>
         <p:spPr>
           <a:xfrm>
-            <a:off x="1042416" y="4495800"/>
-            <a:ext cx="4608576" cy="426720"/>
+            <a:off x="6574536" y="2842260"/>
+            <a:ext cx="1911096" cy="762000"/>
           </a:xfrm>
           <a:prstGeom prst="rect">
             <a:avLst/>
@@ -13817,14 +12406,14 @@
       </p:sp>
       <p:sp>
         <p:nvSpPr>
-          <p:cNvPr id="18" name="mdpr:2-2-447582:item-4:block-30-chunk-2"/>
+          <p:cNvPr id="10" name="mdpr:2-2-447582:item-4:block-30-chunk-2"/>
           <p:cNvSpPr txBox="1"/>
           <p:nvPr/>
         </p:nvSpPr>
         <p:spPr>
           <a:xfrm>
-            <a:off x="6528816" y="4328160"/>
-            <a:ext cx="4608576" cy="762000"/>
+            <a:off x="9409176" y="2674620"/>
+            <a:ext cx="1911096" cy="1097280"/>
           </a:xfrm>
           <a:prstGeom prst="rect">
             <a:avLst/>
@@ -14503,243 +13092,16 @@
           <a:chExt cx="0" cy="0"/>
         </a:xfrm>
       </p:grpSpPr>
-      <p:pic>
-        <p:nvPicPr>
-          <p:cNvPr id="2" name="Image 0" descr="preencoded.png">    </p:cNvPr>
-          <p:cNvPicPr>
-            <a:picLocks noChangeAspect="1"/>
-          </p:cNvPicPr>
-          <p:nvPr/>
-        </p:nvPicPr>
-        <p:blipFill>
-          <a:blip r:embed="rId1">
-            <a:extLst>
-              <a:ext uri="{96DAC541-7B7A-43D3-8B79-37D633B846F1}">
-                <asvg:svgBlip xmlns:asvg="http://schemas.microsoft.com/office/drawing/2016/SVG/main" r:embed="rId2"/>
-              </a:ext>
-            </a:extLst>
-          </a:blip>
-          <a:stretch>
-            <a:fillRect/>
-          </a:stretch>
-        </p:blipFill>
-        <p:spPr>
-          <a:xfrm>
-            <a:off x="914400" y="1865376"/>
-            <a:ext cx="10241280" cy="1024128"/>
-          </a:xfrm>
-          <a:prstGeom prst="rect">
-            <a:avLst/>
-          </a:prstGeom>
-        </p:spPr>
-      </p:pic>
-      <p:sp>
-        <p:nvSpPr>
-          <p:cNvPr id="3" name="Shape 0"/>
+      <p:sp>
+        <p:nvSpPr>
+          <p:cNvPr id="2" name="Shape 0"/>
           <p:cNvSpPr/>
           <p:nvPr/>
         </p:nvSpPr>
         <p:spPr>
           <a:xfrm>
-            <a:off x="914400" y="1865376"/>
-            <a:ext cx="10241280" cy="1024128"/>
-          </a:xfrm>
-          <a:prstGeom prst="rect">
-            <a:avLst/>
-          </a:prstGeom>
-          <a:solidFill>
-            <a:srgbClr val="FFFFFF">
-              <a:alpha val="0"/>
-            </a:srgbClr>
-          </a:solidFill>
-          <a:ln w="12700">
-            <a:solidFill>
-              <a:srgbClr val="E2E8F0">
-                <a:alpha val="0"/>
-              </a:srgbClr>
-            </a:solidFill>
-            <a:prstDash val="solid"/>
-          </a:ln>
-          <a:effectLst>
-            <a:outerShdw sx="100000" sy="100000" kx="0" ky="0" algn="bl" rotWithShape="0" blurRad="12700" dist="50800" dir="2700000">
-              <a:srgbClr val="000000">
-                <a:alpha val="8000"/>
-              </a:srgbClr>
-            </a:outerShdw>
-          </a:effectLst>
-        </p:spPr>
-      </p:sp>
-      <p:pic>
-        <p:nvPicPr>
-          <p:cNvPr id="4" name="Image 1" descr="preencoded.png">    </p:cNvPr>
-          <p:cNvPicPr>
-            <a:picLocks noChangeAspect="1"/>
-          </p:cNvPicPr>
-          <p:nvPr/>
-        </p:nvPicPr>
-        <p:blipFill>
-          <a:blip r:embed="rId3">
-            <a:extLst>
-              <a:ext uri="{96DAC541-7B7A-43D3-8B79-37D633B846F1}">
-                <asvg:svgBlip xmlns:asvg="http://schemas.microsoft.com/office/drawing/2016/SVG/main" r:embed="rId4"/>
-              </a:ext>
-            </a:extLst>
-          </a:blip>
-          <a:stretch>
-            <a:fillRect/>
-          </a:stretch>
-        </p:blipFill>
-        <p:spPr>
-          <a:xfrm>
-            <a:off x="914400" y="3191256"/>
-            <a:ext cx="10241280" cy="1024128"/>
-          </a:xfrm>
-          <a:prstGeom prst="rect">
-            <a:avLst/>
-          </a:prstGeom>
-        </p:spPr>
-      </p:pic>
-      <p:sp>
-        <p:nvSpPr>
-          <p:cNvPr id="5" name="Shape 1"/>
-          <p:cNvSpPr/>
-          <p:nvPr/>
-        </p:nvSpPr>
-        <p:spPr>
-          <a:xfrm>
-            <a:off x="914400" y="3191256"/>
-            <a:ext cx="10241280" cy="1024128"/>
-          </a:xfrm>
-          <a:prstGeom prst="rect">
-            <a:avLst/>
-          </a:prstGeom>
-          <a:solidFill>
-            <a:srgbClr val="FFFFFF">
-              <a:alpha val="0"/>
-            </a:srgbClr>
-          </a:solidFill>
-          <a:ln w="12700">
-            <a:solidFill>
-              <a:srgbClr val="E2E8F0">
-                <a:alpha val="0"/>
-              </a:srgbClr>
-            </a:solidFill>
-            <a:prstDash val="solid"/>
-          </a:ln>
-          <a:effectLst>
-            <a:outerShdw sx="100000" sy="100000" kx="0" ky="0" algn="bl" rotWithShape="0" blurRad="12700" dist="50800" dir="2700000">
-              <a:srgbClr val="000000">
-                <a:alpha val="8000"/>
-              </a:srgbClr>
-            </a:outerShdw>
-          </a:effectLst>
-        </p:spPr>
-      </p:sp>
-      <p:pic>
-        <p:nvPicPr>
-          <p:cNvPr id="6" name="Image 2" descr="preencoded.png">    </p:cNvPr>
-          <p:cNvPicPr>
-            <a:picLocks noChangeAspect="1"/>
-          </p:cNvPicPr>
-          <p:nvPr/>
-        </p:nvPicPr>
-        <p:blipFill>
-          <a:blip r:embed="rId5">
-            <a:extLst>
-              <a:ext uri="{96DAC541-7B7A-43D3-8B79-37D633B846F1}">
-                <asvg:svgBlip xmlns:asvg="http://schemas.microsoft.com/office/drawing/2016/SVG/main" r:embed="rId6"/>
-              </a:ext>
-            </a:extLst>
-          </a:blip>
-          <a:stretch>
-            <a:fillRect/>
-          </a:stretch>
-        </p:blipFill>
-        <p:spPr>
-          <a:xfrm>
-            <a:off x="914400" y="4507992"/>
-            <a:ext cx="10241280" cy="1024128"/>
-          </a:xfrm>
-          <a:prstGeom prst="rect">
-            <a:avLst/>
-          </a:prstGeom>
-        </p:spPr>
-      </p:pic>
-      <p:sp>
-        <p:nvSpPr>
-          <p:cNvPr id="7" name="Shape 2"/>
-          <p:cNvSpPr/>
-          <p:nvPr/>
-        </p:nvSpPr>
-        <p:spPr>
-          <a:xfrm>
-            <a:off x="914400" y="4507992"/>
-            <a:ext cx="10241280" cy="1024128"/>
-          </a:xfrm>
-          <a:prstGeom prst="rect">
-            <a:avLst/>
-          </a:prstGeom>
-          <a:solidFill>
-            <a:srgbClr val="FFFFFF">
-              <a:alpha val="0"/>
-            </a:srgbClr>
-          </a:solidFill>
-          <a:ln w="12700">
-            <a:solidFill>
-              <a:srgbClr val="E2E8F0">
-                <a:alpha val="0"/>
-              </a:srgbClr>
-            </a:solidFill>
-            <a:prstDash val="solid"/>
-          </a:ln>
-          <a:effectLst>
-            <a:outerShdw sx="100000" sy="100000" kx="0" ky="0" algn="bl" rotWithShape="0" blurRad="12700" dist="50800" dir="2700000">
-              <a:srgbClr val="000000">
-                <a:alpha val="8000"/>
-              </a:srgbClr>
-            </a:outerShdw>
-          </a:effectLst>
-        </p:spPr>
-      </p:sp>
-      <p:sp>
-        <p:nvSpPr>
-          <p:cNvPr id="8" name="Shape 3"/>
-          <p:cNvSpPr/>
-          <p:nvPr/>
-        </p:nvSpPr>
-        <p:spPr>
-          <a:xfrm>
-            <a:off x="786384" y="1956816"/>
-            <a:ext cx="32004" cy="3483864"/>
-          </a:xfrm>
-          <a:prstGeom prst="rect">
-            <a:avLst/>
-          </a:prstGeom>
-          <a:solidFill>
-            <a:srgbClr val="DBEAFE">
-              <a:alpha val="80000"/>
-            </a:srgbClr>
-          </a:solidFill>
-          <a:ln w="12700">
-            <a:solidFill>
-              <a:srgbClr val="DBEAFE">
-                <a:alpha val="0"/>
-              </a:srgbClr>
-            </a:solidFill>
-            <a:prstDash val="solid"/>
-          </a:ln>
-        </p:spPr>
-      </p:sp>
-      <p:sp>
-        <p:nvSpPr>
-          <p:cNvPr id="9" name="Shape 4"/>
-          <p:cNvSpPr/>
-          <p:nvPr/>
-        </p:nvSpPr>
-        <p:spPr>
-          <a:xfrm>
-            <a:off x="914400" y="1865376"/>
-            <a:ext cx="73152" cy="1024128"/>
+            <a:off x="822960" y="1938528"/>
+            <a:ext cx="73152" cy="2514600"/>
           </a:xfrm>
           <a:prstGeom prst="rect">
             <a:avLst/>
@@ -14759,14 +13121,14 @@
       </p:sp>
       <p:sp>
         <p:nvSpPr>
-          <p:cNvPr id="10" name="Shape 5"/>
+          <p:cNvPr id="3" name="Shape 1"/>
           <p:cNvSpPr/>
           <p:nvPr/>
         </p:nvSpPr>
         <p:spPr>
           <a:xfrm>
-            <a:off x="914400" y="3191256"/>
-            <a:ext cx="73152" cy="1024128"/>
+            <a:off x="4343400" y="1938528"/>
+            <a:ext cx="73152" cy="2514600"/>
           </a:xfrm>
           <a:prstGeom prst="rect">
             <a:avLst/>
@@ -14786,14 +13148,14 @@
       </p:sp>
       <p:sp>
         <p:nvSpPr>
-          <p:cNvPr id="11" name="Shape 6"/>
+          <p:cNvPr id="4" name="Shape 2"/>
           <p:cNvSpPr/>
           <p:nvPr/>
         </p:nvSpPr>
         <p:spPr>
           <a:xfrm>
-            <a:off x="914400" y="4507992"/>
-            <a:ext cx="73152" cy="1024128"/>
+            <a:off x="7863840" y="1938528"/>
+            <a:ext cx="73152" cy="2514600"/>
           </a:xfrm>
           <a:prstGeom prst="rect">
             <a:avLst/>
@@ -14813,7 +13175,7 @@
       </p:sp>
       <p:sp>
         <p:nvSpPr>
-          <p:cNvPr id="12" name="mdpr:2-2-a2c94a:title:__title:2-2-a2c94a"/>
+          <p:cNvPr id="5" name="mdpr:2-2-a2c94a:title:__title:2-2-a2c94a"/>
           <p:cNvSpPr txBox="1"/>
           <p:nvPr/>
         </p:nvSpPr>
@@ -14847,7 +13209,24 @@
                 <a:ea typeface="Pretendard" pitchFamily="34" charset="-122"/>
                 <a:cs typeface="Pretendard" pitchFamily="34" charset="-120"/>
               </a:rPr>
-              <a:t>Example: examples/pipeline/deck.md (Cont. 2/2)</a:t>
+              <a:t>Example: examples/pipeline/deck.md</a:t>
+            </a:r>
+            <a:pPr algn="ctr" indent="0" marL="0">
+              <a:lnSpc>
+                <a:spcPct val="120000"/>
+              </a:lnSpc>
+              <a:buNone/>
+            </a:pPr>
+            <a:r>
+              <a:rPr lang="en-US" sz="2000" dirty="0">
+                <a:solidFill>
+                  <a:srgbClr val="919191"/>
+                </a:solidFill>
+                <a:latin typeface="Pretendard" pitchFamily="34" charset="0"/>
+                <a:ea typeface="Pretendard" pitchFamily="34" charset="-122"/>
+                <a:cs typeface="Pretendard" pitchFamily="34" charset="-120"/>
+              </a:rPr>
+              <a:t> (Cont. 2/2)</a:t>
             </a:r>
             <a:endParaRPr lang="en-US" sz="3400" dirty="0"/>
           </a:p>
@@ -14855,14 +13234,14 @@
       </p:sp>
       <p:sp>
         <p:nvSpPr>
-          <p:cNvPr id="13" name="mdpr:2-2-a2c94a:item-1:block-32-chunk-2"/>
+          <p:cNvPr id="6" name="mdpr:2-2-a2c94a:item-1:block-32-chunk-2"/>
           <p:cNvSpPr txBox="1"/>
           <p:nvPr/>
         </p:nvSpPr>
         <p:spPr>
           <a:xfrm>
-            <a:off x="1133856" y="2164080"/>
-            <a:ext cx="9820656" cy="426720"/>
+            <a:off x="1042416" y="2982468"/>
+            <a:ext cx="2825496" cy="426720"/>
           </a:xfrm>
           <a:prstGeom prst="rect">
             <a:avLst/>
@@ -14897,14 +13276,14 @@
       </p:sp>
       <p:sp>
         <p:nvSpPr>
-          <p:cNvPr id="14" name="mdpr:2-2-a2c94a:item-2:block-32-chunk-2"/>
+          <p:cNvPr id="7" name="mdpr:2-2-a2c94a:item-2:block-32-chunk-2"/>
           <p:cNvSpPr txBox="1"/>
           <p:nvPr/>
         </p:nvSpPr>
         <p:spPr>
           <a:xfrm>
-            <a:off x="1133856" y="3489960"/>
-            <a:ext cx="9820656" cy="426720"/>
+            <a:off x="4562856" y="2982468"/>
+            <a:ext cx="2825496" cy="426720"/>
           </a:xfrm>
           <a:prstGeom prst="rect">
             <a:avLst/>
@@ -14939,14 +13318,14 @@
       </p:sp>
       <p:sp>
         <p:nvSpPr>
-          <p:cNvPr id="15" name="mdpr:2-2-a2c94a:item-3:block-32-chunk-2"/>
+          <p:cNvPr id="8" name="mdpr:2-2-a2c94a:item-3:block-32-chunk-2"/>
           <p:cNvSpPr txBox="1"/>
           <p:nvPr/>
         </p:nvSpPr>
         <p:spPr>
           <a:xfrm>
-            <a:off x="1133856" y="4806696"/>
-            <a:ext cx="9820656" cy="426720"/>
+            <a:off x="8083296" y="2982468"/>
+            <a:ext cx="2825496" cy="426720"/>
           </a:xfrm>
           <a:prstGeom prst="rect">
             <a:avLst/>
@@ -15903,35 +14282,6 @@
         </p:nvSpPr>
         <p:spPr>
           <a:xfrm>
-            <a:off x="6080760" y="1737360"/>
-            <a:ext cx="22860" cy="3968496"/>
-          </a:xfrm>
-          <a:prstGeom prst="rect">
-            <a:avLst/>
-          </a:prstGeom>
-          <a:solidFill>
-            <a:srgbClr val="E2E8F0">
-              <a:alpha val="90000"/>
-            </a:srgbClr>
-          </a:solidFill>
-          <a:ln w="12700">
-            <a:solidFill>
-              <a:srgbClr val="E2E8F0">
-                <a:alpha val="0"/>
-              </a:srgbClr>
-            </a:solidFill>
-            <a:prstDash val="solid"/>
-          </a:ln>
-        </p:spPr>
-      </p:sp>
-      <p:sp>
-        <p:nvSpPr>
-          <p:cNvPr id="3" name="Shape 1"/>
-          <p:cNvSpPr/>
-          <p:nvPr/>
-        </p:nvSpPr>
-        <p:spPr>
-          <a:xfrm>
             <a:off x="822960" y="1737360"/>
             <a:ext cx="73152" cy="841248"/>
           </a:xfrm>
@@ -15953,7 +14303,7 @@
       </p:sp>
       <p:sp>
         <p:nvSpPr>
-          <p:cNvPr id="4" name="Shape 2"/>
+          <p:cNvPr id="3" name="Shape 1"/>
           <p:cNvSpPr/>
           <p:nvPr/>
         </p:nvSpPr>
@@ -15980,7 +14330,7 @@
       </p:sp>
       <p:sp>
         <p:nvSpPr>
-          <p:cNvPr id="5" name="Shape 3"/>
+          <p:cNvPr id="4" name="Shape 2"/>
           <p:cNvSpPr/>
           <p:nvPr/>
         </p:nvSpPr>
@@ -16007,7 +14357,7 @@
       </p:sp>
       <p:sp>
         <p:nvSpPr>
-          <p:cNvPr id="6" name="Shape 4"/>
+          <p:cNvPr id="5" name="Shape 3"/>
           <p:cNvSpPr/>
           <p:nvPr/>
         </p:nvSpPr>
@@ -16034,7 +14384,7 @@
       </p:sp>
       <p:sp>
         <p:nvSpPr>
-          <p:cNvPr id="7" name="Shape 5"/>
+          <p:cNvPr id="6" name="Shape 4"/>
           <p:cNvSpPr/>
           <p:nvPr/>
         </p:nvSpPr>
@@ -16061,7 +14411,7 @@
       </p:sp>
       <p:sp>
         <p:nvSpPr>
-          <p:cNvPr id="8" name="Shape 6"/>
+          <p:cNvPr id="7" name="Shape 5"/>
           <p:cNvSpPr/>
           <p:nvPr/>
         </p:nvSpPr>
@@ -16088,7 +14438,7 @@
       </p:sp>
       <p:sp>
         <p:nvSpPr>
-          <p:cNvPr id="9" name="Shape 7"/>
+          <p:cNvPr id="8" name="Shape 6"/>
           <p:cNvSpPr/>
           <p:nvPr/>
         </p:nvSpPr>
@@ -16115,7 +14465,7 @@
       </p:sp>
       <p:sp>
         <p:nvSpPr>
-          <p:cNvPr id="10" name="Shape 8"/>
+          <p:cNvPr id="9" name="Shape 7"/>
           <p:cNvSpPr/>
           <p:nvPr/>
         </p:nvSpPr>
@@ -16142,7 +14492,7 @@
       </p:sp>
       <p:sp>
         <p:nvSpPr>
-          <p:cNvPr id="11" name="mdpr:2-2-7bfb60:title:__title:2-2-7bfb60"/>
+          <p:cNvPr id="10" name="mdpr:2-2-7bfb60:title:__title:2-2-7bfb60"/>
           <p:cNvSpPr txBox="1"/>
           <p:nvPr/>
         </p:nvSpPr>
@@ -16176,7 +14526,24 @@
                 <a:ea typeface="Pretendard" pitchFamily="34" charset="-122"/>
                 <a:cs typeface="Pretendard" pitchFamily="34" charset="-120"/>
               </a:rPr>
-              <a:t>Agenda (Cont. 2/2)</a:t>
+              <a:t>Agenda</a:t>
+            </a:r>
+            <a:pPr algn="ctr" indent="0" marL="0">
+              <a:lnSpc>
+                <a:spcPct val="120000"/>
+              </a:lnSpc>
+              <a:buNone/>
+            </a:pPr>
+            <a:r>
+              <a:rPr lang="en-US" sz="2300" dirty="0">
+                <a:solidFill>
+                  <a:srgbClr val="919191"/>
+                </a:solidFill>
+                <a:latin typeface="Pretendard" pitchFamily="34" charset="0"/>
+                <a:ea typeface="Pretendard" pitchFamily="34" charset="-122"/>
+                <a:cs typeface="Pretendard" pitchFamily="34" charset="-120"/>
+              </a:rPr>
+              <a:t> (Cont. 2/2)</a:t>
             </a:r>
             <a:endParaRPr lang="en-US" sz="3800" dirty="0"/>
           </a:p>
@@ -16184,7 +14551,7 @@
       </p:sp>
       <p:sp>
         <p:nvSpPr>
-          <p:cNvPr id="12" name="mdpr:2-2-7bfb60:toc-item-1:toc-item-9"/>
+          <p:cNvPr id="11" name="mdpr:2-2-7bfb60:toc-item-1:toc-item-9"/>
           <p:cNvSpPr txBox="1"/>
           <p:nvPr/>
         </p:nvSpPr>
@@ -16226,7 +14593,7 @@
       </p:sp>
       <p:sp>
         <p:nvSpPr>
-          <p:cNvPr id="13" name="mdpr:2-2-7bfb60:toc-item-2:toc-item-10"/>
+          <p:cNvPr id="12" name="mdpr:2-2-7bfb60:toc-item-2:toc-item-10"/>
           <p:cNvSpPr txBox="1"/>
           <p:nvPr/>
         </p:nvSpPr>
@@ -16268,7 +14635,7 @@
       </p:sp>
       <p:sp>
         <p:nvSpPr>
-          <p:cNvPr id="14" name="mdpr:2-2-7bfb60:toc-item-3:toc-item-11"/>
+          <p:cNvPr id="13" name="mdpr:2-2-7bfb60:toc-item-3:toc-item-11"/>
           <p:cNvSpPr txBox="1"/>
           <p:nvPr/>
         </p:nvSpPr>
@@ -16310,7 +14677,7 @@
       </p:sp>
       <p:sp>
         <p:nvSpPr>
-          <p:cNvPr id="15" name="mdpr:2-2-7bfb60:toc-item-4:toc-item-12"/>
+          <p:cNvPr id="14" name="mdpr:2-2-7bfb60:toc-item-4:toc-item-12"/>
           <p:cNvSpPr txBox="1"/>
           <p:nvPr/>
         </p:nvSpPr>
@@ -16352,7 +14719,7 @@
       </p:sp>
       <p:sp>
         <p:nvSpPr>
-          <p:cNvPr id="16" name="mdpr:2-2-7bfb60:toc-item-5:toc-item-13"/>
+          <p:cNvPr id="15" name="mdpr:2-2-7bfb60:toc-item-5:toc-item-13"/>
           <p:cNvSpPr txBox="1"/>
           <p:nvPr/>
         </p:nvSpPr>
@@ -16394,7 +14761,7 @@
       </p:sp>
       <p:sp>
         <p:nvSpPr>
-          <p:cNvPr id="17" name="mdpr:2-2-7bfb60:toc-item-6:toc-item-14"/>
+          <p:cNvPr id="16" name="mdpr:2-2-7bfb60:toc-item-6:toc-item-14"/>
           <p:cNvSpPr txBox="1"/>
           <p:nvPr/>
         </p:nvSpPr>
@@ -16436,7 +14803,7 @@
       </p:sp>
       <p:sp>
         <p:nvSpPr>
-          <p:cNvPr id="18" name="mdpr:2-2-7bfb60:toc-item-7:toc-item-15"/>
+          <p:cNvPr id="17" name="mdpr:2-2-7bfb60:toc-item-7:toc-item-15"/>
           <p:cNvSpPr txBox="1"/>
           <p:nvPr/>
         </p:nvSpPr>
@@ -16478,7 +14845,7 @@
       </p:sp>
       <p:sp>
         <p:nvSpPr>
-          <p:cNvPr id="19" name="mdpr:2-2-7bfb60:toc-item-8:toc-item-16"/>
+          <p:cNvPr id="18" name="mdpr:2-2-7bfb60:toc-item-8:toc-item-16"/>
           <p:cNvSpPr txBox="1"/>
           <p:nvPr/>
         </p:nvSpPr>
@@ -18048,243 +16415,16 @@
           <a:chExt cx="0" cy="0"/>
         </a:xfrm>
       </p:grpSpPr>
-      <p:pic>
-        <p:nvPicPr>
-          <p:cNvPr id="2" name="Image 0" descr="preencoded.png">    </p:cNvPr>
-          <p:cNvPicPr>
-            <a:picLocks noChangeAspect="1"/>
-          </p:cNvPicPr>
-          <p:nvPr/>
-        </p:nvPicPr>
-        <p:blipFill>
-          <a:blip r:embed="rId1">
-            <a:extLst>
-              <a:ext uri="{96DAC541-7B7A-43D3-8B79-37D633B846F1}">
-                <asvg:svgBlip xmlns:asvg="http://schemas.microsoft.com/office/drawing/2016/SVG/main" r:embed="rId2"/>
-              </a:ext>
-            </a:extLst>
-          </a:blip>
-          <a:stretch>
-            <a:fillRect/>
-          </a:stretch>
-        </p:blipFill>
-        <p:spPr>
-          <a:xfrm>
-            <a:off x="914400" y="1865376"/>
-            <a:ext cx="10241280" cy="1024128"/>
-          </a:xfrm>
-          <a:prstGeom prst="rect">
-            <a:avLst/>
-          </a:prstGeom>
-        </p:spPr>
-      </p:pic>
-      <p:sp>
-        <p:nvSpPr>
-          <p:cNvPr id="3" name="Shape 0"/>
+      <p:sp>
+        <p:nvSpPr>
+          <p:cNvPr id="2" name="Shape 0"/>
           <p:cNvSpPr/>
           <p:nvPr/>
         </p:nvSpPr>
         <p:spPr>
           <a:xfrm>
-            <a:off x="914400" y="1865376"/>
-            <a:ext cx="10241280" cy="1024128"/>
-          </a:xfrm>
-          <a:prstGeom prst="rect">
-            <a:avLst/>
-          </a:prstGeom>
-          <a:solidFill>
-            <a:srgbClr val="FFFFFF">
-              <a:alpha val="0"/>
-            </a:srgbClr>
-          </a:solidFill>
-          <a:ln w="12700">
-            <a:solidFill>
-              <a:srgbClr val="E2E8F0">
-                <a:alpha val="0"/>
-              </a:srgbClr>
-            </a:solidFill>
-            <a:prstDash val="solid"/>
-          </a:ln>
-          <a:effectLst>
-            <a:outerShdw sx="100000" sy="100000" kx="0" ky="0" algn="bl" rotWithShape="0" blurRad="12700" dist="50800" dir="2700000">
-              <a:srgbClr val="000000">
-                <a:alpha val="8000"/>
-              </a:srgbClr>
-            </a:outerShdw>
-          </a:effectLst>
-        </p:spPr>
-      </p:sp>
-      <p:pic>
-        <p:nvPicPr>
-          <p:cNvPr id="4" name="Image 1" descr="preencoded.png">    </p:cNvPr>
-          <p:cNvPicPr>
-            <a:picLocks noChangeAspect="1"/>
-          </p:cNvPicPr>
-          <p:nvPr/>
-        </p:nvPicPr>
-        <p:blipFill>
-          <a:blip r:embed="rId3">
-            <a:extLst>
-              <a:ext uri="{96DAC541-7B7A-43D3-8B79-37D633B846F1}">
-                <asvg:svgBlip xmlns:asvg="http://schemas.microsoft.com/office/drawing/2016/SVG/main" r:embed="rId4"/>
-              </a:ext>
-            </a:extLst>
-          </a:blip>
-          <a:stretch>
-            <a:fillRect/>
-          </a:stretch>
-        </p:blipFill>
-        <p:spPr>
-          <a:xfrm>
-            <a:off x="914400" y="3191256"/>
-            <a:ext cx="10241280" cy="1024128"/>
-          </a:xfrm>
-          <a:prstGeom prst="rect">
-            <a:avLst/>
-          </a:prstGeom>
-        </p:spPr>
-      </p:pic>
-      <p:sp>
-        <p:nvSpPr>
-          <p:cNvPr id="5" name="Shape 1"/>
-          <p:cNvSpPr/>
-          <p:nvPr/>
-        </p:nvSpPr>
-        <p:spPr>
-          <a:xfrm>
-            <a:off x="914400" y="3191256"/>
-            <a:ext cx="10241280" cy="1024128"/>
-          </a:xfrm>
-          <a:prstGeom prst="rect">
-            <a:avLst/>
-          </a:prstGeom>
-          <a:solidFill>
-            <a:srgbClr val="FFFFFF">
-              <a:alpha val="0"/>
-            </a:srgbClr>
-          </a:solidFill>
-          <a:ln w="12700">
-            <a:solidFill>
-              <a:srgbClr val="E2E8F0">
-                <a:alpha val="0"/>
-              </a:srgbClr>
-            </a:solidFill>
-            <a:prstDash val="solid"/>
-          </a:ln>
-          <a:effectLst>
-            <a:outerShdw sx="100000" sy="100000" kx="0" ky="0" algn="bl" rotWithShape="0" blurRad="12700" dist="50800" dir="2700000">
-              <a:srgbClr val="000000">
-                <a:alpha val="8000"/>
-              </a:srgbClr>
-            </a:outerShdw>
-          </a:effectLst>
-        </p:spPr>
-      </p:sp>
-      <p:pic>
-        <p:nvPicPr>
-          <p:cNvPr id="6" name="Image 2" descr="preencoded.png">    </p:cNvPr>
-          <p:cNvPicPr>
-            <a:picLocks noChangeAspect="1"/>
-          </p:cNvPicPr>
-          <p:nvPr/>
-        </p:nvPicPr>
-        <p:blipFill>
-          <a:blip r:embed="rId5">
-            <a:extLst>
-              <a:ext uri="{96DAC541-7B7A-43D3-8B79-37D633B846F1}">
-                <asvg:svgBlip xmlns:asvg="http://schemas.microsoft.com/office/drawing/2016/SVG/main" r:embed="rId6"/>
-              </a:ext>
-            </a:extLst>
-          </a:blip>
-          <a:stretch>
-            <a:fillRect/>
-          </a:stretch>
-        </p:blipFill>
-        <p:spPr>
-          <a:xfrm>
-            <a:off x="914400" y="4507992"/>
-            <a:ext cx="10241280" cy="1024128"/>
-          </a:xfrm>
-          <a:prstGeom prst="rect">
-            <a:avLst/>
-          </a:prstGeom>
-        </p:spPr>
-      </p:pic>
-      <p:sp>
-        <p:nvSpPr>
-          <p:cNvPr id="7" name="Shape 2"/>
-          <p:cNvSpPr/>
-          <p:nvPr/>
-        </p:nvSpPr>
-        <p:spPr>
-          <a:xfrm>
-            <a:off x="914400" y="4507992"/>
-            <a:ext cx="10241280" cy="1024128"/>
-          </a:xfrm>
-          <a:prstGeom prst="rect">
-            <a:avLst/>
-          </a:prstGeom>
-          <a:solidFill>
-            <a:srgbClr val="FFFFFF">
-              <a:alpha val="0"/>
-            </a:srgbClr>
-          </a:solidFill>
-          <a:ln w="12700">
-            <a:solidFill>
-              <a:srgbClr val="E2E8F0">
-                <a:alpha val="0"/>
-              </a:srgbClr>
-            </a:solidFill>
-            <a:prstDash val="solid"/>
-          </a:ln>
-          <a:effectLst>
-            <a:outerShdw sx="100000" sy="100000" kx="0" ky="0" algn="bl" rotWithShape="0" blurRad="12700" dist="50800" dir="2700000">
-              <a:srgbClr val="000000">
-                <a:alpha val="8000"/>
-              </a:srgbClr>
-            </a:outerShdw>
-          </a:effectLst>
-        </p:spPr>
-      </p:sp>
-      <p:sp>
-        <p:nvSpPr>
-          <p:cNvPr id="8" name="Shape 3"/>
-          <p:cNvSpPr/>
-          <p:nvPr/>
-        </p:nvSpPr>
-        <p:spPr>
-          <a:xfrm>
-            <a:off x="786384" y="1956816"/>
-            <a:ext cx="32004" cy="3483864"/>
-          </a:xfrm>
-          <a:prstGeom prst="rect">
-            <a:avLst/>
-          </a:prstGeom>
-          <a:solidFill>
-            <a:srgbClr val="DBEAFE">
-              <a:alpha val="80000"/>
-            </a:srgbClr>
-          </a:solidFill>
-          <a:ln w="12700">
-            <a:solidFill>
-              <a:srgbClr val="DBEAFE">
-                <a:alpha val="0"/>
-              </a:srgbClr>
-            </a:solidFill>
-            <a:prstDash val="solid"/>
-          </a:ln>
-        </p:spPr>
-      </p:sp>
-      <p:sp>
-        <p:nvSpPr>
-          <p:cNvPr id="9" name="Shape 4"/>
-          <p:cNvSpPr/>
-          <p:nvPr/>
-        </p:nvSpPr>
-        <p:spPr>
-          <a:xfrm>
-            <a:off x="914400" y="1865376"/>
-            <a:ext cx="73152" cy="1024128"/>
+            <a:off x="822960" y="1938528"/>
+            <a:ext cx="73152" cy="2514600"/>
           </a:xfrm>
           <a:prstGeom prst="rect">
             <a:avLst/>
@@ -18304,14 +16444,14 @@
       </p:sp>
       <p:sp>
         <p:nvSpPr>
-          <p:cNvPr id="10" name="Shape 5"/>
+          <p:cNvPr id="3" name="Shape 1"/>
           <p:cNvSpPr/>
           <p:nvPr/>
         </p:nvSpPr>
         <p:spPr>
           <a:xfrm>
-            <a:off x="914400" y="3191256"/>
-            <a:ext cx="73152" cy="1024128"/>
+            <a:off x="4343400" y="1938528"/>
+            <a:ext cx="73152" cy="2514600"/>
           </a:xfrm>
           <a:prstGeom prst="rect">
             <a:avLst/>
@@ -18331,14 +16471,14 @@
       </p:sp>
       <p:sp>
         <p:nvSpPr>
-          <p:cNvPr id="11" name="Shape 6"/>
+          <p:cNvPr id="4" name="Shape 2"/>
           <p:cNvSpPr/>
           <p:nvPr/>
         </p:nvSpPr>
         <p:spPr>
           <a:xfrm>
-            <a:off x="914400" y="4507992"/>
-            <a:ext cx="73152" cy="1024128"/>
+            <a:off x="7863840" y="1938528"/>
+            <a:ext cx="73152" cy="2514600"/>
           </a:xfrm>
           <a:prstGeom prst="rect">
             <a:avLst/>
@@ -18358,7 +16498,7 @@
       </p:sp>
       <p:sp>
         <p:nvSpPr>
-          <p:cNvPr id="12" name="mdpr:2-3-298275:title:__title:2-3-298275"/>
+          <p:cNvPr id="5" name="mdpr:2-3-298275:title:__title:2-3-298275"/>
           <p:cNvSpPr txBox="1"/>
           <p:nvPr/>
         </p:nvSpPr>
@@ -18392,7 +16532,24 @@
                 <a:ea typeface="Pretendard" pitchFamily="34" charset="-122"/>
                 <a:cs typeface="Pretendard" pitchFamily="34" charset="-120"/>
               </a:rPr>
-              <a:t>Example: examples/theme-preview-en/deck.md (Cont. 2/3)</a:t>
+              <a:t>Example: examples/theme-preview-en/deck.md</a:t>
+            </a:r>
+            <a:pPr algn="ctr" indent="0" marL="0">
+              <a:lnSpc>
+                <a:spcPct val="120000"/>
+              </a:lnSpc>
+              <a:buNone/>
+            </a:pPr>
+            <a:r>
+              <a:rPr lang="en-US" sz="2000" dirty="0">
+                <a:solidFill>
+                  <a:srgbClr val="919191"/>
+                </a:solidFill>
+                <a:latin typeface="Pretendard" pitchFamily="34" charset="0"/>
+                <a:ea typeface="Pretendard" pitchFamily="34" charset="-122"/>
+                <a:cs typeface="Pretendard" pitchFamily="34" charset="-120"/>
+              </a:rPr>
+              <a:t> (Cont. 2/3)</a:t>
             </a:r>
             <a:endParaRPr lang="en-US" sz="3400" dirty="0"/>
           </a:p>
@@ -18400,14 +16557,14 @@
       </p:sp>
       <p:sp>
         <p:nvSpPr>
-          <p:cNvPr id="13" name="mdpr:2-3-298275:item-1:block-38-chunk-2"/>
+          <p:cNvPr id="6" name="mdpr:2-3-298275:item-1:block-38-chunk-2"/>
           <p:cNvSpPr txBox="1"/>
           <p:nvPr/>
         </p:nvSpPr>
         <p:spPr>
           <a:xfrm>
-            <a:off x="1133856" y="2164080"/>
-            <a:ext cx="9820656" cy="426720"/>
+            <a:off x="1042416" y="2982468"/>
+            <a:ext cx="2825496" cy="426720"/>
           </a:xfrm>
           <a:prstGeom prst="rect">
             <a:avLst/>
@@ -18442,14 +16599,14 @@
       </p:sp>
       <p:sp>
         <p:nvSpPr>
-          <p:cNvPr id="14" name="mdpr:2-3-298275:item-2:block-38-chunk-2"/>
+          <p:cNvPr id="7" name="mdpr:2-3-298275:item-2:block-38-chunk-2"/>
           <p:cNvSpPr txBox="1"/>
           <p:nvPr/>
         </p:nvSpPr>
         <p:spPr>
           <a:xfrm>
-            <a:off x="1133856" y="3489960"/>
-            <a:ext cx="9820656" cy="426720"/>
+            <a:off x="4562856" y="2982468"/>
+            <a:ext cx="2825496" cy="426720"/>
           </a:xfrm>
           <a:prstGeom prst="rect">
             <a:avLst/>
@@ -18484,14 +16641,14 @@
       </p:sp>
       <p:sp>
         <p:nvSpPr>
-          <p:cNvPr id="15" name="mdpr:2-3-298275:item-3:block-38-chunk-2"/>
+          <p:cNvPr id="8" name="mdpr:2-3-298275:item-3:block-38-chunk-2"/>
           <p:cNvSpPr txBox="1"/>
           <p:nvPr/>
         </p:nvSpPr>
         <p:spPr>
           <a:xfrm>
-            <a:off x="1133856" y="4600164"/>
-            <a:ext cx="9820656" cy="839785"/>
+            <a:off x="8083296" y="2103120"/>
+            <a:ext cx="2825496" cy="2185416"/>
           </a:xfrm>
           <a:prstGeom prst="rect">
             <a:avLst/>
@@ -18573,243 +16730,16 @@
           <a:chExt cx="0" cy="0"/>
         </a:xfrm>
       </p:grpSpPr>
-      <p:pic>
-        <p:nvPicPr>
-          <p:cNvPr id="2" name="Image 0" descr="preencoded.png">    </p:cNvPr>
-          <p:cNvPicPr>
-            <a:picLocks noChangeAspect="1"/>
-          </p:cNvPicPr>
-          <p:nvPr/>
-        </p:nvPicPr>
-        <p:blipFill>
-          <a:blip r:embed="rId1">
-            <a:extLst>
-              <a:ext uri="{96DAC541-7B7A-43D3-8B79-37D633B846F1}">
-                <asvg:svgBlip xmlns:asvg="http://schemas.microsoft.com/office/drawing/2016/SVG/main" r:embed="rId2"/>
-              </a:ext>
-            </a:extLst>
-          </a:blip>
-          <a:stretch>
-            <a:fillRect/>
-          </a:stretch>
-        </p:blipFill>
-        <p:spPr>
-          <a:xfrm>
-            <a:off x="914400" y="1865376"/>
-            <a:ext cx="10241280" cy="1024128"/>
-          </a:xfrm>
-          <a:prstGeom prst="rect">
-            <a:avLst/>
-          </a:prstGeom>
-        </p:spPr>
-      </p:pic>
-      <p:sp>
-        <p:nvSpPr>
-          <p:cNvPr id="3" name="Shape 0"/>
+      <p:sp>
+        <p:nvSpPr>
+          <p:cNvPr id="2" name="Shape 0"/>
           <p:cNvSpPr/>
           <p:nvPr/>
         </p:nvSpPr>
         <p:spPr>
           <a:xfrm>
-            <a:off x="914400" y="1865376"/>
-            <a:ext cx="10241280" cy="1024128"/>
-          </a:xfrm>
-          <a:prstGeom prst="rect">
-            <a:avLst/>
-          </a:prstGeom>
-          <a:solidFill>
-            <a:srgbClr val="FFFFFF">
-              <a:alpha val="0"/>
-            </a:srgbClr>
-          </a:solidFill>
-          <a:ln w="12700">
-            <a:solidFill>
-              <a:srgbClr val="E2E8F0">
-                <a:alpha val="0"/>
-              </a:srgbClr>
-            </a:solidFill>
-            <a:prstDash val="solid"/>
-          </a:ln>
-          <a:effectLst>
-            <a:outerShdw sx="100000" sy="100000" kx="0" ky="0" algn="bl" rotWithShape="0" blurRad="12700" dist="50800" dir="2700000">
-              <a:srgbClr val="000000">
-                <a:alpha val="8000"/>
-              </a:srgbClr>
-            </a:outerShdw>
-          </a:effectLst>
-        </p:spPr>
-      </p:sp>
-      <p:pic>
-        <p:nvPicPr>
-          <p:cNvPr id="4" name="Image 1" descr="preencoded.png">    </p:cNvPr>
-          <p:cNvPicPr>
-            <a:picLocks noChangeAspect="1"/>
-          </p:cNvPicPr>
-          <p:nvPr/>
-        </p:nvPicPr>
-        <p:blipFill>
-          <a:blip r:embed="rId3">
-            <a:extLst>
-              <a:ext uri="{96DAC541-7B7A-43D3-8B79-37D633B846F1}">
-                <asvg:svgBlip xmlns:asvg="http://schemas.microsoft.com/office/drawing/2016/SVG/main" r:embed="rId4"/>
-              </a:ext>
-            </a:extLst>
-          </a:blip>
-          <a:stretch>
-            <a:fillRect/>
-          </a:stretch>
-        </p:blipFill>
-        <p:spPr>
-          <a:xfrm>
-            <a:off x="914400" y="3191256"/>
-            <a:ext cx="10241280" cy="1024128"/>
-          </a:xfrm>
-          <a:prstGeom prst="rect">
-            <a:avLst/>
-          </a:prstGeom>
-        </p:spPr>
-      </p:pic>
-      <p:sp>
-        <p:nvSpPr>
-          <p:cNvPr id="5" name="Shape 1"/>
-          <p:cNvSpPr/>
-          <p:nvPr/>
-        </p:nvSpPr>
-        <p:spPr>
-          <a:xfrm>
-            <a:off x="914400" y="3191256"/>
-            <a:ext cx="10241280" cy="1024128"/>
-          </a:xfrm>
-          <a:prstGeom prst="rect">
-            <a:avLst/>
-          </a:prstGeom>
-          <a:solidFill>
-            <a:srgbClr val="FFFFFF">
-              <a:alpha val="0"/>
-            </a:srgbClr>
-          </a:solidFill>
-          <a:ln w="12700">
-            <a:solidFill>
-              <a:srgbClr val="E2E8F0">
-                <a:alpha val="0"/>
-              </a:srgbClr>
-            </a:solidFill>
-            <a:prstDash val="solid"/>
-          </a:ln>
-          <a:effectLst>
-            <a:outerShdw sx="100000" sy="100000" kx="0" ky="0" algn="bl" rotWithShape="0" blurRad="12700" dist="50800" dir="2700000">
-              <a:srgbClr val="000000">
-                <a:alpha val="8000"/>
-              </a:srgbClr>
-            </a:outerShdw>
-          </a:effectLst>
-        </p:spPr>
-      </p:sp>
-      <p:pic>
-        <p:nvPicPr>
-          <p:cNvPr id="6" name="Image 2" descr="preencoded.png">    </p:cNvPr>
-          <p:cNvPicPr>
-            <a:picLocks noChangeAspect="1"/>
-          </p:cNvPicPr>
-          <p:nvPr/>
-        </p:nvPicPr>
-        <p:blipFill>
-          <a:blip r:embed="rId5">
-            <a:extLst>
-              <a:ext uri="{96DAC541-7B7A-43D3-8B79-37D633B846F1}">
-                <asvg:svgBlip xmlns:asvg="http://schemas.microsoft.com/office/drawing/2016/SVG/main" r:embed="rId6"/>
-              </a:ext>
-            </a:extLst>
-          </a:blip>
-          <a:stretch>
-            <a:fillRect/>
-          </a:stretch>
-        </p:blipFill>
-        <p:spPr>
-          <a:xfrm>
-            <a:off x="914400" y="4507992"/>
-            <a:ext cx="10241280" cy="1024128"/>
-          </a:xfrm>
-          <a:prstGeom prst="rect">
-            <a:avLst/>
-          </a:prstGeom>
-        </p:spPr>
-      </p:pic>
-      <p:sp>
-        <p:nvSpPr>
-          <p:cNvPr id="7" name="Shape 2"/>
-          <p:cNvSpPr/>
-          <p:nvPr/>
-        </p:nvSpPr>
-        <p:spPr>
-          <a:xfrm>
-            <a:off x="914400" y="4507992"/>
-            <a:ext cx="10241280" cy="1024128"/>
-          </a:xfrm>
-          <a:prstGeom prst="rect">
-            <a:avLst/>
-          </a:prstGeom>
-          <a:solidFill>
-            <a:srgbClr val="FFFFFF">
-              <a:alpha val="0"/>
-            </a:srgbClr>
-          </a:solidFill>
-          <a:ln w="12700">
-            <a:solidFill>
-              <a:srgbClr val="E2E8F0">
-                <a:alpha val="0"/>
-              </a:srgbClr>
-            </a:solidFill>
-            <a:prstDash val="solid"/>
-          </a:ln>
-          <a:effectLst>
-            <a:outerShdw sx="100000" sy="100000" kx="0" ky="0" algn="bl" rotWithShape="0" blurRad="12700" dist="50800" dir="2700000">
-              <a:srgbClr val="000000">
-                <a:alpha val="8000"/>
-              </a:srgbClr>
-            </a:outerShdw>
-          </a:effectLst>
-        </p:spPr>
-      </p:sp>
-      <p:sp>
-        <p:nvSpPr>
-          <p:cNvPr id="8" name="Shape 3"/>
-          <p:cNvSpPr/>
-          <p:nvPr/>
-        </p:nvSpPr>
-        <p:spPr>
-          <a:xfrm>
-            <a:off x="786384" y="1956816"/>
-            <a:ext cx="32004" cy="3483864"/>
-          </a:xfrm>
-          <a:prstGeom prst="rect">
-            <a:avLst/>
-          </a:prstGeom>
-          <a:solidFill>
-            <a:srgbClr val="DBEAFE">
-              <a:alpha val="80000"/>
-            </a:srgbClr>
-          </a:solidFill>
-          <a:ln w="12700">
-            <a:solidFill>
-              <a:srgbClr val="DBEAFE">
-                <a:alpha val="0"/>
-              </a:srgbClr>
-            </a:solidFill>
-            <a:prstDash val="solid"/>
-          </a:ln>
-        </p:spPr>
-      </p:sp>
-      <p:sp>
-        <p:nvSpPr>
-          <p:cNvPr id="9" name="Shape 4"/>
-          <p:cNvSpPr/>
-          <p:nvPr/>
-        </p:nvSpPr>
-        <p:spPr>
-          <a:xfrm>
-            <a:off x="914400" y="1865376"/>
-            <a:ext cx="73152" cy="1024128"/>
+            <a:off x="822960" y="1938528"/>
+            <a:ext cx="73152" cy="2514600"/>
           </a:xfrm>
           <a:prstGeom prst="rect">
             <a:avLst/>
@@ -18829,14 +16759,14 @@
       </p:sp>
       <p:sp>
         <p:nvSpPr>
-          <p:cNvPr id="10" name="Shape 5"/>
+          <p:cNvPr id="3" name="Shape 1"/>
           <p:cNvSpPr/>
           <p:nvPr/>
         </p:nvSpPr>
         <p:spPr>
           <a:xfrm>
-            <a:off x="914400" y="3191256"/>
-            <a:ext cx="73152" cy="1024128"/>
+            <a:off x="4343400" y="1938528"/>
+            <a:ext cx="73152" cy="2514600"/>
           </a:xfrm>
           <a:prstGeom prst="rect">
             <a:avLst/>
@@ -18856,14 +16786,14 @@
       </p:sp>
       <p:sp>
         <p:nvSpPr>
-          <p:cNvPr id="11" name="Shape 6"/>
+          <p:cNvPr id="4" name="Shape 2"/>
           <p:cNvSpPr/>
           <p:nvPr/>
         </p:nvSpPr>
         <p:spPr>
           <a:xfrm>
-            <a:off x="914400" y="4507992"/>
-            <a:ext cx="73152" cy="1024128"/>
+            <a:off x="7863840" y="1938528"/>
+            <a:ext cx="73152" cy="2514600"/>
           </a:xfrm>
           <a:prstGeom prst="rect">
             <a:avLst/>
@@ -18883,7 +16813,7 @@
       </p:sp>
       <p:sp>
         <p:nvSpPr>
-          <p:cNvPr id="12" name="mdpr:3-3-bec926:title:__title:3-3-bec926"/>
+          <p:cNvPr id="5" name="mdpr:3-3-bec926:title:__title:3-3-bec926"/>
           <p:cNvSpPr txBox="1"/>
           <p:nvPr/>
         </p:nvSpPr>
@@ -18917,7 +16847,24 @@
                 <a:ea typeface="Pretendard" pitchFamily="34" charset="-122"/>
                 <a:cs typeface="Pretendard" pitchFamily="34" charset="-120"/>
               </a:rPr>
-              <a:t>Example: examples/theme-preview-en/deck.md (Cont. 3/3)</a:t>
+              <a:t>Example: examples/theme-preview-en/deck.md</a:t>
+            </a:r>
+            <a:pPr algn="ctr" indent="0" marL="0">
+              <a:lnSpc>
+                <a:spcPct val="120000"/>
+              </a:lnSpc>
+              <a:buNone/>
+            </a:pPr>
+            <a:r>
+              <a:rPr lang="en-US" sz="2000" dirty="0">
+                <a:solidFill>
+                  <a:srgbClr val="919191"/>
+                </a:solidFill>
+                <a:latin typeface="Pretendard" pitchFamily="34" charset="0"/>
+                <a:ea typeface="Pretendard" pitchFamily="34" charset="-122"/>
+                <a:cs typeface="Pretendard" pitchFamily="34" charset="-120"/>
+              </a:rPr>
+              <a:t> (Cont. 3/3)</a:t>
             </a:r>
             <a:endParaRPr lang="en-US" sz="3400" dirty="0"/>
           </a:p>
@@ -18925,14 +16872,14 @@
       </p:sp>
       <p:sp>
         <p:nvSpPr>
-          <p:cNvPr id="13" name="mdpr:3-3-bec926:item-1:block-38-chunk-3"/>
+          <p:cNvPr id="6" name="mdpr:3-3-bec926:item-1:block-38-chunk-3"/>
           <p:cNvSpPr txBox="1"/>
           <p:nvPr/>
         </p:nvSpPr>
         <p:spPr>
           <a:xfrm>
-            <a:off x="1133856" y="1957548"/>
-            <a:ext cx="9820656" cy="839785"/>
+            <a:off x="1042416" y="2103120"/>
+            <a:ext cx="2825496" cy="2185416"/>
           </a:xfrm>
           <a:prstGeom prst="rect">
             <a:avLst/>
@@ -18984,14 +16931,14 @@
       </p:sp>
       <p:sp>
         <p:nvSpPr>
-          <p:cNvPr id="14" name="mdpr:3-3-bec926:item-2:block-38-chunk-3"/>
+          <p:cNvPr id="7" name="mdpr:3-3-bec926:item-2:block-38-chunk-3"/>
           <p:cNvSpPr txBox="1"/>
           <p:nvPr/>
         </p:nvSpPr>
         <p:spPr>
           <a:xfrm>
-            <a:off x="1133856" y="3283428"/>
-            <a:ext cx="9820656" cy="839785"/>
+            <a:off x="4562856" y="2103120"/>
+            <a:ext cx="2825496" cy="2185416"/>
           </a:xfrm>
           <a:prstGeom prst="rect">
             <a:avLst/>
@@ -19043,14 +16990,14 @@
       </p:sp>
       <p:sp>
         <p:nvSpPr>
-          <p:cNvPr id="15" name="mdpr:3-3-bec926:item-3:block-38-chunk-3"/>
+          <p:cNvPr id="8" name="mdpr:3-3-bec926:item-3:block-38-chunk-3"/>
           <p:cNvSpPr txBox="1"/>
           <p:nvPr/>
         </p:nvSpPr>
         <p:spPr>
           <a:xfrm>
-            <a:off x="1133856" y="4600164"/>
-            <a:ext cx="9820656" cy="839785"/>
+            <a:off x="8083296" y="2103120"/>
+            <a:ext cx="2825496" cy="2185416"/>
           </a:xfrm>
           <a:prstGeom prst="rect">
             <a:avLst/>
@@ -22884,7 +20831,24 @@
                 <a:ea typeface="Pretendard" pitchFamily="34" charset="-122"/>
                 <a:cs typeface="Pretendard" pitchFamily="34" charset="-120"/>
               </a:rPr>
-              <a:t>Pipeline boundary (Cont. 2/2)</a:t>
+              <a:t>Pipeline boundary</a:t>
+            </a:r>
+            <a:pPr algn="ctr" indent="0" marL="0">
+              <a:lnSpc>
+                <a:spcPct val="120000"/>
+              </a:lnSpc>
+              <a:buNone/>
+            </a:pPr>
+            <a:r>
+              <a:rPr lang="en-US" sz="2000" dirty="0">
+                <a:solidFill>
+                  <a:srgbClr val="919191"/>
+                </a:solidFill>
+                <a:latin typeface="Pretendard" pitchFamily="34" charset="0"/>
+                <a:ea typeface="Pretendard" pitchFamily="34" charset="-122"/>
+                <a:cs typeface="Pretendard" pitchFamily="34" charset="-120"/>
+              </a:rPr>
+              <a:t> (Cont. 2/2)</a:t>
             </a:r>
             <a:endParaRPr lang="en-US" sz="3400" dirty="0"/>
           </a:p>
@@ -24148,7 +22112,24 @@
                 <a:ea typeface="Pretendard" pitchFamily="34" charset="-122"/>
                 <a:cs typeface="Pretendard" pitchFamily="34" charset="-120"/>
               </a:rPr>
-              <a:t>Architecture (Cont. 2/2)</a:t>
+              <a:t>Architecture</a:t>
+            </a:r>
+            <a:pPr algn="ctr" indent="0" marL="0">
+              <a:lnSpc>
+                <a:spcPct val="120000"/>
+              </a:lnSpc>
+              <a:buNone/>
+            </a:pPr>
+            <a:r>
+              <a:rPr lang="en-US" sz="2000" dirty="0">
+                <a:solidFill>
+                  <a:srgbClr val="919191"/>
+                </a:solidFill>
+                <a:latin typeface="Pretendard" pitchFamily="34" charset="0"/>
+                <a:ea typeface="Pretendard" pitchFamily="34" charset="-122"/>
+                <a:cs typeface="Pretendard" pitchFamily="34" charset="-120"/>
+              </a:rPr>
+              <a:t> (Cont. 2/2)</a:t>
             </a:r>
             <a:endParaRPr lang="en-US" sz="3400" dirty="0"/>
           </a:p>
@@ -25362,243 +23343,16 @@
           <a:chExt cx="0" cy="0"/>
         </a:xfrm>
       </p:grpSpPr>
-      <p:pic>
-        <p:nvPicPr>
-          <p:cNvPr id="2" name="Image 0" descr="preencoded.png">    </p:cNvPr>
-          <p:cNvPicPr>
-            <a:picLocks noChangeAspect="1"/>
-          </p:cNvPicPr>
-          <p:nvPr/>
-        </p:nvPicPr>
-        <p:blipFill>
-          <a:blip r:embed="rId1">
-            <a:extLst>
-              <a:ext uri="{96DAC541-7B7A-43D3-8B79-37D633B846F1}">
-                <asvg:svgBlip xmlns:asvg="http://schemas.microsoft.com/office/drawing/2016/SVG/main" r:embed="rId2"/>
-              </a:ext>
-            </a:extLst>
-          </a:blip>
-          <a:stretch>
-            <a:fillRect/>
-          </a:stretch>
-        </p:blipFill>
-        <p:spPr>
-          <a:xfrm>
-            <a:off x="914400" y="1865376"/>
-            <a:ext cx="10241280" cy="1024128"/>
-          </a:xfrm>
-          <a:prstGeom prst="rect">
-            <a:avLst/>
-          </a:prstGeom>
-        </p:spPr>
-      </p:pic>
-      <p:sp>
-        <p:nvSpPr>
-          <p:cNvPr id="3" name="Shape 0"/>
+      <p:sp>
+        <p:nvSpPr>
+          <p:cNvPr id="2" name="Shape 0"/>
           <p:cNvSpPr/>
           <p:nvPr/>
         </p:nvSpPr>
         <p:spPr>
           <a:xfrm>
-            <a:off x="914400" y="1865376"/>
-            <a:ext cx="10241280" cy="1024128"/>
-          </a:xfrm>
-          <a:prstGeom prst="rect">
-            <a:avLst/>
-          </a:prstGeom>
-          <a:solidFill>
-            <a:srgbClr val="FFFFFF">
-              <a:alpha val="0"/>
-            </a:srgbClr>
-          </a:solidFill>
-          <a:ln w="12700">
-            <a:solidFill>
-              <a:srgbClr val="E2E8F0">
-                <a:alpha val="0"/>
-              </a:srgbClr>
-            </a:solidFill>
-            <a:prstDash val="solid"/>
-          </a:ln>
-          <a:effectLst>
-            <a:outerShdw sx="100000" sy="100000" kx="0" ky="0" algn="bl" rotWithShape="0" blurRad="12700" dist="50800" dir="2700000">
-              <a:srgbClr val="000000">
-                <a:alpha val="8000"/>
-              </a:srgbClr>
-            </a:outerShdw>
-          </a:effectLst>
-        </p:spPr>
-      </p:sp>
-      <p:pic>
-        <p:nvPicPr>
-          <p:cNvPr id="4" name="Image 1" descr="preencoded.png">    </p:cNvPr>
-          <p:cNvPicPr>
-            <a:picLocks noChangeAspect="1"/>
-          </p:cNvPicPr>
-          <p:nvPr/>
-        </p:nvPicPr>
-        <p:blipFill>
-          <a:blip r:embed="rId3">
-            <a:extLst>
-              <a:ext uri="{96DAC541-7B7A-43D3-8B79-37D633B846F1}">
-                <asvg:svgBlip xmlns:asvg="http://schemas.microsoft.com/office/drawing/2016/SVG/main" r:embed="rId4"/>
-              </a:ext>
-            </a:extLst>
-          </a:blip>
-          <a:stretch>
-            <a:fillRect/>
-          </a:stretch>
-        </p:blipFill>
-        <p:spPr>
-          <a:xfrm>
-            <a:off x="914400" y="3191256"/>
-            <a:ext cx="10241280" cy="1024128"/>
-          </a:xfrm>
-          <a:prstGeom prst="rect">
-            <a:avLst/>
-          </a:prstGeom>
-        </p:spPr>
-      </p:pic>
-      <p:sp>
-        <p:nvSpPr>
-          <p:cNvPr id="5" name="Shape 1"/>
-          <p:cNvSpPr/>
-          <p:nvPr/>
-        </p:nvSpPr>
-        <p:spPr>
-          <a:xfrm>
-            <a:off x="914400" y="3191256"/>
-            <a:ext cx="10241280" cy="1024128"/>
-          </a:xfrm>
-          <a:prstGeom prst="rect">
-            <a:avLst/>
-          </a:prstGeom>
-          <a:solidFill>
-            <a:srgbClr val="FFFFFF">
-              <a:alpha val="0"/>
-            </a:srgbClr>
-          </a:solidFill>
-          <a:ln w="12700">
-            <a:solidFill>
-              <a:srgbClr val="E2E8F0">
-                <a:alpha val="0"/>
-              </a:srgbClr>
-            </a:solidFill>
-            <a:prstDash val="solid"/>
-          </a:ln>
-          <a:effectLst>
-            <a:outerShdw sx="100000" sy="100000" kx="0" ky="0" algn="bl" rotWithShape="0" blurRad="12700" dist="50800" dir="2700000">
-              <a:srgbClr val="000000">
-                <a:alpha val="8000"/>
-              </a:srgbClr>
-            </a:outerShdw>
-          </a:effectLst>
-        </p:spPr>
-      </p:sp>
-      <p:pic>
-        <p:nvPicPr>
-          <p:cNvPr id="6" name="Image 2" descr="preencoded.png">    </p:cNvPr>
-          <p:cNvPicPr>
-            <a:picLocks noChangeAspect="1"/>
-          </p:cNvPicPr>
-          <p:nvPr/>
-        </p:nvPicPr>
-        <p:blipFill>
-          <a:blip r:embed="rId5">
-            <a:extLst>
-              <a:ext uri="{96DAC541-7B7A-43D3-8B79-37D633B846F1}">
-                <asvg:svgBlip xmlns:asvg="http://schemas.microsoft.com/office/drawing/2016/SVG/main" r:embed="rId6"/>
-              </a:ext>
-            </a:extLst>
-          </a:blip>
-          <a:stretch>
-            <a:fillRect/>
-          </a:stretch>
-        </p:blipFill>
-        <p:spPr>
-          <a:xfrm>
-            <a:off x="914400" y="4507992"/>
-            <a:ext cx="10241280" cy="1024128"/>
-          </a:xfrm>
-          <a:prstGeom prst="rect">
-            <a:avLst/>
-          </a:prstGeom>
-        </p:spPr>
-      </p:pic>
-      <p:sp>
-        <p:nvSpPr>
-          <p:cNvPr id="7" name="Shape 2"/>
-          <p:cNvSpPr/>
-          <p:nvPr/>
-        </p:nvSpPr>
-        <p:spPr>
-          <a:xfrm>
-            <a:off x="914400" y="4507992"/>
-            <a:ext cx="10241280" cy="1024128"/>
-          </a:xfrm>
-          <a:prstGeom prst="rect">
-            <a:avLst/>
-          </a:prstGeom>
-          <a:solidFill>
-            <a:srgbClr val="FFFFFF">
-              <a:alpha val="0"/>
-            </a:srgbClr>
-          </a:solidFill>
-          <a:ln w="12700">
-            <a:solidFill>
-              <a:srgbClr val="E2E8F0">
-                <a:alpha val="0"/>
-              </a:srgbClr>
-            </a:solidFill>
-            <a:prstDash val="solid"/>
-          </a:ln>
-          <a:effectLst>
-            <a:outerShdw sx="100000" sy="100000" kx="0" ky="0" algn="bl" rotWithShape="0" blurRad="12700" dist="50800" dir="2700000">
-              <a:srgbClr val="000000">
-                <a:alpha val="8000"/>
-              </a:srgbClr>
-            </a:outerShdw>
-          </a:effectLst>
-        </p:spPr>
-      </p:sp>
-      <p:sp>
-        <p:nvSpPr>
-          <p:cNvPr id="8" name="Shape 3"/>
-          <p:cNvSpPr/>
-          <p:nvPr/>
-        </p:nvSpPr>
-        <p:spPr>
-          <a:xfrm>
-            <a:off x="786384" y="1956816"/>
-            <a:ext cx="32004" cy="3483864"/>
-          </a:xfrm>
-          <a:prstGeom prst="rect">
-            <a:avLst/>
-          </a:prstGeom>
-          <a:solidFill>
-            <a:srgbClr val="DBEAFE">
-              <a:alpha val="80000"/>
-            </a:srgbClr>
-          </a:solidFill>
-          <a:ln w="12700">
-            <a:solidFill>
-              <a:srgbClr val="DBEAFE">
-                <a:alpha val="0"/>
-              </a:srgbClr>
-            </a:solidFill>
-            <a:prstDash val="solid"/>
-          </a:ln>
-        </p:spPr>
-      </p:sp>
-      <p:sp>
-        <p:nvSpPr>
-          <p:cNvPr id="9" name="Shape 4"/>
-          <p:cNvSpPr/>
-          <p:nvPr/>
-        </p:nvSpPr>
-        <p:spPr>
-          <a:xfrm>
-            <a:off x="914400" y="1865376"/>
-            <a:ext cx="73152" cy="1024128"/>
+            <a:off x="822960" y="1938528"/>
+            <a:ext cx="73152" cy="2514600"/>
           </a:xfrm>
           <a:prstGeom prst="rect">
             <a:avLst/>
@@ -25618,14 +23372,14 @@
       </p:sp>
       <p:sp>
         <p:nvSpPr>
-          <p:cNvPr id="10" name="Shape 5"/>
+          <p:cNvPr id="3" name="Shape 1"/>
           <p:cNvSpPr/>
           <p:nvPr/>
         </p:nvSpPr>
         <p:spPr>
           <a:xfrm>
-            <a:off x="914400" y="3191256"/>
-            <a:ext cx="73152" cy="1024128"/>
+            <a:off x="4343400" y="1938528"/>
+            <a:ext cx="73152" cy="2514600"/>
           </a:xfrm>
           <a:prstGeom prst="rect">
             <a:avLst/>
@@ -25645,14 +23399,14 @@
       </p:sp>
       <p:sp>
         <p:nvSpPr>
-          <p:cNvPr id="11" name="Shape 6"/>
+          <p:cNvPr id="4" name="Shape 2"/>
           <p:cNvSpPr/>
           <p:nvPr/>
         </p:nvSpPr>
         <p:spPr>
           <a:xfrm>
-            <a:off x="914400" y="4507992"/>
-            <a:ext cx="73152" cy="1024128"/>
+            <a:off x="7863840" y="1938528"/>
+            <a:ext cx="73152" cy="2514600"/>
           </a:xfrm>
           <a:prstGeom prst="rect">
             <a:avLst/>
@@ -25672,7 +23426,7 @@
       </p:sp>
       <p:sp>
         <p:nvSpPr>
-          <p:cNvPr id="12" name="mdpr:1-3-c49d80:title:__title:1-3-c49d80"/>
+          <p:cNvPr id="5" name="mdpr:1-3-c49d80:title:__title:1-3-c49d80"/>
           <p:cNvSpPr txBox="1"/>
           <p:nvPr/>
         </p:nvSpPr>
@@ -25714,14 +23468,14 @@
       </p:sp>
       <p:sp>
         <p:nvSpPr>
-          <p:cNvPr id="13" name="mdpr:1-3-c49d80:item-1:block-12-chunk-1"/>
+          <p:cNvPr id="6" name="mdpr:1-3-c49d80:item-1:block-12-chunk-1"/>
           <p:cNvSpPr txBox="1"/>
           <p:nvPr/>
         </p:nvSpPr>
         <p:spPr>
           <a:xfrm>
-            <a:off x="1133856" y="2164080"/>
-            <a:ext cx="9820656" cy="426720"/>
+            <a:off x="1042416" y="2982468"/>
+            <a:ext cx="2825496" cy="426720"/>
           </a:xfrm>
           <a:prstGeom prst="rect">
             <a:avLst/>
@@ -25756,14 +23510,14 @@
       </p:sp>
       <p:sp>
         <p:nvSpPr>
-          <p:cNvPr id="14" name="mdpr:1-3-c49d80:item-2:block-12-chunk-1"/>
+          <p:cNvPr id="7" name="mdpr:1-3-c49d80:item-2:block-12-chunk-1"/>
           <p:cNvSpPr txBox="1"/>
           <p:nvPr/>
         </p:nvSpPr>
         <p:spPr>
           <a:xfrm>
-            <a:off x="1133856" y="3489960"/>
-            <a:ext cx="9820656" cy="426720"/>
+            <a:off x="4562856" y="2982468"/>
+            <a:ext cx="2825496" cy="426720"/>
           </a:xfrm>
           <a:prstGeom prst="rect">
             <a:avLst/>
@@ -25798,14 +23552,14 @@
       </p:sp>
       <p:sp>
         <p:nvSpPr>
-          <p:cNvPr id="15" name="mdpr:1-3-c49d80:item-3:block-12-chunk-1"/>
+          <p:cNvPr id="8" name="mdpr:1-3-c49d80:item-3:block-12-chunk-1"/>
           <p:cNvSpPr txBox="1"/>
           <p:nvPr/>
         </p:nvSpPr>
         <p:spPr>
           <a:xfrm>
-            <a:off x="1133856" y="4806696"/>
-            <a:ext cx="9820656" cy="426720"/>
+            <a:off x="8083296" y="2982468"/>
+            <a:ext cx="2825496" cy="426720"/>
           </a:xfrm>
           <a:prstGeom prst="rect">
             <a:avLst/>

</xml_diff>

<commit_message>
Content-size sparse continuation evidence
</commit_message>
<xml_diff>
--- a/artifacts/mdpr-vs-skill/mdpr-baseline-result.pptx
+++ b/artifacts/mdpr-vs-skill/mdpr-baseline-result.pptx
@@ -4010,8 +4010,8 @@
         </p:nvSpPr>
         <p:spPr>
           <a:xfrm>
-            <a:off x="822960" y="1938528"/>
-            <a:ext cx="73152" cy="2514600"/>
+            <a:off x="822960" y="2487168"/>
+            <a:ext cx="73152" cy="1417320"/>
           </a:xfrm>
           <a:prstGeom prst="rect">
             <a:avLst/>
@@ -4037,8 +4037,8 @@
         </p:nvSpPr>
         <p:spPr>
           <a:xfrm>
-            <a:off x="4343400" y="1938528"/>
-            <a:ext cx="73152" cy="2514600"/>
+            <a:off x="4343400" y="2487168"/>
+            <a:ext cx="73152" cy="1417320"/>
           </a:xfrm>
           <a:prstGeom prst="rect">
             <a:avLst/>
@@ -4064,8 +4064,8 @@
         </p:nvSpPr>
         <p:spPr>
           <a:xfrm>
-            <a:off x="7863840" y="1938528"/>
-            <a:ext cx="73152" cy="2514600"/>
+            <a:off x="7863840" y="2487168"/>
+            <a:ext cx="73152" cy="1417320"/>
           </a:xfrm>
           <a:prstGeom prst="rect">
             <a:avLst/>
@@ -7574,8 +7574,8 @@
         </p:nvSpPr>
         <p:spPr>
           <a:xfrm>
-            <a:off x="822960" y="1938528"/>
-            <a:ext cx="73152" cy="2514600"/>
+            <a:off x="822960" y="2487168"/>
+            <a:ext cx="73152" cy="1417320"/>
           </a:xfrm>
           <a:prstGeom prst="rect">
             <a:avLst/>
@@ -7601,8 +7601,8 @@
         </p:nvSpPr>
         <p:spPr>
           <a:xfrm>
-            <a:off x="4343400" y="1938528"/>
-            <a:ext cx="73152" cy="2514600"/>
+            <a:off x="4343400" y="2487168"/>
+            <a:ext cx="73152" cy="1417320"/>
           </a:xfrm>
           <a:prstGeom prst="rect">
             <a:avLst/>
@@ -7628,8 +7628,8 @@
         </p:nvSpPr>
         <p:spPr>
           <a:xfrm>
-            <a:off x="7863840" y="1938528"/>
-            <a:ext cx="73152" cy="2514600"/>
+            <a:off x="7863840" y="2487168"/>
+            <a:ext cx="73152" cy="1417320"/>
           </a:xfrm>
           <a:prstGeom prst="rect">
             <a:avLst/>
@@ -11207,8 +11207,8 @@
         </p:nvSpPr>
         <p:spPr>
           <a:xfrm>
-            <a:off x="822960" y="1938528"/>
-            <a:ext cx="73152" cy="2514600"/>
+            <a:off x="822960" y="2487168"/>
+            <a:ext cx="73152" cy="1417320"/>
           </a:xfrm>
           <a:prstGeom prst="rect">
             <a:avLst/>
@@ -11234,8 +11234,8 @@
         </p:nvSpPr>
         <p:spPr>
           <a:xfrm>
-            <a:off x="4343400" y="1938528"/>
-            <a:ext cx="73152" cy="2514600"/>
+            <a:off x="4343400" y="2487168"/>
+            <a:ext cx="73152" cy="1417320"/>
           </a:xfrm>
           <a:prstGeom prst="rect">
             <a:avLst/>
@@ -11261,8 +11261,8 @@
         </p:nvSpPr>
         <p:spPr>
           <a:xfrm>
-            <a:off x="7863840" y="1938528"/>
-            <a:ext cx="73152" cy="2514600"/>
+            <a:off x="7863840" y="2487168"/>
+            <a:ext cx="73152" cy="1417320"/>
           </a:xfrm>
           <a:prstGeom prst="rect">
             <a:avLst/>
@@ -13100,8 +13100,8 @@
         </p:nvSpPr>
         <p:spPr>
           <a:xfrm>
-            <a:off x="822960" y="1938528"/>
-            <a:ext cx="73152" cy="2514600"/>
+            <a:off x="822960" y="2487168"/>
+            <a:ext cx="73152" cy="1417320"/>
           </a:xfrm>
           <a:prstGeom prst="rect">
             <a:avLst/>
@@ -13127,8 +13127,8 @@
         </p:nvSpPr>
         <p:spPr>
           <a:xfrm>
-            <a:off x="4343400" y="1938528"/>
-            <a:ext cx="73152" cy="2514600"/>
+            <a:off x="4343400" y="2487168"/>
+            <a:ext cx="73152" cy="1417320"/>
           </a:xfrm>
           <a:prstGeom prst="rect">
             <a:avLst/>
@@ -13154,8 +13154,8 @@
         </p:nvSpPr>
         <p:spPr>
           <a:xfrm>
-            <a:off x="7863840" y="1938528"/>
-            <a:ext cx="73152" cy="2514600"/>
+            <a:off x="7863840" y="2487168"/>
+            <a:ext cx="73152" cy="1417320"/>
           </a:xfrm>
           <a:prstGeom prst="rect">
             <a:avLst/>

</xml_diff>

<commit_message>
Record sparse pipeline Pro cycle
</commit_message>
<xml_diff>
--- a/artifacts/mdpr-vs-skill/mdpr-baseline-result.pptx
+++ b/artifacts/mdpr-vs-skill/mdpr-baseline-result.pptx
@@ -20862,8 +20862,8 @@
         </p:nvSpPr>
         <p:spPr>
           <a:xfrm>
-            <a:off x="6103620" y="2802407"/>
-            <a:ext cx="0" cy="430225"/>
+            <a:off x="6103620" y="3051581"/>
+            <a:ext cx="0" cy="389077"/>
           </a:xfrm>
           <a:prstGeom prst="line">
             <a:avLst/>
@@ -20886,8 +20886,8 @@
         </p:nvSpPr>
         <p:spPr>
           <a:xfrm>
-            <a:off x="6103620" y="4439183"/>
-            <a:ext cx="0" cy="430225"/>
+            <a:off x="6103620" y="4231157"/>
+            <a:ext cx="0" cy="389077"/>
           </a:xfrm>
           <a:prstGeom prst="line">
             <a:avLst/>
@@ -20910,12 +20910,12 @@
         </p:nvSpPr>
         <p:spPr>
           <a:xfrm>
-            <a:off x="2169871" y="1536192"/>
-            <a:ext cx="7867498" cy="1325880"/>
+            <a:off x="2169871" y="2221992"/>
+            <a:ext cx="7867498" cy="868680"/>
           </a:xfrm>
           <a:prstGeom prst="roundRect">
             <a:avLst>
-              <a:gd name="adj" fmla="val 4138"/>
+              <a:gd name="adj" fmla="val 6316"/>
             </a:avLst>
           </a:prstGeom>
           <a:solidFill>
@@ -20944,7 +20944,7 @@
         </p:nvSpPr>
         <p:spPr>
           <a:xfrm>
-            <a:off x="2169871" y="1536192"/>
+            <a:off x="2169871" y="2221992"/>
             <a:ext cx="7867498" cy="109728"/>
           </a:xfrm>
           <a:prstGeom prst="rect">
@@ -20971,8 +20971,8 @@
         </p:nvSpPr>
         <p:spPr>
           <a:xfrm>
-            <a:off x="2334463" y="1997964"/>
-            <a:ext cx="402336" cy="402336"/>
+            <a:off x="2334463" y="2482596"/>
+            <a:ext cx="347472" cy="347472"/>
           </a:xfrm>
           <a:prstGeom prst="ellipse">
             <a:avLst/>
@@ -20998,8 +20998,8 @@
         </p:nvSpPr>
         <p:spPr>
           <a:xfrm>
-            <a:off x="2334463" y="1997964"/>
-            <a:ext cx="402336" cy="402336"/>
+            <a:off x="2334463" y="2482596"/>
+            <a:ext cx="347472" cy="347472"/>
           </a:xfrm>
           <a:prstGeom prst="rect">
             <a:avLst/>
@@ -21042,8 +21042,8 @@
         </p:nvSpPr>
         <p:spPr>
           <a:xfrm>
-            <a:off x="2883103" y="1664208"/>
-            <a:ext cx="6989674" cy="1069848"/>
+            <a:off x="2828239" y="2350008"/>
+            <a:ext cx="7044538" cy="612648"/>
           </a:xfrm>
           <a:prstGeom prst="rect">
             <a:avLst/>
@@ -21086,12 +21086,12 @@
         </p:nvSpPr>
         <p:spPr>
           <a:xfrm>
-            <a:off x="2169871" y="3172968"/>
-            <a:ext cx="7867498" cy="1325880"/>
+            <a:off x="2169871" y="3401568"/>
+            <a:ext cx="7867498" cy="868680"/>
           </a:xfrm>
           <a:prstGeom prst="roundRect">
             <a:avLst>
-              <a:gd name="adj" fmla="val 4138"/>
+              <a:gd name="adj" fmla="val 6316"/>
             </a:avLst>
           </a:prstGeom>
           <a:solidFill>
@@ -21120,7 +21120,7 @@
         </p:nvSpPr>
         <p:spPr>
           <a:xfrm>
-            <a:off x="2169871" y="3172968"/>
+            <a:off x="2169871" y="3401568"/>
             <a:ext cx="7867498" cy="109728"/>
           </a:xfrm>
           <a:prstGeom prst="rect">
@@ -21147,8 +21147,8 @@
         </p:nvSpPr>
         <p:spPr>
           <a:xfrm>
-            <a:off x="2334463" y="3634740"/>
-            <a:ext cx="402336" cy="402336"/>
+            <a:off x="2334463" y="3662172"/>
+            <a:ext cx="347472" cy="347472"/>
           </a:xfrm>
           <a:prstGeom prst="ellipse">
             <a:avLst/>
@@ -21174,8 +21174,8 @@
         </p:nvSpPr>
         <p:spPr>
           <a:xfrm>
-            <a:off x="2334463" y="3634740"/>
-            <a:ext cx="402336" cy="402336"/>
+            <a:off x="2334463" y="3662172"/>
+            <a:ext cx="347472" cy="347472"/>
           </a:xfrm>
           <a:prstGeom prst="rect">
             <a:avLst/>
@@ -21218,8 +21218,8 @@
         </p:nvSpPr>
         <p:spPr>
           <a:xfrm>
-            <a:off x="2883103" y="3300984"/>
-            <a:ext cx="6989674" cy="1069848"/>
+            <a:off x="2828239" y="3529584"/>
+            <a:ext cx="7044538" cy="612648"/>
           </a:xfrm>
           <a:prstGeom prst="rect">
             <a:avLst/>
@@ -21262,12 +21262,12 @@
         </p:nvSpPr>
         <p:spPr>
           <a:xfrm>
-            <a:off x="2169871" y="4809744"/>
-            <a:ext cx="7867498" cy="1325880"/>
+            <a:off x="2169871" y="4581144"/>
+            <a:ext cx="7867498" cy="868680"/>
           </a:xfrm>
           <a:prstGeom prst="roundRect">
             <a:avLst>
-              <a:gd name="adj" fmla="val 4138"/>
+              <a:gd name="adj" fmla="val 6316"/>
             </a:avLst>
           </a:prstGeom>
           <a:solidFill>
@@ -21296,7 +21296,7 @@
         </p:nvSpPr>
         <p:spPr>
           <a:xfrm>
-            <a:off x="2169871" y="4809744"/>
+            <a:off x="2169871" y="4581144"/>
             <a:ext cx="7867498" cy="109728"/>
           </a:xfrm>
           <a:prstGeom prst="rect">
@@ -21323,8 +21323,8 @@
         </p:nvSpPr>
         <p:spPr>
           <a:xfrm>
-            <a:off x="2334463" y="5271516"/>
-            <a:ext cx="402336" cy="402336"/>
+            <a:off x="2334463" y="4841748"/>
+            <a:ext cx="347472" cy="347472"/>
           </a:xfrm>
           <a:prstGeom prst="ellipse">
             <a:avLst/>
@@ -21350,8 +21350,8 @@
         </p:nvSpPr>
         <p:spPr>
           <a:xfrm>
-            <a:off x="2334463" y="5271516"/>
-            <a:ext cx="402336" cy="402336"/>
+            <a:off x="2334463" y="4841748"/>
+            <a:ext cx="347472" cy="347472"/>
           </a:xfrm>
           <a:prstGeom prst="rect">
             <a:avLst/>
@@ -21394,8 +21394,8 @@
         </p:nvSpPr>
         <p:spPr>
           <a:xfrm>
-            <a:off x="2883103" y="4937760"/>
-            <a:ext cx="6989674" cy="1069848"/>
+            <a:off x="2828239" y="4709160"/>
+            <a:ext cx="7044538" cy="612648"/>
           </a:xfrm>
           <a:prstGeom prst="rect">
             <a:avLst/>

</xml_diff>

<commit_message>
Record follow-up Pro cycle 1 table balance
</commit_message>
<xml_diff>
--- a/artifacts/mdpr-vs-skill/mdpr-baseline-result.pptx
+++ b/artifacts/mdpr-vs-skill/mdpr-baseline-result.pptx
@@ -18035,9 +18035,9 @@
             <a:tbl>
               <a:tblPr/>
               <a:tblGrid>
-                <a:gridCol w="3413760"/>
-                <a:gridCol w="3413760"/>
-                <a:gridCol w="3413760"/>
+                <a:gridCol w="1234440"/>
+                <a:gridCol w="4503420"/>
+                <a:gridCol w="4503420"/>
               </a:tblGrid>
               <a:tr h="905256">
                 <a:tc>

</xml_diff>

<commit_message>
Record follow-up Pro cycle 3 body accents
</commit_message>
<xml_diff>
--- a/artifacts/mdpr-vs-skill/mdpr-baseline-result.pptx
+++ b/artifacts/mdpr-vs-skill/mdpr-baseline-result.pptx
@@ -4368,34 +4368,7 @@
       </p:sp>
       <p:sp>
         <p:nvSpPr>
-          <p:cNvPr id="4" name="Shape 1"/>
-          <p:cNvSpPr/>
-          <p:nvPr/>
-        </p:nvSpPr>
-        <p:spPr>
-          <a:xfrm>
-            <a:off x="822960" y="1417320"/>
-            <a:ext cx="3794760" cy="73152"/>
-          </a:xfrm>
-          <a:prstGeom prst="rect">
-            <a:avLst/>
-          </a:prstGeom>
-          <a:solidFill>
-            <a:srgbClr val="2563EB"/>
-          </a:solidFill>
-          <a:ln w="12700">
-            <a:solidFill>
-              <a:srgbClr val="2563EB">
-                <a:alpha val="0"/>
-              </a:srgbClr>
-            </a:solidFill>
-            <a:prstDash val="solid"/>
-          </a:ln>
-        </p:spPr>
-      </p:sp>
-      <p:sp>
-        <p:nvSpPr>
-          <p:cNvPr id="5" name="mdpr:3-3-a4649c:title:__title:3-3-a4649c"/>
+          <p:cNvPr id="4" name="mdpr:3-3-a4649c:title:__title:3-3-a4649c"/>
           <p:cNvSpPr txBox="1"/>
           <p:nvPr/>
         </p:nvSpPr>
@@ -4454,7 +4427,7 @@
       </p:sp>
       <p:sp>
         <p:nvSpPr>
-          <p:cNvPr id="6" name="mdpr:3-3-a4649c:body:block-12-chunk-3-block-14"/>
+          <p:cNvPr id="5" name="mdpr:3-3-a4649c:body:block-12-chunk-3-block-14"/>
           <p:cNvSpPr txBox="1"/>
           <p:nvPr/>
         </p:nvSpPr>
@@ -6405,34 +6378,7 @@
       </p:sp>
       <p:sp>
         <p:nvSpPr>
-          <p:cNvPr id="4" name="Shape 1"/>
-          <p:cNvSpPr/>
-          <p:nvPr/>
-        </p:nvSpPr>
-        <p:spPr>
-          <a:xfrm>
-            <a:off x="822960" y="1417320"/>
-            <a:ext cx="3794760" cy="73152"/>
-          </a:xfrm>
-          <a:prstGeom prst="rect">
-            <a:avLst/>
-          </a:prstGeom>
-          <a:solidFill>
-            <a:srgbClr val="2563EB"/>
-          </a:solidFill>
-          <a:ln w="12700">
-            <a:solidFill>
-              <a:srgbClr val="2563EB">
-                <a:alpha val="0"/>
-              </a:srgbClr>
-            </a:solidFill>
-            <a:prstDash val="solid"/>
-          </a:ln>
-        </p:spPr>
-      </p:sp>
-      <p:sp>
-        <p:nvSpPr>
-          <p:cNvPr id="5" name="mdpr:3-3-5eedd2:title:__title:3-3-5eedd2"/>
+          <p:cNvPr id="4" name="mdpr:3-3-5eedd2:title:__title:3-3-5eedd2"/>
           <p:cNvSpPr txBox="1"/>
           <p:nvPr/>
         </p:nvSpPr>
@@ -6491,7 +6437,7 @@
       </p:sp>
       <p:sp>
         <p:nvSpPr>
-          <p:cNvPr id="6" name="mdpr:3-3-5eedd2:body:block-16-chunk-3-block-18"/>
+          <p:cNvPr id="5" name="mdpr:3-3-5eedd2:body:block-16-chunk-3-block-18"/>
           <p:cNvSpPr txBox="1"/>
           <p:nvPr/>
         </p:nvSpPr>
@@ -7341,34 +7287,7 @@
       </p:grpSpPr>
       <p:sp>
         <p:nvSpPr>
-          <p:cNvPr id="2" name="Shape 0"/>
-          <p:cNvSpPr/>
-          <p:nvPr/>
-        </p:nvSpPr>
-        <p:spPr>
-          <a:xfrm>
-            <a:off x="914400" y="1463040"/>
-            <a:ext cx="10241280" cy="73152"/>
-          </a:xfrm>
-          <a:prstGeom prst="rect">
-            <a:avLst/>
-          </a:prstGeom>
-          <a:solidFill>
-            <a:srgbClr val="2563EB"/>
-          </a:solidFill>
-          <a:ln w="12700">
-            <a:solidFill>
-              <a:srgbClr val="2563EB">
-                <a:alpha val="0"/>
-              </a:srgbClr>
-            </a:solidFill>
-            <a:prstDash val="solid"/>
-          </a:ln>
-        </p:spPr>
-      </p:sp>
-      <p:sp>
-        <p:nvSpPr>
-          <p:cNvPr id="3" name="mdpr:1-3-0466ef:title:__title:1-3-0466ef"/>
+          <p:cNvPr id="2" name="mdpr:1-3-0466ef:title:__title:1-3-0466ef"/>
           <p:cNvSpPr txBox="1"/>
           <p:nvPr/>
         </p:nvSpPr>
@@ -7410,7 +7329,7 @@
       </p:sp>
       <p:sp>
         <p:nvSpPr>
-          <p:cNvPr id="4" name="mdpr:1-3-0466ef:body:block-20-chunk-1"/>
+          <p:cNvPr id="3" name="mdpr:1-3-0466ef:body:block-20-chunk-1"/>
           <p:cNvSpPr txBox="1"/>
           <p:nvPr/>
         </p:nvSpPr>
@@ -7452,7 +7371,7 @@
       </p:sp>
       <p:sp>
         <p:nvSpPr>
-          <p:cNvPr id="5" name="mdpr:1-3-0466ef:body:block-20-chunk-1"/>
+          <p:cNvPr id="4" name="mdpr:1-3-0466ef:body:block-20-chunk-1"/>
           <p:cNvSpPr txBox="1"/>
           <p:nvPr/>
         </p:nvSpPr>
@@ -7494,7 +7413,7 @@
       </p:sp>
       <p:sp>
         <p:nvSpPr>
-          <p:cNvPr id="6" name="mdpr:1-3-0466ef:body:block-20-chunk-1"/>
+          <p:cNvPr id="5" name="mdpr:1-3-0466ef:body:block-20-chunk-1"/>
           <p:cNvSpPr txBox="1"/>
           <p:nvPr/>
         </p:nvSpPr>

</xml_diff>

<commit_message>
Reconcile corpus evidence labels
</commit_message>
<xml_diff>
--- a/artifacts/mdpr-vs-skill/mdpr-baseline-result.pptx
+++ b/artifacts/mdpr-vs-skill/mdpr-baseline-result.pptx
@@ -19068,150 +19068,6 @@
         </p:nvSpPr>
         <p:spPr>
           <a:xfrm>
-            <a:off x="4002024" y="5317236"/>
-            <a:ext cx="457200" cy="0"/>
-          </a:xfrm>
-          <a:prstGeom prst="line">
-            <a:avLst/>
-          </a:prstGeom>
-          <a:noFill/>
-          <a:ln w="12700">
-            <a:solidFill>
-              <a:srgbClr val="2563EB"/>
-            </a:solidFill>
-            <a:prstDash val="solid"/>
-            <a:tailEnd type="triangle"/>
-          </a:ln>
-        </p:spPr>
-      </p:sp>
-      <p:sp>
-        <p:nvSpPr>
-          <p:cNvPr id="4" name="Shape 2"/>
-          <p:cNvSpPr/>
-          <p:nvPr/>
-        </p:nvSpPr>
-        <p:spPr>
-          <a:xfrm>
-            <a:off x="7748016" y="5317236"/>
-            <a:ext cx="457200" cy="0"/>
-          </a:xfrm>
-          <a:prstGeom prst="line">
-            <a:avLst/>
-          </a:prstGeom>
-          <a:noFill/>
-          <a:ln w="12700">
-            <a:solidFill>
-              <a:srgbClr val="2563EB"/>
-            </a:solidFill>
-            <a:prstDash val="solid"/>
-            <a:tailEnd type="triangle"/>
-          </a:ln>
-        </p:spPr>
-      </p:sp>
-      <p:sp>
-        <p:nvSpPr>
-          <p:cNvPr id="5" name="Shape 3"/>
-          <p:cNvSpPr/>
-          <p:nvPr/>
-        </p:nvSpPr>
-        <p:spPr>
-          <a:xfrm>
-            <a:off x="9849612" y="4368455"/>
-            <a:ext cx="0" cy="416235"/>
-          </a:xfrm>
-          <a:prstGeom prst="line">
-            <a:avLst/>
-          </a:prstGeom>
-          <a:noFill/>
-          <a:ln w="12700">
-            <a:solidFill>
-              <a:srgbClr val="2563EB"/>
-            </a:solidFill>
-            <a:prstDash val="solid"/>
-            <a:headEnd type="triangle"/>
-          </a:ln>
-        </p:spPr>
-      </p:sp>
-      <p:sp>
-        <p:nvSpPr>
-          <p:cNvPr id="6" name="Shape 4"/>
-          <p:cNvSpPr/>
-          <p:nvPr/>
-        </p:nvSpPr>
-        <p:spPr>
-          <a:xfrm>
-            <a:off x="9849612" y="2887127"/>
-            <a:ext cx="0" cy="416235"/>
-          </a:xfrm>
-          <a:prstGeom prst="line">
-            <a:avLst/>
-          </a:prstGeom>
-          <a:noFill/>
-          <a:ln w="12700">
-            <a:solidFill>
-              <a:srgbClr val="2563EB"/>
-            </a:solidFill>
-            <a:prstDash val="solid"/>
-            <a:headEnd type="triangle"/>
-          </a:ln>
-        </p:spPr>
-      </p:sp>
-      <p:sp>
-        <p:nvSpPr>
-          <p:cNvPr id="7" name="Shape 5"/>
-          <p:cNvSpPr/>
-          <p:nvPr/>
-        </p:nvSpPr>
-        <p:spPr>
-          <a:xfrm>
-            <a:off x="7748016" y="2354580"/>
-            <a:ext cx="457200" cy="0"/>
-          </a:xfrm>
-          <a:prstGeom prst="line">
-            <a:avLst/>
-          </a:prstGeom>
-          <a:noFill/>
-          <a:ln w="12700">
-            <a:solidFill>
-              <a:srgbClr val="2563EB"/>
-            </a:solidFill>
-            <a:prstDash val="solid"/>
-            <a:headEnd type="triangle"/>
-          </a:ln>
-        </p:spPr>
-      </p:sp>
-      <p:sp>
-        <p:nvSpPr>
-          <p:cNvPr id="8" name="Shape 6"/>
-          <p:cNvSpPr/>
-          <p:nvPr/>
-        </p:nvSpPr>
-        <p:spPr>
-          <a:xfrm>
-            <a:off x="4002024" y="2354580"/>
-            <a:ext cx="457200" cy="0"/>
-          </a:xfrm>
-          <a:prstGeom prst="line">
-            <a:avLst/>
-          </a:prstGeom>
-          <a:noFill/>
-          <a:ln w="12700">
-            <a:solidFill>
-              <a:srgbClr val="2563EB"/>
-            </a:solidFill>
-            <a:prstDash val="solid"/>
-            <a:headEnd type="triangle"/>
-          </a:ln>
-        </p:spPr>
-      </p:sp>
-      <p:sp>
-        <p:nvSpPr>
-          <p:cNvPr id="9" name="Shape 7"/>
-          <p:cNvSpPr/>
-          <p:nvPr/>
-        </p:nvSpPr>
-        <p:spPr>
-          <a:xfrm>
             <a:off x="4002024" y="2354580"/>
             <a:ext cx="228600" cy="0"/>
           </a:xfrm>
@@ -19229,7 +19085,7 @@
       </p:sp>
       <p:sp>
         <p:nvSpPr>
-          <p:cNvPr id="10" name="Shape 8"/>
+          <p:cNvPr id="4" name="Shape 2"/>
           <p:cNvSpPr/>
           <p:nvPr/>
         </p:nvSpPr>
@@ -19252,31 +19108,7 @@
       </p:sp>
       <p:sp>
         <p:nvSpPr>
-          <p:cNvPr id="11" name="Shape 9"/>
-          <p:cNvSpPr/>
-          <p:nvPr/>
-        </p:nvSpPr>
-        <p:spPr>
-          <a:xfrm>
-            <a:off x="4230624" y="3835908"/>
-            <a:ext cx="228600" cy="0"/>
-          </a:xfrm>
-          <a:prstGeom prst="line">
-            <a:avLst/>
-          </a:prstGeom>
-          <a:noFill/>
-          <a:ln w="12700">
-            <a:solidFill>
-              <a:srgbClr val="2563EB"/>
-            </a:solidFill>
-            <a:prstDash val="solid"/>
-            <a:tailEnd type="triangle"/>
-          </a:ln>
-        </p:spPr>
-      </p:sp>
-      <p:sp>
-        <p:nvSpPr>
-          <p:cNvPr id="12" name="Shape 10"/>
+          <p:cNvPr id="5" name="Shape 3"/>
           <p:cNvSpPr/>
           <p:nvPr/>
         </p:nvSpPr>
@@ -19310,149 +19142,7 @@
       </p:sp>
       <p:sp>
         <p:nvSpPr>
-          <p:cNvPr id="13" name="Shape 11"/>
-          <p:cNvSpPr/>
-          <p:nvPr/>
-        </p:nvSpPr>
-        <p:spPr>
-          <a:xfrm>
-            <a:off x="640080" y="4732020"/>
-            <a:ext cx="3435096" cy="109728"/>
-          </a:xfrm>
-          <a:prstGeom prst="rect">
-            <a:avLst/>
-          </a:prstGeom>
-          <a:solidFill>
-            <a:srgbClr val="2563EB"/>
-          </a:solidFill>
-          <a:ln w="12700">
-            <a:solidFill>
-              <a:srgbClr val="2563EB">
-                <a:alpha val="0"/>
-              </a:srgbClr>
-            </a:solidFill>
-            <a:prstDash val="solid"/>
-          </a:ln>
-        </p:spPr>
-      </p:sp>
-      <p:sp>
-        <p:nvSpPr>
-          <p:cNvPr id="14" name="Shape 12"/>
-          <p:cNvSpPr/>
-          <p:nvPr/>
-        </p:nvSpPr>
-        <p:spPr>
-          <a:xfrm>
-            <a:off x="804672" y="5129967"/>
-            <a:ext cx="374538" cy="374538"/>
-          </a:xfrm>
-          <a:prstGeom prst="ellipse">
-            <a:avLst/>
-          </a:prstGeom>
-          <a:solidFill>
-            <a:srgbClr val="2563EB"/>
-          </a:solidFill>
-          <a:ln w="12700">
-            <a:solidFill>
-              <a:srgbClr val="2563EB">
-                <a:alpha val="0"/>
-              </a:srgbClr>
-            </a:solidFill>
-            <a:prstDash val="solid"/>
-          </a:ln>
-        </p:spPr>
-      </p:sp>
-      <p:sp>
-        <p:nvSpPr>
-          <p:cNvPr id="15" name="Text 13"/>
-          <p:cNvSpPr txBox="1"/>
-          <p:nvPr/>
-        </p:nvSpPr>
-        <p:spPr>
-          <a:xfrm>
-            <a:off x="804672" y="5129967"/>
-            <a:ext cx="374538" cy="374538"/>
-          </a:xfrm>
-          <a:prstGeom prst="rect">
-            <a:avLst/>
-          </a:prstGeom>
-          <a:noFill/>
-          <a:ln/>
-        </p:spPr>
-        <p:txBody>
-          <a:bodyPr wrap="square" lIns="0" tIns="0" rIns="0" bIns="0" rtlCol="0" anchor="ctr">
-            <a:normAutofit/>
-          </a:bodyPr>
-          <a:lstStyle/>
-          <a:p>
-            <a:pPr algn="ctr" indent="0" marL="0">
-              <a:lnSpc>
-                <a:spcPct val="120000"/>
-              </a:lnSpc>
-              <a:buNone/>
-            </a:pPr>
-            <a:r>
-              <a:rPr lang="en-US" sz="1600" b="1" dirty="0">
-                <a:solidFill>
-                  <a:srgbClr val="F8FAFC"/>
-                </a:solidFill>
-                <a:latin typeface="Pretendard" pitchFamily="34" charset="0"/>
-                <a:ea typeface="Pretendard" pitchFamily="34" charset="-122"/>
-                <a:cs typeface="Pretendard" pitchFamily="34" charset="-120"/>
-              </a:rPr>
-              <a:t>1</a:t>
-            </a:r>
-            <a:endParaRPr lang="en-US" sz="1600" dirty="0"/>
-          </a:p>
-        </p:txBody>
-      </p:sp>
-      <p:sp>
-        <p:nvSpPr>
-          <p:cNvPr id="16" name="Text 14"/>
-          <p:cNvSpPr txBox="1"/>
-          <p:nvPr/>
-        </p:nvSpPr>
-        <p:spPr>
-          <a:xfrm>
-            <a:off x="1325514" y="4860036"/>
-            <a:ext cx="2585070" cy="914400"/>
-          </a:xfrm>
-          <a:prstGeom prst="rect">
-            <a:avLst/>
-          </a:prstGeom>
-          <a:noFill/>
-          <a:ln/>
-        </p:spPr>
-        <p:txBody>
-          <a:bodyPr wrap="square" lIns="0" tIns="25400" rIns="25400" bIns="0" rtlCol="0" anchor="ctr">
-            <a:normAutofit/>
-          </a:bodyPr>
-          <a:lstStyle/>
-          <a:p>
-            <a:pPr algn="l" indent="0" marL="0">
-              <a:lnSpc>
-                <a:spcPct val="92000"/>
-              </a:lnSpc>
-              <a:buNone/>
-            </a:pPr>
-            <a:r>
-              <a:rPr lang="en-US" sz="1600" dirty="0">
-                <a:solidFill>
-                  <a:srgbClr val="111111"/>
-                </a:solidFill>
-                <a:latin typeface="Pretendard" pitchFamily="34" charset="0"/>
-                <a:ea typeface="Pretendard" pitchFamily="34" charset="-122"/>
-                <a:cs typeface="Pretendard" pitchFamily="34" charset="-120"/>
-              </a:rPr>
-              <a:t>Markdown</a:t>
-            </a:r>
-            <a:endParaRPr lang="en-US" sz="1600" dirty="0"/>
-          </a:p>
-        </p:txBody>
-      </p:sp>
-      <p:sp>
-        <p:nvSpPr>
-          <p:cNvPr id="17" name="Shape 15"/>
+          <p:cNvPr id="6" name="Shape 4"/>
           <p:cNvSpPr/>
           <p:nvPr/>
         </p:nvSpPr>
@@ -19486,149 +19176,7 @@
       </p:sp>
       <p:sp>
         <p:nvSpPr>
-          <p:cNvPr id="18" name="Shape 16"/>
-          <p:cNvSpPr/>
-          <p:nvPr/>
-        </p:nvSpPr>
-        <p:spPr>
-          <a:xfrm>
-            <a:off x="4386072" y="4732020"/>
-            <a:ext cx="3435096" cy="109728"/>
-          </a:xfrm>
-          <a:prstGeom prst="rect">
-            <a:avLst/>
-          </a:prstGeom>
-          <a:solidFill>
-            <a:srgbClr val="2563EB"/>
-          </a:solidFill>
-          <a:ln w="12700">
-            <a:solidFill>
-              <a:srgbClr val="2563EB">
-                <a:alpha val="0"/>
-              </a:srgbClr>
-            </a:solidFill>
-            <a:prstDash val="solid"/>
-          </a:ln>
-        </p:spPr>
-      </p:sp>
-      <p:sp>
-        <p:nvSpPr>
-          <p:cNvPr id="19" name="Shape 17"/>
-          <p:cNvSpPr/>
-          <p:nvPr/>
-        </p:nvSpPr>
-        <p:spPr>
-          <a:xfrm>
-            <a:off x="4550664" y="5129967"/>
-            <a:ext cx="374538" cy="374538"/>
-          </a:xfrm>
-          <a:prstGeom prst="ellipse">
-            <a:avLst/>
-          </a:prstGeom>
-          <a:solidFill>
-            <a:srgbClr val="2563EB"/>
-          </a:solidFill>
-          <a:ln w="12700">
-            <a:solidFill>
-              <a:srgbClr val="2563EB">
-                <a:alpha val="0"/>
-              </a:srgbClr>
-            </a:solidFill>
-            <a:prstDash val="solid"/>
-          </a:ln>
-        </p:spPr>
-      </p:sp>
-      <p:sp>
-        <p:nvSpPr>
-          <p:cNvPr id="20" name="Text 18"/>
-          <p:cNvSpPr txBox="1"/>
-          <p:nvPr/>
-        </p:nvSpPr>
-        <p:spPr>
-          <a:xfrm>
-            <a:off x="4550664" y="5129967"/>
-            <a:ext cx="374538" cy="374538"/>
-          </a:xfrm>
-          <a:prstGeom prst="rect">
-            <a:avLst/>
-          </a:prstGeom>
-          <a:noFill/>
-          <a:ln/>
-        </p:spPr>
-        <p:txBody>
-          <a:bodyPr wrap="square" lIns="0" tIns="0" rIns="0" bIns="0" rtlCol="0" anchor="ctr">
-            <a:normAutofit/>
-          </a:bodyPr>
-          <a:lstStyle/>
-          <a:p>
-            <a:pPr algn="ctr" indent="0" marL="0">
-              <a:lnSpc>
-                <a:spcPct val="120000"/>
-              </a:lnSpc>
-              <a:buNone/>
-            </a:pPr>
-            <a:r>
-              <a:rPr lang="en-US" sz="1600" b="1" dirty="0">
-                <a:solidFill>
-                  <a:srgbClr val="F8FAFC"/>
-                </a:solidFill>
-                <a:latin typeface="Pretendard" pitchFamily="34" charset="0"/>
-                <a:ea typeface="Pretendard" pitchFamily="34" charset="-122"/>
-                <a:cs typeface="Pretendard" pitchFamily="34" charset="-120"/>
-              </a:rPr>
-              <a:t>2</a:t>
-            </a:r>
-            <a:endParaRPr lang="en-US" sz="1600" dirty="0"/>
-          </a:p>
-        </p:txBody>
-      </p:sp>
-      <p:sp>
-        <p:nvSpPr>
-          <p:cNvPr id="21" name="Text 19"/>
-          <p:cNvSpPr txBox="1"/>
-          <p:nvPr/>
-        </p:nvSpPr>
-        <p:spPr>
-          <a:xfrm>
-            <a:off x="5071506" y="4860036"/>
-            <a:ext cx="2585070" cy="914400"/>
-          </a:xfrm>
-          <a:prstGeom prst="rect">
-            <a:avLst/>
-          </a:prstGeom>
-          <a:noFill/>
-          <a:ln/>
-        </p:spPr>
-        <p:txBody>
-          <a:bodyPr wrap="square" lIns="0" tIns="25400" rIns="25400" bIns="0" rtlCol="0" anchor="ctr">
-            <a:normAutofit/>
-          </a:bodyPr>
-          <a:lstStyle/>
-          <a:p>
-            <a:pPr algn="l" indent="0" marL="0">
-              <a:lnSpc>
-                <a:spcPct val="92000"/>
-              </a:lnSpc>
-              <a:buNone/>
-            </a:pPr>
-            <a:r>
-              <a:rPr lang="en-US" sz="1600" dirty="0">
-                <a:solidFill>
-                  <a:srgbClr val="111111"/>
-                </a:solidFill>
-                <a:latin typeface="Pretendard" pitchFamily="34" charset="0"/>
-                <a:ea typeface="Pretendard" pitchFamily="34" charset="-122"/>
-                <a:cs typeface="Pretendard" pitchFamily="34" charset="-120"/>
-              </a:rPr>
-              <a:t>MDPR parser</a:t>
-            </a:r>
-            <a:endParaRPr lang="en-US" sz="1600" dirty="0"/>
-          </a:p>
-        </p:txBody>
-      </p:sp>
-      <p:sp>
-        <p:nvSpPr>
-          <p:cNvPr id="22" name="Shape 20"/>
+          <p:cNvPr id="7" name="Shape 5"/>
           <p:cNvSpPr/>
           <p:nvPr/>
         </p:nvSpPr>
@@ -19662,149 +19210,7 @@
       </p:sp>
       <p:sp>
         <p:nvSpPr>
-          <p:cNvPr id="23" name="Shape 21"/>
-          <p:cNvSpPr/>
-          <p:nvPr/>
-        </p:nvSpPr>
-        <p:spPr>
-          <a:xfrm>
-            <a:off x="8132064" y="4732020"/>
-            <a:ext cx="3435096" cy="109728"/>
-          </a:xfrm>
-          <a:prstGeom prst="rect">
-            <a:avLst/>
-          </a:prstGeom>
-          <a:solidFill>
-            <a:srgbClr val="2563EB"/>
-          </a:solidFill>
-          <a:ln w="12700">
-            <a:solidFill>
-              <a:srgbClr val="2563EB">
-                <a:alpha val="0"/>
-              </a:srgbClr>
-            </a:solidFill>
-            <a:prstDash val="solid"/>
-          </a:ln>
-        </p:spPr>
-      </p:sp>
-      <p:sp>
-        <p:nvSpPr>
-          <p:cNvPr id="24" name="Shape 22"/>
-          <p:cNvSpPr/>
-          <p:nvPr/>
-        </p:nvSpPr>
-        <p:spPr>
-          <a:xfrm>
-            <a:off x="8296656" y="5129967"/>
-            <a:ext cx="374538" cy="374538"/>
-          </a:xfrm>
-          <a:prstGeom prst="ellipse">
-            <a:avLst/>
-          </a:prstGeom>
-          <a:solidFill>
-            <a:srgbClr val="2563EB"/>
-          </a:solidFill>
-          <a:ln w="12700">
-            <a:solidFill>
-              <a:srgbClr val="2563EB">
-                <a:alpha val="0"/>
-              </a:srgbClr>
-            </a:solidFill>
-            <a:prstDash val="solid"/>
-          </a:ln>
-        </p:spPr>
-      </p:sp>
-      <p:sp>
-        <p:nvSpPr>
-          <p:cNvPr id="25" name="Text 23"/>
-          <p:cNvSpPr txBox="1"/>
-          <p:nvPr/>
-        </p:nvSpPr>
-        <p:spPr>
-          <a:xfrm>
-            <a:off x="8296656" y="5129967"/>
-            <a:ext cx="374538" cy="374538"/>
-          </a:xfrm>
-          <a:prstGeom prst="rect">
-            <a:avLst/>
-          </a:prstGeom>
-          <a:noFill/>
-          <a:ln/>
-        </p:spPr>
-        <p:txBody>
-          <a:bodyPr wrap="square" lIns="0" tIns="0" rIns="0" bIns="0" rtlCol="0" anchor="ctr">
-            <a:normAutofit/>
-          </a:bodyPr>
-          <a:lstStyle/>
-          <a:p>
-            <a:pPr algn="ctr" indent="0" marL="0">
-              <a:lnSpc>
-                <a:spcPct val="120000"/>
-              </a:lnSpc>
-              <a:buNone/>
-            </a:pPr>
-            <a:r>
-              <a:rPr lang="en-US" sz="1600" b="1" dirty="0">
-                <a:solidFill>
-                  <a:srgbClr val="F8FAFC"/>
-                </a:solidFill>
-                <a:latin typeface="Pretendard" pitchFamily="34" charset="0"/>
-                <a:ea typeface="Pretendard" pitchFamily="34" charset="-122"/>
-                <a:cs typeface="Pretendard" pitchFamily="34" charset="-120"/>
-              </a:rPr>
-              <a:t>3</a:t>
-            </a:r>
-            <a:endParaRPr lang="en-US" sz="1600" dirty="0"/>
-          </a:p>
-        </p:txBody>
-      </p:sp>
-      <p:sp>
-        <p:nvSpPr>
-          <p:cNvPr id="26" name="Text 24"/>
-          <p:cNvSpPr txBox="1"/>
-          <p:nvPr/>
-        </p:nvSpPr>
-        <p:spPr>
-          <a:xfrm>
-            <a:off x="8817498" y="4860036"/>
-            <a:ext cx="2585070" cy="914400"/>
-          </a:xfrm>
-          <a:prstGeom prst="rect">
-            <a:avLst/>
-          </a:prstGeom>
-          <a:noFill/>
-          <a:ln/>
-        </p:spPr>
-        <p:txBody>
-          <a:bodyPr wrap="square" lIns="0" tIns="25400" rIns="25400" bIns="0" rtlCol="0" anchor="ctr">
-            <a:normAutofit/>
-          </a:bodyPr>
-          <a:lstStyle/>
-          <a:p>
-            <a:pPr algn="l" indent="0" marL="0">
-              <a:lnSpc>
-                <a:spcPct val="92000"/>
-              </a:lnSpc>
-              <a:buNone/>
-            </a:pPr>
-            <a:r>
-              <a:rPr lang="en-US" sz="1600" dirty="0">
-                <a:solidFill>
-                  <a:srgbClr val="111111"/>
-                </a:solidFill>
-                <a:latin typeface="Pretendard" pitchFamily="34" charset="0"/>
-                <a:ea typeface="Pretendard" pitchFamily="34" charset="-122"/>
-                <a:cs typeface="Pretendard" pitchFamily="34" charset="-120"/>
-              </a:rPr>
-              <a:t>BlockIR</a:t>
-            </a:r>
-            <a:endParaRPr lang="en-US" sz="1600" dirty="0"/>
-          </a:p>
-        </p:txBody>
-      </p:sp>
-      <p:sp>
-        <p:nvSpPr>
-          <p:cNvPr id="27" name="Shape 25"/>
+          <p:cNvPr id="8" name="Shape 6"/>
           <p:cNvSpPr/>
           <p:nvPr/>
         </p:nvSpPr>
@@ -19838,149 +19244,7 @@
       </p:sp>
       <p:sp>
         <p:nvSpPr>
-          <p:cNvPr id="28" name="Shape 26"/>
-          <p:cNvSpPr/>
-          <p:nvPr/>
-        </p:nvSpPr>
-        <p:spPr>
-          <a:xfrm>
-            <a:off x="8132064" y="3250692"/>
-            <a:ext cx="3435096" cy="109728"/>
-          </a:xfrm>
-          <a:prstGeom prst="rect">
-            <a:avLst/>
-          </a:prstGeom>
-          <a:solidFill>
-            <a:srgbClr val="2563EB"/>
-          </a:solidFill>
-          <a:ln w="12700">
-            <a:solidFill>
-              <a:srgbClr val="2563EB">
-                <a:alpha val="0"/>
-              </a:srgbClr>
-            </a:solidFill>
-            <a:prstDash val="solid"/>
-          </a:ln>
-        </p:spPr>
-      </p:sp>
-      <p:sp>
-        <p:nvSpPr>
-          <p:cNvPr id="29" name="Shape 27"/>
-          <p:cNvSpPr/>
-          <p:nvPr/>
-        </p:nvSpPr>
-        <p:spPr>
-          <a:xfrm>
-            <a:off x="8296656" y="3648639"/>
-            <a:ext cx="374538" cy="374538"/>
-          </a:xfrm>
-          <a:prstGeom prst="ellipse">
-            <a:avLst/>
-          </a:prstGeom>
-          <a:solidFill>
-            <a:srgbClr val="2563EB"/>
-          </a:solidFill>
-          <a:ln w="12700">
-            <a:solidFill>
-              <a:srgbClr val="2563EB">
-                <a:alpha val="0"/>
-              </a:srgbClr>
-            </a:solidFill>
-            <a:prstDash val="solid"/>
-          </a:ln>
-        </p:spPr>
-      </p:sp>
-      <p:sp>
-        <p:nvSpPr>
-          <p:cNvPr id="30" name="Text 28"/>
-          <p:cNvSpPr txBox="1"/>
-          <p:nvPr/>
-        </p:nvSpPr>
-        <p:spPr>
-          <a:xfrm>
-            <a:off x="8296656" y="3648639"/>
-            <a:ext cx="374538" cy="374538"/>
-          </a:xfrm>
-          <a:prstGeom prst="rect">
-            <a:avLst/>
-          </a:prstGeom>
-          <a:noFill/>
-          <a:ln/>
-        </p:spPr>
-        <p:txBody>
-          <a:bodyPr wrap="square" lIns="0" tIns="0" rIns="0" bIns="0" rtlCol="0" anchor="ctr">
-            <a:normAutofit/>
-          </a:bodyPr>
-          <a:lstStyle/>
-          <a:p>
-            <a:pPr algn="ctr" indent="0" marL="0">
-              <a:lnSpc>
-                <a:spcPct val="120000"/>
-              </a:lnSpc>
-              <a:buNone/>
-            </a:pPr>
-            <a:r>
-              <a:rPr lang="en-US" sz="1600" b="1" dirty="0">
-                <a:solidFill>
-                  <a:srgbClr val="F8FAFC"/>
-                </a:solidFill>
-                <a:latin typeface="Pretendard" pitchFamily="34" charset="0"/>
-                <a:ea typeface="Pretendard" pitchFamily="34" charset="-122"/>
-                <a:cs typeface="Pretendard" pitchFamily="34" charset="-120"/>
-              </a:rPr>
-              <a:t>4</a:t>
-            </a:r>
-            <a:endParaRPr lang="en-US" sz="1600" dirty="0"/>
-          </a:p>
-        </p:txBody>
-      </p:sp>
-      <p:sp>
-        <p:nvSpPr>
-          <p:cNvPr id="31" name="Text 29"/>
-          <p:cNvSpPr txBox="1"/>
-          <p:nvPr/>
-        </p:nvSpPr>
-        <p:spPr>
-          <a:xfrm>
-            <a:off x="8817498" y="3378708"/>
-            <a:ext cx="2585070" cy="914400"/>
-          </a:xfrm>
-          <a:prstGeom prst="rect">
-            <a:avLst/>
-          </a:prstGeom>
-          <a:noFill/>
-          <a:ln/>
-        </p:spPr>
-        <p:txBody>
-          <a:bodyPr wrap="square" lIns="0" tIns="25400" rIns="25400" bIns="0" rtlCol="0" anchor="ctr">
-            <a:normAutofit/>
-          </a:bodyPr>
-          <a:lstStyle/>
-          <a:p>
-            <a:pPr algn="l" indent="0" marL="0">
-              <a:lnSpc>
-                <a:spcPct val="92000"/>
-              </a:lnSpc>
-              <a:buNone/>
-            </a:pPr>
-            <a:r>
-              <a:rPr lang="en-US" sz="1600" dirty="0">
-                <a:solidFill>
-                  <a:srgbClr val="111111"/>
-                </a:solidFill>
-                <a:latin typeface="Pretendard" pitchFamily="34" charset="0"/>
-                <a:ea typeface="Pretendard" pitchFamily="34" charset="-122"/>
-                <a:cs typeface="Pretendard" pitchFamily="34" charset="-120"/>
-              </a:rPr>
-              <a:t>Outline Tree</a:t>
-            </a:r>
-            <a:endParaRPr lang="en-US" sz="1600" dirty="0"/>
-          </a:p>
-        </p:txBody>
-      </p:sp>
-      <p:sp>
-        <p:nvSpPr>
-          <p:cNvPr id="32" name="Shape 30"/>
+          <p:cNvPr id="9" name="Shape 7"/>
           <p:cNvSpPr/>
           <p:nvPr/>
         </p:nvSpPr>
@@ -20014,149 +19278,7 @@
       </p:sp>
       <p:sp>
         <p:nvSpPr>
-          <p:cNvPr id="33" name="Shape 31"/>
-          <p:cNvSpPr/>
-          <p:nvPr/>
-        </p:nvSpPr>
-        <p:spPr>
-          <a:xfrm>
-            <a:off x="8132064" y="1769364"/>
-            <a:ext cx="3435096" cy="109728"/>
-          </a:xfrm>
-          <a:prstGeom prst="rect">
-            <a:avLst/>
-          </a:prstGeom>
-          <a:solidFill>
-            <a:srgbClr val="2563EB"/>
-          </a:solidFill>
-          <a:ln w="12700">
-            <a:solidFill>
-              <a:srgbClr val="2563EB">
-                <a:alpha val="0"/>
-              </a:srgbClr>
-            </a:solidFill>
-            <a:prstDash val="solid"/>
-          </a:ln>
-        </p:spPr>
-      </p:sp>
-      <p:sp>
-        <p:nvSpPr>
-          <p:cNvPr id="34" name="Shape 32"/>
-          <p:cNvSpPr/>
-          <p:nvPr/>
-        </p:nvSpPr>
-        <p:spPr>
-          <a:xfrm>
-            <a:off x="8296656" y="2167311"/>
-            <a:ext cx="374538" cy="374538"/>
-          </a:xfrm>
-          <a:prstGeom prst="ellipse">
-            <a:avLst/>
-          </a:prstGeom>
-          <a:solidFill>
-            <a:srgbClr val="2563EB"/>
-          </a:solidFill>
-          <a:ln w="12700">
-            <a:solidFill>
-              <a:srgbClr val="2563EB">
-                <a:alpha val="0"/>
-              </a:srgbClr>
-            </a:solidFill>
-            <a:prstDash val="solid"/>
-          </a:ln>
-        </p:spPr>
-      </p:sp>
-      <p:sp>
-        <p:nvSpPr>
-          <p:cNvPr id="35" name="Text 33"/>
-          <p:cNvSpPr txBox="1"/>
-          <p:nvPr/>
-        </p:nvSpPr>
-        <p:spPr>
-          <a:xfrm>
-            <a:off x="8296656" y="2167311"/>
-            <a:ext cx="374538" cy="374538"/>
-          </a:xfrm>
-          <a:prstGeom prst="rect">
-            <a:avLst/>
-          </a:prstGeom>
-          <a:noFill/>
-          <a:ln/>
-        </p:spPr>
-        <p:txBody>
-          <a:bodyPr wrap="square" lIns="0" tIns="0" rIns="0" bIns="0" rtlCol="0" anchor="ctr">
-            <a:normAutofit/>
-          </a:bodyPr>
-          <a:lstStyle/>
-          <a:p>
-            <a:pPr algn="ctr" indent="0" marL="0">
-              <a:lnSpc>
-                <a:spcPct val="120000"/>
-              </a:lnSpc>
-              <a:buNone/>
-            </a:pPr>
-            <a:r>
-              <a:rPr lang="en-US" sz="1600" b="1" dirty="0">
-                <a:solidFill>
-                  <a:srgbClr val="F8FAFC"/>
-                </a:solidFill>
-                <a:latin typeface="Pretendard" pitchFamily="34" charset="0"/>
-                <a:ea typeface="Pretendard" pitchFamily="34" charset="-122"/>
-                <a:cs typeface="Pretendard" pitchFamily="34" charset="-120"/>
-              </a:rPr>
-              <a:t>5</a:t>
-            </a:r>
-            <a:endParaRPr lang="en-US" sz="1600" dirty="0"/>
-          </a:p>
-        </p:txBody>
-      </p:sp>
-      <p:sp>
-        <p:nvSpPr>
-          <p:cNvPr id="36" name="Text 34"/>
-          <p:cNvSpPr txBox="1"/>
-          <p:nvPr/>
-        </p:nvSpPr>
-        <p:spPr>
-          <a:xfrm>
-            <a:off x="8817498" y="1897380"/>
-            <a:ext cx="2585070" cy="914400"/>
-          </a:xfrm>
-          <a:prstGeom prst="rect">
-            <a:avLst/>
-          </a:prstGeom>
-          <a:noFill/>
-          <a:ln/>
-        </p:spPr>
-        <p:txBody>
-          <a:bodyPr wrap="square" lIns="0" tIns="25400" rIns="25400" bIns="0" rtlCol="0" anchor="ctr">
-            <a:normAutofit/>
-          </a:bodyPr>
-          <a:lstStyle/>
-          <a:p>
-            <a:pPr algn="l" indent="0" marL="0">
-              <a:lnSpc>
-                <a:spcPct val="92000"/>
-              </a:lnSpc>
-              <a:buNone/>
-            </a:pPr>
-            <a:r>
-              <a:rPr lang="en-US" sz="1600" dirty="0">
-                <a:solidFill>
-                  <a:srgbClr val="111111"/>
-                </a:solidFill>
-                <a:latin typeface="Pretendard" pitchFamily="34" charset="0"/>
-                <a:ea typeface="Pretendard" pitchFamily="34" charset="-122"/>
-                <a:cs typeface="Pretendard" pitchFamily="34" charset="-120"/>
-              </a:rPr>
-              <a:t>Split Planner</a:t>
-            </a:r>
-            <a:endParaRPr lang="en-US" sz="1600" dirty="0"/>
-          </a:p>
-        </p:txBody>
-      </p:sp>
-      <p:sp>
-        <p:nvSpPr>
-          <p:cNvPr id="37" name="Shape 35"/>
+          <p:cNvPr id="10" name="Shape 8"/>
           <p:cNvSpPr/>
           <p:nvPr/>
         </p:nvSpPr>
@@ -20190,149 +19312,7 @@
       </p:sp>
       <p:sp>
         <p:nvSpPr>
-          <p:cNvPr id="38" name="Shape 36"/>
-          <p:cNvSpPr/>
-          <p:nvPr/>
-        </p:nvSpPr>
-        <p:spPr>
-          <a:xfrm>
-            <a:off x="4386072" y="1769364"/>
-            <a:ext cx="3435096" cy="109728"/>
-          </a:xfrm>
-          <a:prstGeom prst="rect">
-            <a:avLst/>
-          </a:prstGeom>
-          <a:solidFill>
-            <a:srgbClr val="2563EB"/>
-          </a:solidFill>
-          <a:ln w="12700">
-            <a:solidFill>
-              <a:srgbClr val="2563EB">
-                <a:alpha val="0"/>
-              </a:srgbClr>
-            </a:solidFill>
-            <a:prstDash val="solid"/>
-          </a:ln>
-        </p:spPr>
-      </p:sp>
-      <p:sp>
-        <p:nvSpPr>
-          <p:cNvPr id="39" name="Shape 37"/>
-          <p:cNvSpPr/>
-          <p:nvPr/>
-        </p:nvSpPr>
-        <p:spPr>
-          <a:xfrm>
-            <a:off x="4550664" y="2167311"/>
-            <a:ext cx="374538" cy="374538"/>
-          </a:xfrm>
-          <a:prstGeom prst="ellipse">
-            <a:avLst/>
-          </a:prstGeom>
-          <a:solidFill>
-            <a:srgbClr val="2563EB"/>
-          </a:solidFill>
-          <a:ln w="12700">
-            <a:solidFill>
-              <a:srgbClr val="2563EB">
-                <a:alpha val="0"/>
-              </a:srgbClr>
-            </a:solidFill>
-            <a:prstDash val="solid"/>
-          </a:ln>
-        </p:spPr>
-      </p:sp>
-      <p:sp>
-        <p:nvSpPr>
-          <p:cNvPr id="40" name="Text 38"/>
-          <p:cNvSpPr txBox="1"/>
-          <p:nvPr/>
-        </p:nvSpPr>
-        <p:spPr>
-          <a:xfrm>
-            <a:off x="4550664" y="2167311"/>
-            <a:ext cx="374538" cy="374538"/>
-          </a:xfrm>
-          <a:prstGeom prst="rect">
-            <a:avLst/>
-          </a:prstGeom>
-          <a:noFill/>
-          <a:ln/>
-        </p:spPr>
-        <p:txBody>
-          <a:bodyPr wrap="square" lIns="0" tIns="0" rIns="0" bIns="0" rtlCol="0" anchor="ctr">
-            <a:normAutofit/>
-          </a:bodyPr>
-          <a:lstStyle/>
-          <a:p>
-            <a:pPr algn="ctr" indent="0" marL="0">
-              <a:lnSpc>
-                <a:spcPct val="120000"/>
-              </a:lnSpc>
-              <a:buNone/>
-            </a:pPr>
-            <a:r>
-              <a:rPr lang="en-US" sz="1600" b="1" dirty="0">
-                <a:solidFill>
-                  <a:srgbClr val="F8FAFC"/>
-                </a:solidFill>
-                <a:latin typeface="Pretendard" pitchFamily="34" charset="0"/>
-                <a:ea typeface="Pretendard" pitchFamily="34" charset="-122"/>
-                <a:cs typeface="Pretendard" pitchFamily="34" charset="-120"/>
-              </a:rPr>
-              <a:t>6</a:t>
-            </a:r>
-            <a:endParaRPr lang="en-US" sz="1600" dirty="0"/>
-          </a:p>
-        </p:txBody>
-      </p:sp>
-      <p:sp>
-        <p:nvSpPr>
-          <p:cNvPr id="41" name="Text 39"/>
-          <p:cNvSpPr txBox="1"/>
-          <p:nvPr/>
-        </p:nvSpPr>
-        <p:spPr>
-          <a:xfrm>
-            <a:off x="5071506" y="1897380"/>
-            <a:ext cx="2585070" cy="914400"/>
-          </a:xfrm>
-          <a:prstGeom prst="rect">
-            <a:avLst/>
-          </a:prstGeom>
-          <a:noFill/>
-          <a:ln/>
-        </p:spPr>
-        <p:txBody>
-          <a:bodyPr wrap="square" lIns="0" tIns="25400" rIns="25400" bIns="0" rtlCol="0" anchor="ctr">
-            <a:normAutofit/>
-          </a:bodyPr>
-          <a:lstStyle/>
-          <a:p>
-            <a:pPr algn="l" indent="0" marL="0">
-              <a:lnSpc>
-                <a:spcPct val="92000"/>
-              </a:lnSpc>
-              <a:buNone/>
-            </a:pPr>
-            <a:r>
-              <a:rPr lang="en-US" sz="1600" dirty="0">
-                <a:solidFill>
-                  <a:srgbClr val="111111"/>
-                </a:solidFill>
-                <a:latin typeface="Pretendard" pitchFamily="34" charset="0"/>
-                <a:ea typeface="Pretendard" pitchFamily="34" charset="-122"/>
-                <a:cs typeface="Pretendard" pitchFamily="34" charset="-120"/>
-              </a:rPr>
-              <a:t>Presentation IR</a:t>
-            </a:r>
-            <a:endParaRPr lang="en-US" sz="1600" dirty="0"/>
-          </a:p>
-        </p:txBody>
-      </p:sp>
-      <p:sp>
-        <p:nvSpPr>
-          <p:cNvPr id="42" name="Shape 40"/>
+          <p:cNvPr id="11" name="Shape 9"/>
           <p:cNvSpPr/>
           <p:nvPr/>
         </p:nvSpPr>
@@ -20366,149 +19346,7 @@
       </p:sp>
       <p:sp>
         <p:nvSpPr>
-          <p:cNvPr id="43" name="Shape 41"/>
-          <p:cNvSpPr/>
-          <p:nvPr/>
-        </p:nvSpPr>
-        <p:spPr>
-          <a:xfrm>
-            <a:off x="640080" y="1769364"/>
-            <a:ext cx="3435096" cy="109728"/>
-          </a:xfrm>
-          <a:prstGeom prst="rect">
-            <a:avLst/>
-          </a:prstGeom>
-          <a:solidFill>
-            <a:srgbClr val="2563EB"/>
-          </a:solidFill>
-          <a:ln w="12700">
-            <a:solidFill>
-              <a:srgbClr val="2563EB">
-                <a:alpha val="0"/>
-              </a:srgbClr>
-            </a:solidFill>
-            <a:prstDash val="solid"/>
-          </a:ln>
-        </p:spPr>
-      </p:sp>
-      <p:sp>
-        <p:nvSpPr>
-          <p:cNvPr id="44" name="Shape 42"/>
-          <p:cNvSpPr/>
-          <p:nvPr/>
-        </p:nvSpPr>
-        <p:spPr>
-          <a:xfrm>
-            <a:off x="804672" y="2167311"/>
-            <a:ext cx="374538" cy="374538"/>
-          </a:xfrm>
-          <a:prstGeom prst="ellipse">
-            <a:avLst/>
-          </a:prstGeom>
-          <a:solidFill>
-            <a:srgbClr val="2563EB"/>
-          </a:solidFill>
-          <a:ln w="12700">
-            <a:solidFill>
-              <a:srgbClr val="2563EB">
-                <a:alpha val="0"/>
-              </a:srgbClr>
-            </a:solidFill>
-            <a:prstDash val="solid"/>
-          </a:ln>
-        </p:spPr>
-      </p:sp>
-      <p:sp>
-        <p:nvSpPr>
-          <p:cNvPr id="45" name="Text 43"/>
-          <p:cNvSpPr txBox="1"/>
-          <p:nvPr/>
-        </p:nvSpPr>
-        <p:spPr>
-          <a:xfrm>
-            <a:off x="804672" y="2167311"/>
-            <a:ext cx="374538" cy="374538"/>
-          </a:xfrm>
-          <a:prstGeom prst="rect">
-            <a:avLst/>
-          </a:prstGeom>
-          <a:noFill/>
-          <a:ln/>
-        </p:spPr>
-        <p:txBody>
-          <a:bodyPr wrap="square" lIns="0" tIns="0" rIns="0" bIns="0" rtlCol="0" anchor="ctr">
-            <a:normAutofit/>
-          </a:bodyPr>
-          <a:lstStyle/>
-          <a:p>
-            <a:pPr algn="ctr" indent="0" marL="0">
-              <a:lnSpc>
-                <a:spcPct val="120000"/>
-              </a:lnSpc>
-              <a:buNone/>
-            </a:pPr>
-            <a:r>
-              <a:rPr lang="en-US" sz="1600" b="1" dirty="0">
-                <a:solidFill>
-                  <a:srgbClr val="F8FAFC"/>
-                </a:solidFill>
-                <a:latin typeface="Pretendard" pitchFamily="34" charset="0"/>
-                <a:ea typeface="Pretendard" pitchFamily="34" charset="-122"/>
-                <a:cs typeface="Pretendard" pitchFamily="34" charset="-120"/>
-              </a:rPr>
-              <a:t>7</a:t>
-            </a:r>
-            <a:endParaRPr lang="en-US" sz="1600" dirty="0"/>
-          </a:p>
-        </p:txBody>
-      </p:sp>
-      <p:sp>
-        <p:nvSpPr>
-          <p:cNvPr id="46" name="Text 44"/>
-          <p:cNvSpPr txBox="1"/>
-          <p:nvPr/>
-        </p:nvSpPr>
-        <p:spPr>
-          <a:xfrm>
-            <a:off x="1325514" y="1897380"/>
-            <a:ext cx="2585070" cy="914400"/>
-          </a:xfrm>
-          <a:prstGeom prst="rect">
-            <a:avLst/>
-          </a:prstGeom>
-          <a:noFill/>
-          <a:ln/>
-        </p:spPr>
-        <p:txBody>
-          <a:bodyPr wrap="square" lIns="0" tIns="25400" rIns="25400" bIns="0" rtlCol="0" anchor="ctr">
-            <a:normAutofit/>
-          </a:bodyPr>
-          <a:lstStyle/>
-          <a:p>
-            <a:pPr algn="l" indent="0" marL="0">
-              <a:lnSpc>
-                <a:spcPct val="92000"/>
-              </a:lnSpc>
-              <a:buNone/>
-            </a:pPr>
-            <a:r>
-              <a:rPr lang="en-US" sz="1600" dirty="0">
-                <a:solidFill>
-                  <a:srgbClr val="111111"/>
-                </a:solidFill>
-                <a:latin typeface="Pretendard" pitchFamily="34" charset="0"/>
-                <a:ea typeface="Pretendard" pitchFamily="34" charset="-122"/>
-                <a:cs typeface="Pretendard" pitchFamily="34" charset="-120"/>
-              </a:rPr>
-              <a:t>Layout IR</a:t>
-            </a:r>
-            <a:endParaRPr lang="en-US" sz="1600" dirty="0"/>
-          </a:p>
-        </p:txBody>
-      </p:sp>
-      <p:sp>
-        <p:nvSpPr>
-          <p:cNvPr id="47" name="Shape 45"/>
+          <p:cNvPr id="12" name="Shape 10"/>
           <p:cNvSpPr/>
           <p:nvPr/>
         </p:nvSpPr>
@@ -20539,6 +19377,1168 @@
             </a:outerShdw>
           </a:effectLst>
         </p:spPr>
+      </p:sp>
+      <p:sp>
+        <p:nvSpPr>
+          <p:cNvPr id="13" name="Shape 11"/>
+          <p:cNvSpPr/>
+          <p:nvPr/>
+        </p:nvSpPr>
+        <p:spPr>
+          <a:xfrm>
+            <a:off x="4002024" y="5317236"/>
+            <a:ext cx="457200" cy="0"/>
+          </a:xfrm>
+          <a:prstGeom prst="line">
+            <a:avLst/>
+          </a:prstGeom>
+          <a:noFill/>
+          <a:ln w="12700">
+            <a:solidFill>
+              <a:srgbClr val="2563EB"/>
+            </a:solidFill>
+            <a:prstDash val="solid"/>
+            <a:tailEnd type="triangle"/>
+          </a:ln>
+        </p:spPr>
+      </p:sp>
+      <p:sp>
+        <p:nvSpPr>
+          <p:cNvPr id="14" name="Shape 12"/>
+          <p:cNvSpPr/>
+          <p:nvPr/>
+        </p:nvSpPr>
+        <p:spPr>
+          <a:xfrm>
+            <a:off x="7748016" y="5317236"/>
+            <a:ext cx="457200" cy="0"/>
+          </a:xfrm>
+          <a:prstGeom prst="line">
+            <a:avLst/>
+          </a:prstGeom>
+          <a:noFill/>
+          <a:ln w="12700">
+            <a:solidFill>
+              <a:srgbClr val="2563EB"/>
+            </a:solidFill>
+            <a:prstDash val="solid"/>
+            <a:tailEnd type="triangle"/>
+          </a:ln>
+        </p:spPr>
+      </p:sp>
+      <p:sp>
+        <p:nvSpPr>
+          <p:cNvPr id="15" name="Shape 13"/>
+          <p:cNvSpPr/>
+          <p:nvPr/>
+        </p:nvSpPr>
+        <p:spPr>
+          <a:xfrm>
+            <a:off x="9849612" y="4368455"/>
+            <a:ext cx="0" cy="416235"/>
+          </a:xfrm>
+          <a:prstGeom prst="line">
+            <a:avLst/>
+          </a:prstGeom>
+          <a:noFill/>
+          <a:ln w="12700">
+            <a:solidFill>
+              <a:srgbClr val="2563EB"/>
+            </a:solidFill>
+            <a:prstDash val="solid"/>
+            <a:headEnd type="triangle"/>
+          </a:ln>
+        </p:spPr>
+      </p:sp>
+      <p:sp>
+        <p:nvSpPr>
+          <p:cNvPr id="16" name="Shape 14"/>
+          <p:cNvSpPr/>
+          <p:nvPr/>
+        </p:nvSpPr>
+        <p:spPr>
+          <a:xfrm>
+            <a:off x="9849612" y="2887127"/>
+            <a:ext cx="0" cy="416235"/>
+          </a:xfrm>
+          <a:prstGeom prst="line">
+            <a:avLst/>
+          </a:prstGeom>
+          <a:noFill/>
+          <a:ln w="12700">
+            <a:solidFill>
+              <a:srgbClr val="2563EB"/>
+            </a:solidFill>
+            <a:prstDash val="solid"/>
+            <a:headEnd type="triangle"/>
+          </a:ln>
+        </p:spPr>
+      </p:sp>
+      <p:sp>
+        <p:nvSpPr>
+          <p:cNvPr id="17" name="Shape 15"/>
+          <p:cNvSpPr/>
+          <p:nvPr/>
+        </p:nvSpPr>
+        <p:spPr>
+          <a:xfrm>
+            <a:off x="7748016" y="2354580"/>
+            <a:ext cx="457200" cy="0"/>
+          </a:xfrm>
+          <a:prstGeom prst="line">
+            <a:avLst/>
+          </a:prstGeom>
+          <a:noFill/>
+          <a:ln w="12700">
+            <a:solidFill>
+              <a:srgbClr val="2563EB"/>
+            </a:solidFill>
+            <a:prstDash val="solid"/>
+            <a:headEnd type="triangle"/>
+          </a:ln>
+        </p:spPr>
+      </p:sp>
+      <p:sp>
+        <p:nvSpPr>
+          <p:cNvPr id="18" name="Shape 16"/>
+          <p:cNvSpPr/>
+          <p:nvPr/>
+        </p:nvSpPr>
+        <p:spPr>
+          <a:xfrm>
+            <a:off x="4002024" y="2354580"/>
+            <a:ext cx="457200" cy="0"/>
+          </a:xfrm>
+          <a:prstGeom prst="line">
+            <a:avLst/>
+          </a:prstGeom>
+          <a:noFill/>
+          <a:ln w="12700">
+            <a:solidFill>
+              <a:srgbClr val="2563EB"/>
+            </a:solidFill>
+            <a:prstDash val="solid"/>
+            <a:headEnd type="triangle"/>
+          </a:ln>
+        </p:spPr>
+      </p:sp>
+      <p:sp>
+        <p:nvSpPr>
+          <p:cNvPr id="19" name="Shape 17"/>
+          <p:cNvSpPr/>
+          <p:nvPr/>
+        </p:nvSpPr>
+        <p:spPr>
+          <a:xfrm>
+            <a:off x="4230624" y="3835908"/>
+            <a:ext cx="228600" cy="0"/>
+          </a:xfrm>
+          <a:prstGeom prst="line">
+            <a:avLst/>
+          </a:prstGeom>
+          <a:noFill/>
+          <a:ln w="12700">
+            <a:solidFill>
+              <a:srgbClr val="2563EB"/>
+            </a:solidFill>
+            <a:prstDash val="solid"/>
+            <a:tailEnd type="triangle"/>
+          </a:ln>
+        </p:spPr>
+      </p:sp>
+      <p:sp>
+        <p:nvSpPr>
+          <p:cNvPr id="20" name="Shape 18"/>
+          <p:cNvSpPr/>
+          <p:nvPr/>
+        </p:nvSpPr>
+        <p:spPr>
+          <a:xfrm>
+            <a:off x="640080" y="4732020"/>
+            <a:ext cx="3435096" cy="109728"/>
+          </a:xfrm>
+          <a:prstGeom prst="rect">
+            <a:avLst/>
+          </a:prstGeom>
+          <a:solidFill>
+            <a:srgbClr val="2563EB"/>
+          </a:solidFill>
+          <a:ln w="12700">
+            <a:solidFill>
+              <a:srgbClr val="2563EB">
+                <a:alpha val="0"/>
+              </a:srgbClr>
+            </a:solidFill>
+            <a:prstDash val="solid"/>
+          </a:ln>
+        </p:spPr>
+      </p:sp>
+      <p:sp>
+        <p:nvSpPr>
+          <p:cNvPr id="21" name="Shape 19"/>
+          <p:cNvSpPr/>
+          <p:nvPr/>
+        </p:nvSpPr>
+        <p:spPr>
+          <a:xfrm>
+            <a:off x="804672" y="5129967"/>
+            <a:ext cx="374538" cy="374538"/>
+          </a:xfrm>
+          <a:prstGeom prst="ellipse">
+            <a:avLst/>
+          </a:prstGeom>
+          <a:solidFill>
+            <a:srgbClr val="2563EB"/>
+          </a:solidFill>
+          <a:ln w="12700">
+            <a:solidFill>
+              <a:srgbClr val="2563EB">
+                <a:alpha val="0"/>
+              </a:srgbClr>
+            </a:solidFill>
+            <a:prstDash val="solid"/>
+          </a:ln>
+        </p:spPr>
+      </p:sp>
+      <p:sp>
+        <p:nvSpPr>
+          <p:cNvPr id="22" name="Text 20"/>
+          <p:cNvSpPr txBox="1"/>
+          <p:nvPr/>
+        </p:nvSpPr>
+        <p:spPr>
+          <a:xfrm>
+            <a:off x="804672" y="5129967"/>
+            <a:ext cx="374538" cy="374538"/>
+          </a:xfrm>
+          <a:prstGeom prst="rect">
+            <a:avLst/>
+          </a:prstGeom>
+          <a:noFill/>
+          <a:ln/>
+        </p:spPr>
+        <p:txBody>
+          <a:bodyPr wrap="square" lIns="0" tIns="0" rIns="0" bIns="0" rtlCol="0" anchor="ctr">
+            <a:normAutofit/>
+          </a:bodyPr>
+          <a:lstStyle/>
+          <a:p>
+            <a:pPr algn="ctr" indent="0" marL="0">
+              <a:lnSpc>
+                <a:spcPct val="120000"/>
+              </a:lnSpc>
+              <a:buNone/>
+            </a:pPr>
+            <a:r>
+              <a:rPr lang="en-US" sz="1600" b="1" dirty="0">
+                <a:solidFill>
+                  <a:srgbClr val="F8FAFC"/>
+                </a:solidFill>
+                <a:latin typeface="Pretendard" pitchFamily="34" charset="0"/>
+                <a:ea typeface="Pretendard" pitchFamily="34" charset="-122"/>
+                <a:cs typeface="Pretendard" pitchFamily="34" charset="-120"/>
+              </a:rPr>
+              <a:t>1</a:t>
+            </a:r>
+            <a:endParaRPr lang="en-US" sz="1600" dirty="0"/>
+          </a:p>
+        </p:txBody>
+      </p:sp>
+      <p:sp>
+        <p:nvSpPr>
+          <p:cNvPr id="23" name="Text 21"/>
+          <p:cNvSpPr txBox="1"/>
+          <p:nvPr/>
+        </p:nvSpPr>
+        <p:spPr>
+          <a:xfrm>
+            <a:off x="1325514" y="4860036"/>
+            <a:ext cx="2585070" cy="914400"/>
+          </a:xfrm>
+          <a:prstGeom prst="rect">
+            <a:avLst/>
+          </a:prstGeom>
+          <a:noFill/>
+          <a:ln/>
+        </p:spPr>
+        <p:txBody>
+          <a:bodyPr wrap="square" lIns="0" tIns="25400" rIns="25400" bIns="0" rtlCol="0" anchor="ctr">
+            <a:normAutofit/>
+          </a:bodyPr>
+          <a:lstStyle/>
+          <a:p>
+            <a:pPr algn="l" indent="0" marL="0">
+              <a:lnSpc>
+                <a:spcPct val="92000"/>
+              </a:lnSpc>
+              <a:buNone/>
+            </a:pPr>
+            <a:r>
+              <a:rPr lang="en-US" sz="1600" dirty="0">
+                <a:solidFill>
+                  <a:srgbClr val="111111"/>
+                </a:solidFill>
+                <a:latin typeface="Pretendard" pitchFamily="34" charset="0"/>
+                <a:ea typeface="Pretendard" pitchFamily="34" charset="-122"/>
+                <a:cs typeface="Pretendard" pitchFamily="34" charset="-120"/>
+              </a:rPr>
+              <a:t>Markdown</a:t>
+            </a:r>
+            <a:endParaRPr lang="en-US" sz="1600" dirty="0"/>
+          </a:p>
+        </p:txBody>
+      </p:sp>
+      <p:sp>
+        <p:nvSpPr>
+          <p:cNvPr id="24" name="Shape 22"/>
+          <p:cNvSpPr/>
+          <p:nvPr/>
+        </p:nvSpPr>
+        <p:spPr>
+          <a:xfrm>
+            <a:off x="4386072" y="4732020"/>
+            <a:ext cx="3435096" cy="109728"/>
+          </a:xfrm>
+          <a:prstGeom prst="rect">
+            <a:avLst/>
+          </a:prstGeom>
+          <a:solidFill>
+            <a:srgbClr val="2563EB"/>
+          </a:solidFill>
+          <a:ln w="12700">
+            <a:solidFill>
+              <a:srgbClr val="2563EB">
+                <a:alpha val="0"/>
+              </a:srgbClr>
+            </a:solidFill>
+            <a:prstDash val="solid"/>
+          </a:ln>
+        </p:spPr>
+      </p:sp>
+      <p:sp>
+        <p:nvSpPr>
+          <p:cNvPr id="25" name="Shape 23"/>
+          <p:cNvSpPr/>
+          <p:nvPr/>
+        </p:nvSpPr>
+        <p:spPr>
+          <a:xfrm>
+            <a:off x="4550664" y="5129967"/>
+            <a:ext cx="374538" cy="374538"/>
+          </a:xfrm>
+          <a:prstGeom prst="ellipse">
+            <a:avLst/>
+          </a:prstGeom>
+          <a:solidFill>
+            <a:srgbClr val="2563EB"/>
+          </a:solidFill>
+          <a:ln w="12700">
+            <a:solidFill>
+              <a:srgbClr val="2563EB">
+                <a:alpha val="0"/>
+              </a:srgbClr>
+            </a:solidFill>
+            <a:prstDash val="solid"/>
+          </a:ln>
+        </p:spPr>
+      </p:sp>
+      <p:sp>
+        <p:nvSpPr>
+          <p:cNvPr id="26" name="Text 24"/>
+          <p:cNvSpPr txBox="1"/>
+          <p:nvPr/>
+        </p:nvSpPr>
+        <p:spPr>
+          <a:xfrm>
+            <a:off x="4550664" y="5129967"/>
+            <a:ext cx="374538" cy="374538"/>
+          </a:xfrm>
+          <a:prstGeom prst="rect">
+            <a:avLst/>
+          </a:prstGeom>
+          <a:noFill/>
+          <a:ln/>
+        </p:spPr>
+        <p:txBody>
+          <a:bodyPr wrap="square" lIns="0" tIns="0" rIns="0" bIns="0" rtlCol="0" anchor="ctr">
+            <a:normAutofit/>
+          </a:bodyPr>
+          <a:lstStyle/>
+          <a:p>
+            <a:pPr algn="ctr" indent="0" marL="0">
+              <a:lnSpc>
+                <a:spcPct val="120000"/>
+              </a:lnSpc>
+              <a:buNone/>
+            </a:pPr>
+            <a:r>
+              <a:rPr lang="en-US" sz="1600" b="1" dirty="0">
+                <a:solidFill>
+                  <a:srgbClr val="F8FAFC"/>
+                </a:solidFill>
+                <a:latin typeface="Pretendard" pitchFamily="34" charset="0"/>
+                <a:ea typeface="Pretendard" pitchFamily="34" charset="-122"/>
+                <a:cs typeface="Pretendard" pitchFamily="34" charset="-120"/>
+              </a:rPr>
+              <a:t>2</a:t>
+            </a:r>
+            <a:endParaRPr lang="en-US" sz="1600" dirty="0"/>
+          </a:p>
+        </p:txBody>
+      </p:sp>
+      <p:sp>
+        <p:nvSpPr>
+          <p:cNvPr id="27" name="Text 25"/>
+          <p:cNvSpPr txBox="1"/>
+          <p:nvPr/>
+        </p:nvSpPr>
+        <p:spPr>
+          <a:xfrm>
+            <a:off x="5071506" y="4860036"/>
+            <a:ext cx="2585070" cy="914400"/>
+          </a:xfrm>
+          <a:prstGeom prst="rect">
+            <a:avLst/>
+          </a:prstGeom>
+          <a:noFill/>
+          <a:ln/>
+        </p:spPr>
+        <p:txBody>
+          <a:bodyPr wrap="square" lIns="0" tIns="25400" rIns="25400" bIns="0" rtlCol="0" anchor="ctr">
+            <a:normAutofit/>
+          </a:bodyPr>
+          <a:lstStyle/>
+          <a:p>
+            <a:pPr algn="l" indent="0" marL="0">
+              <a:lnSpc>
+                <a:spcPct val="92000"/>
+              </a:lnSpc>
+              <a:buNone/>
+            </a:pPr>
+            <a:r>
+              <a:rPr lang="en-US" sz="1600" dirty="0">
+                <a:solidFill>
+                  <a:srgbClr val="111111"/>
+                </a:solidFill>
+                <a:latin typeface="Pretendard" pitchFamily="34" charset="0"/>
+                <a:ea typeface="Pretendard" pitchFamily="34" charset="-122"/>
+                <a:cs typeface="Pretendard" pitchFamily="34" charset="-120"/>
+              </a:rPr>
+              <a:t>MDPR parser</a:t>
+            </a:r>
+            <a:endParaRPr lang="en-US" sz="1600" dirty="0"/>
+          </a:p>
+        </p:txBody>
+      </p:sp>
+      <p:sp>
+        <p:nvSpPr>
+          <p:cNvPr id="28" name="Shape 26"/>
+          <p:cNvSpPr/>
+          <p:nvPr/>
+        </p:nvSpPr>
+        <p:spPr>
+          <a:xfrm>
+            <a:off x="8132064" y="4732020"/>
+            <a:ext cx="3435096" cy="109728"/>
+          </a:xfrm>
+          <a:prstGeom prst="rect">
+            <a:avLst/>
+          </a:prstGeom>
+          <a:solidFill>
+            <a:srgbClr val="2563EB"/>
+          </a:solidFill>
+          <a:ln w="12700">
+            <a:solidFill>
+              <a:srgbClr val="2563EB">
+                <a:alpha val="0"/>
+              </a:srgbClr>
+            </a:solidFill>
+            <a:prstDash val="solid"/>
+          </a:ln>
+        </p:spPr>
+      </p:sp>
+      <p:sp>
+        <p:nvSpPr>
+          <p:cNvPr id="29" name="Shape 27"/>
+          <p:cNvSpPr/>
+          <p:nvPr/>
+        </p:nvSpPr>
+        <p:spPr>
+          <a:xfrm>
+            <a:off x="8296656" y="5129967"/>
+            <a:ext cx="374538" cy="374538"/>
+          </a:xfrm>
+          <a:prstGeom prst="ellipse">
+            <a:avLst/>
+          </a:prstGeom>
+          <a:solidFill>
+            <a:srgbClr val="2563EB"/>
+          </a:solidFill>
+          <a:ln w="12700">
+            <a:solidFill>
+              <a:srgbClr val="2563EB">
+                <a:alpha val="0"/>
+              </a:srgbClr>
+            </a:solidFill>
+            <a:prstDash val="solid"/>
+          </a:ln>
+        </p:spPr>
+      </p:sp>
+      <p:sp>
+        <p:nvSpPr>
+          <p:cNvPr id="30" name="Text 28"/>
+          <p:cNvSpPr txBox="1"/>
+          <p:nvPr/>
+        </p:nvSpPr>
+        <p:spPr>
+          <a:xfrm>
+            <a:off x="8296656" y="5129967"/>
+            <a:ext cx="374538" cy="374538"/>
+          </a:xfrm>
+          <a:prstGeom prst="rect">
+            <a:avLst/>
+          </a:prstGeom>
+          <a:noFill/>
+          <a:ln/>
+        </p:spPr>
+        <p:txBody>
+          <a:bodyPr wrap="square" lIns="0" tIns="0" rIns="0" bIns="0" rtlCol="0" anchor="ctr">
+            <a:normAutofit/>
+          </a:bodyPr>
+          <a:lstStyle/>
+          <a:p>
+            <a:pPr algn="ctr" indent="0" marL="0">
+              <a:lnSpc>
+                <a:spcPct val="120000"/>
+              </a:lnSpc>
+              <a:buNone/>
+            </a:pPr>
+            <a:r>
+              <a:rPr lang="en-US" sz="1600" b="1" dirty="0">
+                <a:solidFill>
+                  <a:srgbClr val="F8FAFC"/>
+                </a:solidFill>
+                <a:latin typeface="Pretendard" pitchFamily="34" charset="0"/>
+                <a:ea typeface="Pretendard" pitchFamily="34" charset="-122"/>
+                <a:cs typeface="Pretendard" pitchFamily="34" charset="-120"/>
+              </a:rPr>
+              <a:t>3</a:t>
+            </a:r>
+            <a:endParaRPr lang="en-US" sz="1600" dirty="0"/>
+          </a:p>
+        </p:txBody>
+      </p:sp>
+      <p:sp>
+        <p:nvSpPr>
+          <p:cNvPr id="31" name="Text 29"/>
+          <p:cNvSpPr txBox="1"/>
+          <p:nvPr/>
+        </p:nvSpPr>
+        <p:spPr>
+          <a:xfrm>
+            <a:off x="8817498" y="4860036"/>
+            <a:ext cx="2585070" cy="914400"/>
+          </a:xfrm>
+          <a:prstGeom prst="rect">
+            <a:avLst/>
+          </a:prstGeom>
+          <a:noFill/>
+          <a:ln/>
+        </p:spPr>
+        <p:txBody>
+          <a:bodyPr wrap="square" lIns="0" tIns="25400" rIns="25400" bIns="0" rtlCol="0" anchor="ctr">
+            <a:normAutofit/>
+          </a:bodyPr>
+          <a:lstStyle/>
+          <a:p>
+            <a:pPr algn="l" indent="0" marL="0">
+              <a:lnSpc>
+                <a:spcPct val="92000"/>
+              </a:lnSpc>
+              <a:buNone/>
+            </a:pPr>
+            <a:r>
+              <a:rPr lang="en-US" sz="1600" dirty="0">
+                <a:solidFill>
+                  <a:srgbClr val="111111"/>
+                </a:solidFill>
+                <a:latin typeface="Pretendard" pitchFamily="34" charset="0"/>
+                <a:ea typeface="Pretendard" pitchFamily="34" charset="-122"/>
+                <a:cs typeface="Pretendard" pitchFamily="34" charset="-120"/>
+              </a:rPr>
+              <a:t>BlockIR</a:t>
+            </a:r>
+            <a:endParaRPr lang="en-US" sz="1600" dirty="0"/>
+          </a:p>
+        </p:txBody>
+      </p:sp>
+      <p:sp>
+        <p:nvSpPr>
+          <p:cNvPr id="32" name="Shape 30"/>
+          <p:cNvSpPr/>
+          <p:nvPr/>
+        </p:nvSpPr>
+        <p:spPr>
+          <a:xfrm>
+            <a:off x="8132064" y="3250692"/>
+            <a:ext cx="3435096" cy="109728"/>
+          </a:xfrm>
+          <a:prstGeom prst="rect">
+            <a:avLst/>
+          </a:prstGeom>
+          <a:solidFill>
+            <a:srgbClr val="2563EB"/>
+          </a:solidFill>
+          <a:ln w="12700">
+            <a:solidFill>
+              <a:srgbClr val="2563EB">
+                <a:alpha val="0"/>
+              </a:srgbClr>
+            </a:solidFill>
+            <a:prstDash val="solid"/>
+          </a:ln>
+        </p:spPr>
+      </p:sp>
+      <p:sp>
+        <p:nvSpPr>
+          <p:cNvPr id="33" name="Shape 31"/>
+          <p:cNvSpPr/>
+          <p:nvPr/>
+        </p:nvSpPr>
+        <p:spPr>
+          <a:xfrm>
+            <a:off x="8296656" y="3648639"/>
+            <a:ext cx="374538" cy="374538"/>
+          </a:xfrm>
+          <a:prstGeom prst="ellipse">
+            <a:avLst/>
+          </a:prstGeom>
+          <a:solidFill>
+            <a:srgbClr val="2563EB"/>
+          </a:solidFill>
+          <a:ln w="12700">
+            <a:solidFill>
+              <a:srgbClr val="2563EB">
+                <a:alpha val="0"/>
+              </a:srgbClr>
+            </a:solidFill>
+            <a:prstDash val="solid"/>
+          </a:ln>
+        </p:spPr>
+      </p:sp>
+      <p:sp>
+        <p:nvSpPr>
+          <p:cNvPr id="34" name="Text 32"/>
+          <p:cNvSpPr txBox="1"/>
+          <p:nvPr/>
+        </p:nvSpPr>
+        <p:spPr>
+          <a:xfrm>
+            <a:off x="8296656" y="3648639"/>
+            <a:ext cx="374538" cy="374538"/>
+          </a:xfrm>
+          <a:prstGeom prst="rect">
+            <a:avLst/>
+          </a:prstGeom>
+          <a:noFill/>
+          <a:ln/>
+        </p:spPr>
+        <p:txBody>
+          <a:bodyPr wrap="square" lIns="0" tIns="0" rIns="0" bIns="0" rtlCol="0" anchor="ctr">
+            <a:normAutofit/>
+          </a:bodyPr>
+          <a:lstStyle/>
+          <a:p>
+            <a:pPr algn="ctr" indent="0" marL="0">
+              <a:lnSpc>
+                <a:spcPct val="120000"/>
+              </a:lnSpc>
+              <a:buNone/>
+            </a:pPr>
+            <a:r>
+              <a:rPr lang="en-US" sz="1600" b="1" dirty="0">
+                <a:solidFill>
+                  <a:srgbClr val="F8FAFC"/>
+                </a:solidFill>
+                <a:latin typeface="Pretendard" pitchFamily="34" charset="0"/>
+                <a:ea typeface="Pretendard" pitchFamily="34" charset="-122"/>
+                <a:cs typeface="Pretendard" pitchFamily="34" charset="-120"/>
+              </a:rPr>
+              <a:t>4</a:t>
+            </a:r>
+            <a:endParaRPr lang="en-US" sz="1600" dirty="0"/>
+          </a:p>
+        </p:txBody>
+      </p:sp>
+      <p:sp>
+        <p:nvSpPr>
+          <p:cNvPr id="35" name="Text 33"/>
+          <p:cNvSpPr txBox="1"/>
+          <p:nvPr/>
+        </p:nvSpPr>
+        <p:spPr>
+          <a:xfrm>
+            <a:off x="8817498" y="3378708"/>
+            <a:ext cx="2585070" cy="914400"/>
+          </a:xfrm>
+          <a:prstGeom prst="rect">
+            <a:avLst/>
+          </a:prstGeom>
+          <a:noFill/>
+          <a:ln/>
+        </p:spPr>
+        <p:txBody>
+          <a:bodyPr wrap="square" lIns="0" tIns="25400" rIns="25400" bIns="0" rtlCol="0" anchor="ctr">
+            <a:normAutofit/>
+          </a:bodyPr>
+          <a:lstStyle/>
+          <a:p>
+            <a:pPr algn="l" indent="0" marL="0">
+              <a:lnSpc>
+                <a:spcPct val="92000"/>
+              </a:lnSpc>
+              <a:buNone/>
+            </a:pPr>
+            <a:r>
+              <a:rPr lang="en-US" sz="1600" dirty="0">
+                <a:solidFill>
+                  <a:srgbClr val="111111"/>
+                </a:solidFill>
+                <a:latin typeface="Pretendard" pitchFamily="34" charset="0"/>
+                <a:ea typeface="Pretendard" pitchFamily="34" charset="-122"/>
+                <a:cs typeface="Pretendard" pitchFamily="34" charset="-120"/>
+              </a:rPr>
+              <a:t>Outline Tree</a:t>
+            </a:r>
+            <a:endParaRPr lang="en-US" sz="1600" dirty="0"/>
+          </a:p>
+        </p:txBody>
+      </p:sp>
+      <p:sp>
+        <p:nvSpPr>
+          <p:cNvPr id="36" name="Shape 34"/>
+          <p:cNvSpPr/>
+          <p:nvPr/>
+        </p:nvSpPr>
+        <p:spPr>
+          <a:xfrm>
+            <a:off x="8132064" y="1769364"/>
+            <a:ext cx="3435096" cy="109728"/>
+          </a:xfrm>
+          <a:prstGeom prst="rect">
+            <a:avLst/>
+          </a:prstGeom>
+          <a:solidFill>
+            <a:srgbClr val="2563EB"/>
+          </a:solidFill>
+          <a:ln w="12700">
+            <a:solidFill>
+              <a:srgbClr val="2563EB">
+                <a:alpha val="0"/>
+              </a:srgbClr>
+            </a:solidFill>
+            <a:prstDash val="solid"/>
+          </a:ln>
+        </p:spPr>
+      </p:sp>
+      <p:sp>
+        <p:nvSpPr>
+          <p:cNvPr id="37" name="Shape 35"/>
+          <p:cNvSpPr/>
+          <p:nvPr/>
+        </p:nvSpPr>
+        <p:spPr>
+          <a:xfrm>
+            <a:off x="8296656" y="2167311"/>
+            <a:ext cx="374538" cy="374538"/>
+          </a:xfrm>
+          <a:prstGeom prst="ellipse">
+            <a:avLst/>
+          </a:prstGeom>
+          <a:solidFill>
+            <a:srgbClr val="2563EB"/>
+          </a:solidFill>
+          <a:ln w="12700">
+            <a:solidFill>
+              <a:srgbClr val="2563EB">
+                <a:alpha val="0"/>
+              </a:srgbClr>
+            </a:solidFill>
+            <a:prstDash val="solid"/>
+          </a:ln>
+        </p:spPr>
+      </p:sp>
+      <p:sp>
+        <p:nvSpPr>
+          <p:cNvPr id="38" name="Text 36"/>
+          <p:cNvSpPr txBox="1"/>
+          <p:nvPr/>
+        </p:nvSpPr>
+        <p:spPr>
+          <a:xfrm>
+            <a:off x="8296656" y="2167311"/>
+            <a:ext cx="374538" cy="374538"/>
+          </a:xfrm>
+          <a:prstGeom prst="rect">
+            <a:avLst/>
+          </a:prstGeom>
+          <a:noFill/>
+          <a:ln/>
+        </p:spPr>
+        <p:txBody>
+          <a:bodyPr wrap="square" lIns="0" tIns="0" rIns="0" bIns="0" rtlCol="0" anchor="ctr">
+            <a:normAutofit/>
+          </a:bodyPr>
+          <a:lstStyle/>
+          <a:p>
+            <a:pPr algn="ctr" indent="0" marL="0">
+              <a:lnSpc>
+                <a:spcPct val="120000"/>
+              </a:lnSpc>
+              <a:buNone/>
+            </a:pPr>
+            <a:r>
+              <a:rPr lang="en-US" sz="1600" b="1" dirty="0">
+                <a:solidFill>
+                  <a:srgbClr val="F8FAFC"/>
+                </a:solidFill>
+                <a:latin typeface="Pretendard" pitchFamily="34" charset="0"/>
+                <a:ea typeface="Pretendard" pitchFamily="34" charset="-122"/>
+                <a:cs typeface="Pretendard" pitchFamily="34" charset="-120"/>
+              </a:rPr>
+              <a:t>5</a:t>
+            </a:r>
+            <a:endParaRPr lang="en-US" sz="1600" dirty="0"/>
+          </a:p>
+        </p:txBody>
+      </p:sp>
+      <p:sp>
+        <p:nvSpPr>
+          <p:cNvPr id="39" name="Text 37"/>
+          <p:cNvSpPr txBox="1"/>
+          <p:nvPr/>
+        </p:nvSpPr>
+        <p:spPr>
+          <a:xfrm>
+            <a:off x="8817498" y="1897380"/>
+            <a:ext cx="2585070" cy="914400"/>
+          </a:xfrm>
+          <a:prstGeom prst="rect">
+            <a:avLst/>
+          </a:prstGeom>
+          <a:noFill/>
+          <a:ln/>
+        </p:spPr>
+        <p:txBody>
+          <a:bodyPr wrap="square" lIns="0" tIns="25400" rIns="25400" bIns="0" rtlCol="0" anchor="ctr">
+            <a:normAutofit/>
+          </a:bodyPr>
+          <a:lstStyle/>
+          <a:p>
+            <a:pPr algn="l" indent="0" marL="0">
+              <a:lnSpc>
+                <a:spcPct val="92000"/>
+              </a:lnSpc>
+              <a:buNone/>
+            </a:pPr>
+            <a:r>
+              <a:rPr lang="en-US" sz="1600" dirty="0">
+                <a:solidFill>
+                  <a:srgbClr val="111111"/>
+                </a:solidFill>
+                <a:latin typeface="Pretendard" pitchFamily="34" charset="0"/>
+                <a:ea typeface="Pretendard" pitchFamily="34" charset="-122"/>
+                <a:cs typeface="Pretendard" pitchFamily="34" charset="-120"/>
+              </a:rPr>
+              <a:t>Split Planner</a:t>
+            </a:r>
+            <a:endParaRPr lang="en-US" sz="1600" dirty="0"/>
+          </a:p>
+        </p:txBody>
+      </p:sp>
+      <p:sp>
+        <p:nvSpPr>
+          <p:cNvPr id="40" name="Shape 38"/>
+          <p:cNvSpPr/>
+          <p:nvPr/>
+        </p:nvSpPr>
+        <p:spPr>
+          <a:xfrm>
+            <a:off x="4386072" y="1769364"/>
+            <a:ext cx="3435096" cy="109728"/>
+          </a:xfrm>
+          <a:prstGeom prst="rect">
+            <a:avLst/>
+          </a:prstGeom>
+          <a:solidFill>
+            <a:srgbClr val="2563EB"/>
+          </a:solidFill>
+          <a:ln w="12700">
+            <a:solidFill>
+              <a:srgbClr val="2563EB">
+                <a:alpha val="0"/>
+              </a:srgbClr>
+            </a:solidFill>
+            <a:prstDash val="solid"/>
+          </a:ln>
+        </p:spPr>
+      </p:sp>
+      <p:sp>
+        <p:nvSpPr>
+          <p:cNvPr id="41" name="Shape 39"/>
+          <p:cNvSpPr/>
+          <p:nvPr/>
+        </p:nvSpPr>
+        <p:spPr>
+          <a:xfrm>
+            <a:off x="4550664" y="2167311"/>
+            <a:ext cx="374538" cy="374538"/>
+          </a:xfrm>
+          <a:prstGeom prst="ellipse">
+            <a:avLst/>
+          </a:prstGeom>
+          <a:solidFill>
+            <a:srgbClr val="2563EB"/>
+          </a:solidFill>
+          <a:ln w="12700">
+            <a:solidFill>
+              <a:srgbClr val="2563EB">
+                <a:alpha val="0"/>
+              </a:srgbClr>
+            </a:solidFill>
+            <a:prstDash val="solid"/>
+          </a:ln>
+        </p:spPr>
+      </p:sp>
+      <p:sp>
+        <p:nvSpPr>
+          <p:cNvPr id="42" name="Text 40"/>
+          <p:cNvSpPr txBox="1"/>
+          <p:nvPr/>
+        </p:nvSpPr>
+        <p:spPr>
+          <a:xfrm>
+            <a:off x="4550664" y="2167311"/>
+            <a:ext cx="374538" cy="374538"/>
+          </a:xfrm>
+          <a:prstGeom prst="rect">
+            <a:avLst/>
+          </a:prstGeom>
+          <a:noFill/>
+          <a:ln/>
+        </p:spPr>
+        <p:txBody>
+          <a:bodyPr wrap="square" lIns="0" tIns="0" rIns="0" bIns="0" rtlCol="0" anchor="ctr">
+            <a:normAutofit/>
+          </a:bodyPr>
+          <a:lstStyle/>
+          <a:p>
+            <a:pPr algn="ctr" indent="0" marL="0">
+              <a:lnSpc>
+                <a:spcPct val="120000"/>
+              </a:lnSpc>
+              <a:buNone/>
+            </a:pPr>
+            <a:r>
+              <a:rPr lang="en-US" sz="1600" b="1" dirty="0">
+                <a:solidFill>
+                  <a:srgbClr val="F8FAFC"/>
+                </a:solidFill>
+                <a:latin typeface="Pretendard" pitchFamily="34" charset="0"/>
+                <a:ea typeface="Pretendard" pitchFamily="34" charset="-122"/>
+                <a:cs typeface="Pretendard" pitchFamily="34" charset="-120"/>
+              </a:rPr>
+              <a:t>6</a:t>
+            </a:r>
+            <a:endParaRPr lang="en-US" sz="1600" dirty="0"/>
+          </a:p>
+        </p:txBody>
+      </p:sp>
+      <p:sp>
+        <p:nvSpPr>
+          <p:cNvPr id="43" name="Text 41"/>
+          <p:cNvSpPr txBox="1"/>
+          <p:nvPr/>
+        </p:nvSpPr>
+        <p:spPr>
+          <a:xfrm>
+            <a:off x="5071506" y="1897380"/>
+            <a:ext cx="2585070" cy="914400"/>
+          </a:xfrm>
+          <a:prstGeom prst="rect">
+            <a:avLst/>
+          </a:prstGeom>
+          <a:noFill/>
+          <a:ln/>
+        </p:spPr>
+        <p:txBody>
+          <a:bodyPr wrap="square" lIns="0" tIns="25400" rIns="25400" bIns="0" rtlCol="0" anchor="ctr">
+            <a:normAutofit/>
+          </a:bodyPr>
+          <a:lstStyle/>
+          <a:p>
+            <a:pPr algn="l" indent="0" marL="0">
+              <a:lnSpc>
+                <a:spcPct val="92000"/>
+              </a:lnSpc>
+              <a:buNone/>
+            </a:pPr>
+            <a:r>
+              <a:rPr lang="en-US" sz="1600" dirty="0">
+                <a:solidFill>
+                  <a:srgbClr val="111111"/>
+                </a:solidFill>
+                <a:latin typeface="Pretendard" pitchFamily="34" charset="0"/>
+                <a:ea typeface="Pretendard" pitchFamily="34" charset="-122"/>
+                <a:cs typeface="Pretendard" pitchFamily="34" charset="-120"/>
+              </a:rPr>
+              <a:t>Presentation IR</a:t>
+            </a:r>
+            <a:endParaRPr lang="en-US" sz="1600" dirty="0"/>
+          </a:p>
+        </p:txBody>
+      </p:sp>
+      <p:sp>
+        <p:nvSpPr>
+          <p:cNvPr id="44" name="Shape 42"/>
+          <p:cNvSpPr/>
+          <p:nvPr/>
+        </p:nvSpPr>
+        <p:spPr>
+          <a:xfrm>
+            <a:off x="640080" y="1769364"/>
+            <a:ext cx="3435096" cy="109728"/>
+          </a:xfrm>
+          <a:prstGeom prst="rect">
+            <a:avLst/>
+          </a:prstGeom>
+          <a:solidFill>
+            <a:srgbClr val="2563EB"/>
+          </a:solidFill>
+          <a:ln w="12700">
+            <a:solidFill>
+              <a:srgbClr val="2563EB">
+                <a:alpha val="0"/>
+              </a:srgbClr>
+            </a:solidFill>
+            <a:prstDash val="solid"/>
+          </a:ln>
+        </p:spPr>
+      </p:sp>
+      <p:sp>
+        <p:nvSpPr>
+          <p:cNvPr id="45" name="Shape 43"/>
+          <p:cNvSpPr/>
+          <p:nvPr/>
+        </p:nvSpPr>
+        <p:spPr>
+          <a:xfrm>
+            <a:off x="804672" y="2167311"/>
+            <a:ext cx="374538" cy="374538"/>
+          </a:xfrm>
+          <a:prstGeom prst="ellipse">
+            <a:avLst/>
+          </a:prstGeom>
+          <a:solidFill>
+            <a:srgbClr val="2563EB"/>
+          </a:solidFill>
+          <a:ln w="12700">
+            <a:solidFill>
+              <a:srgbClr val="2563EB">
+                <a:alpha val="0"/>
+              </a:srgbClr>
+            </a:solidFill>
+            <a:prstDash val="solid"/>
+          </a:ln>
+        </p:spPr>
+      </p:sp>
+      <p:sp>
+        <p:nvSpPr>
+          <p:cNvPr id="46" name="Text 44"/>
+          <p:cNvSpPr txBox="1"/>
+          <p:nvPr/>
+        </p:nvSpPr>
+        <p:spPr>
+          <a:xfrm>
+            <a:off x="804672" y="2167311"/>
+            <a:ext cx="374538" cy="374538"/>
+          </a:xfrm>
+          <a:prstGeom prst="rect">
+            <a:avLst/>
+          </a:prstGeom>
+          <a:noFill/>
+          <a:ln/>
+        </p:spPr>
+        <p:txBody>
+          <a:bodyPr wrap="square" lIns="0" tIns="0" rIns="0" bIns="0" rtlCol="0" anchor="ctr">
+            <a:normAutofit/>
+          </a:bodyPr>
+          <a:lstStyle/>
+          <a:p>
+            <a:pPr algn="ctr" indent="0" marL="0">
+              <a:lnSpc>
+                <a:spcPct val="120000"/>
+              </a:lnSpc>
+              <a:buNone/>
+            </a:pPr>
+            <a:r>
+              <a:rPr lang="en-US" sz="1600" b="1" dirty="0">
+                <a:solidFill>
+                  <a:srgbClr val="F8FAFC"/>
+                </a:solidFill>
+                <a:latin typeface="Pretendard" pitchFamily="34" charset="0"/>
+                <a:ea typeface="Pretendard" pitchFamily="34" charset="-122"/>
+                <a:cs typeface="Pretendard" pitchFamily="34" charset="-120"/>
+              </a:rPr>
+              <a:t>7</a:t>
+            </a:r>
+            <a:endParaRPr lang="en-US" sz="1600" dirty="0"/>
+          </a:p>
+        </p:txBody>
+      </p:sp>
+      <p:sp>
+        <p:nvSpPr>
+          <p:cNvPr id="47" name="Text 45"/>
+          <p:cNvSpPr txBox="1"/>
+          <p:nvPr/>
+        </p:nvSpPr>
+        <p:spPr>
+          <a:xfrm>
+            <a:off x="1325514" y="1897380"/>
+            <a:ext cx="2585070" cy="914400"/>
+          </a:xfrm>
+          <a:prstGeom prst="rect">
+            <a:avLst/>
+          </a:prstGeom>
+          <a:noFill/>
+          <a:ln/>
+        </p:spPr>
+        <p:txBody>
+          <a:bodyPr wrap="square" lIns="0" tIns="25400" rIns="25400" bIns="0" rtlCol="0" anchor="ctr">
+            <a:normAutofit/>
+          </a:bodyPr>
+          <a:lstStyle/>
+          <a:p>
+            <a:pPr algn="l" indent="0" marL="0">
+              <a:lnSpc>
+                <a:spcPct val="92000"/>
+              </a:lnSpc>
+              <a:buNone/>
+            </a:pPr>
+            <a:r>
+              <a:rPr lang="en-US" sz="1600" dirty="0">
+                <a:solidFill>
+                  <a:srgbClr val="111111"/>
+                </a:solidFill>
+                <a:latin typeface="Pretendard" pitchFamily="34" charset="0"/>
+                <a:ea typeface="Pretendard" pitchFamily="34" charset="-122"/>
+                <a:cs typeface="Pretendard" pitchFamily="34" charset="-120"/>
+              </a:rPr>
+              <a:t>Layout IR</a:t>
+            </a:r>
+            <a:endParaRPr lang="en-US" sz="1600" dirty="0"/>
+          </a:p>
+        </p:txBody>
       </p:sp>
       <p:sp>
         <p:nvSpPr>
@@ -20781,54 +20781,6 @@
         </p:nvSpPr>
         <p:spPr>
           <a:xfrm>
-            <a:off x="6103620" y="3051581"/>
-            <a:ext cx="0" cy="389077"/>
-          </a:xfrm>
-          <a:prstGeom prst="line">
-            <a:avLst/>
-          </a:prstGeom>
-          <a:noFill/>
-          <a:ln w="12700">
-            <a:solidFill>
-              <a:srgbClr val="2563EB"/>
-            </a:solidFill>
-            <a:prstDash val="solid"/>
-            <a:tailEnd type="triangle"/>
-          </a:ln>
-        </p:spPr>
-      </p:sp>
-      <p:sp>
-        <p:nvSpPr>
-          <p:cNvPr id="4" name="Shape 2"/>
-          <p:cNvSpPr/>
-          <p:nvPr/>
-        </p:nvSpPr>
-        <p:spPr>
-          <a:xfrm>
-            <a:off x="6103620" y="4231157"/>
-            <a:ext cx="0" cy="389077"/>
-          </a:xfrm>
-          <a:prstGeom prst="line">
-            <a:avLst/>
-          </a:prstGeom>
-          <a:noFill/>
-          <a:ln w="12700">
-            <a:solidFill>
-              <a:srgbClr val="2563EB"/>
-            </a:solidFill>
-            <a:prstDash val="solid"/>
-            <a:tailEnd type="triangle"/>
-          </a:ln>
-        </p:spPr>
-      </p:sp>
-      <p:sp>
-        <p:nvSpPr>
-          <p:cNvPr id="5" name="Shape 3"/>
-          <p:cNvSpPr/>
-          <p:nvPr/>
-        </p:nvSpPr>
-        <p:spPr>
-          <a:xfrm>
             <a:off x="2169871" y="2221992"/>
             <a:ext cx="7867498" cy="868680"/>
           </a:xfrm>
@@ -20857,149 +20809,7 @@
       </p:sp>
       <p:sp>
         <p:nvSpPr>
-          <p:cNvPr id="6" name="Shape 4"/>
-          <p:cNvSpPr/>
-          <p:nvPr/>
-        </p:nvSpPr>
-        <p:spPr>
-          <a:xfrm>
-            <a:off x="2169871" y="2221992"/>
-            <a:ext cx="7867498" cy="109728"/>
-          </a:xfrm>
-          <a:prstGeom prst="rect">
-            <a:avLst/>
-          </a:prstGeom>
-          <a:solidFill>
-            <a:srgbClr val="2563EB"/>
-          </a:solidFill>
-          <a:ln w="12700">
-            <a:solidFill>
-              <a:srgbClr val="2563EB">
-                <a:alpha val="0"/>
-              </a:srgbClr>
-            </a:solidFill>
-            <a:prstDash val="solid"/>
-          </a:ln>
-        </p:spPr>
-      </p:sp>
-      <p:sp>
-        <p:nvSpPr>
-          <p:cNvPr id="7" name="Shape 5"/>
-          <p:cNvSpPr/>
-          <p:nvPr/>
-        </p:nvSpPr>
-        <p:spPr>
-          <a:xfrm>
-            <a:off x="2334463" y="2482596"/>
-            <a:ext cx="347472" cy="347472"/>
-          </a:xfrm>
-          <a:prstGeom prst="ellipse">
-            <a:avLst/>
-          </a:prstGeom>
-          <a:solidFill>
-            <a:srgbClr val="2563EB"/>
-          </a:solidFill>
-          <a:ln w="12700">
-            <a:solidFill>
-              <a:srgbClr val="2563EB">
-                <a:alpha val="0"/>
-              </a:srgbClr>
-            </a:solidFill>
-            <a:prstDash val="solid"/>
-          </a:ln>
-        </p:spPr>
-      </p:sp>
-      <p:sp>
-        <p:nvSpPr>
-          <p:cNvPr id="8" name="Text 6"/>
-          <p:cNvSpPr txBox="1"/>
-          <p:nvPr/>
-        </p:nvSpPr>
-        <p:spPr>
-          <a:xfrm>
-            <a:off x="2334463" y="2482596"/>
-            <a:ext cx="347472" cy="347472"/>
-          </a:xfrm>
-          <a:prstGeom prst="rect">
-            <a:avLst/>
-          </a:prstGeom>
-          <a:noFill/>
-          <a:ln/>
-        </p:spPr>
-        <p:txBody>
-          <a:bodyPr wrap="square" lIns="0" tIns="0" rIns="0" bIns="0" rtlCol="0" anchor="ctr">
-            <a:normAutofit/>
-          </a:bodyPr>
-          <a:lstStyle/>
-          <a:p>
-            <a:pPr algn="ctr" indent="0" marL="0">
-              <a:lnSpc>
-                <a:spcPct val="120000"/>
-              </a:lnSpc>
-              <a:buNone/>
-            </a:pPr>
-            <a:r>
-              <a:rPr lang="en-US" sz="1600" b="1" dirty="0">
-                <a:solidFill>
-                  <a:srgbClr val="F8FAFC"/>
-                </a:solidFill>
-                <a:latin typeface="Pretendard" pitchFamily="34" charset="0"/>
-                <a:ea typeface="Pretendard" pitchFamily="34" charset="-122"/>
-                <a:cs typeface="Pretendard" pitchFamily="34" charset="-120"/>
-              </a:rPr>
-              <a:t>1</a:t>
-            </a:r>
-            <a:endParaRPr lang="en-US" sz="1600" dirty="0"/>
-          </a:p>
-        </p:txBody>
-      </p:sp>
-      <p:sp>
-        <p:nvSpPr>
-          <p:cNvPr id="9" name="Text 7"/>
-          <p:cNvSpPr txBox="1"/>
-          <p:nvPr/>
-        </p:nvSpPr>
-        <p:spPr>
-          <a:xfrm>
-            <a:off x="2828239" y="2350008"/>
-            <a:ext cx="7044538" cy="612648"/>
-          </a:xfrm>
-          <a:prstGeom prst="rect">
-            <a:avLst/>
-          </a:prstGeom>
-          <a:noFill/>
-          <a:ln/>
-        </p:spPr>
-        <p:txBody>
-          <a:bodyPr wrap="square" lIns="0" tIns="25400" rIns="25400" bIns="0" rtlCol="0" anchor="ctr">
-            <a:normAutofit/>
-          </a:bodyPr>
-          <a:lstStyle/>
-          <a:p>
-            <a:pPr algn="l" indent="0" marL="0">
-              <a:lnSpc>
-                <a:spcPct val="92000"/>
-              </a:lnSpc>
-              <a:buNone/>
-            </a:pPr>
-            <a:r>
-              <a:rPr lang="en-US" sz="1600" dirty="0">
-                <a:solidFill>
-                  <a:srgbClr val="111111"/>
-                </a:solidFill>
-                <a:latin typeface="Pretendard" pitchFamily="34" charset="0"/>
-                <a:ea typeface="Pretendard" pitchFamily="34" charset="-122"/>
-                <a:cs typeface="Pretendard" pitchFamily="34" charset="-120"/>
-              </a:rPr>
-              <a:t>MDPR manifest and previews</a:t>
-            </a:r>
-            <a:endParaRPr lang="en-US" sz="1600" dirty="0"/>
-          </a:p>
-        </p:txBody>
-      </p:sp>
-      <p:sp>
-        <p:nvSpPr>
-          <p:cNvPr id="10" name="Shape 8"/>
+          <p:cNvPr id="4" name="Shape 2"/>
           <p:cNvSpPr/>
           <p:nvPr/>
         </p:nvSpPr>
@@ -21033,149 +20843,7 @@
       </p:sp>
       <p:sp>
         <p:nvSpPr>
-          <p:cNvPr id="11" name="Shape 9"/>
-          <p:cNvSpPr/>
-          <p:nvPr/>
-        </p:nvSpPr>
-        <p:spPr>
-          <a:xfrm>
-            <a:off x="2169871" y="3401568"/>
-            <a:ext cx="7867498" cy="109728"/>
-          </a:xfrm>
-          <a:prstGeom prst="rect">
-            <a:avLst/>
-          </a:prstGeom>
-          <a:solidFill>
-            <a:srgbClr val="2563EB"/>
-          </a:solidFill>
-          <a:ln w="12700">
-            <a:solidFill>
-              <a:srgbClr val="2563EB">
-                <a:alpha val="0"/>
-              </a:srgbClr>
-            </a:solidFill>
-            <a:prstDash val="solid"/>
-          </a:ln>
-        </p:spPr>
-      </p:sp>
-      <p:sp>
-        <p:nvSpPr>
-          <p:cNvPr id="12" name="Shape 10"/>
-          <p:cNvSpPr/>
-          <p:nvPr/>
-        </p:nvSpPr>
-        <p:spPr>
-          <a:xfrm>
-            <a:off x="2334463" y="3662172"/>
-            <a:ext cx="347472" cy="347472"/>
-          </a:xfrm>
-          <a:prstGeom prst="ellipse">
-            <a:avLst/>
-          </a:prstGeom>
-          <a:solidFill>
-            <a:srgbClr val="2563EB"/>
-          </a:solidFill>
-          <a:ln w="12700">
-            <a:solidFill>
-              <a:srgbClr val="2563EB">
-                <a:alpha val="0"/>
-              </a:srgbClr>
-            </a:solidFill>
-            <a:prstDash val="solid"/>
-          </a:ln>
-        </p:spPr>
-      </p:sp>
-      <p:sp>
-        <p:nvSpPr>
-          <p:cNvPr id="13" name="Text 11"/>
-          <p:cNvSpPr txBox="1"/>
-          <p:nvPr/>
-        </p:nvSpPr>
-        <p:spPr>
-          <a:xfrm>
-            <a:off x="2334463" y="3662172"/>
-            <a:ext cx="347472" cy="347472"/>
-          </a:xfrm>
-          <a:prstGeom prst="rect">
-            <a:avLst/>
-          </a:prstGeom>
-          <a:noFill/>
-          <a:ln/>
-        </p:spPr>
-        <p:txBody>
-          <a:bodyPr wrap="square" lIns="0" tIns="0" rIns="0" bIns="0" rtlCol="0" anchor="ctr">
-            <a:normAutofit/>
-          </a:bodyPr>
-          <a:lstStyle/>
-          <a:p>
-            <a:pPr algn="ctr" indent="0" marL="0">
-              <a:lnSpc>
-                <a:spcPct val="120000"/>
-              </a:lnSpc>
-              <a:buNone/>
-            </a:pPr>
-            <a:r>
-              <a:rPr lang="en-US" sz="1600" b="1" dirty="0">
-                <a:solidFill>
-                  <a:srgbClr val="F8FAFC"/>
-                </a:solidFill>
-                <a:latin typeface="Pretendard" pitchFamily="34" charset="0"/>
-                <a:ea typeface="Pretendard" pitchFamily="34" charset="-122"/>
-                <a:cs typeface="Pretendard" pitchFamily="34" charset="-120"/>
-              </a:rPr>
-              <a:t>2</a:t>
-            </a:r>
-            <a:endParaRPr lang="en-US" sz="1600" dirty="0"/>
-          </a:p>
-        </p:txBody>
-      </p:sp>
-      <p:sp>
-        <p:nvSpPr>
-          <p:cNvPr id="14" name="Text 12"/>
-          <p:cNvSpPr txBox="1"/>
-          <p:nvPr/>
-        </p:nvSpPr>
-        <p:spPr>
-          <a:xfrm>
-            <a:off x="2828239" y="3529584"/>
-            <a:ext cx="7044538" cy="612648"/>
-          </a:xfrm>
-          <a:prstGeom prst="rect">
-            <a:avLst/>
-          </a:prstGeom>
-          <a:noFill/>
-          <a:ln/>
-        </p:spPr>
-        <p:txBody>
-          <a:bodyPr wrap="square" lIns="0" tIns="25400" rIns="25400" bIns="0" rtlCol="0" anchor="ctr">
-            <a:normAutofit/>
-          </a:bodyPr>
-          <a:lstStyle/>
-          <a:p>
-            <a:pPr algn="l" indent="0" marL="0">
-              <a:lnSpc>
-                <a:spcPct val="92000"/>
-              </a:lnSpc>
-              <a:buNone/>
-            </a:pPr>
-            <a:r>
-              <a:rPr lang="en-US" sz="1600" dirty="0">
-                <a:solidFill>
-                  <a:srgbClr val="111111"/>
-                </a:solidFill>
-                <a:latin typeface="Pretendard" pitchFamily="34" charset="0"/>
-                <a:ea typeface="Pretendard" pitchFamily="34" charset="-122"/>
-                <a:cs typeface="Pretendard" pitchFamily="34" charset="-120"/>
-              </a:rPr>
-              <a:t>mdpr-skill hints or review findings</a:t>
-            </a:r>
-            <a:endParaRPr lang="en-US" sz="1600" dirty="0"/>
-          </a:p>
-        </p:txBody>
-      </p:sp>
-      <p:sp>
-        <p:nvSpPr>
-          <p:cNvPr id="15" name="Shape 13"/>
+          <p:cNvPr id="5" name="Shape 3"/>
           <p:cNvSpPr/>
           <p:nvPr/>
         </p:nvSpPr>
@@ -21206,6 +20874,338 @@
             </a:outerShdw>
           </a:effectLst>
         </p:spPr>
+      </p:sp>
+      <p:sp>
+        <p:nvSpPr>
+          <p:cNvPr id="6" name="Shape 4"/>
+          <p:cNvSpPr/>
+          <p:nvPr/>
+        </p:nvSpPr>
+        <p:spPr>
+          <a:xfrm>
+            <a:off x="6103620" y="3051581"/>
+            <a:ext cx="0" cy="389077"/>
+          </a:xfrm>
+          <a:prstGeom prst="line">
+            <a:avLst/>
+          </a:prstGeom>
+          <a:noFill/>
+          <a:ln w="12700">
+            <a:solidFill>
+              <a:srgbClr val="2563EB"/>
+            </a:solidFill>
+            <a:prstDash val="solid"/>
+            <a:tailEnd type="triangle"/>
+          </a:ln>
+        </p:spPr>
+      </p:sp>
+      <p:sp>
+        <p:nvSpPr>
+          <p:cNvPr id="7" name="Shape 5"/>
+          <p:cNvSpPr/>
+          <p:nvPr/>
+        </p:nvSpPr>
+        <p:spPr>
+          <a:xfrm>
+            <a:off x="6103620" y="4231157"/>
+            <a:ext cx="0" cy="389077"/>
+          </a:xfrm>
+          <a:prstGeom prst="line">
+            <a:avLst/>
+          </a:prstGeom>
+          <a:noFill/>
+          <a:ln w="12700">
+            <a:solidFill>
+              <a:srgbClr val="2563EB"/>
+            </a:solidFill>
+            <a:prstDash val="solid"/>
+            <a:tailEnd type="triangle"/>
+          </a:ln>
+        </p:spPr>
+      </p:sp>
+      <p:sp>
+        <p:nvSpPr>
+          <p:cNvPr id="8" name="Shape 6"/>
+          <p:cNvSpPr/>
+          <p:nvPr/>
+        </p:nvSpPr>
+        <p:spPr>
+          <a:xfrm>
+            <a:off x="2169871" y="2221992"/>
+            <a:ext cx="7867498" cy="109728"/>
+          </a:xfrm>
+          <a:prstGeom prst="rect">
+            <a:avLst/>
+          </a:prstGeom>
+          <a:solidFill>
+            <a:srgbClr val="2563EB"/>
+          </a:solidFill>
+          <a:ln w="12700">
+            <a:solidFill>
+              <a:srgbClr val="2563EB">
+                <a:alpha val="0"/>
+              </a:srgbClr>
+            </a:solidFill>
+            <a:prstDash val="solid"/>
+          </a:ln>
+        </p:spPr>
+      </p:sp>
+      <p:sp>
+        <p:nvSpPr>
+          <p:cNvPr id="9" name="Shape 7"/>
+          <p:cNvSpPr/>
+          <p:nvPr/>
+        </p:nvSpPr>
+        <p:spPr>
+          <a:xfrm>
+            <a:off x="2334463" y="2482596"/>
+            <a:ext cx="347472" cy="347472"/>
+          </a:xfrm>
+          <a:prstGeom prst="ellipse">
+            <a:avLst/>
+          </a:prstGeom>
+          <a:solidFill>
+            <a:srgbClr val="2563EB"/>
+          </a:solidFill>
+          <a:ln w="12700">
+            <a:solidFill>
+              <a:srgbClr val="2563EB">
+                <a:alpha val="0"/>
+              </a:srgbClr>
+            </a:solidFill>
+            <a:prstDash val="solid"/>
+          </a:ln>
+        </p:spPr>
+      </p:sp>
+      <p:sp>
+        <p:nvSpPr>
+          <p:cNvPr id="10" name="Text 8"/>
+          <p:cNvSpPr txBox="1"/>
+          <p:nvPr/>
+        </p:nvSpPr>
+        <p:spPr>
+          <a:xfrm>
+            <a:off x="2334463" y="2482596"/>
+            <a:ext cx="347472" cy="347472"/>
+          </a:xfrm>
+          <a:prstGeom prst="rect">
+            <a:avLst/>
+          </a:prstGeom>
+          <a:noFill/>
+          <a:ln/>
+        </p:spPr>
+        <p:txBody>
+          <a:bodyPr wrap="square" lIns="0" tIns="0" rIns="0" bIns="0" rtlCol="0" anchor="ctr">
+            <a:normAutofit/>
+          </a:bodyPr>
+          <a:lstStyle/>
+          <a:p>
+            <a:pPr algn="ctr" indent="0" marL="0">
+              <a:lnSpc>
+                <a:spcPct val="120000"/>
+              </a:lnSpc>
+              <a:buNone/>
+            </a:pPr>
+            <a:r>
+              <a:rPr lang="en-US" sz="1600" b="1" dirty="0">
+                <a:solidFill>
+                  <a:srgbClr val="F8FAFC"/>
+                </a:solidFill>
+                <a:latin typeface="Pretendard" pitchFamily="34" charset="0"/>
+                <a:ea typeface="Pretendard" pitchFamily="34" charset="-122"/>
+                <a:cs typeface="Pretendard" pitchFamily="34" charset="-120"/>
+              </a:rPr>
+              <a:t>1</a:t>
+            </a:r>
+            <a:endParaRPr lang="en-US" sz="1600" dirty="0"/>
+          </a:p>
+        </p:txBody>
+      </p:sp>
+      <p:sp>
+        <p:nvSpPr>
+          <p:cNvPr id="11" name="Text 9"/>
+          <p:cNvSpPr txBox="1"/>
+          <p:nvPr/>
+        </p:nvSpPr>
+        <p:spPr>
+          <a:xfrm>
+            <a:off x="2828239" y="2350008"/>
+            <a:ext cx="7044538" cy="612648"/>
+          </a:xfrm>
+          <a:prstGeom prst="rect">
+            <a:avLst/>
+          </a:prstGeom>
+          <a:noFill/>
+          <a:ln/>
+        </p:spPr>
+        <p:txBody>
+          <a:bodyPr wrap="square" lIns="0" tIns="25400" rIns="25400" bIns="0" rtlCol="0" anchor="ctr">
+            <a:normAutofit/>
+          </a:bodyPr>
+          <a:lstStyle/>
+          <a:p>
+            <a:pPr algn="l" indent="0" marL="0">
+              <a:lnSpc>
+                <a:spcPct val="92000"/>
+              </a:lnSpc>
+              <a:buNone/>
+            </a:pPr>
+            <a:r>
+              <a:rPr lang="en-US" sz="1600" dirty="0">
+                <a:solidFill>
+                  <a:srgbClr val="111111"/>
+                </a:solidFill>
+                <a:latin typeface="Pretendard" pitchFamily="34" charset="0"/>
+                <a:ea typeface="Pretendard" pitchFamily="34" charset="-122"/>
+                <a:cs typeface="Pretendard" pitchFamily="34" charset="-120"/>
+              </a:rPr>
+              <a:t>MDPR manifest and previews</a:t>
+            </a:r>
+            <a:endParaRPr lang="en-US" sz="1600" dirty="0"/>
+          </a:p>
+        </p:txBody>
+      </p:sp>
+      <p:sp>
+        <p:nvSpPr>
+          <p:cNvPr id="12" name="Shape 10"/>
+          <p:cNvSpPr/>
+          <p:nvPr/>
+        </p:nvSpPr>
+        <p:spPr>
+          <a:xfrm>
+            <a:off x="2169871" y="3401568"/>
+            <a:ext cx="7867498" cy="109728"/>
+          </a:xfrm>
+          <a:prstGeom prst="rect">
+            <a:avLst/>
+          </a:prstGeom>
+          <a:solidFill>
+            <a:srgbClr val="2563EB"/>
+          </a:solidFill>
+          <a:ln w="12700">
+            <a:solidFill>
+              <a:srgbClr val="2563EB">
+                <a:alpha val="0"/>
+              </a:srgbClr>
+            </a:solidFill>
+            <a:prstDash val="solid"/>
+          </a:ln>
+        </p:spPr>
+      </p:sp>
+      <p:sp>
+        <p:nvSpPr>
+          <p:cNvPr id="13" name="Shape 11"/>
+          <p:cNvSpPr/>
+          <p:nvPr/>
+        </p:nvSpPr>
+        <p:spPr>
+          <a:xfrm>
+            <a:off x="2334463" y="3662172"/>
+            <a:ext cx="347472" cy="347472"/>
+          </a:xfrm>
+          <a:prstGeom prst="ellipse">
+            <a:avLst/>
+          </a:prstGeom>
+          <a:solidFill>
+            <a:srgbClr val="2563EB"/>
+          </a:solidFill>
+          <a:ln w="12700">
+            <a:solidFill>
+              <a:srgbClr val="2563EB">
+                <a:alpha val="0"/>
+              </a:srgbClr>
+            </a:solidFill>
+            <a:prstDash val="solid"/>
+          </a:ln>
+        </p:spPr>
+      </p:sp>
+      <p:sp>
+        <p:nvSpPr>
+          <p:cNvPr id="14" name="Text 12"/>
+          <p:cNvSpPr txBox="1"/>
+          <p:nvPr/>
+        </p:nvSpPr>
+        <p:spPr>
+          <a:xfrm>
+            <a:off x="2334463" y="3662172"/>
+            <a:ext cx="347472" cy="347472"/>
+          </a:xfrm>
+          <a:prstGeom prst="rect">
+            <a:avLst/>
+          </a:prstGeom>
+          <a:noFill/>
+          <a:ln/>
+        </p:spPr>
+        <p:txBody>
+          <a:bodyPr wrap="square" lIns="0" tIns="0" rIns="0" bIns="0" rtlCol="0" anchor="ctr">
+            <a:normAutofit/>
+          </a:bodyPr>
+          <a:lstStyle/>
+          <a:p>
+            <a:pPr algn="ctr" indent="0" marL="0">
+              <a:lnSpc>
+                <a:spcPct val="120000"/>
+              </a:lnSpc>
+              <a:buNone/>
+            </a:pPr>
+            <a:r>
+              <a:rPr lang="en-US" sz="1600" b="1" dirty="0">
+                <a:solidFill>
+                  <a:srgbClr val="F8FAFC"/>
+                </a:solidFill>
+                <a:latin typeface="Pretendard" pitchFamily="34" charset="0"/>
+                <a:ea typeface="Pretendard" pitchFamily="34" charset="-122"/>
+                <a:cs typeface="Pretendard" pitchFamily="34" charset="-120"/>
+              </a:rPr>
+              <a:t>2</a:t>
+            </a:r>
+            <a:endParaRPr lang="en-US" sz="1600" dirty="0"/>
+          </a:p>
+        </p:txBody>
+      </p:sp>
+      <p:sp>
+        <p:nvSpPr>
+          <p:cNvPr id="15" name="Text 13"/>
+          <p:cNvSpPr txBox="1"/>
+          <p:nvPr/>
+        </p:nvSpPr>
+        <p:spPr>
+          <a:xfrm>
+            <a:off x="2828239" y="3529584"/>
+            <a:ext cx="7044538" cy="612648"/>
+          </a:xfrm>
+          <a:prstGeom prst="rect">
+            <a:avLst/>
+          </a:prstGeom>
+          <a:noFill/>
+          <a:ln/>
+        </p:spPr>
+        <p:txBody>
+          <a:bodyPr wrap="square" lIns="0" tIns="25400" rIns="25400" bIns="0" rtlCol="0" anchor="ctr">
+            <a:normAutofit/>
+          </a:bodyPr>
+          <a:lstStyle/>
+          <a:p>
+            <a:pPr algn="l" indent="0" marL="0">
+              <a:lnSpc>
+                <a:spcPct val="92000"/>
+              </a:lnSpc>
+              <a:buNone/>
+            </a:pPr>
+            <a:r>
+              <a:rPr lang="en-US" sz="1600" dirty="0">
+                <a:solidFill>
+                  <a:srgbClr val="111111"/>
+                </a:solidFill>
+                <a:latin typeface="Pretendard" pitchFamily="34" charset="0"/>
+                <a:ea typeface="Pretendard" pitchFamily="34" charset="-122"/>
+                <a:cs typeface="Pretendard" pitchFamily="34" charset="-120"/>
+              </a:rPr>
+              <a:t>mdpr-skill hints or review findings</a:t>
+            </a:r>
+            <a:endParaRPr lang="en-US" sz="1600" dirty="0"/>
+          </a:p>
+        </p:txBody>
       </p:sp>
       <p:sp>
         <p:nvSpPr>
@@ -22062,126 +22062,6 @@
         </p:nvSpPr>
         <p:spPr>
           <a:xfrm>
-            <a:off x="4002024" y="3095244"/>
-            <a:ext cx="457200" cy="0"/>
-          </a:xfrm>
-          <a:prstGeom prst="line">
-            <a:avLst/>
-          </a:prstGeom>
-          <a:noFill/>
-          <a:ln w="12700">
-            <a:solidFill>
-              <a:srgbClr val="2563EB"/>
-            </a:solidFill>
-            <a:prstDash val="solid"/>
-            <a:tailEnd type="triangle"/>
-          </a:ln>
-        </p:spPr>
-      </p:sp>
-      <p:sp>
-        <p:nvSpPr>
-          <p:cNvPr id="4" name="Shape 2"/>
-          <p:cNvSpPr/>
-          <p:nvPr/>
-        </p:nvSpPr>
-        <p:spPr>
-          <a:xfrm>
-            <a:off x="7748016" y="3095244"/>
-            <a:ext cx="457200" cy="0"/>
-          </a:xfrm>
-          <a:prstGeom prst="line">
-            <a:avLst/>
-          </a:prstGeom>
-          <a:noFill/>
-          <a:ln w="12700">
-            <a:solidFill>
-              <a:srgbClr val="2563EB"/>
-            </a:solidFill>
-            <a:prstDash val="solid"/>
-            <a:tailEnd type="triangle"/>
-          </a:ln>
-        </p:spPr>
-      </p:sp>
-      <p:sp>
-        <p:nvSpPr>
-          <p:cNvPr id="5" name="Shape 3"/>
-          <p:cNvSpPr/>
-          <p:nvPr/>
-        </p:nvSpPr>
-        <p:spPr>
-          <a:xfrm>
-            <a:off x="9849612" y="3627791"/>
-            <a:ext cx="0" cy="416235"/>
-          </a:xfrm>
-          <a:prstGeom prst="line">
-            <a:avLst/>
-          </a:prstGeom>
-          <a:noFill/>
-          <a:ln w="12700">
-            <a:solidFill>
-              <a:srgbClr val="2563EB"/>
-            </a:solidFill>
-            <a:prstDash val="solid"/>
-            <a:tailEnd type="triangle"/>
-          </a:ln>
-        </p:spPr>
-      </p:sp>
-      <p:sp>
-        <p:nvSpPr>
-          <p:cNvPr id="6" name="Shape 4"/>
-          <p:cNvSpPr/>
-          <p:nvPr/>
-        </p:nvSpPr>
-        <p:spPr>
-          <a:xfrm>
-            <a:off x="7748016" y="4576572"/>
-            <a:ext cx="457200" cy="0"/>
-          </a:xfrm>
-          <a:prstGeom prst="line">
-            <a:avLst/>
-          </a:prstGeom>
-          <a:noFill/>
-          <a:ln w="12700">
-            <a:solidFill>
-              <a:srgbClr val="2563EB"/>
-            </a:solidFill>
-            <a:prstDash val="solid"/>
-            <a:headEnd type="triangle"/>
-          </a:ln>
-        </p:spPr>
-      </p:sp>
-      <p:sp>
-        <p:nvSpPr>
-          <p:cNvPr id="7" name="Shape 5"/>
-          <p:cNvSpPr/>
-          <p:nvPr/>
-        </p:nvSpPr>
-        <p:spPr>
-          <a:xfrm>
-            <a:off x="4002024" y="4576572"/>
-            <a:ext cx="457200" cy="0"/>
-          </a:xfrm>
-          <a:prstGeom prst="line">
-            <a:avLst/>
-          </a:prstGeom>
-          <a:noFill/>
-          <a:ln w="12700">
-            <a:solidFill>
-              <a:srgbClr val="2563EB"/>
-            </a:solidFill>
-            <a:prstDash val="solid"/>
-            <a:headEnd type="triangle"/>
-          </a:ln>
-        </p:spPr>
-      </p:sp>
-      <p:sp>
-        <p:nvSpPr>
-          <p:cNvPr id="8" name="Shape 6"/>
-          <p:cNvSpPr/>
-          <p:nvPr/>
-        </p:nvSpPr>
-        <p:spPr>
-          <a:xfrm>
             <a:off x="640080" y="2510028"/>
             <a:ext cx="3435096" cy="1170432"/>
           </a:xfrm>
@@ -22210,149 +22090,7 @@
       </p:sp>
       <p:sp>
         <p:nvSpPr>
-          <p:cNvPr id="9" name="Shape 7"/>
-          <p:cNvSpPr/>
-          <p:nvPr/>
-        </p:nvSpPr>
-        <p:spPr>
-          <a:xfrm>
-            <a:off x="640080" y="2510028"/>
-            <a:ext cx="3435096" cy="109728"/>
-          </a:xfrm>
-          <a:prstGeom prst="rect">
-            <a:avLst/>
-          </a:prstGeom>
-          <a:solidFill>
-            <a:srgbClr val="2563EB"/>
-          </a:solidFill>
-          <a:ln w="12700">
-            <a:solidFill>
-              <a:srgbClr val="2563EB">
-                <a:alpha val="0"/>
-              </a:srgbClr>
-            </a:solidFill>
-            <a:prstDash val="solid"/>
-          </a:ln>
-        </p:spPr>
-      </p:sp>
-      <p:sp>
-        <p:nvSpPr>
-          <p:cNvPr id="10" name="Shape 8"/>
-          <p:cNvSpPr/>
-          <p:nvPr/>
-        </p:nvSpPr>
-        <p:spPr>
-          <a:xfrm>
-            <a:off x="804672" y="2907975"/>
-            <a:ext cx="374538" cy="374538"/>
-          </a:xfrm>
-          <a:prstGeom prst="ellipse">
-            <a:avLst/>
-          </a:prstGeom>
-          <a:solidFill>
-            <a:srgbClr val="2563EB"/>
-          </a:solidFill>
-          <a:ln w="12700">
-            <a:solidFill>
-              <a:srgbClr val="2563EB">
-                <a:alpha val="0"/>
-              </a:srgbClr>
-            </a:solidFill>
-            <a:prstDash val="solid"/>
-          </a:ln>
-        </p:spPr>
-      </p:sp>
-      <p:sp>
-        <p:nvSpPr>
-          <p:cNvPr id="11" name="Text 9"/>
-          <p:cNvSpPr txBox="1"/>
-          <p:nvPr/>
-        </p:nvSpPr>
-        <p:spPr>
-          <a:xfrm>
-            <a:off x="804672" y="2907975"/>
-            <a:ext cx="374538" cy="374538"/>
-          </a:xfrm>
-          <a:prstGeom prst="rect">
-            <a:avLst/>
-          </a:prstGeom>
-          <a:noFill/>
-          <a:ln/>
-        </p:spPr>
-        <p:txBody>
-          <a:bodyPr wrap="square" lIns="0" tIns="0" rIns="0" bIns="0" rtlCol="0" anchor="ctr">
-            <a:normAutofit/>
-          </a:bodyPr>
-          <a:lstStyle/>
-          <a:p>
-            <a:pPr algn="ctr" indent="0" marL="0">
-              <a:lnSpc>
-                <a:spcPct val="120000"/>
-              </a:lnSpc>
-              <a:buNone/>
-            </a:pPr>
-            <a:r>
-              <a:rPr lang="en-US" sz="1600" b="1" dirty="0">
-                <a:solidFill>
-                  <a:srgbClr val="F8FAFC"/>
-                </a:solidFill>
-                <a:latin typeface="Pretendard" pitchFamily="34" charset="0"/>
-                <a:ea typeface="Pretendard" pitchFamily="34" charset="-122"/>
-                <a:cs typeface="Pretendard" pitchFamily="34" charset="-120"/>
-              </a:rPr>
-              <a:t>1</a:t>
-            </a:r>
-            <a:endParaRPr lang="en-US" sz="1600" dirty="0"/>
-          </a:p>
-        </p:txBody>
-      </p:sp>
-      <p:sp>
-        <p:nvSpPr>
-          <p:cNvPr id="12" name="Text 10"/>
-          <p:cNvSpPr txBox="1"/>
-          <p:nvPr/>
-        </p:nvSpPr>
-        <p:spPr>
-          <a:xfrm>
-            <a:off x="1325514" y="2638044"/>
-            <a:ext cx="2585070" cy="914400"/>
-          </a:xfrm>
-          <a:prstGeom prst="rect">
-            <a:avLst/>
-          </a:prstGeom>
-          <a:noFill/>
-          <a:ln/>
-        </p:spPr>
-        <p:txBody>
-          <a:bodyPr wrap="square" lIns="0" tIns="25400" rIns="25400" bIns="0" rtlCol="0" anchor="ctr">
-            <a:normAutofit/>
-          </a:bodyPr>
-          <a:lstStyle/>
-          <a:p>
-            <a:pPr algn="l" indent="0" marL="0">
-              <a:lnSpc>
-                <a:spcPct val="92000"/>
-              </a:lnSpc>
-              <a:buNone/>
-            </a:pPr>
-            <a:r>
-              <a:rPr lang="en-US" sz="1600" dirty="0">
-                <a:solidFill>
-                  <a:srgbClr val="111111"/>
-                </a:solidFill>
-                <a:latin typeface="Pretendard" pitchFamily="34" charset="0"/>
-                <a:ea typeface="Pretendard" pitchFamily="34" charset="-122"/>
-                <a:cs typeface="Pretendard" pitchFamily="34" charset="-120"/>
-              </a:rPr>
-              <a:t>Markdown</a:t>
-            </a:r>
-            <a:endParaRPr lang="en-US" sz="1600" dirty="0"/>
-          </a:p>
-        </p:txBody>
-      </p:sp>
-      <p:sp>
-        <p:nvSpPr>
-          <p:cNvPr id="13" name="Shape 11"/>
+          <p:cNvPr id="4" name="Shape 2"/>
           <p:cNvSpPr/>
           <p:nvPr/>
         </p:nvSpPr>
@@ -22386,149 +22124,7 @@
       </p:sp>
       <p:sp>
         <p:nvSpPr>
-          <p:cNvPr id="14" name="Shape 12"/>
-          <p:cNvSpPr/>
-          <p:nvPr/>
-        </p:nvSpPr>
-        <p:spPr>
-          <a:xfrm>
-            <a:off x="4386072" y="2510028"/>
-            <a:ext cx="3435096" cy="109728"/>
-          </a:xfrm>
-          <a:prstGeom prst="rect">
-            <a:avLst/>
-          </a:prstGeom>
-          <a:solidFill>
-            <a:srgbClr val="2563EB"/>
-          </a:solidFill>
-          <a:ln w="12700">
-            <a:solidFill>
-              <a:srgbClr val="2563EB">
-                <a:alpha val="0"/>
-              </a:srgbClr>
-            </a:solidFill>
-            <a:prstDash val="solid"/>
-          </a:ln>
-        </p:spPr>
-      </p:sp>
-      <p:sp>
-        <p:nvSpPr>
-          <p:cNvPr id="15" name="Shape 13"/>
-          <p:cNvSpPr/>
-          <p:nvPr/>
-        </p:nvSpPr>
-        <p:spPr>
-          <a:xfrm>
-            <a:off x="4550664" y="2907975"/>
-            <a:ext cx="374538" cy="374538"/>
-          </a:xfrm>
-          <a:prstGeom prst="ellipse">
-            <a:avLst/>
-          </a:prstGeom>
-          <a:solidFill>
-            <a:srgbClr val="2563EB"/>
-          </a:solidFill>
-          <a:ln w="12700">
-            <a:solidFill>
-              <a:srgbClr val="2563EB">
-                <a:alpha val="0"/>
-              </a:srgbClr>
-            </a:solidFill>
-            <a:prstDash val="solid"/>
-          </a:ln>
-        </p:spPr>
-      </p:sp>
-      <p:sp>
-        <p:nvSpPr>
-          <p:cNvPr id="16" name="Text 14"/>
-          <p:cNvSpPr txBox="1"/>
-          <p:nvPr/>
-        </p:nvSpPr>
-        <p:spPr>
-          <a:xfrm>
-            <a:off x="4550664" y="2907975"/>
-            <a:ext cx="374538" cy="374538"/>
-          </a:xfrm>
-          <a:prstGeom prst="rect">
-            <a:avLst/>
-          </a:prstGeom>
-          <a:noFill/>
-          <a:ln/>
-        </p:spPr>
-        <p:txBody>
-          <a:bodyPr wrap="square" lIns="0" tIns="0" rIns="0" bIns="0" rtlCol="0" anchor="ctr">
-            <a:normAutofit/>
-          </a:bodyPr>
-          <a:lstStyle/>
-          <a:p>
-            <a:pPr algn="ctr" indent="0" marL="0">
-              <a:lnSpc>
-                <a:spcPct val="120000"/>
-              </a:lnSpc>
-              <a:buNone/>
-            </a:pPr>
-            <a:r>
-              <a:rPr lang="en-US" sz="1600" b="1" dirty="0">
-                <a:solidFill>
-                  <a:srgbClr val="F8FAFC"/>
-                </a:solidFill>
-                <a:latin typeface="Pretendard" pitchFamily="34" charset="0"/>
-                <a:ea typeface="Pretendard" pitchFamily="34" charset="-122"/>
-                <a:cs typeface="Pretendard" pitchFamily="34" charset="-120"/>
-              </a:rPr>
-              <a:t>2</a:t>
-            </a:r>
-            <a:endParaRPr lang="en-US" sz="1600" dirty="0"/>
-          </a:p>
-        </p:txBody>
-      </p:sp>
-      <p:sp>
-        <p:nvSpPr>
-          <p:cNvPr id="17" name="Text 15"/>
-          <p:cNvSpPr txBox="1"/>
-          <p:nvPr/>
-        </p:nvSpPr>
-        <p:spPr>
-          <a:xfrm>
-            <a:off x="5071506" y="2638044"/>
-            <a:ext cx="2585070" cy="914400"/>
-          </a:xfrm>
-          <a:prstGeom prst="rect">
-            <a:avLst/>
-          </a:prstGeom>
-          <a:noFill/>
-          <a:ln/>
-        </p:spPr>
-        <p:txBody>
-          <a:bodyPr wrap="square" lIns="0" tIns="25400" rIns="25400" bIns="0" rtlCol="0" anchor="ctr">
-            <a:normAutofit/>
-          </a:bodyPr>
-          <a:lstStyle/>
-          <a:p>
-            <a:pPr algn="l" indent="0" marL="0">
-              <a:lnSpc>
-                <a:spcPct val="92000"/>
-              </a:lnSpc>
-              <a:buNone/>
-            </a:pPr>
-            <a:r>
-              <a:rPr lang="en-US" sz="1600" dirty="0">
-                <a:solidFill>
-                  <a:srgbClr val="111111"/>
-                </a:solidFill>
-                <a:latin typeface="Pretendard" pitchFamily="34" charset="0"/>
-                <a:ea typeface="Pretendard" pitchFamily="34" charset="-122"/>
-                <a:cs typeface="Pretendard" pitchFamily="34" charset="-120"/>
-              </a:rPr>
-              <a:t>Parser (simple Markdown or Pandoc JSON)</a:t>
-            </a:r>
-            <a:endParaRPr lang="en-US" sz="1600" dirty="0"/>
-          </a:p>
-        </p:txBody>
-      </p:sp>
-      <p:sp>
-        <p:nvSpPr>
-          <p:cNvPr id="18" name="Shape 16"/>
+          <p:cNvPr id="5" name="Shape 3"/>
           <p:cNvSpPr/>
           <p:nvPr/>
         </p:nvSpPr>
@@ -22562,149 +22158,7 @@
       </p:sp>
       <p:sp>
         <p:nvSpPr>
-          <p:cNvPr id="19" name="Shape 17"/>
-          <p:cNvSpPr/>
-          <p:nvPr/>
-        </p:nvSpPr>
-        <p:spPr>
-          <a:xfrm>
-            <a:off x="8132064" y="2510028"/>
-            <a:ext cx="3435096" cy="109728"/>
-          </a:xfrm>
-          <a:prstGeom prst="rect">
-            <a:avLst/>
-          </a:prstGeom>
-          <a:solidFill>
-            <a:srgbClr val="2563EB"/>
-          </a:solidFill>
-          <a:ln w="12700">
-            <a:solidFill>
-              <a:srgbClr val="2563EB">
-                <a:alpha val="0"/>
-              </a:srgbClr>
-            </a:solidFill>
-            <a:prstDash val="solid"/>
-          </a:ln>
-        </p:spPr>
-      </p:sp>
-      <p:sp>
-        <p:nvSpPr>
-          <p:cNvPr id="20" name="Shape 18"/>
-          <p:cNvSpPr/>
-          <p:nvPr/>
-        </p:nvSpPr>
-        <p:spPr>
-          <a:xfrm>
-            <a:off x="8296656" y="2907975"/>
-            <a:ext cx="374538" cy="374538"/>
-          </a:xfrm>
-          <a:prstGeom prst="ellipse">
-            <a:avLst/>
-          </a:prstGeom>
-          <a:solidFill>
-            <a:srgbClr val="2563EB"/>
-          </a:solidFill>
-          <a:ln w="12700">
-            <a:solidFill>
-              <a:srgbClr val="2563EB">
-                <a:alpha val="0"/>
-              </a:srgbClr>
-            </a:solidFill>
-            <a:prstDash val="solid"/>
-          </a:ln>
-        </p:spPr>
-      </p:sp>
-      <p:sp>
-        <p:nvSpPr>
-          <p:cNvPr id="21" name="Text 19"/>
-          <p:cNvSpPr txBox="1"/>
-          <p:nvPr/>
-        </p:nvSpPr>
-        <p:spPr>
-          <a:xfrm>
-            <a:off x="8296656" y="2907975"/>
-            <a:ext cx="374538" cy="374538"/>
-          </a:xfrm>
-          <a:prstGeom prst="rect">
-            <a:avLst/>
-          </a:prstGeom>
-          <a:noFill/>
-          <a:ln/>
-        </p:spPr>
-        <p:txBody>
-          <a:bodyPr wrap="square" lIns="0" tIns="0" rIns="0" bIns="0" rtlCol="0" anchor="ctr">
-            <a:normAutofit/>
-          </a:bodyPr>
-          <a:lstStyle/>
-          <a:p>
-            <a:pPr algn="ctr" indent="0" marL="0">
-              <a:lnSpc>
-                <a:spcPct val="120000"/>
-              </a:lnSpc>
-              <a:buNone/>
-            </a:pPr>
-            <a:r>
-              <a:rPr lang="en-US" sz="1600" b="1" dirty="0">
-                <a:solidFill>
-                  <a:srgbClr val="F8FAFC"/>
-                </a:solidFill>
-                <a:latin typeface="Pretendard" pitchFamily="34" charset="0"/>
-                <a:ea typeface="Pretendard" pitchFamily="34" charset="-122"/>
-                <a:cs typeface="Pretendard" pitchFamily="34" charset="-120"/>
-              </a:rPr>
-              <a:t>3</a:t>
-            </a:r>
-            <a:endParaRPr lang="en-US" sz="1600" dirty="0"/>
-          </a:p>
-        </p:txBody>
-      </p:sp>
-      <p:sp>
-        <p:nvSpPr>
-          <p:cNvPr id="22" name="Text 20"/>
-          <p:cNvSpPr txBox="1"/>
-          <p:nvPr/>
-        </p:nvSpPr>
-        <p:spPr>
-          <a:xfrm>
-            <a:off x="8817498" y="2638044"/>
-            <a:ext cx="2585070" cy="914400"/>
-          </a:xfrm>
-          <a:prstGeom prst="rect">
-            <a:avLst/>
-          </a:prstGeom>
-          <a:noFill/>
-          <a:ln/>
-        </p:spPr>
-        <p:txBody>
-          <a:bodyPr wrap="square" lIns="0" tIns="25400" rIns="25400" bIns="0" rtlCol="0" anchor="ctr">
-            <a:normAutofit/>
-          </a:bodyPr>
-          <a:lstStyle/>
-          <a:p>
-            <a:pPr algn="l" indent="0" marL="0">
-              <a:lnSpc>
-                <a:spcPct val="92000"/>
-              </a:lnSpc>
-              <a:buNone/>
-            </a:pPr>
-            <a:r>
-              <a:rPr lang="en-US" sz="1600" dirty="0">
-                <a:solidFill>
-                  <a:srgbClr val="111111"/>
-                </a:solidFill>
-                <a:latin typeface="Pretendard" pitchFamily="34" charset="0"/>
-                <a:ea typeface="Pretendard" pitchFamily="34" charset="-122"/>
-                <a:cs typeface="Pretendard" pitchFamily="34" charset="-120"/>
-              </a:rPr>
-              <a:t>Outline Builder</a:t>
-            </a:r>
-            <a:endParaRPr lang="en-US" sz="1600" dirty="0"/>
-          </a:p>
-        </p:txBody>
-      </p:sp>
-      <p:sp>
-        <p:nvSpPr>
-          <p:cNvPr id="23" name="Shape 21"/>
+          <p:cNvPr id="6" name="Shape 4"/>
           <p:cNvSpPr/>
           <p:nvPr/>
         </p:nvSpPr>
@@ -22738,149 +22192,7 @@
       </p:sp>
       <p:sp>
         <p:nvSpPr>
-          <p:cNvPr id="24" name="Shape 22"/>
-          <p:cNvSpPr/>
-          <p:nvPr/>
-        </p:nvSpPr>
-        <p:spPr>
-          <a:xfrm>
-            <a:off x="8132064" y="3991356"/>
-            <a:ext cx="3435096" cy="109728"/>
-          </a:xfrm>
-          <a:prstGeom prst="rect">
-            <a:avLst/>
-          </a:prstGeom>
-          <a:solidFill>
-            <a:srgbClr val="2563EB"/>
-          </a:solidFill>
-          <a:ln w="12700">
-            <a:solidFill>
-              <a:srgbClr val="2563EB">
-                <a:alpha val="0"/>
-              </a:srgbClr>
-            </a:solidFill>
-            <a:prstDash val="solid"/>
-          </a:ln>
-        </p:spPr>
-      </p:sp>
-      <p:sp>
-        <p:nvSpPr>
-          <p:cNvPr id="25" name="Shape 23"/>
-          <p:cNvSpPr/>
-          <p:nvPr/>
-        </p:nvSpPr>
-        <p:spPr>
-          <a:xfrm>
-            <a:off x="8296656" y="4389303"/>
-            <a:ext cx="374538" cy="374538"/>
-          </a:xfrm>
-          <a:prstGeom prst="ellipse">
-            <a:avLst/>
-          </a:prstGeom>
-          <a:solidFill>
-            <a:srgbClr val="2563EB"/>
-          </a:solidFill>
-          <a:ln w="12700">
-            <a:solidFill>
-              <a:srgbClr val="2563EB">
-                <a:alpha val="0"/>
-              </a:srgbClr>
-            </a:solidFill>
-            <a:prstDash val="solid"/>
-          </a:ln>
-        </p:spPr>
-      </p:sp>
-      <p:sp>
-        <p:nvSpPr>
-          <p:cNvPr id="26" name="Text 24"/>
-          <p:cNvSpPr txBox="1"/>
-          <p:nvPr/>
-        </p:nvSpPr>
-        <p:spPr>
-          <a:xfrm>
-            <a:off x="8296656" y="4389303"/>
-            <a:ext cx="374538" cy="374538"/>
-          </a:xfrm>
-          <a:prstGeom prst="rect">
-            <a:avLst/>
-          </a:prstGeom>
-          <a:noFill/>
-          <a:ln/>
-        </p:spPr>
-        <p:txBody>
-          <a:bodyPr wrap="square" lIns="0" tIns="0" rIns="0" bIns="0" rtlCol="0" anchor="ctr">
-            <a:normAutofit/>
-          </a:bodyPr>
-          <a:lstStyle/>
-          <a:p>
-            <a:pPr algn="ctr" indent="0" marL="0">
-              <a:lnSpc>
-                <a:spcPct val="120000"/>
-              </a:lnSpc>
-              <a:buNone/>
-            </a:pPr>
-            <a:r>
-              <a:rPr lang="en-US" sz="1600" b="1" dirty="0">
-                <a:solidFill>
-                  <a:srgbClr val="F8FAFC"/>
-                </a:solidFill>
-                <a:latin typeface="Pretendard" pitchFamily="34" charset="0"/>
-                <a:ea typeface="Pretendard" pitchFamily="34" charset="-122"/>
-                <a:cs typeface="Pretendard" pitchFamily="34" charset="-120"/>
-              </a:rPr>
-              <a:t>4</a:t>
-            </a:r>
-            <a:endParaRPr lang="en-US" sz="1600" dirty="0"/>
-          </a:p>
-        </p:txBody>
-      </p:sp>
-      <p:sp>
-        <p:nvSpPr>
-          <p:cNvPr id="27" name="Text 25"/>
-          <p:cNvSpPr txBox="1"/>
-          <p:nvPr/>
-        </p:nvSpPr>
-        <p:spPr>
-          <a:xfrm>
-            <a:off x="8817498" y="4119372"/>
-            <a:ext cx="2585070" cy="914400"/>
-          </a:xfrm>
-          <a:prstGeom prst="rect">
-            <a:avLst/>
-          </a:prstGeom>
-          <a:noFill/>
-          <a:ln/>
-        </p:spPr>
-        <p:txBody>
-          <a:bodyPr wrap="square" lIns="0" tIns="25400" rIns="25400" bIns="0" rtlCol="0" anchor="ctr">
-            <a:normAutofit/>
-          </a:bodyPr>
-          <a:lstStyle/>
-          <a:p>
-            <a:pPr algn="l" indent="0" marL="0">
-              <a:lnSpc>
-                <a:spcPct val="92000"/>
-              </a:lnSpc>
-              <a:buNone/>
-            </a:pPr>
-            <a:r>
-              <a:rPr lang="en-US" sz="1600" dirty="0">
-                <a:solidFill>
-                  <a:srgbClr val="111111"/>
-                </a:solidFill>
-                <a:latin typeface="Pretendard" pitchFamily="34" charset="0"/>
-                <a:ea typeface="Pretendard" pitchFamily="34" charset="-122"/>
-                <a:cs typeface="Pretendard" pitchFamily="34" charset="-120"/>
-              </a:rPr>
-              <a:t>Split Planner</a:t>
-            </a:r>
-            <a:endParaRPr lang="en-US" sz="1600" dirty="0"/>
-          </a:p>
-        </p:txBody>
-      </p:sp>
-      <p:sp>
-        <p:nvSpPr>
-          <p:cNvPr id="28" name="Shape 26"/>
+          <p:cNvPr id="7" name="Shape 5"/>
           <p:cNvSpPr/>
           <p:nvPr/>
         </p:nvSpPr>
@@ -22914,149 +22226,7 @@
       </p:sp>
       <p:sp>
         <p:nvSpPr>
-          <p:cNvPr id="29" name="Shape 27"/>
-          <p:cNvSpPr/>
-          <p:nvPr/>
-        </p:nvSpPr>
-        <p:spPr>
-          <a:xfrm>
-            <a:off x="4386072" y="3991356"/>
-            <a:ext cx="3435096" cy="109728"/>
-          </a:xfrm>
-          <a:prstGeom prst="rect">
-            <a:avLst/>
-          </a:prstGeom>
-          <a:solidFill>
-            <a:srgbClr val="2563EB"/>
-          </a:solidFill>
-          <a:ln w="12700">
-            <a:solidFill>
-              <a:srgbClr val="2563EB">
-                <a:alpha val="0"/>
-              </a:srgbClr>
-            </a:solidFill>
-            <a:prstDash val="solid"/>
-          </a:ln>
-        </p:spPr>
-      </p:sp>
-      <p:sp>
-        <p:nvSpPr>
-          <p:cNvPr id="30" name="Shape 28"/>
-          <p:cNvSpPr/>
-          <p:nvPr/>
-        </p:nvSpPr>
-        <p:spPr>
-          <a:xfrm>
-            <a:off x="4550664" y="4389303"/>
-            <a:ext cx="374538" cy="374538"/>
-          </a:xfrm>
-          <a:prstGeom prst="ellipse">
-            <a:avLst/>
-          </a:prstGeom>
-          <a:solidFill>
-            <a:srgbClr val="2563EB"/>
-          </a:solidFill>
-          <a:ln w="12700">
-            <a:solidFill>
-              <a:srgbClr val="2563EB">
-                <a:alpha val="0"/>
-              </a:srgbClr>
-            </a:solidFill>
-            <a:prstDash val="solid"/>
-          </a:ln>
-        </p:spPr>
-      </p:sp>
-      <p:sp>
-        <p:nvSpPr>
-          <p:cNvPr id="31" name="Text 29"/>
-          <p:cNvSpPr txBox="1"/>
-          <p:nvPr/>
-        </p:nvSpPr>
-        <p:spPr>
-          <a:xfrm>
-            <a:off x="4550664" y="4389303"/>
-            <a:ext cx="374538" cy="374538"/>
-          </a:xfrm>
-          <a:prstGeom prst="rect">
-            <a:avLst/>
-          </a:prstGeom>
-          <a:noFill/>
-          <a:ln/>
-        </p:spPr>
-        <p:txBody>
-          <a:bodyPr wrap="square" lIns="0" tIns="0" rIns="0" bIns="0" rtlCol="0" anchor="ctr">
-            <a:normAutofit/>
-          </a:bodyPr>
-          <a:lstStyle/>
-          <a:p>
-            <a:pPr algn="ctr" indent="0" marL="0">
-              <a:lnSpc>
-                <a:spcPct val="120000"/>
-              </a:lnSpc>
-              <a:buNone/>
-            </a:pPr>
-            <a:r>
-              <a:rPr lang="en-US" sz="1600" b="1" dirty="0">
-                <a:solidFill>
-                  <a:srgbClr val="F8FAFC"/>
-                </a:solidFill>
-                <a:latin typeface="Pretendard" pitchFamily="34" charset="0"/>
-                <a:ea typeface="Pretendard" pitchFamily="34" charset="-122"/>
-                <a:cs typeface="Pretendard" pitchFamily="34" charset="-120"/>
-              </a:rPr>
-              <a:t>5</a:t>
-            </a:r>
-            <a:endParaRPr lang="en-US" sz="1600" dirty="0"/>
-          </a:p>
-        </p:txBody>
-      </p:sp>
-      <p:sp>
-        <p:nvSpPr>
-          <p:cNvPr id="32" name="Text 30"/>
-          <p:cNvSpPr txBox="1"/>
-          <p:nvPr/>
-        </p:nvSpPr>
-        <p:spPr>
-          <a:xfrm>
-            <a:off x="5071506" y="4119372"/>
-            <a:ext cx="2585070" cy="914400"/>
-          </a:xfrm>
-          <a:prstGeom prst="rect">
-            <a:avLst/>
-          </a:prstGeom>
-          <a:noFill/>
-          <a:ln/>
-        </p:spPr>
-        <p:txBody>
-          <a:bodyPr wrap="square" lIns="0" tIns="25400" rIns="25400" bIns="0" rtlCol="0" anchor="ctr">
-            <a:normAutofit/>
-          </a:bodyPr>
-          <a:lstStyle/>
-          <a:p>
-            <a:pPr algn="l" indent="0" marL="0">
-              <a:lnSpc>
-                <a:spcPct val="92000"/>
-              </a:lnSpc>
-              <a:buNone/>
-            </a:pPr>
-            <a:r>
-              <a:rPr lang="en-US" sz="1600" dirty="0">
-                <a:solidFill>
-                  <a:srgbClr val="111111"/>
-                </a:solidFill>
-                <a:latin typeface="Pretendard" pitchFamily="34" charset="0"/>
-                <a:ea typeface="Pretendard" pitchFamily="34" charset="-122"/>
-                <a:cs typeface="Pretendard" pitchFamily="34" charset="-120"/>
-              </a:rPr>
-              <a:t>Coherence Grouping</a:t>
-            </a:r>
-            <a:endParaRPr lang="en-US" sz="1600" dirty="0"/>
-          </a:p>
-        </p:txBody>
-      </p:sp>
-      <p:sp>
-        <p:nvSpPr>
-          <p:cNvPr id="33" name="Shape 31"/>
+          <p:cNvPr id="8" name="Shape 6"/>
           <p:cNvSpPr/>
           <p:nvPr/>
         </p:nvSpPr>
@@ -23087,6 +22257,836 @@
             </a:outerShdw>
           </a:effectLst>
         </p:spPr>
+      </p:sp>
+      <p:sp>
+        <p:nvSpPr>
+          <p:cNvPr id="9" name="Shape 7"/>
+          <p:cNvSpPr/>
+          <p:nvPr/>
+        </p:nvSpPr>
+        <p:spPr>
+          <a:xfrm>
+            <a:off x="4002024" y="3095244"/>
+            <a:ext cx="457200" cy="0"/>
+          </a:xfrm>
+          <a:prstGeom prst="line">
+            <a:avLst/>
+          </a:prstGeom>
+          <a:noFill/>
+          <a:ln w="12700">
+            <a:solidFill>
+              <a:srgbClr val="2563EB"/>
+            </a:solidFill>
+            <a:prstDash val="solid"/>
+            <a:tailEnd type="triangle"/>
+          </a:ln>
+        </p:spPr>
+      </p:sp>
+      <p:sp>
+        <p:nvSpPr>
+          <p:cNvPr id="10" name="Shape 8"/>
+          <p:cNvSpPr/>
+          <p:nvPr/>
+        </p:nvSpPr>
+        <p:spPr>
+          <a:xfrm>
+            <a:off x="7748016" y="3095244"/>
+            <a:ext cx="457200" cy="0"/>
+          </a:xfrm>
+          <a:prstGeom prst="line">
+            <a:avLst/>
+          </a:prstGeom>
+          <a:noFill/>
+          <a:ln w="12700">
+            <a:solidFill>
+              <a:srgbClr val="2563EB"/>
+            </a:solidFill>
+            <a:prstDash val="solid"/>
+            <a:tailEnd type="triangle"/>
+          </a:ln>
+        </p:spPr>
+      </p:sp>
+      <p:sp>
+        <p:nvSpPr>
+          <p:cNvPr id="11" name="Shape 9"/>
+          <p:cNvSpPr/>
+          <p:nvPr/>
+        </p:nvSpPr>
+        <p:spPr>
+          <a:xfrm>
+            <a:off x="9849612" y="3627791"/>
+            <a:ext cx="0" cy="416235"/>
+          </a:xfrm>
+          <a:prstGeom prst="line">
+            <a:avLst/>
+          </a:prstGeom>
+          <a:noFill/>
+          <a:ln w="12700">
+            <a:solidFill>
+              <a:srgbClr val="2563EB"/>
+            </a:solidFill>
+            <a:prstDash val="solid"/>
+            <a:tailEnd type="triangle"/>
+          </a:ln>
+        </p:spPr>
+      </p:sp>
+      <p:sp>
+        <p:nvSpPr>
+          <p:cNvPr id="12" name="Shape 10"/>
+          <p:cNvSpPr/>
+          <p:nvPr/>
+        </p:nvSpPr>
+        <p:spPr>
+          <a:xfrm>
+            <a:off x="7748016" y="4576572"/>
+            <a:ext cx="457200" cy="0"/>
+          </a:xfrm>
+          <a:prstGeom prst="line">
+            <a:avLst/>
+          </a:prstGeom>
+          <a:noFill/>
+          <a:ln w="12700">
+            <a:solidFill>
+              <a:srgbClr val="2563EB"/>
+            </a:solidFill>
+            <a:prstDash val="solid"/>
+            <a:headEnd type="triangle"/>
+          </a:ln>
+        </p:spPr>
+      </p:sp>
+      <p:sp>
+        <p:nvSpPr>
+          <p:cNvPr id="13" name="Shape 11"/>
+          <p:cNvSpPr/>
+          <p:nvPr/>
+        </p:nvSpPr>
+        <p:spPr>
+          <a:xfrm>
+            <a:off x="4002024" y="4576572"/>
+            <a:ext cx="457200" cy="0"/>
+          </a:xfrm>
+          <a:prstGeom prst="line">
+            <a:avLst/>
+          </a:prstGeom>
+          <a:noFill/>
+          <a:ln w="12700">
+            <a:solidFill>
+              <a:srgbClr val="2563EB"/>
+            </a:solidFill>
+            <a:prstDash val="solid"/>
+            <a:headEnd type="triangle"/>
+          </a:ln>
+        </p:spPr>
+      </p:sp>
+      <p:sp>
+        <p:nvSpPr>
+          <p:cNvPr id="14" name="Shape 12"/>
+          <p:cNvSpPr/>
+          <p:nvPr/>
+        </p:nvSpPr>
+        <p:spPr>
+          <a:xfrm>
+            <a:off x="640080" y="2510028"/>
+            <a:ext cx="3435096" cy="109728"/>
+          </a:xfrm>
+          <a:prstGeom prst="rect">
+            <a:avLst/>
+          </a:prstGeom>
+          <a:solidFill>
+            <a:srgbClr val="2563EB"/>
+          </a:solidFill>
+          <a:ln w="12700">
+            <a:solidFill>
+              <a:srgbClr val="2563EB">
+                <a:alpha val="0"/>
+              </a:srgbClr>
+            </a:solidFill>
+            <a:prstDash val="solid"/>
+          </a:ln>
+        </p:spPr>
+      </p:sp>
+      <p:sp>
+        <p:nvSpPr>
+          <p:cNvPr id="15" name="Shape 13"/>
+          <p:cNvSpPr/>
+          <p:nvPr/>
+        </p:nvSpPr>
+        <p:spPr>
+          <a:xfrm>
+            <a:off x="804672" y="2907975"/>
+            <a:ext cx="374538" cy="374538"/>
+          </a:xfrm>
+          <a:prstGeom prst="ellipse">
+            <a:avLst/>
+          </a:prstGeom>
+          <a:solidFill>
+            <a:srgbClr val="2563EB"/>
+          </a:solidFill>
+          <a:ln w="12700">
+            <a:solidFill>
+              <a:srgbClr val="2563EB">
+                <a:alpha val="0"/>
+              </a:srgbClr>
+            </a:solidFill>
+            <a:prstDash val="solid"/>
+          </a:ln>
+        </p:spPr>
+      </p:sp>
+      <p:sp>
+        <p:nvSpPr>
+          <p:cNvPr id="16" name="Text 14"/>
+          <p:cNvSpPr txBox="1"/>
+          <p:nvPr/>
+        </p:nvSpPr>
+        <p:spPr>
+          <a:xfrm>
+            <a:off x="804672" y="2907975"/>
+            <a:ext cx="374538" cy="374538"/>
+          </a:xfrm>
+          <a:prstGeom prst="rect">
+            <a:avLst/>
+          </a:prstGeom>
+          <a:noFill/>
+          <a:ln/>
+        </p:spPr>
+        <p:txBody>
+          <a:bodyPr wrap="square" lIns="0" tIns="0" rIns="0" bIns="0" rtlCol="0" anchor="ctr">
+            <a:normAutofit/>
+          </a:bodyPr>
+          <a:lstStyle/>
+          <a:p>
+            <a:pPr algn="ctr" indent="0" marL="0">
+              <a:lnSpc>
+                <a:spcPct val="120000"/>
+              </a:lnSpc>
+              <a:buNone/>
+            </a:pPr>
+            <a:r>
+              <a:rPr lang="en-US" sz="1600" b="1" dirty="0">
+                <a:solidFill>
+                  <a:srgbClr val="F8FAFC"/>
+                </a:solidFill>
+                <a:latin typeface="Pretendard" pitchFamily="34" charset="0"/>
+                <a:ea typeface="Pretendard" pitchFamily="34" charset="-122"/>
+                <a:cs typeface="Pretendard" pitchFamily="34" charset="-120"/>
+              </a:rPr>
+              <a:t>1</a:t>
+            </a:r>
+            <a:endParaRPr lang="en-US" sz="1600" dirty="0"/>
+          </a:p>
+        </p:txBody>
+      </p:sp>
+      <p:sp>
+        <p:nvSpPr>
+          <p:cNvPr id="17" name="Text 15"/>
+          <p:cNvSpPr txBox="1"/>
+          <p:nvPr/>
+        </p:nvSpPr>
+        <p:spPr>
+          <a:xfrm>
+            <a:off x="1325514" y="2638044"/>
+            <a:ext cx="2585070" cy="914400"/>
+          </a:xfrm>
+          <a:prstGeom prst="rect">
+            <a:avLst/>
+          </a:prstGeom>
+          <a:noFill/>
+          <a:ln/>
+        </p:spPr>
+        <p:txBody>
+          <a:bodyPr wrap="square" lIns="0" tIns="25400" rIns="25400" bIns="0" rtlCol="0" anchor="ctr">
+            <a:normAutofit/>
+          </a:bodyPr>
+          <a:lstStyle/>
+          <a:p>
+            <a:pPr algn="l" indent="0" marL="0">
+              <a:lnSpc>
+                <a:spcPct val="92000"/>
+              </a:lnSpc>
+              <a:buNone/>
+            </a:pPr>
+            <a:r>
+              <a:rPr lang="en-US" sz="1600" dirty="0">
+                <a:solidFill>
+                  <a:srgbClr val="111111"/>
+                </a:solidFill>
+                <a:latin typeface="Pretendard" pitchFamily="34" charset="0"/>
+                <a:ea typeface="Pretendard" pitchFamily="34" charset="-122"/>
+                <a:cs typeface="Pretendard" pitchFamily="34" charset="-120"/>
+              </a:rPr>
+              <a:t>Markdown</a:t>
+            </a:r>
+            <a:endParaRPr lang="en-US" sz="1600" dirty="0"/>
+          </a:p>
+        </p:txBody>
+      </p:sp>
+      <p:sp>
+        <p:nvSpPr>
+          <p:cNvPr id="18" name="Shape 16"/>
+          <p:cNvSpPr/>
+          <p:nvPr/>
+        </p:nvSpPr>
+        <p:spPr>
+          <a:xfrm>
+            <a:off x="4386072" y="2510028"/>
+            <a:ext cx="3435096" cy="109728"/>
+          </a:xfrm>
+          <a:prstGeom prst="rect">
+            <a:avLst/>
+          </a:prstGeom>
+          <a:solidFill>
+            <a:srgbClr val="2563EB"/>
+          </a:solidFill>
+          <a:ln w="12700">
+            <a:solidFill>
+              <a:srgbClr val="2563EB">
+                <a:alpha val="0"/>
+              </a:srgbClr>
+            </a:solidFill>
+            <a:prstDash val="solid"/>
+          </a:ln>
+        </p:spPr>
+      </p:sp>
+      <p:sp>
+        <p:nvSpPr>
+          <p:cNvPr id="19" name="Shape 17"/>
+          <p:cNvSpPr/>
+          <p:nvPr/>
+        </p:nvSpPr>
+        <p:spPr>
+          <a:xfrm>
+            <a:off x="4550664" y="2907975"/>
+            <a:ext cx="374538" cy="374538"/>
+          </a:xfrm>
+          <a:prstGeom prst="ellipse">
+            <a:avLst/>
+          </a:prstGeom>
+          <a:solidFill>
+            <a:srgbClr val="2563EB"/>
+          </a:solidFill>
+          <a:ln w="12700">
+            <a:solidFill>
+              <a:srgbClr val="2563EB">
+                <a:alpha val="0"/>
+              </a:srgbClr>
+            </a:solidFill>
+            <a:prstDash val="solid"/>
+          </a:ln>
+        </p:spPr>
+      </p:sp>
+      <p:sp>
+        <p:nvSpPr>
+          <p:cNvPr id="20" name="Text 18"/>
+          <p:cNvSpPr txBox="1"/>
+          <p:nvPr/>
+        </p:nvSpPr>
+        <p:spPr>
+          <a:xfrm>
+            <a:off x="4550664" y="2907975"/>
+            <a:ext cx="374538" cy="374538"/>
+          </a:xfrm>
+          <a:prstGeom prst="rect">
+            <a:avLst/>
+          </a:prstGeom>
+          <a:noFill/>
+          <a:ln/>
+        </p:spPr>
+        <p:txBody>
+          <a:bodyPr wrap="square" lIns="0" tIns="0" rIns="0" bIns="0" rtlCol="0" anchor="ctr">
+            <a:normAutofit/>
+          </a:bodyPr>
+          <a:lstStyle/>
+          <a:p>
+            <a:pPr algn="ctr" indent="0" marL="0">
+              <a:lnSpc>
+                <a:spcPct val="120000"/>
+              </a:lnSpc>
+              <a:buNone/>
+            </a:pPr>
+            <a:r>
+              <a:rPr lang="en-US" sz="1600" b="1" dirty="0">
+                <a:solidFill>
+                  <a:srgbClr val="F8FAFC"/>
+                </a:solidFill>
+                <a:latin typeface="Pretendard" pitchFamily="34" charset="0"/>
+                <a:ea typeface="Pretendard" pitchFamily="34" charset="-122"/>
+                <a:cs typeface="Pretendard" pitchFamily="34" charset="-120"/>
+              </a:rPr>
+              <a:t>2</a:t>
+            </a:r>
+            <a:endParaRPr lang="en-US" sz="1600" dirty="0"/>
+          </a:p>
+        </p:txBody>
+      </p:sp>
+      <p:sp>
+        <p:nvSpPr>
+          <p:cNvPr id="21" name="Text 19"/>
+          <p:cNvSpPr txBox="1"/>
+          <p:nvPr/>
+        </p:nvSpPr>
+        <p:spPr>
+          <a:xfrm>
+            <a:off x="5071506" y="2638044"/>
+            <a:ext cx="2585070" cy="914400"/>
+          </a:xfrm>
+          <a:prstGeom prst="rect">
+            <a:avLst/>
+          </a:prstGeom>
+          <a:noFill/>
+          <a:ln/>
+        </p:spPr>
+        <p:txBody>
+          <a:bodyPr wrap="square" lIns="0" tIns="25400" rIns="25400" bIns="0" rtlCol="0" anchor="ctr">
+            <a:normAutofit/>
+          </a:bodyPr>
+          <a:lstStyle/>
+          <a:p>
+            <a:pPr algn="l" indent="0" marL="0">
+              <a:lnSpc>
+                <a:spcPct val="92000"/>
+              </a:lnSpc>
+              <a:buNone/>
+            </a:pPr>
+            <a:r>
+              <a:rPr lang="en-US" sz="1600" dirty="0">
+                <a:solidFill>
+                  <a:srgbClr val="111111"/>
+                </a:solidFill>
+                <a:latin typeface="Pretendard" pitchFamily="34" charset="0"/>
+                <a:ea typeface="Pretendard" pitchFamily="34" charset="-122"/>
+                <a:cs typeface="Pretendard" pitchFamily="34" charset="-120"/>
+              </a:rPr>
+              <a:t>Parser (simple Markdown or Pandoc JSON)</a:t>
+            </a:r>
+            <a:endParaRPr lang="en-US" sz="1600" dirty="0"/>
+          </a:p>
+        </p:txBody>
+      </p:sp>
+      <p:sp>
+        <p:nvSpPr>
+          <p:cNvPr id="22" name="Shape 20"/>
+          <p:cNvSpPr/>
+          <p:nvPr/>
+        </p:nvSpPr>
+        <p:spPr>
+          <a:xfrm>
+            <a:off x="8132064" y="2510028"/>
+            <a:ext cx="3435096" cy="109728"/>
+          </a:xfrm>
+          <a:prstGeom prst="rect">
+            <a:avLst/>
+          </a:prstGeom>
+          <a:solidFill>
+            <a:srgbClr val="2563EB"/>
+          </a:solidFill>
+          <a:ln w="12700">
+            <a:solidFill>
+              <a:srgbClr val="2563EB">
+                <a:alpha val="0"/>
+              </a:srgbClr>
+            </a:solidFill>
+            <a:prstDash val="solid"/>
+          </a:ln>
+        </p:spPr>
+      </p:sp>
+      <p:sp>
+        <p:nvSpPr>
+          <p:cNvPr id="23" name="Shape 21"/>
+          <p:cNvSpPr/>
+          <p:nvPr/>
+        </p:nvSpPr>
+        <p:spPr>
+          <a:xfrm>
+            <a:off x="8296656" y="2907975"/>
+            <a:ext cx="374538" cy="374538"/>
+          </a:xfrm>
+          <a:prstGeom prst="ellipse">
+            <a:avLst/>
+          </a:prstGeom>
+          <a:solidFill>
+            <a:srgbClr val="2563EB"/>
+          </a:solidFill>
+          <a:ln w="12700">
+            <a:solidFill>
+              <a:srgbClr val="2563EB">
+                <a:alpha val="0"/>
+              </a:srgbClr>
+            </a:solidFill>
+            <a:prstDash val="solid"/>
+          </a:ln>
+        </p:spPr>
+      </p:sp>
+      <p:sp>
+        <p:nvSpPr>
+          <p:cNvPr id="24" name="Text 22"/>
+          <p:cNvSpPr txBox="1"/>
+          <p:nvPr/>
+        </p:nvSpPr>
+        <p:spPr>
+          <a:xfrm>
+            <a:off x="8296656" y="2907975"/>
+            <a:ext cx="374538" cy="374538"/>
+          </a:xfrm>
+          <a:prstGeom prst="rect">
+            <a:avLst/>
+          </a:prstGeom>
+          <a:noFill/>
+          <a:ln/>
+        </p:spPr>
+        <p:txBody>
+          <a:bodyPr wrap="square" lIns="0" tIns="0" rIns="0" bIns="0" rtlCol="0" anchor="ctr">
+            <a:normAutofit/>
+          </a:bodyPr>
+          <a:lstStyle/>
+          <a:p>
+            <a:pPr algn="ctr" indent="0" marL="0">
+              <a:lnSpc>
+                <a:spcPct val="120000"/>
+              </a:lnSpc>
+              <a:buNone/>
+            </a:pPr>
+            <a:r>
+              <a:rPr lang="en-US" sz="1600" b="1" dirty="0">
+                <a:solidFill>
+                  <a:srgbClr val="F8FAFC"/>
+                </a:solidFill>
+                <a:latin typeface="Pretendard" pitchFamily="34" charset="0"/>
+                <a:ea typeface="Pretendard" pitchFamily="34" charset="-122"/>
+                <a:cs typeface="Pretendard" pitchFamily="34" charset="-120"/>
+              </a:rPr>
+              <a:t>3</a:t>
+            </a:r>
+            <a:endParaRPr lang="en-US" sz="1600" dirty="0"/>
+          </a:p>
+        </p:txBody>
+      </p:sp>
+      <p:sp>
+        <p:nvSpPr>
+          <p:cNvPr id="25" name="Text 23"/>
+          <p:cNvSpPr txBox="1"/>
+          <p:nvPr/>
+        </p:nvSpPr>
+        <p:spPr>
+          <a:xfrm>
+            <a:off x="8817498" y="2638044"/>
+            <a:ext cx="2585070" cy="914400"/>
+          </a:xfrm>
+          <a:prstGeom prst="rect">
+            <a:avLst/>
+          </a:prstGeom>
+          <a:noFill/>
+          <a:ln/>
+        </p:spPr>
+        <p:txBody>
+          <a:bodyPr wrap="square" lIns="0" tIns="25400" rIns="25400" bIns="0" rtlCol="0" anchor="ctr">
+            <a:normAutofit/>
+          </a:bodyPr>
+          <a:lstStyle/>
+          <a:p>
+            <a:pPr algn="l" indent="0" marL="0">
+              <a:lnSpc>
+                <a:spcPct val="92000"/>
+              </a:lnSpc>
+              <a:buNone/>
+            </a:pPr>
+            <a:r>
+              <a:rPr lang="en-US" sz="1600" dirty="0">
+                <a:solidFill>
+                  <a:srgbClr val="111111"/>
+                </a:solidFill>
+                <a:latin typeface="Pretendard" pitchFamily="34" charset="0"/>
+                <a:ea typeface="Pretendard" pitchFamily="34" charset="-122"/>
+                <a:cs typeface="Pretendard" pitchFamily="34" charset="-120"/>
+              </a:rPr>
+              <a:t>Outline Builder</a:t>
+            </a:r>
+            <a:endParaRPr lang="en-US" sz="1600" dirty="0"/>
+          </a:p>
+        </p:txBody>
+      </p:sp>
+      <p:sp>
+        <p:nvSpPr>
+          <p:cNvPr id="26" name="Shape 24"/>
+          <p:cNvSpPr/>
+          <p:nvPr/>
+        </p:nvSpPr>
+        <p:spPr>
+          <a:xfrm>
+            <a:off x="8132064" y="3991356"/>
+            <a:ext cx="3435096" cy="109728"/>
+          </a:xfrm>
+          <a:prstGeom prst="rect">
+            <a:avLst/>
+          </a:prstGeom>
+          <a:solidFill>
+            <a:srgbClr val="2563EB"/>
+          </a:solidFill>
+          <a:ln w="12700">
+            <a:solidFill>
+              <a:srgbClr val="2563EB">
+                <a:alpha val="0"/>
+              </a:srgbClr>
+            </a:solidFill>
+            <a:prstDash val="solid"/>
+          </a:ln>
+        </p:spPr>
+      </p:sp>
+      <p:sp>
+        <p:nvSpPr>
+          <p:cNvPr id="27" name="Shape 25"/>
+          <p:cNvSpPr/>
+          <p:nvPr/>
+        </p:nvSpPr>
+        <p:spPr>
+          <a:xfrm>
+            <a:off x="8296656" y="4389303"/>
+            <a:ext cx="374538" cy="374538"/>
+          </a:xfrm>
+          <a:prstGeom prst="ellipse">
+            <a:avLst/>
+          </a:prstGeom>
+          <a:solidFill>
+            <a:srgbClr val="2563EB"/>
+          </a:solidFill>
+          <a:ln w="12700">
+            <a:solidFill>
+              <a:srgbClr val="2563EB">
+                <a:alpha val="0"/>
+              </a:srgbClr>
+            </a:solidFill>
+            <a:prstDash val="solid"/>
+          </a:ln>
+        </p:spPr>
+      </p:sp>
+      <p:sp>
+        <p:nvSpPr>
+          <p:cNvPr id="28" name="Text 26"/>
+          <p:cNvSpPr txBox="1"/>
+          <p:nvPr/>
+        </p:nvSpPr>
+        <p:spPr>
+          <a:xfrm>
+            <a:off x="8296656" y="4389303"/>
+            <a:ext cx="374538" cy="374538"/>
+          </a:xfrm>
+          <a:prstGeom prst="rect">
+            <a:avLst/>
+          </a:prstGeom>
+          <a:noFill/>
+          <a:ln/>
+        </p:spPr>
+        <p:txBody>
+          <a:bodyPr wrap="square" lIns="0" tIns="0" rIns="0" bIns="0" rtlCol="0" anchor="ctr">
+            <a:normAutofit/>
+          </a:bodyPr>
+          <a:lstStyle/>
+          <a:p>
+            <a:pPr algn="ctr" indent="0" marL="0">
+              <a:lnSpc>
+                <a:spcPct val="120000"/>
+              </a:lnSpc>
+              <a:buNone/>
+            </a:pPr>
+            <a:r>
+              <a:rPr lang="en-US" sz="1600" b="1" dirty="0">
+                <a:solidFill>
+                  <a:srgbClr val="F8FAFC"/>
+                </a:solidFill>
+                <a:latin typeface="Pretendard" pitchFamily="34" charset="0"/>
+                <a:ea typeface="Pretendard" pitchFamily="34" charset="-122"/>
+                <a:cs typeface="Pretendard" pitchFamily="34" charset="-120"/>
+              </a:rPr>
+              <a:t>4</a:t>
+            </a:r>
+            <a:endParaRPr lang="en-US" sz="1600" dirty="0"/>
+          </a:p>
+        </p:txBody>
+      </p:sp>
+      <p:sp>
+        <p:nvSpPr>
+          <p:cNvPr id="29" name="Text 27"/>
+          <p:cNvSpPr txBox="1"/>
+          <p:nvPr/>
+        </p:nvSpPr>
+        <p:spPr>
+          <a:xfrm>
+            <a:off x="8817498" y="4119372"/>
+            <a:ext cx="2585070" cy="914400"/>
+          </a:xfrm>
+          <a:prstGeom prst="rect">
+            <a:avLst/>
+          </a:prstGeom>
+          <a:noFill/>
+          <a:ln/>
+        </p:spPr>
+        <p:txBody>
+          <a:bodyPr wrap="square" lIns="0" tIns="25400" rIns="25400" bIns="0" rtlCol="0" anchor="ctr">
+            <a:normAutofit/>
+          </a:bodyPr>
+          <a:lstStyle/>
+          <a:p>
+            <a:pPr algn="l" indent="0" marL="0">
+              <a:lnSpc>
+                <a:spcPct val="92000"/>
+              </a:lnSpc>
+              <a:buNone/>
+            </a:pPr>
+            <a:r>
+              <a:rPr lang="en-US" sz="1600" dirty="0">
+                <a:solidFill>
+                  <a:srgbClr val="111111"/>
+                </a:solidFill>
+                <a:latin typeface="Pretendard" pitchFamily="34" charset="0"/>
+                <a:ea typeface="Pretendard" pitchFamily="34" charset="-122"/>
+                <a:cs typeface="Pretendard" pitchFamily="34" charset="-120"/>
+              </a:rPr>
+              <a:t>Split Planner</a:t>
+            </a:r>
+            <a:endParaRPr lang="en-US" sz="1600" dirty="0"/>
+          </a:p>
+        </p:txBody>
+      </p:sp>
+      <p:sp>
+        <p:nvSpPr>
+          <p:cNvPr id="30" name="Shape 28"/>
+          <p:cNvSpPr/>
+          <p:nvPr/>
+        </p:nvSpPr>
+        <p:spPr>
+          <a:xfrm>
+            <a:off x="4386072" y="3991356"/>
+            <a:ext cx="3435096" cy="109728"/>
+          </a:xfrm>
+          <a:prstGeom prst="rect">
+            <a:avLst/>
+          </a:prstGeom>
+          <a:solidFill>
+            <a:srgbClr val="2563EB"/>
+          </a:solidFill>
+          <a:ln w="12700">
+            <a:solidFill>
+              <a:srgbClr val="2563EB">
+                <a:alpha val="0"/>
+              </a:srgbClr>
+            </a:solidFill>
+            <a:prstDash val="solid"/>
+          </a:ln>
+        </p:spPr>
+      </p:sp>
+      <p:sp>
+        <p:nvSpPr>
+          <p:cNvPr id="31" name="Shape 29"/>
+          <p:cNvSpPr/>
+          <p:nvPr/>
+        </p:nvSpPr>
+        <p:spPr>
+          <a:xfrm>
+            <a:off x="4550664" y="4389303"/>
+            <a:ext cx="374538" cy="374538"/>
+          </a:xfrm>
+          <a:prstGeom prst="ellipse">
+            <a:avLst/>
+          </a:prstGeom>
+          <a:solidFill>
+            <a:srgbClr val="2563EB"/>
+          </a:solidFill>
+          <a:ln w="12700">
+            <a:solidFill>
+              <a:srgbClr val="2563EB">
+                <a:alpha val="0"/>
+              </a:srgbClr>
+            </a:solidFill>
+            <a:prstDash val="solid"/>
+          </a:ln>
+        </p:spPr>
+      </p:sp>
+      <p:sp>
+        <p:nvSpPr>
+          <p:cNvPr id="32" name="Text 30"/>
+          <p:cNvSpPr txBox="1"/>
+          <p:nvPr/>
+        </p:nvSpPr>
+        <p:spPr>
+          <a:xfrm>
+            <a:off x="4550664" y="4389303"/>
+            <a:ext cx="374538" cy="374538"/>
+          </a:xfrm>
+          <a:prstGeom prst="rect">
+            <a:avLst/>
+          </a:prstGeom>
+          <a:noFill/>
+          <a:ln/>
+        </p:spPr>
+        <p:txBody>
+          <a:bodyPr wrap="square" lIns="0" tIns="0" rIns="0" bIns="0" rtlCol="0" anchor="ctr">
+            <a:normAutofit/>
+          </a:bodyPr>
+          <a:lstStyle/>
+          <a:p>
+            <a:pPr algn="ctr" indent="0" marL="0">
+              <a:lnSpc>
+                <a:spcPct val="120000"/>
+              </a:lnSpc>
+              <a:buNone/>
+            </a:pPr>
+            <a:r>
+              <a:rPr lang="en-US" sz="1600" b="1" dirty="0">
+                <a:solidFill>
+                  <a:srgbClr val="F8FAFC"/>
+                </a:solidFill>
+                <a:latin typeface="Pretendard" pitchFamily="34" charset="0"/>
+                <a:ea typeface="Pretendard" pitchFamily="34" charset="-122"/>
+                <a:cs typeface="Pretendard" pitchFamily="34" charset="-120"/>
+              </a:rPr>
+              <a:t>5</a:t>
+            </a:r>
+            <a:endParaRPr lang="en-US" sz="1600" dirty="0"/>
+          </a:p>
+        </p:txBody>
+      </p:sp>
+      <p:sp>
+        <p:nvSpPr>
+          <p:cNvPr id="33" name="Text 31"/>
+          <p:cNvSpPr txBox="1"/>
+          <p:nvPr/>
+        </p:nvSpPr>
+        <p:spPr>
+          <a:xfrm>
+            <a:off x="5071506" y="4119372"/>
+            <a:ext cx="2585070" cy="914400"/>
+          </a:xfrm>
+          <a:prstGeom prst="rect">
+            <a:avLst/>
+          </a:prstGeom>
+          <a:noFill/>
+          <a:ln/>
+        </p:spPr>
+        <p:txBody>
+          <a:bodyPr wrap="square" lIns="0" tIns="25400" rIns="25400" bIns="0" rtlCol="0" anchor="ctr">
+            <a:normAutofit/>
+          </a:bodyPr>
+          <a:lstStyle/>
+          <a:p>
+            <a:pPr algn="l" indent="0" marL="0">
+              <a:lnSpc>
+                <a:spcPct val="92000"/>
+              </a:lnSpc>
+              <a:buNone/>
+            </a:pPr>
+            <a:r>
+              <a:rPr lang="en-US" sz="1600" dirty="0">
+                <a:solidFill>
+                  <a:srgbClr val="111111"/>
+                </a:solidFill>
+                <a:latin typeface="Pretendard" pitchFamily="34" charset="0"/>
+                <a:ea typeface="Pretendard" pitchFamily="34" charset="-122"/>
+                <a:cs typeface="Pretendard" pitchFamily="34" charset="-120"/>
+              </a:rPr>
+              <a:t>Coherence Grouping</a:t>
+            </a:r>
+            <a:endParaRPr lang="en-US" sz="1600" dirty="0"/>
+          </a:p>
+        </p:txBody>
       </p:sp>
       <p:sp>
         <p:nvSpPr>

</xml_diff>

<commit_message>
Complete selected example overview coverage
</commit_message>
<xml_diff>
--- a/artifacts/mdpr-vs-skill/mdpr-baseline-result.pptx
+++ b/artifacts/mdpr-vs-skill/mdpr-baseline-result.pptx
@@ -9457,9 +9457,288 @@
           <a:chExt cx="0" cy="0"/>
         </a:xfrm>
       </p:grpSpPr>
-      <p:sp>
-        <p:nvSpPr>
-          <p:cNvPr id="2" name="mdpr:example-decks-from-mdpr-1f8782:title:__title:example-decks-from-mdpr-1f8782"/>
+      <p:pic>
+        <p:nvPicPr>
+          <p:cNvPr id="2" name="Image 0" descr="preencoded.png">    </p:cNvPr>
+          <p:cNvPicPr>
+            <a:picLocks noChangeAspect="1"/>
+          </p:cNvPicPr>
+          <p:nvPr/>
+        </p:nvPicPr>
+        <p:blipFill>
+          <a:blip r:embed="rId1">
+            <a:extLst>
+              <a:ext uri="{96DAC541-7B7A-43D3-8B79-37D633B846F1}">
+                <asvg:svgBlip xmlns:asvg="http://schemas.microsoft.com/office/drawing/2016/SVG/main" r:embed="rId2"/>
+              </a:ext>
+            </a:extLst>
+          </a:blip>
+          <a:stretch>
+            <a:fillRect/>
+          </a:stretch>
+        </p:blipFill>
+        <p:spPr>
+          <a:xfrm>
+            <a:off x="914400" y="1865376"/>
+            <a:ext cx="10241280" cy="1024128"/>
+          </a:xfrm>
+          <a:prstGeom prst="rect">
+            <a:avLst/>
+          </a:prstGeom>
+        </p:spPr>
+      </p:pic>
+      <p:sp>
+        <p:nvSpPr>
+          <p:cNvPr id="3" name="Shape 0"/>
+          <p:cNvSpPr/>
+          <p:nvPr/>
+        </p:nvSpPr>
+        <p:spPr>
+          <a:xfrm>
+            <a:off x="914400" y="1865376"/>
+            <a:ext cx="10241280" cy="1024128"/>
+          </a:xfrm>
+          <a:prstGeom prst="rect">
+            <a:avLst/>
+          </a:prstGeom>
+          <a:solidFill>
+            <a:srgbClr val="FFFFFF">
+              <a:alpha val="0"/>
+            </a:srgbClr>
+          </a:solidFill>
+          <a:ln w="12700">
+            <a:solidFill>
+              <a:srgbClr val="E2E8F0">
+                <a:alpha val="0"/>
+              </a:srgbClr>
+            </a:solidFill>
+            <a:prstDash val="solid"/>
+          </a:ln>
+          <a:effectLst>
+            <a:outerShdw sx="100000" sy="100000" kx="0" ky="0" algn="bl" rotWithShape="0" blurRad="12700" dist="50800" dir="2700000">
+              <a:srgbClr val="000000">
+                <a:alpha val="8000"/>
+              </a:srgbClr>
+            </a:outerShdw>
+          </a:effectLst>
+        </p:spPr>
+      </p:sp>
+      <p:pic>
+        <p:nvPicPr>
+          <p:cNvPr id="4" name="Image 1" descr="preencoded.png">    </p:cNvPr>
+          <p:cNvPicPr>
+            <a:picLocks noChangeAspect="1"/>
+          </p:cNvPicPr>
+          <p:nvPr/>
+        </p:nvPicPr>
+        <p:blipFill>
+          <a:blip r:embed="rId3">
+            <a:extLst>
+              <a:ext uri="{96DAC541-7B7A-43D3-8B79-37D633B846F1}">
+                <asvg:svgBlip xmlns:asvg="http://schemas.microsoft.com/office/drawing/2016/SVG/main" r:embed="rId4"/>
+              </a:ext>
+            </a:extLst>
+          </a:blip>
+          <a:stretch>
+            <a:fillRect/>
+          </a:stretch>
+        </p:blipFill>
+        <p:spPr>
+          <a:xfrm>
+            <a:off x="914400" y="3191256"/>
+            <a:ext cx="10241280" cy="1024128"/>
+          </a:xfrm>
+          <a:prstGeom prst="rect">
+            <a:avLst/>
+          </a:prstGeom>
+        </p:spPr>
+      </p:pic>
+      <p:sp>
+        <p:nvSpPr>
+          <p:cNvPr id="5" name="Shape 1"/>
+          <p:cNvSpPr/>
+          <p:nvPr/>
+        </p:nvSpPr>
+        <p:spPr>
+          <a:xfrm>
+            <a:off x="914400" y="3191256"/>
+            <a:ext cx="10241280" cy="1024128"/>
+          </a:xfrm>
+          <a:prstGeom prst="rect">
+            <a:avLst/>
+          </a:prstGeom>
+          <a:solidFill>
+            <a:srgbClr val="FFFFFF">
+              <a:alpha val="0"/>
+            </a:srgbClr>
+          </a:solidFill>
+          <a:ln w="12700">
+            <a:solidFill>
+              <a:srgbClr val="E2E8F0">
+                <a:alpha val="0"/>
+              </a:srgbClr>
+            </a:solidFill>
+            <a:prstDash val="solid"/>
+          </a:ln>
+          <a:effectLst>
+            <a:outerShdw sx="100000" sy="100000" kx="0" ky="0" algn="bl" rotWithShape="0" blurRad="12700" dist="50800" dir="2700000">
+              <a:srgbClr val="000000">
+                <a:alpha val="8000"/>
+              </a:srgbClr>
+            </a:outerShdw>
+          </a:effectLst>
+        </p:spPr>
+      </p:sp>
+      <p:pic>
+        <p:nvPicPr>
+          <p:cNvPr id="6" name="Image 2" descr="preencoded.png">    </p:cNvPr>
+          <p:cNvPicPr>
+            <a:picLocks noChangeAspect="1"/>
+          </p:cNvPicPr>
+          <p:nvPr/>
+        </p:nvPicPr>
+        <p:blipFill>
+          <a:blip r:embed="rId5">
+            <a:extLst>
+              <a:ext uri="{96DAC541-7B7A-43D3-8B79-37D633B846F1}">
+                <asvg:svgBlip xmlns:asvg="http://schemas.microsoft.com/office/drawing/2016/SVG/main" r:embed="rId6"/>
+              </a:ext>
+            </a:extLst>
+          </a:blip>
+          <a:stretch>
+            <a:fillRect/>
+          </a:stretch>
+        </p:blipFill>
+        <p:spPr>
+          <a:xfrm>
+            <a:off x="914400" y="4507992"/>
+            <a:ext cx="10241280" cy="1024128"/>
+          </a:xfrm>
+          <a:prstGeom prst="rect">
+            <a:avLst/>
+          </a:prstGeom>
+        </p:spPr>
+      </p:pic>
+      <p:sp>
+        <p:nvSpPr>
+          <p:cNvPr id="7" name="Shape 2"/>
+          <p:cNvSpPr/>
+          <p:nvPr/>
+        </p:nvSpPr>
+        <p:spPr>
+          <a:xfrm>
+            <a:off x="914400" y="4507992"/>
+            <a:ext cx="10241280" cy="1024128"/>
+          </a:xfrm>
+          <a:prstGeom prst="rect">
+            <a:avLst/>
+          </a:prstGeom>
+          <a:solidFill>
+            <a:srgbClr val="FFFFFF">
+              <a:alpha val="0"/>
+            </a:srgbClr>
+          </a:solidFill>
+          <a:ln w="12700">
+            <a:solidFill>
+              <a:srgbClr val="E2E8F0">
+                <a:alpha val="0"/>
+              </a:srgbClr>
+            </a:solidFill>
+            <a:prstDash val="solid"/>
+          </a:ln>
+          <a:effectLst>
+            <a:outerShdw sx="100000" sy="100000" kx="0" ky="0" algn="bl" rotWithShape="0" blurRad="12700" dist="50800" dir="2700000">
+              <a:srgbClr val="000000">
+                <a:alpha val="8000"/>
+              </a:srgbClr>
+            </a:outerShdw>
+          </a:effectLst>
+        </p:spPr>
+      </p:sp>
+      <p:sp>
+        <p:nvSpPr>
+          <p:cNvPr id="8" name="Shape 3"/>
+          <p:cNvSpPr/>
+          <p:nvPr/>
+        </p:nvSpPr>
+        <p:spPr>
+          <a:xfrm>
+            <a:off x="914400" y="1865376"/>
+            <a:ext cx="73152" cy="1024128"/>
+          </a:xfrm>
+          <a:prstGeom prst="rect">
+            <a:avLst/>
+          </a:prstGeom>
+          <a:solidFill>
+            <a:srgbClr val="2563EB"/>
+          </a:solidFill>
+          <a:ln w="12700">
+            <a:solidFill>
+              <a:srgbClr val="2563EB">
+                <a:alpha val="0"/>
+              </a:srgbClr>
+            </a:solidFill>
+            <a:prstDash val="solid"/>
+          </a:ln>
+        </p:spPr>
+      </p:sp>
+      <p:sp>
+        <p:nvSpPr>
+          <p:cNvPr id="9" name="Shape 4"/>
+          <p:cNvSpPr/>
+          <p:nvPr/>
+        </p:nvSpPr>
+        <p:spPr>
+          <a:xfrm>
+            <a:off x="914400" y="3191256"/>
+            <a:ext cx="73152" cy="1024128"/>
+          </a:xfrm>
+          <a:prstGeom prst="rect">
+            <a:avLst/>
+          </a:prstGeom>
+          <a:solidFill>
+            <a:srgbClr val="DBEAFE"/>
+          </a:solidFill>
+          <a:ln w="12700">
+            <a:solidFill>
+              <a:srgbClr val="DBEAFE">
+                <a:alpha val="0"/>
+              </a:srgbClr>
+            </a:solidFill>
+            <a:prstDash val="solid"/>
+          </a:ln>
+        </p:spPr>
+      </p:sp>
+      <p:sp>
+        <p:nvSpPr>
+          <p:cNvPr id="10" name="Shape 5"/>
+          <p:cNvSpPr/>
+          <p:nvPr/>
+        </p:nvSpPr>
+        <p:spPr>
+          <a:xfrm>
+            <a:off x="914400" y="4507992"/>
+            <a:ext cx="73152" cy="1024128"/>
+          </a:xfrm>
+          <a:prstGeom prst="rect">
+            <a:avLst/>
+          </a:prstGeom>
+          <a:solidFill>
+            <a:srgbClr val="2563EB"/>
+          </a:solidFill>
+          <a:ln w="12700">
+            <a:solidFill>
+              <a:srgbClr val="2563EB">
+                <a:alpha val="0"/>
+              </a:srgbClr>
+            </a:solidFill>
+            <a:prstDash val="solid"/>
+          </a:ln>
+        </p:spPr>
+      </p:sp>
+      <p:sp>
+        <p:nvSpPr>
+          <p:cNvPr id="11" name="mdpr:example-decks-from-mdpr-1f8782:title:__title:example-decks-from-mdpr-1f8782"/>
           <p:cNvSpPr txBox="1"/>
           <p:nvPr/>
         </p:nvSpPr>
@@ -9501,14 +9780,14 @@
       </p:sp>
       <p:sp>
         <p:nvSpPr>
-          <p:cNvPr id="3" name="mdpr:example-decks-from-mdpr-1f8782:left:block-26-block-26-block-26"/>
+          <p:cNvPr id="12" name="mdpr:example-decks-from-mdpr-1f8782:item-1:block-26"/>
           <p:cNvSpPr txBox="1"/>
           <p:nvPr/>
         </p:nvSpPr>
         <p:spPr>
           <a:xfrm>
-            <a:off x="896112" y="1463040"/>
-            <a:ext cx="4791456" cy="762000"/>
+            <a:off x="1133856" y="2164080"/>
+            <a:ext cx="9820656" cy="426720"/>
           </a:xfrm>
           <a:prstGeom prst="rect">
             <a:avLst/>
@@ -9517,10 +9796,10 @@
           <a:ln/>
         </p:spPr>
         <p:txBody>
-          <a:bodyPr wrap="square" lIns="0" tIns="25400" rIns="25400" bIns="0" rtlCol="0" anchor="t"/>
+          <a:bodyPr wrap="square" lIns="0" tIns="25400" rIns="25400" bIns="0" rtlCol="0" anchor="ctr"/>
           <a:lstStyle/>
           <a:p>
-            <a:pPr algn="l" indent="0" marL="0">
+            <a:pPr algn="ctr" indent="0" marL="0">
               <a:lnSpc>
                 <a:spcPct val="120000"/>
               </a:lnSpc>
@@ -9535,7 +9814,7 @@
                 <a:ea typeface="Pretendard" pitchFamily="34" charset="-122"/>
                 <a:cs typeface="Pretendard" pitchFamily="34" charset="-120"/>
               </a:rPr>
-              <a:t>- basic/deck.md covers core flow and expected effects.</a:t>
+              <a:t>basic/deck.md · comparison/deck.md</a:t>
             </a:r>
             <a:endParaRPr lang="en-US" sz="2200" dirty="0"/>
           </a:p>
@@ -9543,14 +9822,14 @@
       </p:sp>
       <p:sp>
         <p:nvSpPr>
-          <p:cNvPr id="4" name="mdpr:example-decks-from-mdpr-1f8782:left:block-26-block-26-block-26"/>
+          <p:cNvPr id="13" name="mdpr:example-decks-from-mdpr-1f8782:item-2:block-26"/>
           <p:cNvSpPr txBox="1"/>
           <p:nvPr/>
         </p:nvSpPr>
         <p:spPr>
           <a:xfrm>
-            <a:off x="896112" y="2225040"/>
-            <a:ext cx="4791456" cy="762000"/>
+            <a:off x="1133856" y="3489960"/>
+            <a:ext cx="9820656" cy="426720"/>
           </a:xfrm>
           <a:prstGeom prst="rect">
             <a:avLst/>
@@ -9559,10 +9838,10 @@
           <a:ln/>
         </p:spPr>
         <p:txBody>
-          <a:bodyPr wrap="square" lIns="0" tIns="25400" rIns="25400" bIns="0" rtlCol="0" anchor="t"/>
+          <a:bodyPr wrap="square" lIns="0" tIns="25400" rIns="25400" bIns="0" rtlCol="0" anchor="ctr"/>
           <a:lstStyle/>
           <a:p>
-            <a:pPr algn="l" indent="0" marL="0">
+            <a:pPr algn="ctr" indent="0" marL="0">
               <a:lnSpc>
                 <a:spcPct val="120000"/>
               </a:lnSpc>
@@ -9577,7 +9856,7 @@
                 <a:ea typeface="Pretendard" pitchFamily="34" charset="-122"/>
                 <a:cs typeface="Pretendard" pitchFamily="34" charset="-120"/>
               </a:rPr>
-              <a:t>- comparison/deck.md exercises before/after content.</a:t>
+              <a:t>pipeline/deck.md · diagram-arrangements/deck.md</a:t>
             </a:r>
             <a:endParaRPr lang="en-US" sz="2200" dirty="0"/>
           </a:p>
@@ -9585,14 +9864,14 @@
       </p:sp>
       <p:sp>
         <p:nvSpPr>
-          <p:cNvPr id="5" name="mdpr:example-decks-from-mdpr-1f8782:left:block-26-block-26-block-26"/>
+          <p:cNvPr id="14" name="mdpr:example-decks-from-mdpr-1f8782:item-3:block-26"/>
           <p:cNvSpPr txBox="1"/>
           <p:nvPr/>
         </p:nvSpPr>
         <p:spPr>
           <a:xfrm>
-            <a:off x="896112" y="2987040"/>
-            <a:ext cx="4791456" cy="762000"/>
+            <a:off x="1133856" y="4639056"/>
+            <a:ext cx="9820656" cy="762000"/>
           </a:xfrm>
           <a:prstGeom prst="rect">
             <a:avLst/>
@@ -9601,10 +9880,10 @@
           <a:ln/>
         </p:spPr>
         <p:txBody>
-          <a:bodyPr wrap="square" lIns="0" tIns="25400" rIns="25400" bIns="0" rtlCol="0" anchor="t"/>
+          <a:bodyPr wrap="square" lIns="0" tIns="25400" rIns="25400" bIns="0" rtlCol="0" anchor="ctr"/>
           <a:lstStyle/>
           <a:p>
-            <a:pPr algn="l" indent="0" marL="0">
+            <a:pPr algn="ctr" indent="0" marL="0">
               <a:lnSpc>
                 <a:spcPct val="120000"/>
               </a:lnSpc>
@@ -9619,91 +9898,7 @@
                 <a:ea typeface="Pretendard" pitchFamily="34" charset="-122"/>
                 <a:cs typeface="Pretendard" pitchFamily="34" charset="-120"/>
               </a:rPr>
-              <a:t>- pipeline/deck.md exercises diagram conversion.</a:t>
-            </a:r>
-            <a:endParaRPr lang="en-US" sz="2200" dirty="0"/>
-          </a:p>
-        </p:txBody>
-      </p:sp>
-      <p:sp>
-        <p:nvSpPr>
-          <p:cNvPr id="6" name="mdpr:example-decks-from-mdpr-1f8782:right:block-26-block-26"/>
-          <p:cNvSpPr txBox="1"/>
-          <p:nvPr/>
-        </p:nvSpPr>
-        <p:spPr>
-          <a:xfrm>
-            <a:off x="6473952" y="1463040"/>
-            <a:ext cx="4791456" cy="1097280"/>
-          </a:xfrm>
-          <a:prstGeom prst="rect">
-            <a:avLst/>
-          </a:prstGeom>
-          <a:noFill/>
-          <a:ln/>
-        </p:spPr>
-        <p:txBody>
-          <a:bodyPr wrap="square" lIns="0" tIns="25400" rIns="25400" bIns="0" rtlCol="0" anchor="t"/>
-          <a:lstStyle/>
-          <a:p>
-            <a:pPr algn="l" indent="0" marL="0">
-              <a:lnSpc>
-                <a:spcPct val="120000"/>
-              </a:lnSpc>
-              <a:buNone/>
-            </a:pPr>
-            <a:r>
-              <a:rPr lang="en-US" sz="2200" dirty="0">
-                <a:solidFill>
-                  <a:srgbClr val="111111"/>
-                </a:solidFill>
-                <a:latin typeface="Pretendard" pitchFamily="34" charset="0"/>
-                <a:ea typeface="Pretendard" pitchFamily="34" charset="-122"/>
-                <a:cs typeface="Pretendard" pitchFamily="34" charset="-120"/>
-              </a:rPr>
-              <a:t>- diagram-arrangements/deck.md exercises multiple diagram structures.</a:t>
-            </a:r>
-            <a:endParaRPr lang="en-US" sz="2200" dirty="0"/>
-          </a:p>
-        </p:txBody>
-      </p:sp>
-      <p:sp>
-        <p:nvSpPr>
-          <p:cNvPr id="7" name="mdpr:example-decks-from-mdpr-1f8782:right:block-26-block-26"/>
-          <p:cNvSpPr txBox="1"/>
-          <p:nvPr/>
-        </p:nvSpPr>
-        <p:spPr>
-          <a:xfrm>
-            <a:off x="6473952" y="2560320"/>
-            <a:ext cx="4791456" cy="762000"/>
-          </a:xfrm>
-          <a:prstGeom prst="rect">
-            <a:avLst/>
-          </a:prstGeom>
-          <a:noFill/>
-          <a:ln/>
-        </p:spPr>
-        <p:txBody>
-          <a:bodyPr wrap="square" lIns="0" tIns="25400" rIns="25400" bIns="0" rtlCol="0" anchor="t"/>
-          <a:lstStyle/>
-          <a:p>
-            <a:pPr algn="l" indent="0" marL="0">
-              <a:lnSpc>
-                <a:spcPct val="120000"/>
-              </a:lnSpc>
-              <a:buNone/>
-            </a:pPr>
-            <a:r>
-              <a:rPr lang="en-US" sz="2200" dirty="0">
-                <a:solidFill>
-                  <a:srgbClr val="111111"/>
-                </a:solidFill>
-                <a:latin typeface="Pretendard" pitchFamily="34" charset="0"/>
-                <a:ea typeface="Pretendard" pitchFamily="34" charset="-122"/>
-                <a:cs typeface="Pretendard" pitchFamily="34" charset="-120"/>
-              </a:rPr>
-              <a:t>- theme-preview decks exercise preset variety.</a:t>
+              <a:t>five-methods/deck.md — Five-Item Layout Example · theme-preview-en/deck.md</a:t>
             </a:r>
             <a:endParaRPr lang="en-US" sz="2200" dirty="0"/>
           </a:p>
@@ -11783,214 +11978,16 @@
           <a:chExt cx="0" cy="0"/>
         </a:xfrm>
       </p:grpSpPr>
-      <p:pic>
-        <p:nvPicPr>
-          <p:cNvPr id="2" name="Image 0" descr="preencoded.png">    </p:cNvPr>
-          <p:cNvPicPr>
-            <a:picLocks noChangeAspect="1"/>
-          </p:cNvPicPr>
-          <p:nvPr/>
-        </p:nvPicPr>
-        <p:blipFill>
-          <a:blip r:embed="rId1">
-            <a:extLst>
-              <a:ext uri="{96DAC541-7B7A-43D3-8B79-37D633B846F1}">
-                <asvg:svgBlip xmlns:asvg="http://schemas.microsoft.com/office/drawing/2016/SVG/main" r:embed="rId2"/>
-              </a:ext>
-            </a:extLst>
-          </a:blip>
-          <a:stretch>
-            <a:fillRect/>
-          </a:stretch>
-        </p:blipFill>
-        <p:spPr>
-          <a:xfrm>
-            <a:off x="914400" y="1865376"/>
-            <a:ext cx="10241280" cy="1024128"/>
-          </a:xfrm>
-          <a:prstGeom prst="rect">
-            <a:avLst/>
-          </a:prstGeom>
-        </p:spPr>
-      </p:pic>
-      <p:sp>
-        <p:nvSpPr>
-          <p:cNvPr id="3" name="Shape 0"/>
+      <p:sp>
+        <p:nvSpPr>
+          <p:cNvPr id="2" name="Shape 0"/>
           <p:cNvSpPr/>
           <p:nvPr/>
         </p:nvSpPr>
         <p:spPr>
           <a:xfrm>
-            <a:off x="914400" y="1865376"/>
-            <a:ext cx="10241280" cy="1024128"/>
-          </a:xfrm>
-          <a:prstGeom prst="rect">
-            <a:avLst/>
-          </a:prstGeom>
-          <a:solidFill>
-            <a:srgbClr val="FFFFFF">
-              <a:alpha val="0"/>
-            </a:srgbClr>
-          </a:solidFill>
-          <a:ln w="12700">
-            <a:solidFill>
-              <a:srgbClr val="E2E8F0">
-                <a:alpha val="0"/>
-              </a:srgbClr>
-            </a:solidFill>
-            <a:prstDash val="solid"/>
-          </a:ln>
-          <a:effectLst>
-            <a:outerShdw sx="100000" sy="100000" kx="0" ky="0" algn="bl" rotWithShape="0" blurRad="12700" dist="50800" dir="2700000">
-              <a:srgbClr val="000000">
-                <a:alpha val="8000"/>
-              </a:srgbClr>
-            </a:outerShdw>
-          </a:effectLst>
-        </p:spPr>
-      </p:sp>
-      <p:pic>
-        <p:nvPicPr>
-          <p:cNvPr id="4" name="Image 1" descr="preencoded.png">    </p:cNvPr>
-          <p:cNvPicPr>
-            <a:picLocks noChangeAspect="1"/>
-          </p:cNvPicPr>
-          <p:nvPr/>
-        </p:nvPicPr>
-        <p:blipFill>
-          <a:blip r:embed="rId3">
-            <a:extLst>
-              <a:ext uri="{96DAC541-7B7A-43D3-8B79-37D633B846F1}">
-                <asvg:svgBlip xmlns:asvg="http://schemas.microsoft.com/office/drawing/2016/SVG/main" r:embed="rId4"/>
-              </a:ext>
-            </a:extLst>
-          </a:blip>
-          <a:stretch>
-            <a:fillRect/>
-          </a:stretch>
-        </p:blipFill>
-        <p:spPr>
-          <a:xfrm>
-            <a:off x="914400" y="3191256"/>
-            <a:ext cx="10241280" cy="1024128"/>
-          </a:xfrm>
-          <a:prstGeom prst="rect">
-            <a:avLst/>
-          </a:prstGeom>
-        </p:spPr>
-      </p:pic>
-      <p:sp>
-        <p:nvSpPr>
-          <p:cNvPr id="5" name="Shape 1"/>
-          <p:cNvSpPr/>
-          <p:nvPr/>
-        </p:nvSpPr>
-        <p:spPr>
-          <a:xfrm>
-            <a:off x="914400" y="3191256"/>
-            <a:ext cx="10241280" cy="1024128"/>
-          </a:xfrm>
-          <a:prstGeom prst="rect">
-            <a:avLst/>
-          </a:prstGeom>
-          <a:solidFill>
-            <a:srgbClr val="FFFFFF">
-              <a:alpha val="0"/>
-            </a:srgbClr>
-          </a:solidFill>
-          <a:ln w="12700">
-            <a:solidFill>
-              <a:srgbClr val="E2E8F0">
-                <a:alpha val="0"/>
-              </a:srgbClr>
-            </a:solidFill>
-            <a:prstDash val="solid"/>
-          </a:ln>
-          <a:effectLst>
-            <a:outerShdw sx="100000" sy="100000" kx="0" ky="0" algn="bl" rotWithShape="0" blurRad="12700" dist="50800" dir="2700000">
-              <a:srgbClr val="000000">
-                <a:alpha val="8000"/>
-              </a:srgbClr>
-            </a:outerShdw>
-          </a:effectLst>
-        </p:spPr>
-      </p:sp>
-      <p:pic>
-        <p:nvPicPr>
-          <p:cNvPr id="6" name="Image 2" descr="preencoded.png">    </p:cNvPr>
-          <p:cNvPicPr>
-            <a:picLocks noChangeAspect="1"/>
-          </p:cNvPicPr>
-          <p:nvPr/>
-        </p:nvPicPr>
-        <p:blipFill>
-          <a:blip r:embed="rId5">
-            <a:extLst>
-              <a:ext uri="{96DAC541-7B7A-43D3-8B79-37D633B846F1}">
-                <asvg:svgBlip xmlns:asvg="http://schemas.microsoft.com/office/drawing/2016/SVG/main" r:embed="rId6"/>
-              </a:ext>
-            </a:extLst>
-          </a:blip>
-          <a:stretch>
-            <a:fillRect/>
-          </a:stretch>
-        </p:blipFill>
-        <p:spPr>
-          <a:xfrm>
-            <a:off x="914400" y="4507992"/>
-            <a:ext cx="10241280" cy="1024128"/>
-          </a:xfrm>
-          <a:prstGeom prst="rect">
-            <a:avLst/>
-          </a:prstGeom>
-        </p:spPr>
-      </p:pic>
-      <p:sp>
-        <p:nvSpPr>
-          <p:cNvPr id="7" name="Shape 2"/>
-          <p:cNvSpPr/>
-          <p:nvPr/>
-        </p:nvSpPr>
-        <p:spPr>
-          <a:xfrm>
-            <a:off x="914400" y="4507992"/>
-            <a:ext cx="10241280" cy="1024128"/>
-          </a:xfrm>
-          <a:prstGeom prst="rect">
-            <a:avLst/>
-          </a:prstGeom>
-          <a:solidFill>
-            <a:srgbClr val="FFFFFF">
-              <a:alpha val="0"/>
-            </a:srgbClr>
-          </a:solidFill>
-          <a:ln w="12700">
-            <a:solidFill>
-              <a:srgbClr val="E2E8F0">
-                <a:alpha val="0"/>
-              </a:srgbClr>
-            </a:solidFill>
-            <a:prstDash val="solid"/>
-          </a:ln>
-          <a:effectLst>
-            <a:outerShdw sx="100000" sy="100000" kx="0" ky="0" algn="bl" rotWithShape="0" blurRad="12700" dist="50800" dir="2700000">
-              <a:srgbClr val="000000">
-                <a:alpha val="8000"/>
-              </a:srgbClr>
-            </a:outerShdw>
-          </a:effectLst>
-        </p:spPr>
-      </p:sp>
-      <p:sp>
-        <p:nvSpPr>
-          <p:cNvPr id="8" name="Shape 3"/>
-          <p:cNvSpPr/>
-          <p:nvPr/>
-        </p:nvSpPr>
-        <p:spPr>
-          <a:xfrm>
-            <a:off x="914400" y="1865376"/>
-            <a:ext cx="73152" cy="1024128"/>
+            <a:off x="822960" y="2487168"/>
+            <a:ext cx="73152" cy="1417320"/>
           </a:xfrm>
           <a:prstGeom prst="rect">
             <a:avLst/>
@@ -12010,14 +12007,14 @@
       </p:sp>
       <p:sp>
         <p:nvSpPr>
-          <p:cNvPr id="9" name="Shape 4"/>
+          <p:cNvPr id="3" name="Shape 1"/>
           <p:cNvSpPr/>
           <p:nvPr/>
         </p:nvSpPr>
         <p:spPr>
           <a:xfrm>
-            <a:off x="914400" y="3191256"/>
-            <a:ext cx="73152" cy="1024128"/>
+            <a:off x="4343400" y="2487168"/>
+            <a:ext cx="73152" cy="1417320"/>
           </a:xfrm>
           <a:prstGeom prst="rect">
             <a:avLst/>
@@ -12037,14 +12034,14 @@
       </p:sp>
       <p:sp>
         <p:nvSpPr>
-          <p:cNvPr id="10" name="Shape 5"/>
+          <p:cNvPr id="4" name="Shape 2"/>
           <p:cNvSpPr/>
           <p:nvPr/>
         </p:nvSpPr>
         <p:spPr>
           <a:xfrm>
-            <a:off x="914400" y="4507992"/>
-            <a:ext cx="73152" cy="1024128"/>
+            <a:off x="7863840" y="2487168"/>
+            <a:ext cx="73152" cy="1417320"/>
           </a:xfrm>
           <a:prstGeom prst="rect">
             <a:avLst/>
@@ -12064,7 +12061,7 @@
       </p:sp>
       <p:sp>
         <p:nvSpPr>
-          <p:cNvPr id="11" name="mdpr:2-2-a2c94a:title:__title:2-2-a2c94a"/>
+          <p:cNvPr id="5" name="mdpr:2-2-a2c94a:title:__title:2-2-a2c94a"/>
           <p:cNvSpPr txBox="1"/>
           <p:nvPr/>
         </p:nvSpPr>
@@ -12123,14 +12120,14 @@
       </p:sp>
       <p:sp>
         <p:nvSpPr>
-          <p:cNvPr id="12" name="mdpr:2-2-a2c94a:item-1:block-32-chunk-2"/>
+          <p:cNvPr id="6" name="mdpr:2-2-a2c94a:item-1:block-32-chunk-2"/>
           <p:cNvSpPr txBox="1"/>
           <p:nvPr/>
         </p:nvSpPr>
         <p:spPr>
           <a:xfrm>
-            <a:off x="1335024" y="2164080"/>
-            <a:ext cx="9619488" cy="426720"/>
+            <a:off x="1243584" y="2982468"/>
+            <a:ext cx="2624328" cy="426720"/>
           </a:xfrm>
           <a:prstGeom prst="rect">
             <a:avLst/>
@@ -12165,14 +12162,14 @@
       </p:sp>
       <p:sp>
         <p:nvSpPr>
-          <p:cNvPr id="13" name="mdpr:2-2-a2c94a:item-2:block-32-chunk-2"/>
+          <p:cNvPr id="7" name="mdpr:2-2-a2c94a:item-2:block-32-chunk-2"/>
           <p:cNvSpPr txBox="1"/>
           <p:nvPr/>
         </p:nvSpPr>
         <p:spPr>
           <a:xfrm>
-            <a:off x="1335024" y="3489960"/>
-            <a:ext cx="9619488" cy="426720"/>
+            <a:off x="4764024" y="2982468"/>
+            <a:ext cx="2624328" cy="426720"/>
           </a:xfrm>
           <a:prstGeom prst="rect">
             <a:avLst/>
@@ -12207,14 +12204,14 @@
       </p:sp>
       <p:sp>
         <p:nvSpPr>
-          <p:cNvPr id="14" name="mdpr:2-2-a2c94a:item-3:block-32-chunk-2"/>
+          <p:cNvPr id="8" name="mdpr:2-2-a2c94a:item-3:block-32-chunk-2"/>
           <p:cNvSpPr txBox="1"/>
           <p:nvPr/>
         </p:nvSpPr>
         <p:spPr>
           <a:xfrm>
-            <a:off x="1335024" y="4806696"/>
-            <a:ext cx="9619488" cy="426720"/>
+            <a:off x="8284464" y="2982468"/>
+            <a:ext cx="2624328" cy="426720"/>
           </a:xfrm>
           <a:prstGeom prst="rect">
             <a:avLst/>

</xml_diff>